<commit_message>
Update winnercomb.pptx - slide7 layout fix
</commit_message>
<xml_diff>
--- a/winnercomb.pptx
+++ b/winnercomb.pptx
@@ -10424,12 +10424,12 @@
         </p:nvSpPr>
         <p:spPr>
           <a:xfrm>
-            <a:off x="365760" y="1042416"/>
-            <a:ext cx="1594714" cy="1481328"/>
+            <a:off x="365760" y="1078992"/>
+            <a:ext cx="1594714" cy="1261872"/>
           </a:xfrm>
           <a:prstGeom prst="roundRect">
             <a:avLst>
-              <a:gd name="adj" fmla="val 4321"/>
+              <a:gd name="adj" fmla="val 5072"/>
             </a:avLst>
           </a:prstGeom>
           <a:solidFill>
@@ -10458,8 +10458,8 @@
         </p:nvSpPr>
         <p:spPr>
           <a:xfrm>
-            <a:off x="365760" y="1042416"/>
-            <a:ext cx="1594714" cy="182880"/>
+            <a:off x="365760" y="1078992"/>
+            <a:ext cx="1594714" cy="146304"/>
           </a:xfrm>
           <a:prstGeom prst="rect">
             <a:avLst/>
@@ -10483,8 +10483,8 @@
         </p:nvSpPr>
         <p:spPr>
           <a:xfrm>
-            <a:off x="888797" y="1298448"/>
-            <a:ext cx="548640" cy="548640"/>
+            <a:off x="925373" y="1243584"/>
+            <a:ext cx="475488" cy="475488"/>
           </a:xfrm>
           <a:prstGeom prst="ellipse">
             <a:avLst/>
@@ -10508,8 +10508,8 @@
         </p:nvSpPr>
         <p:spPr>
           <a:xfrm>
-            <a:off x="888797" y="1298448"/>
-            <a:ext cx="548640" cy="548640"/>
+            <a:off x="925373" y="1243584"/>
+            <a:ext cx="475488" cy="475488"/>
           </a:xfrm>
           <a:prstGeom prst="rect">
             <a:avLst/>
@@ -10525,7 +10525,7 @@
               <a:buNone/>
             </a:pPr>
             <a:r>
-              <a:rPr lang="en-US" sz="1800" dirty="0">
+              <a:rPr lang="en-US" sz="1600" dirty="0">
                 <a:solidFill>
                   <a:srgbClr val="000000"/>
                 </a:solidFill>
@@ -10535,7 +10535,7 @@
               </a:rPr>
               <a:t>🎯</a:t>
             </a:r>
-            <a:endParaRPr lang="en-US" sz="1800" dirty="0"/>
+            <a:endParaRPr lang="en-US" sz="1600" dirty="0"/>
           </a:p>
         </p:txBody>
       </p:sp>
@@ -10547,8 +10547,8 @@
         </p:nvSpPr>
         <p:spPr>
           <a:xfrm>
-            <a:off x="420624" y="1938528"/>
-            <a:ext cx="1484986" cy="347472"/>
+            <a:off x="411480" y="1755648"/>
+            <a:ext cx="1503274" cy="347472"/>
           </a:xfrm>
           <a:prstGeom prst="rect">
             <a:avLst/>
@@ -10567,7 +10567,7 @@
               <a:buNone/>
             </a:pPr>
             <a:r>
-              <a:rPr lang="en-US" sz="950" b="1" dirty="0">
+              <a:rPr lang="en-US" sz="900" b="1" dirty="0">
                 <a:solidFill>
                   <a:srgbClr val="1B2F5E"/>
                 </a:solidFill>
@@ -10577,7 +10577,7 @@
               </a:rPr>
               <a:t>딥러닝</a:t>
             </a:r>
-            <a:endParaRPr lang="en-US" sz="950" dirty="0"/>
+            <a:endParaRPr lang="en-US" sz="900" dirty="0"/>
           </a:p>
           <a:p>
             <a:pPr algn="ctr" indent="0" marL="0">
@@ -10587,7 +10587,7 @@
               <a:buNone/>
             </a:pPr>
             <a:r>
-              <a:rPr lang="en-US" sz="950" b="1" dirty="0">
+              <a:rPr lang="en-US" sz="900" b="1" dirty="0">
                 <a:solidFill>
                   <a:srgbClr val="1B2F5E"/>
                 </a:solidFill>
@@ -10597,7 +10597,7 @@
               </a:rPr>
               <a:t>자동학습</a:t>
             </a:r>
-            <a:endParaRPr lang="en-US" sz="950" dirty="0"/>
+            <a:endParaRPr lang="en-US" sz="900" dirty="0"/>
           </a:p>
         </p:txBody>
       </p:sp>
@@ -10609,8 +10609,8 @@
         </p:nvSpPr>
         <p:spPr>
           <a:xfrm>
-            <a:off x="493776" y="2322576"/>
-            <a:ext cx="1338682" cy="0"/>
+            <a:off x="475488" y="2084832"/>
+            <a:ext cx="1375258" cy="0"/>
           </a:xfrm>
           <a:prstGeom prst="line">
             <a:avLst/>
@@ -10632,8 +10632,8 @@
         </p:nvSpPr>
         <p:spPr>
           <a:xfrm>
-            <a:off x="420624" y="2377440"/>
-            <a:ext cx="1484986" cy="91440"/>
+            <a:off x="411480" y="2130552"/>
+            <a:ext cx="1503274" cy="347472"/>
           </a:xfrm>
           <a:prstGeom prst="rect">
             <a:avLst/>
@@ -10647,12 +10647,12 @@
           <a:p>
             <a:pPr algn="ctr" indent="0" marL="0">
               <a:lnSpc>
-                <a:spcPct val="125000"/>
+                <a:spcPct val="120000"/>
               </a:lnSpc>
               <a:buNone/>
             </a:pPr>
             <a:r>
-              <a:rPr lang="en-US" sz="850" dirty="0">
+              <a:rPr lang="en-US" sz="800" dirty="0">
                 <a:solidFill>
                   <a:srgbClr val="475569"/>
                 </a:solidFill>
@@ -10662,17 +10662,17 @@
               </a:rPr>
               <a:t>데이터 누적</a:t>
             </a:r>
-            <a:endParaRPr lang="en-US" sz="850" dirty="0"/>
+            <a:endParaRPr lang="en-US" sz="800" dirty="0"/>
           </a:p>
           <a:p>
             <a:pPr algn="ctr" indent="0" marL="0">
               <a:lnSpc>
-                <a:spcPct val="125000"/>
+                <a:spcPct val="120000"/>
               </a:lnSpc>
               <a:buNone/>
             </a:pPr>
             <a:r>
-              <a:rPr lang="en-US" sz="850" dirty="0">
+              <a:rPr lang="en-US" sz="800" dirty="0">
                 <a:solidFill>
                   <a:srgbClr val="475569"/>
                 </a:solidFill>
@@ -10682,7 +10682,7 @@
               </a:rPr>
               <a:t>→ 정확도 지속 향상</a:t>
             </a:r>
-            <a:endParaRPr lang="en-US" sz="850" dirty="0"/>
+            <a:endParaRPr lang="en-US" sz="800" dirty="0"/>
           </a:p>
         </p:txBody>
       </p:sp>
@@ -10694,12 +10694,12 @@
         </p:nvSpPr>
         <p:spPr>
           <a:xfrm>
-            <a:off x="2070202" y="1042416"/>
-            <a:ext cx="1594714" cy="1481328"/>
+            <a:off x="2070202" y="1078992"/>
+            <a:ext cx="1594714" cy="1261872"/>
           </a:xfrm>
           <a:prstGeom prst="roundRect">
             <a:avLst>
-              <a:gd name="adj" fmla="val 4321"/>
+              <a:gd name="adj" fmla="val 5072"/>
             </a:avLst>
           </a:prstGeom>
           <a:solidFill>
@@ -10728,8 +10728,8 @@
         </p:nvSpPr>
         <p:spPr>
           <a:xfrm>
-            <a:off x="2070202" y="1042416"/>
-            <a:ext cx="1594714" cy="182880"/>
+            <a:off x="2070202" y="1078992"/>
+            <a:ext cx="1594714" cy="146304"/>
           </a:xfrm>
           <a:prstGeom prst="rect">
             <a:avLst/>
@@ -10753,8 +10753,8 @@
         </p:nvSpPr>
         <p:spPr>
           <a:xfrm>
-            <a:off x="2593238" y="1298448"/>
-            <a:ext cx="548640" cy="548640"/>
+            <a:off x="2629814" y="1243584"/>
+            <a:ext cx="475488" cy="475488"/>
           </a:xfrm>
           <a:prstGeom prst="ellipse">
             <a:avLst/>
@@ -10778,8 +10778,8 @@
         </p:nvSpPr>
         <p:spPr>
           <a:xfrm>
-            <a:off x="2593238" y="1298448"/>
-            <a:ext cx="548640" cy="548640"/>
+            <a:off x="2629814" y="1243584"/>
+            <a:ext cx="475488" cy="475488"/>
           </a:xfrm>
           <a:prstGeom prst="rect">
             <a:avLst/>
@@ -10795,7 +10795,7 @@
               <a:buNone/>
             </a:pPr>
             <a:r>
-              <a:rPr lang="en-US" sz="1800" dirty="0">
+              <a:rPr lang="en-US" sz="1600" dirty="0">
                 <a:solidFill>
                   <a:srgbClr val="000000"/>
                 </a:solidFill>
@@ -10805,7 +10805,7 @@
               </a:rPr>
               <a:t>⚖️</a:t>
             </a:r>
-            <a:endParaRPr lang="en-US" sz="1800" dirty="0"/>
+            <a:endParaRPr lang="en-US" sz="1600" dirty="0"/>
           </a:p>
         </p:txBody>
       </p:sp>
@@ -10817,8 +10817,8 @@
         </p:nvSpPr>
         <p:spPr>
           <a:xfrm>
-            <a:off x="2125066" y="1938528"/>
-            <a:ext cx="1484986" cy="347472"/>
+            <a:off x="2115922" y="1755648"/>
+            <a:ext cx="1503274" cy="347472"/>
           </a:xfrm>
           <a:prstGeom prst="rect">
             <a:avLst/>
@@ -10837,7 +10837,7 @@
               <a:buNone/>
             </a:pPr>
             <a:r>
-              <a:rPr lang="en-US" sz="950" b="1" dirty="0">
+              <a:rPr lang="en-US" sz="900" b="1" dirty="0">
                 <a:solidFill>
                   <a:srgbClr val="1B2F5E"/>
                 </a:solidFill>
@@ -10847,7 +10847,7 @@
               </a:rPr>
               <a:t>일관된</a:t>
             </a:r>
-            <a:endParaRPr lang="en-US" sz="950" dirty="0"/>
+            <a:endParaRPr lang="en-US" sz="900" dirty="0"/>
           </a:p>
           <a:p>
             <a:pPr algn="ctr" indent="0" marL="0">
@@ -10857,7 +10857,7 @@
               <a:buNone/>
             </a:pPr>
             <a:r>
-              <a:rPr lang="en-US" sz="950" b="1" dirty="0">
+              <a:rPr lang="en-US" sz="900" b="1" dirty="0">
                 <a:solidFill>
                   <a:srgbClr val="1B2F5E"/>
                 </a:solidFill>
@@ -10867,7 +10867,7 @@
               </a:rPr>
               <a:t>검사 기준</a:t>
             </a:r>
-            <a:endParaRPr lang="en-US" sz="950" dirty="0"/>
+            <a:endParaRPr lang="en-US" sz="900" dirty="0"/>
           </a:p>
         </p:txBody>
       </p:sp>
@@ -10879,8 +10879,8 @@
         </p:nvSpPr>
         <p:spPr>
           <a:xfrm>
-            <a:off x="2198218" y="2322576"/>
-            <a:ext cx="1338682" cy="0"/>
+            <a:off x="2179930" y="2084832"/>
+            <a:ext cx="1375258" cy="0"/>
           </a:xfrm>
           <a:prstGeom prst="line">
             <a:avLst/>
@@ -10902,8 +10902,8 @@
         </p:nvSpPr>
         <p:spPr>
           <a:xfrm>
-            <a:off x="2125066" y="2377440"/>
-            <a:ext cx="1484986" cy="91440"/>
+            <a:off x="2115922" y="2130552"/>
+            <a:ext cx="1503274" cy="347472"/>
           </a:xfrm>
           <a:prstGeom prst="rect">
             <a:avLst/>
@@ -10917,12 +10917,12 @@
           <a:p>
             <a:pPr algn="ctr" indent="0" marL="0">
               <a:lnSpc>
-                <a:spcPct val="125000"/>
+                <a:spcPct val="120000"/>
               </a:lnSpc>
               <a:buNone/>
             </a:pPr>
             <a:r>
-              <a:rPr lang="en-US" sz="850" dirty="0">
+              <a:rPr lang="en-US" sz="800" dirty="0">
                 <a:solidFill>
                   <a:srgbClr val="475569"/>
                 </a:solidFill>
@@ -10932,17 +10932,17 @@
               </a:rPr>
               <a:t>컨디션 무관</a:t>
             </a:r>
-            <a:endParaRPr lang="en-US" sz="850" dirty="0"/>
+            <a:endParaRPr lang="en-US" sz="800" dirty="0"/>
           </a:p>
           <a:p>
             <a:pPr algn="ctr" indent="0" marL="0">
               <a:lnSpc>
-                <a:spcPct val="125000"/>
+                <a:spcPct val="120000"/>
               </a:lnSpc>
               <a:buNone/>
             </a:pPr>
             <a:r>
-              <a:rPr lang="en-US" sz="850" dirty="0">
+              <a:rPr lang="en-US" sz="800" dirty="0">
                 <a:solidFill>
                   <a:srgbClr val="475569"/>
                 </a:solidFill>
@@ -10952,7 +10952,7 @@
               </a:rPr>
               <a:t>동일 기준 판정</a:t>
             </a:r>
-            <a:endParaRPr lang="en-US" sz="850" dirty="0"/>
+            <a:endParaRPr lang="en-US" sz="800" dirty="0"/>
           </a:p>
         </p:txBody>
       </p:sp>
@@ -10964,12 +10964,12 @@
         </p:nvSpPr>
         <p:spPr>
           <a:xfrm>
-            <a:off x="3774643" y="1042416"/>
-            <a:ext cx="1594714" cy="1481328"/>
+            <a:off x="3774643" y="1078992"/>
+            <a:ext cx="1594714" cy="1261872"/>
           </a:xfrm>
           <a:prstGeom prst="roundRect">
             <a:avLst>
-              <a:gd name="adj" fmla="val 4321"/>
+              <a:gd name="adj" fmla="val 5072"/>
             </a:avLst>
           </a:prstGeom>
           <a:solidFill>
@@ -10998,8 +10998,8 @@
         </p:nvSpPr>
         <p:spPr>
           <a:xfrm>
-            <a:off x="3774643" y="1042416"/>
-            <a:ext cx="1594714" cy="182880"/>
+            <a:off x="3774643" y="1078992"/>
+            <a:ext cx="1594714" cy="146304"/>
           </a:xfrm>
           <a:prstGeom prst="rect">
             <a:avLst/>
@@ -11023,8 +11023,8 @@
         </p:nvSpPr>
         <p:spPr>
           <a:xfrm>
-            <a:off x="4297680" y="1298448"/>
-            <a:ext cx="548640" cy="548640"/>
+            <a:off x="4334256" y="1243584"/>
+            <a:ext cx="475488" cy="475488"/>
           </a:xfrm>
           <a:prstGeom prst="ellipse">
             <a:avLst/>
@@ -11048,8 +11048,8 @@
         </p:nvSpPr>
         <p:spPr>
           <a:xfrm>
-            <a:off x="4297680" y="1298448"/>
-            <a:ext cx="548640" cy="548640"/>
+            <a:off x="4334256" y="1243584"/>
+            <a:ext cx="475488" cy="475488"/>
           </a:xfrm>
           <a:prstGeom prst="rect">
             <a:avLst/>
@@ -11065,7 +11065,7 @@
               <a:buNone/>
             </a:pPr>
             <a:r>
-              <a:rPr lang="en-US" sz="1800" dirty="0">
+              <a:rPr lang="en-US" sz="1600" dirty="0">
                 <a:solidFill>
                   <a:srgbClr val="000000"/>
                 </a:solidFill>
@@ -11075,7 +11075,7 @@
               </a:rPr>
               <a:t>🚫</a:t>
             </a:r>
-            <a:endParaRPr lang="en-US" sz="1800" dirty="0"/>
+            <a:endParaRPr lang="en-US" sz="1600" dirty="0"/>
           </a:p>
         </p:txBody>
       </p:sp>
@@ -11087,8 +11087,8 @@
         </p:nvSpPr>
         <p:spPr>
           <a:xfrm>
-            <a:off x="3829507" y="1938528"/>
-            <a:ext cx="1484986" cy="347472"/>
+            <a:off x="3820363" y="1755648"/>
+            <a:ext cx="1503274" cy="347472"/>
           </a:xfrm>
           <a:prstGeom prst="rect">
             <a:avLst/>
@@ -11107,7 +11107,7 @@
               <a:buNone/>
             </a:pPr>
             <a:r>
-              <a:rPr lang="en-US" sz="950" b="1" dirty="0">
+              <a:rPr lang="en-US" sz="900" b="1" dirty="0">
                 <a:solidFill>
                   <a:srgbClr val="1B2F5E"/>
                 </a:solidFill>
@@ -11117,7 +11117,7 @@
               </a:rPr>
               <a:t>불량 혼입</a:t>
             </a:r>
-            <a:endParaRPr lang="en-US" sz="950" dirty="0"/>
+            <a:endParaRPr lang="en-US" sz="900" dirty="0"/>
           </a:p>
           <a:p>
             <a:pPr algn="ctr" indent="0" marL="0">
@@ -11127,7 +11127,7 @@
               <a:buNone/>
             </a:pPr>
             <a:r>
-              <a:rPr lang="en-US" sz="950" b="1" dirty="0">
+              <a:rPr lang="en-US" sz="900" b="1" dirty="0">
                 <a:solidFill>
                   <a:srgbClr val="1B2F5E"/>
                 </a:solidFill>
@@ -11137,7 +11137,7 @@
               </a:rPr>
               <a:t>원천 차단</a:t>
             </a:r>
-            <a:endParaRPr lang="en-US" sz="950" dirty="0"/>
+            <a:endParaRPr lang="en-US" sz="900" dirty="0"/>
           </a:p>
         </p:txBody>
       </p:sp>
@@ -11149,8 +11149,8 @@
         </p:nvSpPr>
         <p:spPr>
           <a:xfrm>
-            <a:off x="3902659" y="2322576"/>
-            <a:ext cx="1338682" cy="0"/>
+            <a:off x="3884371" y="2084832"/>
+            <a:ext cx="1375258" cy="0"/>
           </a:xfrm>
           <a:prstGeom prst="line">
             <a:avLst/>
@@ -11172,8 +11172,8 @@
         </p:nvSpPr>
         <p:spPr>
           <a:xfrm>
-            <a:off x="3829507" y="2377440"/>
-            <a:ext cx="1484986" cy="91440"/>
+            <a:off x="3820363" y="2130552"/>
+            <a:ext cx="1503274" cy="347472"/>
           </a:xfrm>
           <a:prstGeom prst="rect">
             <a:avLst/>
@@ -11187,12 +11187,12 @@
           <a:p>
             <a:pPr algn="ctr" indent="0" marL="0">
               <a:lnSpc>
-                <a:spcPct val="125000"/>
+                <a:spcPct val="120000"/>
               </a:lnSpc>
               <a:buNone/>
             </a:pPr>
             <a:r>
-              <a:rPr lang="en-US" sz="850" dirty="0">
+              <a:rPr lang="en-US" sz="800" dirty="0">
                 <a:solidFill>
                   <a:srgbClr val="475569"/>
                 </a:solidFill>
@@ -11202,17 +11202,17 @@
               </a:rPr>
               <a:t>자동 분리 배출</a:t>
             </a:r>
-            <a:endParaRPr lang="en-US" sz="850" dirty="0"/>
+            <a:endParaRPr lang="en-US" sz="800" dirty="0"/>
           </a:p>
           <a:p>
             <a:pPr algn="ctr" indent="0" marL="0">
               <a:lnSpc>
-                <a:spcPct val="125000"/>
+                <a:spcPct val="120000"/>
               </a:lnSpc>
               <a:buNone/>
             </a:pPr>
             <a:r>
-              <a:rPr lang="en-US" sz="850" dirty="0">
+              <a:rPr lang="en-US" sz="800" dirty="0">
                 <a:solidFill>
                   <a:srgbClr val="475569"/>
                 </a:solidFill>
@@ -11222,7 +11222,7 @@
               </a:rPr>
               <a:t>재검사 불필요</a:t>
             </a:r>
-            <a:endParaRPr lang="en-US" sz="850" dirty="0"/>
+            <a:endParaRPr lang="en-US" sz="800" dirty="0"/>
           </a:p>
         </p:txBody>
       </p:sp>
@@ -11234,12 +11234,12 @@
         </p:nvSpPr>
         <p:spPr>
           <a:xfrm>
-            <a:off x="5479085" y="1042416"/>
-            <a:ext cx="1594714" cy="1481328"/>
+            <a:off x="5479085" y="1078992"/>
+            <a:ext cx="1594714" cy="1261872"/>
           </a:xfrm>
           <a:prstGeom prst="roundRect">
             <a:avLst>
-              <a:gd name="adj" fmla="val 4321"/>
+              <a:gd name="adj" fmla="val 5072"/>
             </a:avLst>
           </a:prstGeom>
           <a:solidFill>
@@ -11268,8 +11268,8 @@
         </p:nvSpPr>
         <p:spPr>
           <a:xfrm>
-            <a:off x="5479085" y="1042416"/>
-            <a:ext cx="1594714" cy="182880"/>
+            <a:off x="5479085" y="1078992"/>
+            <a:ext cx="1594714" cy="146304"/>
           </a:xfrm>
           <a:prstGeom prst="rect">
             <a:avLst/>
@@ -11293,8 +11293,8 @@
         </p:nvSpPr>
         <p:spPr>
           <a:xfrm>
-            <a:off x="6002122" y="1298448"/>
-            <a:ext cx="548640" cy="548640"/>
+            <a:off x="6038698" y="1243584"/>
+            <a:ext cx="475488" cy="475488"/>
           </a:xfrm>
           <a:prstGeom prst="ellipse">
             <a:avLst/>
@@ -11318,8 +11318,8 @@
         </p:nvSpPr>
         <p:spPr>
           <a:xfrm>
-            <a:off x="6002122" y="1298448"/>
-            <a:ext cx="548640" cy="548640"/>
+            <a:off x="6038698" y="1243584"/>
+            <a:ext cx="475488" cy="475488"/>
           </a:xfrm>
           <a:prstGeom prst="rect">
             <a:avLst/>
@@ -11335,7 +11335,7 @@
               <a:buNone/>
             </a:pPr>
             <a:r>
-              <a:rPr lang="en-US" sz="1800" dirty="0">
+              <a:rPr lang="en-US" sz="1600" dirty="0">
                 <a:solidFill>
                   <a:srgbClr val="000000"/>
                 </a:solidFill>
@@ -11345,7 +11345,7 @@
               </a:rPr>
               <a:t>📈</a:t>
             </a:r>
-            <a:endParaRPr lang="en-US" sz="1800" dirty="0"/>
+            <a:endParaRPr lang="en-US" sz="1600" dirty="0"/>
           </a:p>
         </p:txBody>
       </p:sp>
@@ -11357,8 +11357,8 @@
         </p:nvSpPr>
         <p:spPr>
           <a:xfrm>
-            <a:off x="5533949" y="1938528"/>
-            <a:ext cx="1484986" cy="347472"/>
+            <a:off x="5524805" y="1755648"/>
+            <a:ext cx="1503274" cy="347472"/>
           </a:xfrm>
           <a:prstGeom prst="rect">
             <a:avLst/>
@@ -11377,7 +11377,7 @@
               <a:buNone/>
             </a:pPr>
             <a:r>
-              <a:rPr lang="en-US" sz="950" b="1" dirty="0">
+              <a:rPr lang="en-US" sz="900" b="1" dirty="0">
                 <a:solidFill>
                   <a:srgbClr val="1B2F5E"/>
                 </a:solidFill>
@@ -11387,7 +11387,7 @@
               </a:rPr>
               <a:t>품질 데이터</a:t>
             </a:r>
-            <a:endParaRPr lang="en-US" sz="950" dirty="0"/>
+            <a:endParaRPr lang="en-US" sz="900" dirty="0"/>
           </a:p>
           <a:p>
             <a:pPr algn="ctr" indent="0" marL="0">
@@ -11397,7 +11397,7 @@
               <a:buNone/>
             </a:pPr>
             <a:r>
-              <a:rPr lang="en-US" sz="950" b="1" dirty="0">
+              <a:rPr lang="en-US" sz="900" b="1" dirty="0">
                 <a:solidFill>
                   <a:srgbClr val="1B2F5E"/>
                 </a:solidFill>
@@ -11407,7 +11407,7 @@
               </a:rPr>
               <a:t>자산화</a:t>
             </a:r>
-            <a:endParaRPr lang="en-US" sz="950" dirty="0"/>
+            <a:endParaRPr lang="en-US" sz="900" dirty="0"/>
           </a:p>
         </p:txBody>
       </p:sp>
@@ -11419,8 +11419,8 @@
         </p:nvSpPr>
         <p:spPr>
           <a:xfrm>
-            <a:off x="5607101" y="2322576"/>
-            <a:ext cx="1338682" cy="0"/>
+            <a:off x="5588813" y="2084832"/>
+            <a:ext cx="1375258" cy="0"/>
           </a:xfrm>
           <a:prstGeom prst="line">
             <a:avLst/>
@@ -11442,8 +11442,8 @@
         </p:nvSpPr>
         <p:spPr>
           <a:xfrm>
-            <a:off x="5533949" y="2377440"/>
-            <a:ext cx="1484986" cy="91440"/>
+            <a:off x="5524805" y="2130552"/>
+            <a:ext cx="1503274" cy="347472"/>
           </a:xfrm>
           <a:prstGeom prst="rect">
             <a:avLst/>
@@ -11457,12 +11457,12 @@
           <a:p>
             <a:pPr algn="ctr" indent="0" marL="0">
               <a:lnSpc>
-                <a:spcPct val="125000"/>
+                <a:spcPct val="120000"/>
               </a:lnSpc>
               <a:buNone/>
             </a:pPr>
             <a:r>
-              <a:rPr lang="en-US" sz="850" dirty="0">
+              <a:rPr lang="en-US" sz="800" dirty="0">
                 <a:solidFill>
                   <a:srgbClr val="475569"/>
                 </a:solidFill>
@@ -11472,17 +11472,17 @@
               </a:rPr>
               <a:t>통계·트렌드</a:t>
             </a:r>
-            <a:endParaRPr lang="en-US" sz="850" dirty="0"/>
+            <a:endParaRPr lang="en-US" sz="800" dirty="0"/>
           </a:p>
           <a:p>
             <a:pPr algn="ctr" indent="0" marL="0">
               <a:lnSpc>
-                <a:spcPct val="125000"/>
+                <a:spcPct val="120000"/>
               </a:lnSpc>
               <a:buNone/>
             </a:pPr>
             <a:r>
-              <a:rPr lang="en-US" sz="850" dirty="0">
+              <a:rPr lang="en-US" sz="800" dirty="0">
                 <a:solidFill>
                   <a:srgbClr val="475569"/>
                 </a:solidFill>
@@ -11492,7 +11492,7 @@
               </a:rPr>
               <a:t>리포트 자동 생성</a:t>
             </a:r>
-            <a:endParaRPr lang="en-US" sz="850" dirty="0"/>
+            <a:endParaRPr lang="en-US" sz="800" dirty="0"/>
           </a:p>
         </p:txBody>
       </p:sp>
@@ -11504,12 +11504,12 @@
         </p:nvSpPr>
         <p:spPr>
           <a:xfrm>
-            <a:off x="7183526" y="1042416"/>
-            <a:ext cx="1594714" cy="1481328"/>
+            <a:off x="7183526" y="1078992"/>
+            <a:ext cx="1594714" cy="1261872"/>
           </a:xfrm>
           <a:prstGeom prst="roundRect">
             <a:avLst>
-              <a:gd name="adj" fmla="val 4321"/>
+              <a:gd name="adj" fmla="val 5072"/>
             </a:avLst>
           </a:prstGeom>
           <a:solidFill>
@@ -11538,8 +11538,8 @@
         </p:nvSpPr>
         <p:spPr>
           <a:xfrm>
-            <a:off x="7183526" y="1042416"/>
-            <a:ext cx="1594714" cy="182880"/>
+            <a:off x="7183526" y="1078992"/>
+            <a:ext cx="1594714" cy="146304"/>
           </a:xfrm>
           <a:prstGeom prst="rect">
             <a:avLst/>
@@ -11563,8 +11563,8 @@
         </p:nvSpPr>
         <p:spPr>
           <a:xfrm>
-            <a:off x="7706563" y="1298448"/>
-            <a:ext cx="548640" cy="548640"/>
+            <a:off x="7743139" y="1243584"/>
+            <a:ext cx="475488" cy="475488"/>
           </a:xfrm>
           <a:prstGeom prst="ellipse">
             <a:avLst/>
@@ -11588,8 +11588,8 @@
         </p:nvSpPr>
         <p:spPr>
           <a:xfrm>
-            <a:off x="7706563" y="1298448"/>
-            <a:ext cx="548640" cy="548640"/>
+            <a:off x="7743139" y="1243584"/>
+            <a:ext cx="475488" cy="475488"/>
           </a:xfrm>
           <a:prstGeom prst="rect">
             <a:avLst/>
@@ -11605,7 +11605,7 @@
               <a:buNone/>
             </a:pPr>
             <a:r>
-              <a:rPr lang="en-US" sz="1800" dirty="0">
+              <a:rPr lang="en-US" sz="1600" dirty="0">
                 <a:solidFill>
                   <a:srgbClr val="000000"/>
                 </a:solidFill>
@@ -11615,7 +11615,7 @@
               </a:rPr>
               <a:t>👤</a:t>
             </a:r>
-            <a:endParaRPr lang="en-US" sz="1800" dirty="0"/>
+            <a:endParaRPr lang="en-US" sz="1600" dirty="0"/>
           </a:p>
         </p:txBody>
       </p:sp>
@@ -11627,8 +11627,8 @@
         </p:nvSpPr>
         <p:spPr>
           <a:xfrm>
-            <a:off x="7238390" y="1938528"/>
-            <a:ext cx="1484986" cy="347472"/>
+            <a:off x="7229246" y="1755648"/>
+            <a:ext cx="1503274" cy="347472"/>
           </a:xfrm>
           <a:prstGeom prst="rect">
             <a:avLst/>
@@ -11647,7 +11647,7 @@
               <a:buNone/>
             </a:pPr>
             <a:r>
-              <a:rPr lang="en-US" sz="950" b="1" dirty="0">
+              <a:rPr lang="en-US" sz="900" b="1" dirty="0">
                 <a:solidFill>
                   <a:srgbClr val="1B2F5E"/>
                 </a:solidFill>
@@ -11657,7 +11657,7 @@
               </a:rPr>
               <a:t>별도 인력</a:t>
             </a:r>
-            <a:endParaRPr lang="en-US" sz="950" dirty="0"/>
+            <a:endParaRPr lang="en-US" sz="900" dirty="0"/>
           </a:p>
           <a:p>
             <a:pPr algn="ctr" indent="0" marL="0">
@@ -11667,7 +11667,7 @@
               <a:buNone/>
             </a:pPr>
             <a:r>
-              <a:rPr lang="en-US" sz="950" b="1" dirty="0">
+              <a:rPr lang="en-US" sz="900" b="1" dirty="0">
                 <a:solidFill>
                   <a:srgbClr val="1B2F5E"/>
                 </a:solidFill>
@@ -11677,7 +11677,7 @@
               </a:rPr>
               <a:t>불필요</a:t>
             </a:r>
-            <a:endParaRPr lang="en-US" sz="950" dirty="0"/>
+            <a:endParaRPr lang="en-US" sz="900" dirty="0"/>
           </a:p>
         </p:txBody>
       </p:sp>
@@ -11689,8 +11689,8 @@
         </p:nvSpPr>
         <p:spPr>
           <a:xfrm>
-            <a:off x="7311542" y="2322576"/>
-            <a:ext cx="1338682" cy="0"/>
+            <a:off x="7293254" y="2084832"/>
+            <a:ext cx="1375258" cy="0"/>
           </a:xfrm>
           <a:prstGeom prst="line">
             <a:avLst/>
@@ -11712,8 +11712,8 @@
         </p:nvSpPr>
         <p:spPr>
           <a:xfrm>
-            <a:off x="7238390" y="2377440"/>
-            <a:ext cx="1484986" cy="91440"/>
+            <a:off x="7229246" y="2130552"/>
+            <a:ext cx="1503274" cy="347472"/>
           </a:xfrm>
           <a:prstGeom prst="rect">
             <a:avLst/>
@@ -11727,12 +11727,12 @@
           <a:p>
             <a:pPr algn="ctr" indent="0" marL="0">
               <a:lnSpc>
-                <a:spcPct val="125000"/>
+                <a:spcPct val="120000"/>
               </a:lnSpc>
               <a:buNone/>
             </a:pPr>
             <a:r>
-              <a:rPr lang="en-US" sz="850" dirty="0">
+              <a:rPr lang="en-US" sz="800" dirty="0">
                 <a:solidFill>
                   <a:srgbClr val="475569"/>
                 </a:solidFill>
@@ -11742,17 +11742,17 @@
               </a:rPr>
               <a:t>전 과정 자동</a:t>
             </a:r>
-            <a:endParaRPr lang="en-US" sz="850" dirty="0"/>
+            <a:endParaRPr lang="en-US" sz="800" dirty="0"/>
           </a:p>
           <a:p>
             <a:pPr algn="ctr" indent="0" marL="0">
               <a:lnSpc>
-                <a:spcPct val="125000"/>
+                <a:spcPct val="120000"/>
               </a:lnSpc>
               <a:buNone/>
             </a:pPr>
             <a:r>
-              <a:rPr lang="en-US" sz="850" dirty="0">
+              <a:rPr lang="en-US" sz="800" dirty="0">
                 <a:solidFill>
                   <a:srgbClr val="475569"/>
                 </a:solidFill>
@@ -11762,7 +11762,7 @@
               </a:rPr>
               <a:t>인력 재배치 가능</a:t>
             </a:r>
-            <a:endParaRPr lang="en-US" sz="850" dirty="0"/>
+            <a:endParaRPr lang="en-US" sz="800" dirty="0"/>
           </a:p>
         </p:txBody>
       </p:sp>
@@ -11774,12 +11774,12 @@
         </p:nvSpPr>
         <p:spPr>
           <a:xfrm>
-            <a:off x="365760" y="2633472"/>
-            <a:ext cx="2743200" cy="2395728"/>
+            <a:off x="365760" y="2432304"/>
+            <a:ext cx="2743200" cy="2176272"/>
           </a:xfrm>
           <a:prstGeom prst="roundRect">
             <a:avLst>
-              <a:gd name="adj" fmla="val 2672"/>
+              <a:gd name="adj" fmla="val 2941"/>
             </a:avLst>
           </a:prstGeom>
           <a:solidFill>
@@ -11808,12 +11808,12 @@
         </p:nvSpPr>
         <p:spPr>
           <a:xfrm>
-            <a:off x="365760" y="2633472"/>
-            <a:ext cx="2743200" cy="347472"/>
+            <a:off x="365760" y="2432304"/>
+            <a:ext cx="2743200" cy="329184"/>
           </a:xfrm>
           <a:prstGeom prst="roundRect">
             <a:avLst>
-              <a:gd name="adj" fmla="val 18421"/>
+              <a:gd name="adj" fmla="val 19444"/>
             </a:avLst>
           </a:prstGeom>
           <a:solidFill>
@@ -11835,8 +11835,8 @@
         </p:nvSpPr>
         <p:spPr>
           <a:xfrm>
-            <a:off x="365760" y="2633472"/>
-            <a:ext cx="2743200" cy="347472"/>
+            <a:off x="365760" y="2432304"/>
+            <a:ext cx="2743200" cy="329184"/>
           </a:xfrm>
           <a:prstGeom prst="rect">
             <a:avLst/>
@@ -11874,12 +11874,12 @@
         </p:nvSpPr>
         <p:spPr>
           <a:xfrm>
-            <a:off x="457200" y="3072384"/>
-            <a:ext cx="2560320" cy="530352"/>
+            <a:off x="457200" y="2834640"/>
+            <a:ext cx="2560320" cy="493776"/>
           </a:xfrm>
           <a:prstGeom prst="roundRect">
             <a:avLst>
-              <a:gd name="adj" fmla="val 12069"/>
+              <a:gd name="adj" fmla="val 12963"/>
             </a:avLst>
           </a:prstGeom>
           <a:solidFill>
@@ -11908,8 +11908,8 @@
         </p:nvSpPr>
         <p:spPr>
           <a:xfrm>
-            <a:off x="530352" y="3127248"/>
-            <a:ext cx="2414016" cy="420624"/>
+            <a:off x="530352" y="2880360"/>
+            <a:ext cx="2414016" cy="402336"/>
           </a:xfrm>
           <a:prstGeom prst="rect">
             <a:avLst/>
@@ -11950,12 +11950,12 @@
         </p:nvSpPr>
         <p:spPr>
           <a:xfrm>
-            <a:off x="457200" y="3694176"/>
-            <a:ext cx="2560320" cy="530352"/>
+            <a:off x="457200" y="3401568"/>
+            <a:ext cx="2560320" cy="493776"/>
           </a:xfrm>
           <a:prstGeom prst="roundRect">
             <a:avLst>
-              <a:gd name="adj" fmla="val 12069"/>
+              <a:gd name="adj" fmla="val 12963"/>
             </a:avLst>
           </a:prstGeom>
           <a:solidFill>
@@ -11984,8 +11984,8 @@
         </p:nvSpPr>
         <p:spPr>
           <a:xfrm>
-            <a:off x="530352" y="3749040"/>
-            <a:ext cx="2414016" cy="420624"/>
+            <a:off x="530352" y="3447288"/>
+            <a:ext cx="2414016" cy="402336"/>
           </a:xfrm>
           <a:prstGeom prst="rect">
             <a:avLst/>
@@ -12026,12 +12026,12 @@
         </p:nvSpPr>
         <p:spPr>
           <a:xfrm>
-            <a:off x="457200" y="4315968"/>
-            <a:ext cx="2560320" cy="530352"/>
+            <a:off x="457200" y="3968496"/>
+            <a:ext cx="2560320" cy="493776"/>
           </a:xfrm>
           <a:prstGeom prst="roundRect">
             <a:avLst>
-              <a:gd name="adj" fmla="val 12069"/>
+              <a:gd name="adj" fmla="val 12963"/>
             </a:avLst>
           </a:prstGeom>
           <a:solidFill>
@@ -12060,8 +12060,8 @@
         </p:nvSpPr>
         <p:spPr>
           <a:xfrm>
-            <a:off x="530352" y="4370832"/>
-            <a:ext cx="2414016" cy="420624"/>
+            <a:off x="530352" y="4014216"/>
+            <a:ext cx="2414016" cy="402336"/>
           </a:xfrm>
           <a:prstGeom prst="rect">
             <a:avLst/>
@@ -12102,12 +12102,12 @@
         </p:nvSpPr>
         <p:spPr>
           <a:xfrm>
-            <a:off x="3200400" y="2633472"/>
-            <a:ext cx="2743200" cy="2395728"/>
+            <a:off x="3200400" y="2432304"/>
+            <a:ext cx="2743200" cy="2176272"/>
           </a:xfrm>
           <a:prstGeom prst="roundRect">
             <a:avLst>
-              <a:gd name="adj" fmla="val 2672"/>
+              <a:gd name="adj" fmla="val 2941"/>
             </a:avLst>
           </a:prstGeom>
           <a:solidFill>
@@ -12136,12 +12136,12 @@
         </p:nvSpPr>
         <p:spPr>
           <a:xfrm>
-            <a:off x="3200400" y="2633472"/>
-            <a:ext cx="2743200" cy="347472"/>
+            <a:off x="3200400" y="2432304"/>
+            <a:ext cx="2743200" cy="329184"/>
           </a:xfrm>
           <a:prstGeom prst="roundRect">
             <a:avLst>
-              <a:gd name="adj" fmla="val 18421"/>
+              <a:gd name="adj" fmla="val 19444"/>
             </a:avLst>
           </a:prstGeom>
           <a:solidFill>
@@ -12163,8 +12163,8 @@
         </p:nvSpPr>
         <p:spPr>
           <a:xfrm>
-            <a:off x="3200400" y="2633472"/>
-            <a:ext cx="2743200" cy="347472"/>
+            <a:off x="3200400" y="2432304"/>
+            <a:ext cx="2743200" cy="329184"/>
           </a:xfrm>
           <a:prstGeom prst="rect">
             <a:avLst/>
@@ -12202,12 +12202,12 @@
         </p:nvSpPr>
         <p:spPr>
           <a:xfrm>
-            <a:off x="3291840" y="3072384"/>
-            <a:ext cx="2560320" cy="530352"/>
+            <a:off x="3291840" y="2834640"/>
+            <a:ext cx="2560320" cy="493776"/>
           </a:xfrm>
           <a:prstGeom prst="roundRect">
             <a:avLst>
-              <a:gd name="adj" fmla="val 12069"/>
+              <a:gd name="adj" fmla="val 12963"/>
             </a:avLst>
           </a:prstGeom>
           <a:solidFill>
@@ -12236,8 +12236,8 @@
         </p:nvSpPr>
         <p:spPr>
           <a:xfrm>
-            <a:off x="3364992" y="3127248"/>
-            <a:ext cx="2414016" cy="420624"/>
+            <a:off x="3364992" y="2880360"/>
+            <a:ext cx="2414016" cy="402336"/>
           </a:xfrm>
           <a:prstGeom prst="rect">
             <a:avLst/>
@@ -12278,12 +12278,12 @@
         </p:nvSpPr>
         <p:spPr>
           <a:xfrm>
-            <a:off x="3291840" y="3694176"/>
-            <a:ext cx="2560320" cy="530352"/>
+            <a:off x="3291840" y="3401568"/>
+            <a:ext cx="2560320" cy="493776"/>
           </a:xfrm>
           <a:prstGeom prst="roundRect">
             <a:avLst>
-              <a:gd name="adj" fmla="val 12069"/>
+              <a:gd name="adj" fmla="val 12963"/>
             </a:avLst>
           </a:prstGeom>
           <a:solidFill>
@@ -12312,8 +12312,8 @@
         </p:nvSpPr>
         <p:spPr>
           <a:xfrm>
-            <a:off x="3364992" y="3749040"/>
-            <a:ext cx="2414016" cy="420624"/>
+            <a:off x="3364992" y="3447288"/>
+            <a:ext cx="2414016" cy="402336"/>
           </a:xfrm>
           <a:prstGeom prst="rect">
             <a:avLst/>
@@ -12354,12 +12354,12 @@
         </p:nvSpPr>
         <p:spPr>
           <a:xfrm>
-            <a:off x="3291840" y="4315968"/>
-            <a:ext cx="2560320" cy="530352"/>
+            <a:off x="3291840" y="3968496"/>
+            <a:ext cx="2560320" cy="493776"/>
           </a:xfrm>
           <a:prstGeom prst="roundRect">
             <a:avLst>
-              <a:gd name="adj" fmla="val 12069"/>
+              <a:gd name="adj" fmla="val 12963"/>
             </a:avLst>
           </a:prstGeom>
           <a:solidFill>
@@ -12388,8 +12388,8 @@
         </p:nvSpPr>
         <p:spPr>
           <a:xfrm>
-            <a:off x="3364992" y="4370832"/>
-            <a:ext cx="2414016" cy="420624"/>
+            <a:off x="3364992" y="4014216"/>
+            <a:ext cx="2414016" cy="402336"/>
           </a:xfrm>
           <a:prstGeom prst="rect">
             <a:avLst/>
@@ -12430,12 +12430,12 @@
         </p:nvSpPr>
         <p:spPr>
           <a:xfrm>
-            <a:off x="6035040" y="2633472"/>
-            <a:ext cx="2743200" cy="2395728"/>
+            <a:off x="6035040" y="2432304"/>
+            <a:ext cx="2743200" cy="2176272"/>
           </a:xfrm>
           <a:prstGeom prst="roundRect">
             <a:avLst>
-              <a:gd name="adj" fmla="val 2672"/>
+              <a:gd name="adj" fmla="val 2941"/>
             </a:avLst>
           </a:prstGeom>
           <a:solidFill>
@@ -12464,12 +12464,12 @@
         </p:nvSpPr>
         <p:spPr>
           <a:xfrm>
-            <a:off x="6035040" y="2633472"/>
-            <a:ext cx="2743200" cy="347472"/>
+            <a:off x="6035040" y="2432304"/>
+            <a:ext cx="2743200" cy="329184"/>
           </a:xfrm>
           <a:prstGeom prst="roundRect">
             <a:avLst>
-              <a:gd name="adj" fmla="val 18421"/>
+              <a:gd name="adj" fmla="val 19444"/>
             </a:avLst>
           </a:prstGeom>
           <a:solidFill>
@@ -12491,8 +12491,8 @@
         </p:nvSpPr>
         <p:spPr>
           <a:xfrm>
-            <a:off x="6035040" y="2633472"/>
-            <a:ext cx="2743200" cy="347472"/>
+            <a:off x="6035040" y="2432304"/>
+            <a:ext cx="2743200" cy="329184"/>
           </a:xfrm>
           <a:prstGeom prst="rect">
             <a:avLst/>
@@ -12530,12 +12530,12 @@
         </p:nvSpPr>
         <p:spPr>
           <a:xfrm>
-            <a:off x="6126480" y="3072384"/>
-            <a:ext cx="2560320" cy="530352"/>
+            <a:off x="6126480" y="2834640"/>
+            <a:ext cx="2560320" cy="493776"/>
           </a:xfrm>
           <a:prstGeom prst="roundRect">
             <a:avLst>
-              <a:gd name="adj" fmla="val 12069"/>
+              <a:gd name="adj" fmla="val 12963"/>
             </a:avLst>
           </a:prstGeom>
           <a:solidFill>
@@ -12564,8 +12564,8 @@
         </p:nvSpPr>
         <p:spPr>
           <a:xfrm>
-            <a:off x="6199632" y="3127248"/>
-            <a:ext cx="2414016" cy="420624"/>
+            <a:off x="6199632" y="2880360"/>
+            <a:ext cx="2414016" cy="402336"/>
           </a:xfrm>
           <a:prstGeom prst="rect">
             <a:avLst/>
@@ -12606,12 +12606,12 @@
         </p:nvSpPr>
         <p:spPr>
           <a:xfrm>
-            <a:off x="6126480" y="3694176"/>
-            <a:ext cx="2560320" cy="530352"/>
+            <a:off x="6126480" y="3401568"/>
+            <a:ext cx="2560320" cy="493776"/>
           </a:xfrm>
           <a:prstGeom prst="roundRect">
             <a:avLst>
-              <a:gd name="adj" fmla="val 12069"/>
+              <a:gd name="adj" fmla="val 12963"/>
             </a:avLst>
           </a:prstGeom>
           <a:solidFill>
@@ -12640,8 +12640,8 @@
         </p:nvSpPr>
         <p:spPr>
           <a:xfrm>
-            <a:off x="6199632" y="3749040"/>
-            <a:ext cx="2414016" cy="420624"/>
+            <a:off x="6199632" y="3447288"/>
+            <a:ext cx="2414016" cy="402336"/>
           </a:xfrm>
           <a:prstGeom prst="rect">
             <a:avLst/>
@@ -12682,12 +12682,12 @@
         </p:nvSpPr>
         <p:spPr>
           <a:xfrm>
-            <a:off x="6126480" y="4315968"/>
-            <a:ext cx="2560320" cy="530352"/>
+            <a:off x="6126480" y="3968496"/>
+            <a:ext cx="2560320" cy="493776"/>
           </a:xfrm>
           <a:prstGeom prst="roundRect">
             <a:avLst>
-              <a:gd name="adj" fmla="val 12069"/>
+              <a:gd name="adj" fmla="val 12963"/>
             </a:avLst>
           </a:prstGeom>
           <a:solidFill>
@@ -12716,8 +12716,8 @@
         </p:nvSpPr>
         <p:spPr>
           <a:xfrm>
-            <a:off x="6199632" y="4370832"/>
-            <a:ext cx="2414016" cy="420624"/>
+            <a:off x="6199632" y="4014216"/>
+            <a:ext cx="2414016" cy="402336"/>
           </a:xfrm>
           <a:prstGeom prst="rect">
             <a:avLst/>

</xml_diff>

<commit_message>
Update winnercomb.pptx - lighting comparison update
</commit_message>
<xml_diff>
--- a/winnercomb.pptx
+++ b/winnercomb.pptx
@@ -4867,7 +4867,7 @@
                 <a:ea typeface="Noto Sans KR" pitchFamily="34" charset="-122"/>
                 <a:cs typeface="Noto Sans KR" pitchFamily="34" charset="-120"/>
               </a:rPr>
-              <a:t>왜 딥러닝 + 돔조명 조합인가?</a:t>
+              <a:t>검사 목적에 따른 최적 조명 선택이 딥러닝 정확도를 결정합니다</a:t>
             </a:r>
             <a:endParaRPr lang="en-US" sz="1050" dirty="0"/>
           </a:p>
@@ -5521,7 +5521,7 @@
                 <a:ea typeface="Noto Sans KR" pitchFamily="34" charset="-122"/>
                 <a:cs typeface="Noto Sans KR" pitchFamily="34" charset="-120"/>
               </a:rPr>
-              <a:t>딥러닝 비전 + 돔조명  ★ 제안 방식</a:t>
+              <a:t>딥러닝 비전 + 최적 조명 선택  ★ 제안 방식</a:t>
             </a:r>
             <a:endParaRPr lang="en-US" sz="1150" dirty="0"/>
           </a:p>
@@ -5706,7 +5706,7 @@
                 <a:ea typeface="Noto Sans KR" pitchFamily="34" charset="-122"/>
                 <a:cs typeface="Noto Sans KR" pitchFamily="34" charset="-120"/>
               </a:rPr>
-              <a:t>✅ 돔조명 — 반사·음영 제거</a:t>
+              <a:t>✅ 검사 목적별 최적 조명 선택</a:t>
             </a:r>
             <a:endParaRPr lang="en-US" sz="950" dirty="0"/>
           </a:p>
@@ -5745,7 +5745,7 @@
                 <a:ea typeface="Noto Sans KR" pitchFamily="34" charset="-122"/>
                 <a:cs typeface="Noto Sans KR" pitchFamily="34" charset="-120"/>
               </a:rPr>
-              <a:t>표면 긁힘·핀홀·광택 이상까지 가시화</a:t>
+              <a:t>불량 유형에 따라 조명 방식 결정</a:t>
             </a:r>
             <a:endParaRPr lang="en-US" sz="800" dirty="0"/>
           </a:p>
@@ -5969,7 +5969,7 @@
                 <a:ea typeface="Noto Sans KR" pitchFamily="34" charset="-122"/>
                 <a:cs typeface="Noto Sans KR" pitchFamily="34" charset="-120"/>
               </a:rPr>
-              <a:t>균일 확산광으로 변화 영향 최소화</a:t>
+              <a:t>균일 조명 설계로 오검 최소화</a:t>
             </a:r>
             <a:endParaRPr lang="en-US" sz="800" dirty="0"/>
           </a:p>
@@ -6235,33 +6235,99 @@
       </p:sp>
       <p:sp>
         <p:nvSpPr>
-          <p:cNvPr id="43" name="Text 41"/>
-          <p:cNvSpPr/>
-          <p:nvPr/>
-        </p:nvSpPr>
-        <p:spPr>
-          <a:xfrm>
-            <a:off x="4078224" y="3657600"/>
-            <a:ext cx="4645152" cy="877824"/>
-          </a:xfrm>
-          <a:prstGeom prst="rect">
-            <a:avLst/>
-          </a:prstGeom>
-          <a:noFill/>
-          <a:ln/>
-        </p:spPr>
-        <p:txBody>
-          <a:bodyPr wrap="square" lIns="0" tIns="0" rIns="0" bIns="0" rtlCol="0" anchor="ctr"/>
-          <a:lstStyle/>
-          <a:p>
-            <a:pPr indent="0" marL="0">
+          <p:cNvPr id="43" name="Shape 41"/>
+          <p:cNvSpPr/>
+          <p:nvPr/>
+        </p:nvSpPr>
+        <p:spPr>
+          <a:xfrm>
+            <a:off x="3986784" y="3639312"/>
+            <a:ext cx="1426464" cy="877824"/>
+          </a:xfrm>
+          <a:prstGeom prst="roundRect">
+            <a:avLst>
+              <a:gd name="adj" fmla="val 5208"/>
+            </a:avLst>
+          </a:prstGeom>
+          <a:solidFill>
+            <a:srgbClr val="0F1D40"/>
+          </a:solidFill>
+          <a:ln w="12700">
+            <a:solidFill>
+              <a:srgbClr val="2E4D8A"/>
+            </a:solidFill>
+            <a:prstDash val="solid"/>
+          </a:ln>
+        </p:spPr>
+      </p:sp>
+      <p:sp>
+        <p:nvSpPr>
+          <p:cNvPr id="44" name="Text 42"/>
+          <p:cNvSpPr/>
+          <p:nvPr/>
+        </p:nvSpPr>
+        <p:spPr>
+          <a:xfrm>
+            <a:off x="3986784" y="3639312"/>
+            <a:ext cx="1426464" cy="274320"/>
+          </a:xfrm>
+          <a:prstGeom prst="rect">
+            <a:avLst/>
+          </a:prstGeom>
+          <a:noFill/>
+          <a:ln/>
+        </p:spPr>
+        <p:txBody>
+          <a:bodyPr wrap="square" lIns="0" tIns="0" rIns="0" bIns="0" rtlCol="0" anchor="ctr"/>
+          <a:lstStyle/>
+          <a:p>
+            <a:pPr algn="ctr" indent="0" marL="0">
+              <a:buNone/>
+            </a:pPr>
+            <a:r>
+              <a:rPr lang="en-US" sz="850" b="1" dirty="0">
+                <a:solidFill>
+                  <a:srgbClr val="F59E0B"/>
+                </a:solidFill>
+                <a:latin typeface="Noto Sans KR" pitchFamily="34" charset="0"/>
+                <a:ea typeface="Noto Sans KR" pitchFamily="34" charset="-122"/>
+                <a:cs typeface="Noto Sans KR" pitchFamily="34" charset="-120"/>
+              </a:rPr>
+              <a:t>돔조명</a:t>
+            </a:r>
+            <a:endParaRPr lang="en-US" sz="850" dirty="0"/>
+          </a:p>
+        </p:txBody>
+      </p:sp>
+      <p:sp>
+        <p:nvSpPr>
+          <p:cNvPr id="45" name="Text 43"/>
+          <p:cNvSpPr/>
+          <p:nvPr/>
+        </p:nvSpPr>
+        <p:spPr>
+          <a:xfrm>
+            <a:off x="3986784" y="3913632"/>
+            <a:ext cx="1426464" cy="566928"/>
+          </a:xfrm>
+          <a:prstGeom prst="rect">
+            <a:avLst/>
+          </a:prstGeom>
+          <a:noFill/>
+          <a:ln/>
+        </p:spPr>
+        <p:txBody>
+          <a:bodyPr wrap="square" lIns="0" tIns="0" rIns="0" bIns="0" rtlCol="0" anchor="ctr"/>
+          <a:lstStyle/>
+          <a:p>
+            <a:pPr algn="ctr" indent="0" marL="0">
               <a:lnSpc>
-                <a:spcPct val="135000"/>
+                <a:spcPct val="125000"/>
               </a:lnSpc>
               <a:buNone/>
             </a:pPr>
             <a:r>
-              <a:rPr lang="en-US" sz="950" dirty="0">
+              <a:rPr lang="en-US" sz="750" dirty="0">
                 <a:solidFill>
                   <a:srgbClr val="A5C4F3"/>
                 </a:solidFill>
@@ -6269,19 +6335,19 @@
                 <a:ea typeface="Noto Sans KR" pitchFamily="34" charset="-122"/>
                 <a:cs typeface="Noto Sans KR" pitchFamily="34" charset="-120"/>
               </a:rPr>
-              <a:t>돔조명은 빛을 사방에서 균일하게 확산시켜 반사·음영을 제거합니다.</a:t>
-            </a:r>
-            <a:endParaRPr lang="en-US" sz="950" dirty="0"/>
-          </a:p>
-          <a:p>
-            <a:pPr indent="0" marL="0">
+              <a:t>Edge·형상 검출</a:t>
+            </a:r>
+            <a:endParaRPr lang="en-US" sz="750" dirty="0"/>
+          </a:p>
+          <a:p>
+            <a:pPr algn="ctr" indent="0" marL="0">
               <a:lnSpc>
-                <a:spcPct val="135000"/>
+                <a:spcPct val="125000"/>
               </a:lnSpc>
               <a:buNone/>
             </a:pPr>
             <a:r>
-              <a:rPr lang="en-US" sz="950" dirty="0">
+              <a:rPr lang="en-US" sz="750" dirty="0">
                 <a:solidFill>
                   <a:srgbClr val="A5C4F3"/>
                 </a:solidFill>
@@ -6289,9 +6355,282 @@
                 <a:ea typeface="Noto Sans KR" pitchFamily="34" charset="-122"/>
                 <a:cs typeface="Noto Sans KR" pitchFamily="34" charset="-120"/>
               </a:rPr>
-              <a:t>표면의 미세 긁힘·핀홀·광택 이상이 또렷하게 드러나 딥러닝 학습 정확도를 극대화합니다.</a:t>
-            </a:r>
-            <a:endParaRPr lang="en-US" sz="950" dirty="0"/>
+              <a:t>반사 억제</a:t>
+            </a:r>
+            <a:endParaRPr lang="en-US" sz="750" dirty="0"/>
+          </a:p>
+        </p:txBody>
+      </p:sp>
+      <p:sp>
+        <p:nvSpPr>
+          <p:cNvPr id="46" name="Shape 44"/>
+          <p:cNvSpPr/>
+          <p:nvPr/>
+        </p:nvSpPr>
+        <p:spPr>
+          <a:xfrm>
+            <a:off x="5522976" y="3639312"/>
+            <a:ext cx="1426464" cy="877824"/>
+          </a:xfrm>
+          <a:prstGeom prst="roundRect">
+            <a:avLst>
+              <a:gd name="adj" fmla="val 5208"/>
+            </a:avLst>
+          </a:prstGeom>
+          <a:solidFill>
+            <a:srgbClr val="0F1D40"/>
+          </a:solidFill>
+          <a:ln w="12700">
+            <a:solidFill>
+              <a:srgbClr val="2E4D8A"/>
+            </a:solidFill>
+            <a:prstDash val="solid"/>
+          </a:ln>
+        </p:spPr>
+      </p:sp>
+      <p:sp>
+        <p:nvSpPr>
+          <p:cNvPr id="47" name="Text 45"/>
+          <p:cNvSpPr/>
+          <p:nvPr/>
+        </p:nvSpPr>
+        <p:spPr>
+          <a:xfrm>
+            <a:off x="5522976" y="3639312"/>
+            <a:ext cx="1426464" cy="274320"/>
+          </a:xfrm>
+          <a:prstGeom prst="rect">
+            <a:avLst/>
+          </a:prstGeom>
+          <a:noFill/>
+          <a:ln/>
+        </p:spPr>
+        <p:txBody>
+          <a:bodyPr wrap="square" lIns="0" tIns="0" rIns="0" bIns="0" rtlCol="0" anchor="ctr"/>
+          <a:lstStyle/>
+          <a:p>
+            <a:pPr algn="ctr" indent="0" marL="0">
+              <a:buNone/>
+            </a:pPr>
+            <a:r>
+              <a:rPr lang="en-US" sz="850" b="1" dirty="0">
+                <a:solidFill>
+                  <a:srgbClr val="F59E0B"/>
+                </a:solidFill>
+                <a:latin typeface="Noto Sans KR" pitchFamily="34" charset="0"/>
+                <a:ea typeface="Noto Sans KR" pitchFamily="34" charset="-122"/>
+                <a:cs typeface="Noto Sans KR" pitchFamily="34" charset="-120"/>
+              </a:rPr>
+              <a:t>동축조명</a:t>
+            </a:r>
+            <a:endParaRPr lang="en-US" sz="850" dirty="0"/>
+          </a:p>
+        </p:txBody>
+      </p:sp>
+      <p:sp>
+        <p:nvSpPr>
+          <p:cNvPr id="48" name="Text 46"/>
+          <p:cNvSpPr/>
+          <p:nvPr/>
+        </p:nvSpPr>
+        <p:spPr>
+          <a:xfrm>
+            <a:off x="5522976" y="3913632"/>
+            <a:ext cx="1426464" cy="566928"/>
+          </a:xfrm>
+          <a:prstGeom prst="rect">
+            <a:avLst/>
+          </a:prstGeom>
+          <a:noFill/>
+          <a:ln/>
+        </p:spPr>
+        <p:txBody>
+          <a:bodyPr wrap="square" lIns="0" tIns="0" rIns="0" bIns="0" rtlCol="0" anchor="ctr"/>
+          <a:lstStyle/>
+          <a:p>
+            <a:pPr algn="ctr" indent="0" marL="0">
+              <a:lnSpc>
+                <a:spcPct val="125000"/>
+              </a:lnSpc>
+              <a:buNone/>
+            </a:pPr>
+            <a:r>
+              <a:rPr lang="en-US" sz="750" dirty="0">
+                <a:solidFill>
+                  <a:srgbClr val="A5C4F3"/>
+                </a:solidFill>
+                <a:latin typeface="Noto Sans KR" pitchFamily="34" charset="0"/>
+                <a:ea typeface="Noto Sans KR" pitchFamily="34" charset="-122"/>
+                <a:cs typeface="Noto Sans KR" pitchFamily="34" charset="-120"/>
+              </a:rPr>
+              <a:t>표면 스크래치</a:t>
+            </a:r>
+            <a:endParaRPr lang="en-US" sz="750" dirty="0"/>
+          </a:p>
+          <a:p>
+            <a:pPr algn="ctr" indent="0" marL="0">
+              <a:lnSpc>
+                <a:spcPct val="125000"/>
+              </a:lnSpc>
+              <a:buNone/>
+            </a:pPr>
+            <a:r>
+              <a:rPr lang="en-US" sz="750" dirty="0">
+                <a:solidFill>
+                  <a:srgbClr val="A5C4F3"/>
+                </a:solidFill>
+                <a:latin typeface="Noto Sans KR" pitchFamily="34" charset="0"/>
+                <a:ea typeface="Noto Sans KR" pitchFamily="34" charset="-122"/>
+                <a:cs typeface="Noto Sans KR" pitchFamily="34" charset="-120"/>
+              </a:rPr>
+              <a:t>광택 이상 검출</a:t>
+            </a:r>
+            <a:endParaRPr lang="en-US" sz="750" dirty="0"/>
+          </a:p>
+        </p:txBody>
+      </p:sp>
+      <p:sp>
+        <p:nvSpPr>
+          <p:cNvPr id="49" name="Shape 47"/>
+          <p:cNvSpPr/>
+          <p:nvPr/>
+        </p:nvSpPr>
+        <p:spPr>
+          <a:xfrm>
+            <a:off x="7059168" y="3639312"/>
+            <a:ext cx="1426464" cy="877824"/>
+          </a:xfrm>
+          <a:prstGeom prst="roundRect">
+            <a:avLst>
+              <a:gd name="adj" fmla="val 5208"/>
+            </a:avLst>
+          </a:prstGeom>
+          <a:solidFill>
+            <a:srgbClr val="0F1D40"/>
+          </a:solidFill>
+          <a:ln w="12700">
+            <a:solidFill>
+              <a:srgbClr val="2E4D8A"/>
+            </a:solidFill>
+            <a:prstDash val="solid"/>
+          </a:ln>
+        </p:spPr>
+      </p:sp>
+      <p:sp>
+        <p:nvSpPr>
+          <p:cNvPr id="50" name="Text 48"/>
+          <p:cNvSpPr/>
+          <p:nvPr/>
+        </p:nvSpPr>
+        <p:spPr>
+          <a:xfrm>
+            <a:off x="7059168" y="3639312"/>
+            <a:ext cx="1426464" cy="274320"/>
+          </a:xfrm>
+          <a:prstGeom prst="rect">
+            <a:avLst/>
+          </a:prstGeom>
+          <a:noFill/>
+          <a:ln/>
+        </p:spPr>
+        <p:txBody>
+          <a:bodyPr wrap="square" lIns="0" tIns="0" rIns="0" bIns="0" rtlCol="0" anchor="ctr"/>
+          <a:lstStyle/>
+          <a:p>
+            <a:pPr algn="ctr" indent="0" marL="0">
+              <a:buNone/>
+            </a:pPr>
+            <a:r>
+              <a:rPr lang="en-US" sz="850" b="1" dirty="0">
+                <a:solidFill>
+                  <a:srgbClr val="F59E0B"/>
+                </a:solidFill>
+                <a:latin typeface="Noto Sans KR" pitchFamily="34" charset="0"/>
+                <a:ea typeface="Noto Sans KR" pitchFamily="34" charset="-122"/>
+                <a:cs typeface="Noto Sans KR" pitchFamily="34" charset="-120"/>
+              </a:rPr>
+              <a:t>Low Angle</a:t>
+            </a:r>
+            <a:endParaRPr lang="en-US" sz="850" dirty="0"/>
+          </a:p>
+          <a:p>
+            <a:pPr algn="ctr" indent="0" marL="0">
+              <a:buNone/>
+            </a:pPr>
+            <a:r>
+              <a:rPr lang="en-US" sz="850" b="1" dirty="0">
+                <a:solidFill>
+                  <a:srgbClr val="F59E0B"/>
+                </a:solidFill>
+                <a:latin typeface="Noto Sans KR" pitchFamily="34" charset="0"/>
+                <a:ea typeface="Noto Sans KR" pitchFamily="34" charset="-122"/>
+                <a:cs typeface="Noto Sans KR" pitchFamily="34" charset="-120"/>
+              </a:rPr>
+              <a:t>Ring 조명</a:t>
+            </a:r>
+            <a:endParaRPr lang="en-US" sz="850" dirty="0"/>
+          </a:p>
+        </p:txBody>
+      </p:sp>
+      <p:sp>
+        <p:nvSpPr>
+          <p:cNvPr id="51" name="Text 49"/>
+          <p:cNvSpPr/>
+          <p:nvPr/>
+        </p:nvSpPr>
+        <p:spPr>
+          <a:xfrm>
+            <a:off x="7059168" y="3913632"/>
+            <a:ext cx="1426464" cy="566928"/>
+          </a:xfrm>
+          <a:prstGeom prst="rect">
+            <a:avLst/>
+          </a:prstGeom>
+          <a:noFill/>
+          <a:ln/>
+        </p:spPr>
+        <p:txBody>
+          <a:bodyPr wrap="square" lIns="0" tIns="0" rIns="0" bIns="0" rtlCol="0" anchor="ctr"/>
+          <a:lstStyle/>
+          <a:p>
+            <a:pPr algn="ctr" indent="0" marL="0">
+              <a:lnSpc>
+                <a:spcPct val="125000"/>
+              </a:lnSpc>
+              <a:buNone/>
+            </a:pPr>
+            <a:r>
+              <a:rPr lang="en-US" sz="750" dirty="0">
+                <a:solidFill>
+                  <a:srgbClr val="A5C4F3"/>
+                </a:solidFill>
+                <a:latin typeface="Noto Sans KR" pitchFamily="34" charset="0"/>
+                <a:ea typeface="Noto Sans KR" pitchFamily="34" charset="-122"/>
+                <a:cs typeface="Noto Sans KR" pitchFamily="34" charset="-120"/>
+              </a:rPr>
+              <a:t>표면 미세 흠집</a:t>
+            </a:r>
+            <a:endParaRPr lang="en-US" sz="750" dirty="0"/>
+          </a:p>
+          <a:p>
+            <a:pPr algn="ctr" indent="0" marL="0">
+              <a:lnSpc>
+                <a:spcPct val="125000"/>
+              </a:lnSpc>
+              <a:buNone/>
+            </a:pPr>
+            <a:r>
+              <a:rPr lang="en-US" sz="750" dirty="0">
+                <a:solidFill>
+                  <a:srgbClr val="A5C4F3"/>
+                </a:solidFill>
+                <a:latin typeface="Noto Sans KR" pitchFamily="34" charset="0"/>
+                <a:ea typeface="Noto Sans KR" pitchFamily="34" charset="-122"/>
+                <a:cs typeface="Noto Sans KR" pitchFamily="34" charset="-120"/>
+              </a:rPr>
+              <a:t>요철·질감 검출</a:t>
+            </a:r>
+            <a:endParaRPr lang="en-US" sz="750" dirty="0"/>
           </a:p>
         </p:txBody>
       </p:sp>

</xml_diff>

<commit_message>
Update winnercomb.pptx - slide8 overlap fix
</commit_message>
<xml_diff>
--- a/winnercomb.pptx
+++ b/winnercomb.pptx
@@ -15261,12 +15261,12 @@
         </p:nvSpPr>
         <p:spPr>
           <a:xfrm>
-            <a:off x="365760" y="1078992"/>
-            <a:ext cx="1594714" cy="1261872"/>
+            <a:off x="365760" y="1060704"/>
+            <a:ext cx="1594714" cy="1170432"/>
           </a:xfrm>
           <a:prstGeom prst="roundRect">
             <a:avLst>
-              <a:gd name="adj" fmla="val 5072"/>
+              <a:gd name="adj" fmla="val 5469"/>
             </a:avLst>
           </a:prstGeom>
           <a:solidFill>
@@ -15295,8 +15295,8 @@
         </p:nvSpPr>
         <p:spPr>
           <a:xfrm>
-            <a:off x="365760" y="1078992"/>
-            <a:ext cx="1594714" cy="146304"/>
+            <a:off x="365760" y="1060704"/>
+            <a:ext cx="1594714" cy="118872"/>
           </a:xfrm>
           <a:prstGeom prst="rect">
             <a:avLst/>
@@ -15320,8 +15320,8 @@
         </p:nvSpPr>
         <p:spPr>
           <a:xfrm>
-            <a:off x="925373" y="1243584"/>
-            <a:ext cx="475488" cy="475488"/>
+            <a:off x="943661" y="1216152"/>
+            <a:ext cx="438912" cy="438912"/>
           </a:xfrm>
           <a:prstGeom prst="ellipse">
             <a:avLst/>
@@ -15345,8 +15345,8 @@
         </p:nvSpPr>
         <p:spPr>
           <a:xfrm>
-            <a:off x="925373" y="1243584"/>
-            <a:ext cx="475488" cy="475488"/>
+            <a:off x="943661" y="1216152"/>
+            <a:ext cx="438912" cy="438912"/>
           </a:xfrm>
           <a:prstGeom prst="rect">
             <a:avLst/>
@@ -15362,7 +15362,7 @@
               <a:buNone/>
             </a:pPr>
             <a:r>
-              <a:rPr lang="en-US" sz="1600" dirty="0">
+              <a:rPr lang="en-US" sz="1500" dirty="0">
                 <a:solidFill>
                   <a:srgbClr val="000000"/>
                 </a:solidFill>
@@ -15372,7 +15372,7 @@
               </a:rPr>
               <a:t>🎯</a:t>
             </a:r>
-            <a:endParaRPr lang="en-US" sz="1600" dirty="0"/>
+            <a:endParaRPr lang="en-US" sz="1500" dirty="0"/>
           </a:p>
         </p:txBody>
       </p:sp>
@@ -15384,8 +15384,8 @@
         </p:nvSpPr>
         <p:spPr>
           <a:xfrm>
-            <a:off x="411480" y="1755648"/>
-            <a:ext cx="1503274" cy="347472"/>
+            <a:off x="411480" y="1700784"/>
+            <a:ext cx="1503274" cy="274320"/>
           </a:xfrm>
           <a:prstGeom prst="rect">
             <a:avLst/>
@@ -15404,7 +15404,7 @@
               <a:buNone/>
             </a:pPr>
             <a:r>
-              <a:rPr lang="en-US" sz="900" b="1" dirty="0">
+              <a:rPr lang="en-US" sz="850" b="1" dirty="0">
                 <a:solidFill>
                   <a:srgbClr val="1B2F5E"/>
                 </a:solidFill>
@@ -15414,7 +15414,7 @@
               </a:rPr>
               <a:t>딥러닝</a:t>
             </a:r>
-            <a:endParaRPr lang="en-US" sz="900" dirty="0"/>
+            <a:endParaRPr lang="en-US" sz="850" dirty="0"/>
           </a:p>
           <a:p>
             <a:pPr algn="ctr" indent="0" marL="0">
@@ -15424,7 +15424,7 @@
               <a:buNone/>
             </a:pPr>
             <a:r>
-              <a:rPr lang="en-US" sz="900" b="1" dirty="0">
+              <a:rPr lang="en-US" sz="850" b="1" dirty="0">
                 <a:solidFill>
                   <a:srgbClr val="1B2F5E"/>
                 </a:solidFill>
@@ -15434,7 +15434,7 @@
               </a:rPr>
               <a:t>자동학습</a:t>
             </a:r>
-            <a:endParaRPr lang="en-US" sz="900" dirty="0"/>
+            <a:endParaRPr lang="en-US" sz="850" dirty="0"/>
           </a:p>
         </p:txBody>
       </p:sp>
@@ -15446,7 +15446,7 @@
         </p:nvSpPr>
         <p:spPr>
           <a:xfrm>
-            <a:off x="475488" y="2084832"/>
+            <a:off x="475488" y="1993392"/>
             <a:ext cx="1375258" cy="0"/>
           </a:xfrm>
           <a:prstGeom prst="line">
@@ -15469,8 +15469,8 @@
         </p:nvSpPr>
         <p:spPr>
           <a:xfrm>
-            <a:off x="411480" y="2130552"/>
-            <a:ext cx="1503274" cy="347472"/>
+            <a:off x="411480" y="2039112"/>
+            <a:ext cx="1503274" cy="310896"/>
           </a:xfrm>
           <a:prstGeom prst="rect">
             <a:avLst/>
@@ -15489,7 +15489,7 @@
               <a:buNone/>
             </a:pPr>
             <a:r>
-              <a:rPr lang="en-US" sz="800" dirty="0">
+              <a:rPr lang="en-US" sz="750" dirty="0">
                 <a:solidFill>
                   <a:srgbClr val="475569"/>
                 </a:solidFill>
@@ -15499,7 +15499,7 @@
               </a:rPr>
               <a:t>데이터 누적</a:t>
             </a:r>
-            <a:endParaRPr lang="en-US" sz="800" dirty="0"/>
+            <a:endParaRPr lang="en-US" sz="750" dirty="0"/>
           </a:p>
           <a:p>
             <a:pPr algn="ctr" indent="0" marL="0">
@@ -15509,7 +15509,7 @@
               <a:buNone/>
             </a:pPr>
             <a:r>
-              <a:rPr lang="en-US" sz="800" dirty="0">
+              <a:rPr lang="en-US" sz="750" dirty="0">
                 <a:solidFill>
                   <a:srgbClr val="475569"/>
                 </a:solidFill>
@@ -15519,7 +15519,7 @@
               </a:rPr>
               <a:t>→ 정확도 지속 향상</a:t>
             </a:r>
-            <a:endParaRPr lang="en-US" sz="800" dirty="0"/>
+            <a:endParaRPr lang="en-US" sz="750" dirty="0"/>
           </a:p>
         </p:txBody>
       </p:sp>
@@ -15531,12 +15531,12 @@
         </p:nvSpPr>
         <p:spPr>
           <a:xfrm>
-            <a:off x="2070202" y="1078992"/>
-            <a:ext cx="1594714" cy="1261872"/>
+            <a:off x="2070202" y="1060704"/>
+            <a:ext cx="1594714" cy="1170432"/>
           </a:xfrm>
           <a:prstGeom prst="roundRect">
             <a:avLst>
-              <a:gd name="adj" fmla="val 5072"/>
+              <a:gd name="adj" fmla="val 5469"/>
             </a:avLst>
           </a:prstGeom>
           <a:solidFill>
@@ -15565,8 +15565,8 @@
         </p:nvSpPr>
         <p:spPr>
           <a:xfrm>
-            <a:off x="2070202" y="1078992"/>
-            <a:ext cx="1594714" cy="146304"/>
+            <a:off x="2070202" y="1060704"/>
+            <a:ext cx="1594714" cy="118872"/>
           </a:xfrm>
           <a:prstGeom prst="rect">
             <a:avLst/>
@@ -15590,8 +15590,8 @@
         </p:nvSpPr>
         <p:spPr>
           <a:xfrm>
-            <a:off x="2629814" y="1243584"/>
-            <a:ext cx="475488" cy="475488"/>
+            <a:off x="2648102" y="1216152"/>
+            <a:ext cx="438912" cy="438912"/>
           </a:xfrm>
           <a:prstGeom prst="ellipse">
             <a:avLst/>
@@ -15615,8 +15615,8 @@
         </p:nvSpPr>
         <p:spPr>
           <a:xfrm>
-            <a:off x="2629814" y="1243584"/>
-            <a:ext cx="475488" cy="475488"/>
+            <a:off x="2648102" y="1216152"/>
+            <a:ext cx="438912" cy="438912"/>
           </a:xfrm>
           <a:prstGeom prst="rect">
             <a:avLst/>
@@ -15632,7 +15632,7 @@
               <a:buNone/>
             </a:pPr>
             <a:r>
-              <a:rPr lang="en-US" sz="1600" dirty="0">
+              <a:rPr lang="en-US" sz="1500" dirty="0">
                 <a:solidFill>
                   <a:srgbClr val="000000"/>
                 </a:solidFill>
@@ -15642,7 +15642,7 @@
               </a:rPr>
               <a:t>⚖️</a:t>
             </a:r>
-            <a:endParaRPr lang="en-US" sz="1600" dirty="0"/>
+            <a:endParaRPr lang="en-US" sz="1500" dirty="0"/>
           </a:p>
         </p:txBody>
       </p:sp>
@@ -15654,8 +15654,8 @@
         </p:nvSpPr>
         <p:spPr>
           <a:xfrm>
-            <a:off x="2115922" y="1755648"/>
-            <a:ext cx="1503274" cy="347472"/>
+            <a:off x="2115922" y="1700784"/>
+            <a:ext cx="1503274" cy="274320"/>
           </a:xfrm>
           <a:prstGeom prst="rect">
             <a:avLst/>
@@ -15674,7 +15674,7 @@
               <a:buNone/>
             </a:pPr>
             <a:r>
-              <a:rPr lang="en-US" sz="900" b="1" dirty="0">
+              <a:rPr lang="en-US" sz="850" b="1" dirty="0">
                 <a:solidFill>
                   <a:srgbClr val="1B2F5E"/>
                 </a:solidFill>
@@ -15684,7 +15684,7 @@
               </a:rPr>
               <a:t>일관된</a:t>
             </a:r>
-            <a:endParaRPr lang="en-US" sz="900" dirty="0"/>
+            <a:endParaRPr lang="en-US" sz="850" dirty="0"/>
           </a:p>
           <a:p>
             <a:pPr algn="ctr" indent="0" marL="0">
@@ -15694,7 +15694,7 @@
               <a:buNone/>
             </a:pPr>
             <a:r>
-              <a:rPr lang="en-US" sz="900" b="1" dirty="0">
+              <a:rPr lang="en-US" sz="850" b="1" dirty="0">
                 <a:solidFill>
                   <a:srgbClr val="1B2F5E"/>
                 </a:solidFill>
@@ -15704,7 +15704,7 @@
               </a:rPr>
               <a:t>검사 기준</a:t>
             </a:r>
-            <a:endParaRPr lang="en-US" sz="900" dirty="0"/>
+            <a:endParaRPr lang="en-US" sz="850" dirty="0"/>
           </a:p>
         </p:txBody>
       </p:sp>
@@ -15716,7 +15716,7 @@
         </p:nvSpPr>
         <p:spPr>
           <a:xfrm>
-            <a:off x="2179930" y="2084832"/>
+            <a:off x="2179930" y="1993392"/>
             <a:ext cx="1375258" cy="0"/>
           </a:xfrm>
           <a:prstGeom prst="line">
@@ -15739,8 +15739,8 @@
         </p:nvSpPr>
         <p:spPr>
           <a:xfrm>
-            <a:off x="2115922" y="2130552"/>
-            <a:ext cx="1503274" cy="347472"/>
+            <a:off x="2115922" y="2039112"/>
+            <a:ext cx="1503274" cy="310896"/>
           </a:xfrm>
           <a:prstGeom prst="rect">
             <a:avLst/>
@@ -15759,7 +15759,7 @@
               <a:buNone/>
             </a:pPr>
             <a:r>
-              <a:rPr lang="en-US" sz="800" dirty="0">
+              <a:rPr lang="en-US" sz="750" dirty="0">
                 <a:solidFill>
                   <a:srgbClr val="475569"/>
                 </a:solidFill>
@@ -15769,7 +15769,7 @@
               </a:rPr>
               <a:t>컨디션 무관</a:t>
             </a:r>
-            <a:endParaRPr lang="en-US" sz="800" dirty="0"/>
+            <a:endParaRPr lang="en-US" sz="750" dirty="0"/>
           </a:p>
           <a:p>
             <a:pPr algn="ctr" indent="0" marL="0">
@@ -15779,7 +15779,7 @@
               <a:buNone/>
             </a:pPr>
             <a:r>
-              <a:rPr lang="en-US" sz="800" dirty="0">
+              <a:rPr lang="en-US" sz="750" dirty="0">
                 <a:solidFill>
                   <a:srgbClr val="475569"/>
                 </a:solidFill>
@@ -15789,7 +15789,7 @@
               </a:rPr>
               <a:t>동일 기준 판정</a:t>
             </a:r>
-            <a:endParaRPr lang="en-US" sz="800" dirty="0"/>
+            <a:endParaRPr lang="en-US" sz="750" dirty="0"/>
           </a:p>
         </p:txBody>
       </p:sp>
@@ -15801,12 +15801,12 @@
         </p:nvSpPr>
         <p:spPr>
           <a:xfrm>
-            <a:off x="3774643" y="1078992"/>
-            <a:ext cx="1594714" cy="1261872"/>
+            <a:off x="3774643" y="1060704"/>
+            <a:ext cx="1594714" cy="1170432"/>
           </a:xfrm>
           <a:prstGeom prst="roundRect">
             <a:avLst>
-              <a:gd name="adj" fmla="val 5072"/>
+              <a:gd name="adj" fmla="val 5469"/>
             </a:avLst>
           </a:prstGeom>
           <a:solidFill>
@@ -15835,8 +15835,8 @@
         </p:nvSpPr>
         <p:spPr>
           <a:xfrm>
-            <a:off x="3774643" y="1078992"/>
-            <a:ext cx="1594714" cy="146304"/>
+            <a:off x="3774643" y="1060704"/>
+            <a:ext cx="1594714" cy="118872"/>
           </a:xfrm>
           <a:prstGeom prst="rect">
             <a:avLst/>
@@ -15860,8 +15860,8 @@
         </p:nvSpPr>
         <p:spPr>
           <a:xfrm>
-            <a:off x="4334256" y="1243584"/>
-            <a:ext cx="475488" cy="475488"/>
+            <a:off x="4352544" y="1216152"/>
+            <a:ext cx="438912" cy="438912"/>
           </a:xfrm>
           <a:prstGeom prst="ellipse">
             <a:avLst/>
@@ -15885,8 +15885,8 @@
         </p:nvSpPr>
         <p:spPr>
           <a:xfrm>
-            <a:off x="4334256" y="1243584"/>
-            <a:ext cx="475488" cy="475488"/>
+            <a:off x="4352544" y="1216152"/>
+            <a:ext cx="438912" cy="438912"/>
           </a:xfrm>
           <a:prstGeom prst="rect">
             <a:avLst/>
@@ -15902,7 +15902,7 @@
               <a:buNone/>
             </a:pPr>
             <a:r>
-              <a:rPr lang="en-US" sz="1600" dirty="0">
+              <a:rPr lang="en-US" sz="1500" dirty="0">
                 <a:solidFill>
                   <a:srgbClr val="000000"/>
                 </a:solidFill>
@@ -15912,7 +15912,7 @@
               </a:rPr>
               <a:t>🚫</a:t>
             </a:r>
-            <a:endParaRPr lang="en-US" sz="1600" dirty="0"/>
+            <a:endParaRPr lang="en-US" sz="1500" dirty="0"/>
           </a:p>
         </p:txBody>
       </p:sp>
@@ -15924,8 +15924,8 @@
         </p:nvSpPr>
         <p:spPr>
           <a:xfrm>
-            <a:off x="3820363" y="1755648"/>
-            <a:ext cx="1503274" cy="347472"/>
+            <a:off x="3820363" y="1700784"/>
+            <a:ext cx="1503274" cy="274320"/>
           </a:xfrm>
           <a:prstGeom prst="rect">
             <a:avLst/>
@@ -15944,7 +15944,7 @@
               <a:buNone/>
             </a:pPr>
             <a:r>
-              <a:rPr lang="en-US" sz="900" b="1" dirty="0">
+              <a:rPr lang="en-US" sz="850" b="1" dirty="0">
                 <a:solidFill>
                   <a:srgbClr val="1B2F5E"/>
                 </a:solidFill>
@@ -15954,7 +15954,7 @@
               </a:rPr>
               <a:t>불량 혼입</a:t>
             </a:r>
-            <a:endParaRPr lang="en-US" sz="900" dirty="0"/>
+            <a:endParaRPr lang="en-US" sz="850" dirty="0"/>
           </a:p>
           <a:p>
             <a:pPr algn="ctr" indent="0" marL="0">
@@ -15964,7 +15964,7 @@
               <a:buNone/>
             </a:pPr>
             <a:r>
-              <a:rPr lang="en-US" sz="900" b="1" dirty="0">
+              <a:rPr lang="en-US" sz="850" b="1" dirty="0">
                 <a:solidFill>
                   <a:srgbClr val="1B2F5E"/>
                 </a:solidFill>
@@ -15974,7 +15974,7 @@
               </a:rPr>
               <a:t>원천 차단</a:t>
             </a:r>
-            <a:endParaRPr lang="en-US" sz="900" dirty="0"/>
+            <a:endParaRPr lang="en-US" sz="850" dirty="0"/>
           </a:p>
         </p:txBody>
       </p:sp>
@@ -15986,7 +15986,7 @@
         </p:nvSpPr>
         <p:spPr>
           <a:xfrm>
-            <a:off x="3884371" y="2084832"/>
+            <a:off x="3884371" y="1993392"/>
             <a:ext cx="1375258" cy="0"/>
           </a:xfrm>
           <a:prstGeom prst="line">
@@ -16009,8 +16009,8 @@
         </p:nvSpPr>
         <p:spPr>
           <a:xfrm>
-            <a:off x="3820363" y="2130552"/>
-            <a:ext cx="1503274" cy="347472"/>
+            <a:off x="3820363" y="2039112"/>
+            <a:ext cx="1503274" cy="310896"/>
           </a:xfrm>
           <a:prstGeom prst="rect">
             <a:avLst/>
@@ -16029,7 +16029,7 @@
               <a:buNone/>
             </a:pPr>
             <a:r>
-              <a:rPr lang="en-US" sz="800" dirty="0">
+              <a:rPr lang="en-US" sz="750" dirty="0">
                 <a:solidFill>
                   <a:srgbClr val="475569"/>
                 </a:solidFill>
@@ -16039,7 +16039,7 @@
               </a:rPr>
               <a:t>자동 분리 배출</a:t>
             </a:r>
-            <a:endParaRPr lang="en-US" sz="800" dirty="0"/>
+            <a:endParaRPr lang="en-US" sz="750" dirty="0"/>
           </a:p>
           <a:p>
             <a:pPr algn="ctr" indent="0" marL="0">
@@ -16049,7 +16049,7 @@
               <a:buNone/>
             </a:pPr>
             <a:r>
-              <a:rPr lang="en-US" sz="800" dirty="0">
+              <a:rPr lang="en-US" sz="750" dirty="0">
                 <a:solidFill>
                   <a:srgbClr val="475569"/>
                 </a:solidFill>
@@ -16059,7 +16059,7 @@
               </a:rPr>
               <a:t>재검사 불필요</a:t>
             </a:r>
-            <a:endParaRPr lang="en-US" sz="800" dirty="0"/>
+            <a:endParaRPr lang="en-US" sz="750" dirty="0"/>
           </a:p>
         </p:txBody>
       </p:sp>
@@ -16071,12 +16071,12 @@
         </p:nvSpPr>
         <p:spPr>
           <a:xfrm>
-            <a:off x="5479085" y="1078992"/>
-            <a:ext cx="1594714" cy="1261872"/>
+            <a:off x="5479085" y="1060704"/>
+            <a:ext cx="1594714" cy="1170432"/>
           </a:xfrm>
           <a:prstGeom prst="roundRect">
             <a:avLst>
-              <a:gd name="adj" fmla="val 5072"/>
+              <a:gd name="adj" fmla="val 5469"/>
             </a:avLst>
           </a:prstGeom>
           <a:solidFill>
@@ -16105,8 +16105,8 @@
         </p:nvSpPr>
         <p:spPr>
           <a:xfrm>
-            <a:off x="5479085" y="1078992"/>
-            <a:ext cx="1594714" cy="146304"/>
+            <a:off x="5479085" y="1060704"/>
+            <a:ext cx="1594714" cy="118872"/>
           </a:xfrm>
           <a:prstGeom prst="rect">
             <a:avLst/>
@@ -16130,8 +16130,8 @@
         </p:nvSpPr>
         <p:spPr>
           <a:xfrm>
-            <a:off x="6038698" y="1243584"/>
-            <a:ext cx="475488" cy="475488"/>
+            <a:off x="6056986" y="1216152"/>
+            <a:ext cx="438912" cy="438912"/>
           </a:xfrm>
           <a:prstGeom prst="ellipse">
             <a:avLst/>
@@ -16155,8 +16155,8 @@
         </p:nvSpPr>
         <p:spPr>
           <a:xfrm>
-            <a:off x="6038698" y="1243584"/>
-            <a:ext cx="475488" cy="475488"/>
+            <a:off x="6056986" y="1216152"/>
+            <a:ext cx="438912" cy="438912"/>
           </a:xfrm>
           <a:prstGeom prst="rect">
             <a:avLst/>
@@ -16172,7 +16172,7 @@
               <a:buNone/>
             </a:pPr>
             <a:r>
-              <a:rPr lang="en-US" sz="1600" dirty="0">
+              <a:rPr lang="en-US" sz="1500" dirty="0">
                 <a:solidFill>
                   <a:srgbClr val="000000"/>
                 </a:solidFill>
@@ -16182,7 +16182,7 @@
               </a:rPr>
               <a:t>📈</a:t>
             </a:r>
-            <a:endParaRPr lang="en-US" sz="1600" dirty="0"/>
+            <a:endParaRPr lang="en-US" sz="1500" dirty="0"/>
           </a:p>
         </p:txBody>
       </p:sp>
@@ -16194,8 +16194,8 @@
         </p:nvSpPr>
         <p:spPr>
           <a:xfrm>
-            <a:off x="5524805" y="1755648"/>
-            <a:ext cx="1503274" cy="347472"/>
+            <a:off x="5524805" y="1700784"/>
+            <a:ext cx="1503274" cy="274320"/>
           </a:xfrm>
           <a:prstGeom prst="rect">
             <a:avLst/>
@@ -16214,7 +16214,7 @@
               <a:buNone/>
             </a:pPr>
             <a:r>
-              <a:rPr lang="en-US" sz="900" b="1" dirty="0">
+              <a:rPr lang="en-US" sz="850" b="1" dirty="0">
                 <a:solidFill>
                   <a:srgbClr val="1B2F5E"/>
                 </a:solidFill>
@@ -16224,7 +16224,7 @@
               </a:rPr>
               <a:t>품질 데이터</a:t>
             </a:r>
-            <a:endParaRPr lang="en-US" sz="900" dirty="0"/>
+            <a:endParaRPr lang="en-US" sz="850" dirty="0"/>
           </a:p>
           <a:p>
             <a:pPr algn="ctr" indent="0" marL="0">
@@ -16234,7 +16234,7 @@
               <a:buNone/>
             </a:pPr>
             <a:r>
-              <a:rPr lang="en-US" sz="900" b="1" dirty="0">
+              <a:rPr lang="en-US" sz="850" b="1" dirty="0">
                 <a:solidFill>
                   <a:srgbClr val="1B2F5E"/>
                 </a:solidFill>
@@ -16244,7 +16244,7 @@
               </a:rPr>
               <a:t>자산화</a:t>
             </a:r>
-            <a:endParaRPr lang="en-US" sz="900" dirty="0"/>
+            <a:endParaRPr lang="en-US" sz="850" dirty="0"/>
           </a:p>
         </p:txBody>
       </p:sp>
@@ -16256,7 +16256,7 @@
         </p:nvSpPr>
         <p:spPr>
           <a:xfrm>
-            <a:off x="5588813" y="2084832"/>
+            <a:off x="5588813" y="1993392"/>
             <a:ext cx="1375258" cy="0"/>
           </a:xfrm>
           <a:prstGeom prst="line">
@@ -16279,8 +16279,8 @@
         </p:nvSpPr>
         <p:spPr>
           <a:xfrm>
-            <a:off x="5524805" y="2130552"/>
-            <a:ext cx="1503274" cy="347472"/>
+            <a:off x="5524805" y="2039112"/>
+            <a:ext cx="1503274" cy="310896"/>
           </a:xfrm>
           <a:prstGeom prst="rect">
             <a:avLst/>
@@ -16299,7 +16299,7 @@
               <a:buNone/>
             </a:pPr>
             <a:r>
-              <a:rPr lang="en-US" sz="800" dirty="0">
+              <a:rPr lang="en-US" sz="750" dirty="0">
                 <a:solidFill>
                   <a:srgbClr val="475569"/>
                 </a:solidFill>
@@ -16309,7 +16309,7 @@
               </a:rPr>
               <a:t>통계·트렌드</a:t>
             </a:r>
-            <a:endParaRPr lang="en-US" sz="800" dirty="0"/>
+            <a:endParaRPr lang="en-US" sz="750" dirty="0"/>
           </a:p>
           <a:p>
             <a:pPr algn="ctr" indent="0" marL="0">
@@ -16319,7 +16319,7 @@
               <a:buNone/>
             </a:pPr>
             <a:r>
-              <a:rPr lang="en-US" sz="800" dirty="0">
+              <a:rPr lang="en-US" sz="750" dirty="0">
                 <a:solidFill>
                   <a:srgbClr val="475569"/>
                 </a:solidFill>
@@ -16329,7 +16329,7 @@
               </a:rPr>
               <a:t>리포트 자동 생성</a:t>
             </a:r>
-            <a:endParaRPr lang="en-US" sz="800" dirty="0"/>
+            <a:endParaRPr lang="en-US" sz="750" dirty="0"/>
           </a:p>
         </p:txBody>
       </p:sp>
@@ -16341,12 +16341,12 @@
         </p:nvSpPr>
         <p:spPr>
           <a:xfrm>
-            <a:off x="7183526" y="1078992"/>
-            <a:ext cx="1594714" cy="1261872"/>
+            <a:off x="7183526" y="1060704"/>
+            <a:ext cx="1594714" cy="1170432"/>
           </a:xfrm>
           <a:prstGeom prst="roundRect">
             <a:avLst>
-              <a:gd name="adj" fmla="val 5072"/>
+              <a:gd name="adj" fmla="val 5469"/>
             </a:avLst>
           </a:prstGeom>
           <a:solidFill>
@@ -16375,8 +16375,8 @@
         </p:nvSpPr>
         <p:spPr>
           <a:xfrm>
-            <a:off x="7183526" y="1078992"/>
-            <a:ext cx="1594714" cy="146304"/>
+            <a:off x="7183526" y="1060704"/>
+            <a:ext cx="1594714" cy="118872"/>
           </a:xfrm>
           <a:prstGeom prst="rect">
             <a:avLst/>
@@ -16400,8 +16400,8 @@
         </p:nvSpPr>
         <p:spPr>
           <a:xfrm>
-            <a:off x="7743139" y="1243584"/>
-            <a:ext cx="475488" cy="475488"/>
+            <a:off x="7761427" y="1216152"/>
+            <a:ext cx="438912" cy="438912"/>
           </a:xfrm>
           <a:prstGeom prst="ellipse">
             <a:avLst/>
@@ -16425,8 +16425,8 @@
         </p:nvSpPr>
         <p:spPr>
           <a:xfrm>
-            <a:off x="7743139" y="1243584"/>
-            <a:ext cx="475488" cy="475488"/>
+            <a:off x="7761427" y="1216152"/>
+            <a:ext cx="438912" cy="438912"/>
           </a:xfrm>
           <a:prstGeom prst="rect">
             <a:avLst/>
@@ -16442,7 +16442,7 @@
               <a:buNone/>
             </a:pPr>
             <a:r>
-              <a:rPr lang="en-US" sz="1600" dirty="0">
+              <a:rPr lang="en-US" sz="1500" dirty="0">
                 <a:solidFill>
                   <a:srgbClr val="000000"/>
                 </a:solidFill>
@@ -16452,7 +16452,7 @@
               </a:rPr>
               <a:t>👤</a:t>
             </a:r>
-            <a:endParaRPr lang="en-US" sz="1600" dirty="0"/>
+            <a:endParaRPr lang="en-US" sz="1500" dirty="0"/>
           </a:p>
         </p:txBody>
       </p:sp>
@@ -16464,8 +16464,8 @@
         </p:nvSpPr>
         <p:spPr>
           <a:xfrm>
-            <a:off x="7229246" y="1755648"/>
-            <a:ext cx="1503274" cy="347472"/>
+            <a:off x="7229246" y="1700784"/>
+            <a:ext cx="1503274" cy="274320"/>
           </a:xfrm>
           <a:prstGeom prst="rect">
             <a:avLst/>
@@ -16484,7 +16484,7 @@
               <a:buNone/>
             </a:pPr>
             <a:r>
-              <a:rPr lang="en-US" sz="900" b="1" dirty="0">
+              <a:rPr lang="en-US" sz="850" b="1" dirty="0">
                 <a:solidFill>
                   <a:srgbClr val="1B2F5E"/>
                 </a:solidFill>
@@ -16494,7 +16494,7 @@
               </a:rPr>
               <a:t>별도 인력</a:t>
             </a:r>
-            <a:endParaRPr lang="en-US" sz="900" dirty="0"/>
+            <a:endParaRPr lang="en-US" sz="850" dirty="0"/>
           </a:p>
           <a:p>
             <a:pPr algn="ctr" indent="0" marL="0">
@@ -16504,7 +16504,7 @@
               <a:buNone/>
             </a:pPr>
             <a:r>
-              <a:rPr lang="en-US" sz="900" b="1" dirty="0">
+              <a:rPr lang="en-US" sz="850" b="1" dirty="0">
                 <a:solidFill>
                   <a:srgbClr val="1B2F5E"/>
                 </a:solidFill>
@@ -16514,7 +16514,7 @@
               </a:rPr>
               <a:t>불필요</a:t>
             </a:r>
-            <a:endParaRPr lang="en-US" sz="900" dirty="0"/>
+            <a:endParaRPr lang="en-US" sz="850" dirty="0"/>
           </a:p>
         </p:txBody>
       </p:sp>
@@ -16526,7 +16526,7 @@
         </p:nvSpPr>
         <p:spPr>
           <a:xfrm>
-            <a:off x="7293254" y="2084832"/>
+            <a:off x="7293254" y="1993392"/>
             <a:ext cx="1375258" cy="0"/>
           </a:xfrm>
           <a:prstGeom prst="line">
@@ -16549,8 +16549,8 @@
         </p:nvSpPr>
         <p:spPr>
           <a:xfrm>
-            <a:off x="7229246" y="2130552"/>
-            <a:ext cx="1503274" cy="347472"/>
+            <a:off x="7229246" y="2039112"/>
+            <a:ext cx="1503274" cy="310896"/>
           </a:xfrm>
           <a:prstGeom prst="rect">
             <a:avLst/>
@@ -16569,7 +16569,7 @@
               <a:buNone/>
             </a:pPr>
             <a:r>
-              <a:rPr lang="en-US" sz="800" dirty="0">
+              <a:rPr lang="en-US" sz="750" dirty="0">
                 <a:solidFill>
                   <a:srgbClr val="475569"/>
                 </a:solidFill>
@@ -16579,7 +16579,7 @@
               </a:rPr>
               <a:t>전 과정 자동</a:t>
             </a:r>
-            <a:endParaRPr lang="en-US" sz="800" dirty="0"/>
+            <a:endParaRPr lang="en-US" sz="750" dirty="0"/>
           </a:p>
           <a:p>
             <a:pPr algn="ctr" indent="0" marL="0">
@@ -16589,7 +16589,7 @@
               <a:buNone/>
             </a:pPr>
             <a:r>
-              <a:rPr lang="en-US" sz="800" dirty="0">
+              <a:rPr lang="en-US" sz="750" dirty="0">
                 <a:solidFill>
                   <a:srgbClr val="475569"/>
                 </a:solidFill>
@@ -16599,7 +16599,7 @@
               </a:rPr>
               <a:t>인력 재배치 가능</a:t>
             </a:r>
-            <a:endParaRPr lang="en-US" sz="800" dirty="0"/>
+            <a:endParaRPr lang="en-US" sz="750" dirty="0"/>
           </a:p>
         </p:txBody>
       </p:sp>
@@ -16611,12 +16611,12 @@
         </p:nvSpPr>
         <p:spPr>
           <a:xfrm>
-            <a:off x="365760" y="2432304"/>
-            <a:ext cx="2743200" cy="2176272"/>
+            <a:off x="365760" y="2377440"/>
+            <a:ext cx="2743200" cy="2692908"/>
           </a:xfrm>
           <a:prstGeom prst="roundRect">
             <a:avLst>
-              <a:gd name="adj" fmla="val 2941"/>
+              <a:gd name="adj" fmla="val 2377"/>
             </a:avLst>
           </a:prstGeom>
           <a:solidFill>
@@ -16645,12 +16645,12 @@
         </p:nvSpPr>
         <p:spPr>
           <a:xfrm>
-            <a:off x="365760" y="2432304"/>
-            <a:ext cx="2743200" cy="329184"/>
+            <a:off x="365760" y="2377440"/>
+            <a:ext cx="2743200" cy="310896"/>
           </a:xfrm>
           <a:prstGeom prst="roundRect">
             <a:avLst>
-              <a:gd name="adj" fmla="val 19444"/>
+              <a:gd name="adj" fmla="val 20588"/>
             </a:avLst>
           </a:prstGeom>
           <a:solidFill>
@@ -16672,8 +16672,8 @@
         </p:nvSpPr>
         <p:spPr>
           <a:xfrm>
-            <a:off x="365760" y="2432304"/>
-            <a:ext cx="2743200" cy="329184"/>
+            <a:off x="365760" y="2377440"/>
+            <a:ext cx="2743200" cy="310896"/>
           </a:xfrm>
           <a:prstGeom prst="rect">
             <a:avLst/>
@@ -16689,7 +16689,7 @@
               <a:buNone/>
             </a:pPr>
             <a:r>
-              <a:rPr lang="en-US" sz="1200" b="1" dirty="0">
+              <a:rPr lang="en-US" sz="1150" b="1" dirty="0">
                 <a:solidFill>
                   <a:srgbClr val="FFFFFF"/>
                 </a:solidFill>
@@ -16699,7 +16699,7 @@
               </a:rPr>
               <a:t>품질</a:t>
             </a:r>
-            <a:endParaRPr lang="en-US" sz="1200" dirty="0"/>
+            <a:endParaRPr lang="en-US" sz="1150" dirty="0"/>
           </a:p>
         </p:txBody>
       </p:sp>
@@ -16711,12 +16711,12 @@
         </p:nvSpPr>
         <p:spPr>
           <a:xfrm>
-            <a:off x="457200" y="2834640"/>
-            <a:ext cx="2560320" cy="493776"/>
+            <a:off x="457200" y="2761488"/>
+            <a:ext cx="2560320" cy="763524"/>
           </a:xfrm>
           <a:prstGeom prst="roundRect">
             <a:avLst>
-              <a:gd name="adj" fmla="val 12963"/>
+              <a:gd name="adj" fmla="val 8383"/>
             </a:avLst>
           </a:prstGeom>
           <a:solidFill>
@@ -16745,8 +16745,8 @@
         </p:nvSpPr>
         <p:spPr>
           <a:xfrm>
-            <a:off x="530352" y="2880360"/>
-            <a:ext cx="2414016" cy="402336"/>
+            <a:off x="530352" y="2816352"/>
+            <a:ext cx="2414016" cy="672084"/>
           </a:xfrm>
           <a:prstGeom prst="rect">
             <a:avLst/>
@@ -16787,12 +16787,12 @@
         </p:nvSpPr>
         <p:spPr>
           <a:xfrm>
-            <a:off x="457200" y="3401568"/>
-            <a:ext cx="2560320" cy="493776"/>
+            <a:off x="457200" y="3579876"/>
+            <a:ext cx="2560320" cy="763524"/>
           </a:xfrm>
           <a:prstGeom prst="roundRect">
             <a:avLst>
-              <a:gd name="adj" fmla="val 12963"/>
+              <a:gd name="adj" fmla="val 8383"/>
             </a:avLst>
           </a:prstGeom>
           <a:solidFill>
@@ -16821,8 +16821,8 @@
         </p:nvSpPr>
         <p:spPr>
           <a:xfrm>
-            <a:off x="530352" y="3447288"/>
-            <a:ext cx="2414016" cy="402336"/>
+            <a:off x="530352" y="3634740"/>
+            <a:ext cx="2414016" cy="672084"/>
           </a:xfrm>
           <a:prstGeom prst="rect">
             <a:avLst/>
@@ -16863,12 +16863,12 @@
         </p:nvSpPr>
         <p:spPr>
           <a:xfrm>
-            <a:off x="457200" y="3968496"/>
-            <a:ext cx="2560320" cy="493776"/>
+            <a:off x="457200" y="4398264"/>
+            <a:ext cx="2560320" cy="763524"/>
           </a:xfrm>
           <a:prstGeom prst="roundRect">
             <a:avLst>
-              <a:gd name="adj" fmla="val 12963"/>
+              <a:gd name="adj" fmla="val 8383"/>
             </a:avLst>
           </a:prstGeom>
           <a:solidFill>
@@ -16897,8 +16897,8 @@
         </p:nvSpPr>
         <p:spPr>
           <a:xfrm>
-            <a:off x="530352" y="4014216"/>
-            <a:ext cx="2414016" cy="402336"/>
+            <a:off x="530352" y="4453128"/>
+            <a:ext cx="2414016" cy="672084"/>
           </a:xfrm>
           <a:prstGeom prst="rect">
             <a:avLst/>
@@ -16939,12 +16939,12 @@
         </p:nvSpPr>
         <p:spPr>
           <a:xfrm>
-            <a:off x="3200400" y="2432304"/>
-            <a:ext cx="2743200" cy="2176272"/>
+            <a:off x="3200400" y="2377440"/>
+            <a:ext cx="2743200" cy="2692908"/>
           </a:xfrm>
           <a:prstGeom prst="roundRect">
             <a:avLst>
-              <a:gd name="adj" fmla="val 2941"/>
+              <a:gd name="adj" fmla="val 2377"/>
             </a:avLst>
           </a:prstGeom>
           <a:solidFill>
@@ -16973,12 +16973,12 @@
         </p:nvSpPr>
         <p:spPr>
           <a:xfrm>
-            <a:off x="3200400" y="2432304"/>
-            <a:ext cx="2743200" cy="329184"/>
+            <a:off x="3200400" y="2377440"/>
+            <a:ext cx="2743200" cy="310896"/>
           </a:xfrm>
           <a:prstGeom prst="roundRect">
             <a:avLst>
-              <a:gd name="adj" fmla="val 19444"/>
+              <a:gd name="adj" fmla="val 20588"/>
             </a:avLst>
           </a:prstGeom>
           <a:solidFill>
@@ -17000,8 +17000,8 @@
         </p:nvSpPr>
         <p:spPr>
           <a:xfrm>
-            <a:off x="3200400" y="2432304"/>
-            <a:ext cx="2743200" cy="329184"/>
+            <a:off x="3200400" y="2377440"/>
+            <a:ext cx="2743200" cy="310896"/>
           </a:xfrm>
           <a:prstGeom prst="rect">
             <a:avLst/>
@@ -17017,7 +17017,7 @@
               <a:buNone/>
             </a:pPr>
             <a:r>
-              <a:rPr lang="en-US" sz="1200" b="1" dirty="0">
+              <a:rPr lang="en-US" sz="1150" b="1" dirty="0">
                 <a:solidFill>
                   <a:srgbClr val="FFFFFF"/>
                 </a:solidFill>
@@ -17027,7 +17027,7 @@
               </a:rPr>
               <a:t>운영</a:t>
             </a:r>
-            <a:endParaRPr lang="en-US" sz="1200" dirty="0"/>
+            <a:endParaRPr lang="en-US" sz="1150" dirty="0"/>
           </a:p>
         </p:txBody>
       </p:sp>
@@ -17039,12 +17039,12 @@
         </p:nvSpPr>
         <p:spPr>
           <a:xfrm>
-            <a:off x="3291840" y="2834640"/>
-            <a:ext cx="2560320" cy="493776"/>
+            <a:off x="3291840" y="2761488"/>
+            <a:ext cx="2560320" cy="763524"/>
           </a:xfrm>
           <a:prstGeom prst="roundRect">
             <a:avLst>
-              <a:gd name="adj" fmla="val 12963"/>
+              <a:gd name="adj" fmla="val 8383"/>
             </a:avLst>
           </a:prstGeom>
           <a:solidFill>
@@ -17073,8 +17073,8 @@
         </p:nvSpPr>
         <p:spPr>
           <a:xfrm>
-            <a:off x="3364992" y="2880360"/>
-            <a:ext cx="2414016" cy="402336"/>
+            <a:off x="3364992" y="2816352"/>
+            <a:ext cx="2414016" cy="672084"/>
           </a:xfrm>
           <a:prstGeom prst="rect">
             <a:avLst/>
@@ -17115,12 +17115,12 @@
         </p:nvSpPr>
         <p:spPr>
           <a:xfrm>
-            <a:off x="3291840" y="3401568"/>
-            <a:ext cx="2560320" cy="493776"/>
+            <a:off x="3291840" y="3579876"/>
+            <a:ext cx="2560320" cy="763524"/>
           </a:xfrm>
           <a:prstGeom prst="roundRect">
             <a:avLst>
-              <a:gd name="adj" fmla="val 12963"/>
+              <a:gd name="adj" fmla="val 8383"/>
             </a:avLst>
           </a:prstGeom>
           <a:solidFill>
@@ -17149,8 +17149,8 @@
         </p:nvSpPr>
         <p:spPr>
           <a:xfrm>
-            <a:off x="3364992" y="3447288"/>
-            <a:ext cx="2414016" cy="402336"/>
+            <a:off x="3364992" y="3634740"/>
+            <a:ext cx="2414016" cy="672084"/>
           </a:xfrm>
           <a:prstGeom prst="rect">
             <a:avLst/>
@@ -17191,12 +17191,12 @@
         </p:nvSpPr>
         <p:spPr>
           <a:xfrm>
-            <a:off x="3291840" y="3968496"/>
-            <a:ext cx="2560320" cy="493776"/>
+            <a:off x="3291840" y="4398264"/>
+            <a:ext cx="2560320" cy="763524"/>
           </a:xfrm>
           <a:prstGeom prst="roundRect">
             <a:avLst>
-              <a:gd name="adj" fmla="val 12963"/>
+              <a:gd name="adj" fmla="val 8383"/>
             </a:avLst>
           </a:prstGeom>
           <a:solidFill>
@@ -17225,8 +17225,8 @@
         </p:nvSpPr>
         <p:spPr>
           <a:xfrm>
-            <a:off x="3364992" y="4014216"/>
-            <a:ext cx="2414016" cy="402336"/>
+            <a:off x="3364992" y="4453128"/>
+            <a:ext cx="2414016" cy="672084"/>
           </a:xfrm>
           <a:prstGeom prst="rect">
             <a:avLst/>
@@ -17267,12 +17267,12 @@
         </p:nvSpPr>
         <p:spPr>
           <a:xfrm>
-            <a:off x="6035040" y="2432304"/>
-            <a:ext cx="2743200" cy="2176272"/>
+            <a:off x="6035040" y="2377440"/>
+            <a:ext cx="2743200" cy="2692908"/>
           </a:xfrm>
           <a:prstGeom prst="roundRect">
             <a:avLst>
-              <a:gd name="adj" fmla="val 2941"/>
+              <a:gd name="adj" fmla="val 2377"/>
             </a:avLst>
           </a:prstGeom>
           <a:solidFill>
@@ -17301,12 +17301,12 @@
         </p:nvSpPr>
         <p:spPr>
           <a:xfrm>
-            <a:off x="6035040" y="2432304"/>
-            <a:ext cx="2743200" cy="329184"/>
+            <a:off x="6035040" y="2377440"/>
+            <a:ext cx="2743200" cy="310896"/>
           </a:xfrm>
           <a:prstGeom prst="roundRect">
             <a:avLst>
-              <a:gd name="adj" fmla="val 19444"/>
+              <a:gd name="adj" fmla="val 20588"/>
             </a:avLst>
           </a:prstGeom>
           <a:solidFill>
@@ -17328,8 +17328,8 @@
         </p:nvSpPr>
         <p:spPr>
           <a:xfrm>
-            <a:off x="6035040" y="2432304"/>
-            <a:ext cx="2743200" cy="329184"/>
+            <a:off x="6035040" y="2377440"/>
+            <a:ext cx="2743200" cy="310896"/>
           </a:xfrm>
           <a:prstGeom prst="rect">
             <a:avLst/>
@@ -17345,7 +17345,7 @@
               <a:buNone/>
             </a:pPr>
             <a:r>
-              <a:rPr lang="en-US" sz="1200" b="1" dirty="0">
+              <a:rPr lang="en-US" sz="1150" b="1" dirty="0">
                 <a:solidFill>
                   <a:srgbClr val="FFFFFF"/>
                 </a:solidFill>
@@ -17355,7 +17355,7 @@
               </a:rPr>
               <a:t>경쟁력</a:t>
             </a:r>
-            <a:endParaRPr lang="en-US" sz="1200" dirty="0"/>
+            <a:endParaRPr lang="en-US" sz="1150" dirty="0"/>
           </a:p>
         </p:txBody>
       </p:sp>
@@ -17367,12 +17367,12 @@
         </p:nvSpPr>
         <p:spPr>
           <a:xfrm>
-            <a:off x="6126480" y="2834640"/>
-            <a:ext cx="2560320" cy="493776"/>
+            <a:off x="6126480" y="2761488"/>
+            <a:ext cx="2560320" cy="763524"/>
           </a:xfrm>
           <a:prstGeom prst="roundRect">
             <a:avLst>
-              <a:gd name="adj" fmla="val 12963"/>
+              <a:gd name="adj" fmla="val 8383"/>
             </a:avLst>
           </a:prstGeom>
           <a:solidFill>
@@ -17401,8 +17401,8 @@
         </p:nvSpPr>
         <p:spPr>
           <a:xfrm>
-            <a:off x="6199632" y="2880360"/>
-            <a:ext cx="2414016" cy="402336"/>
+            <a:off x="6199632" y="2816352"/>
+            <a:ext cx="2414016" cy="672084"/>
           </a:xfrm>
           <a:prstGeom prst="rect">
             <a:avLst/>
@@ -17443,12 +17443,12 @@
         </p:nvSpPr>
         <p:spPr>
           <a:xfrm>
-            <a:off x="6126480" y="3401568"/>
-            <a:ext cx="2560320" cy="493776"/>
+            <a:off x="6126480" y="3579876"/>
+            <a:ext cx="2560320" cy="763524"/>
           </a:xfrm>
           <a:prstGeom prst="roundRect">
             <a:avLst>
-              <a:gd name="adj" fmla="val 12963"/>
+              <a:gd name="adj" fmla="val 8383"/>
             </a:avLst>
           </a:prstGeom>
           <a:solidFill>
@@ -17477,8 +17477,8 @@
         </p:nvSpPr>
         <p:spPr>
           <a:xfrm>
-            <a:off x="6199632" y="3447288"/>
-            <a:ext cx="2414016" cy="402336"/>
+            <a:off x="6199632" y="3634740"/>
+            <a:ext cx="2414016" cy="672084"/>
           </a:xfrm>
           <a:prstGeom prst="rect">
             <a:avLst/>
@@ -17519,12 +17519,12 @@
         </p:nvSpPr>
         <p:spPr>
           <a:xfrm>
-            <a:off x="6126480" y="3968496"/>
-            <a:ext cx="2560320" cy="493776"/>
+            <a:off x="6126480" y="4398264"/>
+            <a:ext cx="2560320" cy="763524"/>
           </a:xfrm>
           <a:prstGeom prst="roundRect">
             <a:avLst>
-              <a:gd name="adj" fmla="val 12963"/>
+              <a:gd name="adj" fmla="val 8383"/>
             </a:avLst>
           </a:prstGeom>
           <a:solidFill>
@@ -17553,8 +17553,8 @@
         </p:nvSpPr>
         <p:spPr>
           <a:xfrm>
-            <a:off x="6199632" y="4014216"/>
-            <a:ext cx="2414016" cy="402336"/>
+            <a:off x="6199632" y="4453128"/>
+            <a:ext cx="2414016" cy="672084"/>
           </a:xfrm>
           <a:prstGeom prst="rect">
             <a:avLst/>

</xml_diff>

<commit_message>
Update winnercomb.pptx - slide7 MES overlap fix
</commit_message>
<xml_diff>
--- a/winnercomb.pptx
+++ b/winnercomb.pptx
@@ -13255,7 +13255,7 @@
         <p:spPr>
           <a:xfrm>
             <a:off x="365760" y="1078992"/>
-            <a:ext cx="2578608" cy="676656"/>
+            <a:ext cx="2377440" cy="676656"/>
           </a:xfrm>
           <a:prstGeom prst="roundRect">
             <a:avLst>
@@ -13353,7 +13353,7 @@
         <p:spPr>
           <a:xfrm>
             <a:off x="475488" y="1133856"/>
-            <a:ext cx="2377440" cy="237744"/>
+            <a:ext cx="2176272" cy="237744"/>
           </a:xfrm>
           <a:prstGeom prst="rect">
             <a:avLst/>
@@ -13392,7 +13392,7 @@
         <p:spPr>
           <a:xfrm>
             <a:off x="475488" y="1408176"/>
-            <a:ext cx="2377440" cy="310896"/>
+            <a:ext cx="2176272" cy="310896"/>
           </a:xfrm>
           <a:prstGeom prst="rect">
             <a:avLst/>
@@ -13453,8 +13453,8 @@
         </p:nvSpPr>
         <p:spPr>
           <a:xfrm>
-            <a:off x="3090672" y="1078992"/>
-            <a:ext cx="2578608" cy="676656"/>
+            <a:off x="2871216" y="1078992"/>
+            <a:ext cx="2377440" cy="676656"/>
           </a:xfrm>
           <a:prstGeom prst="roundRect">
             <a:avLst>
@@ -13487,7 +13487,7 @@
         </p:nvSpPr>
         <p:spPr>
           <a:xfrm>
-            <a:off x="3090672" y="1078992"/>
+            <a:off x="2871216" y="1078992"/>
             <a:ext cx="54864" cy="676656"/>
           </a:xfrm>
           <a:prstGeom prst="rect">
@@ -13512,7 +13512,7 @@
         </p:nvSpPr>
         <p:spPr>
           <a:xfrm>
-            <a:off x="3200400" y="1133856"/>
+            <a:off x="2980944" y="1133856"/>
             <a:ext cx="274320" cy="201168"/>
           </a:xfrm>
           <a:prstGeom prst="rect">
@@ -13551,8 +13551,8 @@
         </p:nvSpPr>
         <p:spPr>
           <a:xfrm>
-            <a:off x="3200400" y="1133856"/>
-            <a:ext cx="2377440" cy="237744"/>
+            <a:off x="2980944" y="1133856"/>
+            <a:ext cx="2176272" cy="237744"/>
           </a:xfrm>
           <a:prstGeom prst="rect">
             <a:avLst/>
@@ -13590,8 +13590,8 @@
         </p:nvSpPr>
         <p:spPr>
           <a:xfrm>
-            <a:off x="3200400" y="1408176"/>
-            <a:ext cx="2377440" cy="310896"/>
+            <a:off x="2980944" y="1408176"/>
+            <a:ext cx="2176272" cy="310896"/>
           </a:xfrm>
           <a:prstGeom prst="rect">
             <a:avLst/>
@@ -13653,7 +13653,7 @@
         <p:spPr>
           <a:xfrm>
             <a:off x="365760" y="1847088"/>
-            <a:ext cx="2578608" cy="676656"/>
+            <a:ext cx="2377440" cy="676656"/>
           </a:xfrm>
           <a:prstGeom prst="roundRect">
             <a:avLst>
@@ -13751,7 +13751,7 @@
         <p:spPr>
           <a:xfrm>
             <a:off x="475488" y="1901952"/>
-            <a:ext cx="2377440" cy="237744"/>
+            <a:ext cx="2176272" cy="237744"/>
           </a:xfrm>
           <a:prstGeom prst="rect">
             <a:avLst/>
@@ -13790,7 +13790,7 @@
         <p:spPr>
           <a:xfrm>
             <a:off x="475488" y="2176272"/>
-            <a:ext cx="2377440" cy="310896"/>
+            <a:ext cx="2176272" cy="310896"/>
           </a:xfrm>
           <a:prstGeom prst="rect">
             <a:avLst/>
@@ -13851,8 +13851,8 @@
         </p:nvSpPr>
         <p:spPr>
           <a:xfrm>
-            <a:off x="3090672" y="1847088"/>
-            <a:ext cx="2578608" cy="676656"/>
+            <a:off x="2871216" y="1847088"/>
+            <a:ext cx="2377440" cy="676656"/>
           </a:xfrm>
           <a:prstGeom prst="roundRect">
             <a:avLst>
@@ -13885,7 +13885,7 @@
         </p:nvSpPr>
         <p:spPr>
           <a:xfrm>
-            <a:off x="3090672" y="1847088"/>
+            <a:off x="2871216" y="1847088"/>
             <a:ext cx="54864" cy="676656"/>
           </a:xfrm>
           <a:prstGeom prst="rect">
@@ -13910,7 +13910,7 @@
         </p:nvSpPr>
         <p:spPr>
           <a:xfrm>
-            <a:off x="3200400" y="1901952"/>
+            <a:off x="2980944" y="1901952"/>
             <a:ext cx="274320" cy="201168"/>
           </a:xfrm>
           <a:prstGeom prst="rect">
@@ -13949,8 +13949,8 @@
         </p:nvSpPr>
         <p:spPr>
           <a:xfrm>
-            <a:off x="3200400" y="1901952"/>
-            <a:ext cx="2377440" cy="237744"/>
+            <a:off x="2980944" y="1901952"/>
+            <a:ext cx="2176272" cy="237744"/>
           </a:xfrm>
           <a:prstGeom prst="rect">
             <a:avLst/>
@@ -13988,8 +13988,8 @@
         </p:nvSpPr>
         <p:spPr>
           <a:xfrm>
-            <a:off x="3200400" y="2176272"/>
-            <a:ext cx="2377440" cy="310896"/>
+            <a:off x="2980944" y="2176272"/>
+            <a:ext cx="2176272" cy="310896"/>
           </a:xfrm>
           <a:prstGeom prst="rect">
             <a:avLst/>
@@ -14051,7 +14051,7 @@
         <p:spPr>
           <a:xfrm>
             <a:off x="365760" y="2615184"/>
-            <a:ext cx="2578608" cy="676656"/>
+            <a:ext cx="2377440" cy="676656"/>
           </a:xfrm>
           <a:prstGeom prst="roundRect">
             <a:avLst>
@@ -14149,7 +14149,7 @@
         <p:spPr>
           <a:xfrm>
             <a:off x="475488" y="2670048"/>
-            <a:ext cx="2377440" cy="237744"/>
+            <a:ext cx="2176272" cy="237744"/>
           </a:xfrm>
           <a:prstGeom prst="rect">
             <a:avLst/>
@@ -14188,7 +14188,7 @@
         <p:spPr>
           <a:xfrm>
             <a:off x="475488" y="2944368"/>
-            <a:ext cx="2377440" cy="310896"/>
+            <a:ext cx="2176272" cy="310896"/>
           </a:xfrm>
           <a:prstGeom prst="rect">
             <a:avLst/>
@@ -14249,8 +14249,8 @@
         </p:nvSpPr>
         <p:spPr>
           <a:xfrm>
-            <a:off x="3090672" y="2615184"/>
-            <a:ext cx="2578608" cy="676656"/>
+            <a:off x="2871216" y="2615184"/>
+            <a:ext cx="2377440" cy="676656"/>
           </a:xfrm>
           <a:prstGeom prst="roundRect">
             <a:avLst>
@@ -14283,7 +14283,7 @@
         </p:nvSpPr>
         <p:spPr>
           <a:xfrm>
-            <a:off x="3090672" y="2615184"/>
+            <a:off x="2871216" y="2615184"/>
             <a:ext cx="54864" cy="676656"/>
           </a:xfrm>
           <a:prstGeom prst="rect">
@@ -14308,7 +14308,7 @@
         </p:nvSpPr>
         <p:spPr>
           <a:xfrm>
-            <a:off x="3200400" y="2670048"/>
+            <a:off x="2980944" y="2670048"/>
             <a:ext cx="274320" cy="201168"/>
           </a:xfrm>
           <a:prstGeom prst="rect">
@@ -14347,8 +14347,8 @@
         </p:nvSpPr>
         <p:spPr>
           <a:xfrm>
-            <a:off x="3200400" y="2670048"/>
-            <a:ext cx="2377440" cy="237744"/>
+            <a:off x="2980944" y="2670048"/>
+            <a:ext cx="2176272" cy="237744"/>
           </a:xfrm>
           <a:prstGeom prst="rect">
             <a:avLst/>
@@ -14386,8 +14386,8 @@
         </p:nvSpPr>
         <p:spPr>
           <a:xfrm>
-            <a:off x="3200400" y="2944368"/>
-            <a:ext cx="2377440" cy="310896"/>
+            <a:off x="2980944" y="2944368"/>
+            <a:ext cx="2176272" cy="310896"/>
           </a:xfrm>
           <a:prstGeom prst="rect">
             <a:avLst/>
@@ -14448,12 +14448,12 @@
         </p:nvSpPr>
         <p:spPr>
           <a:xfrm>
-            <a:off x="5632704" y="1078992"/>
-            <a:ext cx="3145536" cy="3493008"/>
+            <a:off x="5431536" y="1078992"/>
+            <a:ext cx="3346704" cy="3493008"/>
           </a:xfrm>
           <a:prstGeom prst="roundRect">
             <a:avLst>
-              <a:gd name="adj" fmla="val 2035"/>
+              <a:gd name="adj" fmla="val 1913"/>
             </a:avLst>
           </a:prstGeom>
           <a:solidFill>
@@ -14482,8 +14482,8 @@
         </p:nvSpPr>
         <p:spPr>
           <a:xfrm>
-            <a:off x="5632704" y="1078992"/>
-            <a:ext cx="3145536" cy="384048"/>
+            <a:off x="5431536" y="1078992"/>
+            <a:ext cx="3346704" cy="384048"/>
           </a:xfrm>
           <a:prstGeom prst="roundRect">
             <a:avLst>
@@ -14509,8 +14509,8 @@
         </p:nvSpPr>
         <p:spPr>
           <a:xfrm>
-            <a:off x="5632704" y="1078992"/>
-            <a:ext cx="3145536" cy="384048"/>
+            <a:off x="5431536" y="1078992"/>
+            <a:ext cx="3346704" cy="384048"/>
           </a:xfrm>
           <a:prstGeom prst="rect">
             <a:avLst/>
@@ -14548,8 +14548,8 @@
         </p:nvSpPr>
         <p:spPr>
           <a:xfrm>
-            <a:off x="5760720" y="1554480"/>
-            <a:ext cx="2889504" cy="457200"/>
+            <a:off x="5559552" y="1554480"/>
+            <a:ext cx="3090672" cy="457200"/>
           </a:xfrm>
           <a:prstGeom prst="roundRect">
             <a:avLst>
@@ -14582,8 +14582,8 @@
         </p:nvSpPr>
         <p:spPr>
           <a:xfrm>
-            <a:off x="5852160" y="1591056"/>
-            <a:ext cx="2706624" cy="219456"/>
+            <a:off x="5650992" y="1591056"/>
+            <a:ext cx="2907792" cy="219456"/>
           </a:xfrm>
           <a:prstGeom prst="rect">
             <a:avLst/>
@@ -14621,8 +14621,8 @@
         </p:nvSpPr>
         <p:spPr>
           <a:xfrm>
-            <a:off x="5852160" y="1792224"/>
-            <a:ext cx="2706624" cy="182880"/>
+            <a:off x="5650992" y="1792224"/>
+            <a:ext cx="2907792" cy="182880"/>
           </a:xfrm>
           <a:prstGeom prst="rect">
             <a:avLst/>
@@ -14660,8 +14660,8 @@
         </p:nvSpPr>
         <p:spPr>
           <a:xfrm>
-            <a:off x="5760720" y="2084832"/>
-            <a:ext cx="2889504" cy="457200"/>
+            <a:off x="5559552" y="2084832"/>
+            <a:ext cx="3090672" cy="457200"/>
           </a:xfrm>
           <a:prstGeom prst="roundRect">
             <a:avLst>
@@ -14694,8 +14694,8 @@
         </p:nvSpPr>
         <p:spPr>
           <a:xfrm>
-            <a:off x="5852160" y="2121408"/>
-            <a:ext cx="2706624" cy="219456"/>
+            <a:off x="5650992" y="2121408"/>
+            <a:ext cx="2907792" cy="219456"/>
           </a:xfrm>
           <a:prstGeom prst="rect">
             <a:avLst/>
@@ -14733,8 +14733,8 @@
         </p:nvSpPr>
         <p:spPr>
           <a:xfrm>
-            <a:off x="5852160" y="2322576"/>
-            <a:ext cx="2706624" cy="182880"/>
+            <a:off x="5650992" y="2322576"/>
+            <a:ext cx="2907792" cy="182880"/>
           </a:xfrm>
           <a:prstGeom prst="rect">
             <a:avLst/>
@@ -14772,8 +14772,8 @@
         </p:nvSpPr>
         <p:spPr>
           <a:xfrm>
-            <a:off x="5760720" y="2615184"/>
-            <a:ext cx="2889504" cy="457200"/>
+            <a:off x="5559552" y="2615184"/>
+            <a:ext cx="3090672" cy="457200"/>
           </a:xfrm>
           <a:prstGeom prst="roundRect">
             <a:avLst>
@@ -14806,8 +14806,8 @@
         </p:nvSpPr>
         <p:spPr>
           <a:xfrm>
-            <a:off x="5852160" y="2651760"/>
-            <a:ext cx="2706624" cy="219456"/>
+            <a:off x="5650992" y="2651760"/>
+            <a:ext cx="2907792" cy="219456"/>
           </a:xfrm>
           <a:prstGeom prst="rect">
             <a:avLst/>
@@ -14845,8 +14845,8 @@
         </p:nvSpPr>
         <p:spPr>
           <a:xfrm>
-            <a:off x="5852160" y="2852928"/>
-            <a:ext cx="2706624" cy="182880"/>
+            <a:off x="5650992" y="2852928"/>
+            <a:ext cx="2907792" cy="182880"/>
           </a:xfrm>
           <a:prstGeom prst="rect">
             <a:avLst/>
@@ -14884,8 +14884,8 @@
         </p:nvSpPr>
         <p:spPr>
           <a:xfrm>
-            <a:off x="5760720" y="3145536"/>
-            <a:ext cx="2889504" cy="457200"/>
+            <a:off x="5559552" y="3145536"/>
+            <a:ext cx="3090672" cy="457200"/>
           </a:xfrm>
           <a:prstGeom prst="roundRect">
             <a:avLst>
@@ -14918,8 +14918,8 @@
         </p:nvSpPr>
         <p:spPr>
           <a:xfrm>
-            <a:off x="5852160" y="3182112"/>
-            <a:ext cx="2706624" cy="219456"/>
+            <a:off x="5650992" y="3182112"/>
+            <a:ext cx="2907792" cy="219456"/>
           </a:xfrm>
           <a:prstGeom prst="rect">
             <a:avLst/>
@@ -14957,8 +14957,8 @@
         </p:nvSpPr>
         <p:spPr>
           <a:xfrm>
-            <a:off x="5852160" y="3383280"/>
-            <a:ext cx="2706624" cy="182880"/>
+            <a:off x="5650992" y="3383280"/>
+            <a:ext cx="2907792" cy="182880"/>
           </a:xfrm>
           <a:prstGeom prst="rect">
             <a:avLst/>
@@ -14996,8 +14996,8 @@
         </p:nvSpPr>
         <p:spPr>
           <a:xfrm>
-            <a:off x="5760720" y="3675888"/>
-            <a:ext cx="2889504" cy="457200"/>
+            <a:off x="5559552" y="3675888"/>
+            <a:ext cx="3090672" cy="457200"/>
           </a:xfrm>
           <a:prstGeom prst="roundRect">
             <a:avLst>
@@ -15030,8 +15030,8 @@
         </p:nvSpPr>
         <p:spPr>
           <a:xfrm>
-            <a:off x="5852160" y="3712464"/>
-            <a:ext cx="2706624" cy="219456"/>
+            <a:off x="5650992" y="3712464"/>
+            <a:ext cx="2907792" cy="219456"/>
           </a:xfrm>
           <a:prstGeom prst="rect">
             <a:avLst/>
@@ -15069,8 +15069,8 @@
         </p:nvSpPr>
         <p:spPr>
           <a:xfrm>
-            <a:off x="5852160" y="3913632"/>
-            <a:ext cx="2706624" cy="182880"/>
+            <a:off x="5650992" y="3913632"/>
+            <a:ext cx="2907792" cy="182880"/>
           </a:xfrm>
           <a:prstGeom prst="rect">
             <a:avLst/>

</xml_diff>

<commit_message>
Update winnercomb.pptx - slide8 final overlap fix
</commit_message>
<xml_diff>
--- a/winnercomb.pptx
+++ b/winnercomb.pptx
@@ -15261,12 +15261,12 @@
         </p:nvSpPr>
         <p:spPr>
           <a:xfrm>
-            <a:off x="365760" y="1060704"/>
-            <a:ext cx="1594714" cy="1170432"/>
+            <a:off x="365760" y="1042416"/>
+            <a:ext cx="1594714" cy="1389888"/>
           </a:xfrm>
           <a:prstGeom prst="roundRect">
             <a:avLst>
-              <a:gd name="adj" fmla="val 5469"/>
+              <a:gd name="adj" fmla="val 4605"/>
             </a:avLst>
           </a:prstGeom>
           <a:solidFill>
@@ -15295,8 +15295,8 @@
         </p:nvSpPr>
         <p:spPr>
           <a:xfrm>
-            <a:off x="365760" y="1060704"/>
-            <a:ext cx="1594714" cy="118872"/>
+            <a:off x="365760" y="1042416"/>
+            <a:ext cx="1594714" cy="128016"/>
           </a:xfrm>
           <a:prstGeom prst="rect">
             <a:avLst/>
@@ -15320,8 +15320,8 @@
         </p:nvSpPr>
         <p:spPr>
           <a:xfrm>
-            <a:off x="943661" y="1216152"/>
-            <a:ext cx="438912" cy="438912"/>
+            <a:off x="934517" y="1225296"/>
+            <a:ext cx="457200" cy="457200"/>
           </a:xfrm>
           <a:prstGeom prst="ellipse">
             <a:avLst/>
@@ -15345,8 +15345,8 @@
         </p:nvSpPr>
         <p:spPr>
           <a:xfrm>
-            <a:off x="943661" y="1216152"/>
-            <a:ext cx="438912" cy="438912"/>
+            <a:off x="934517" y="1225296"/>
+            <a:ext cx="457200" cy="457200"/>
           </a:xfrm>
           <a:prstGeom prst="rect">
             <a:avLst/>
@@ -15362,7 +15362,7 @@
               <a:buNone/>
             </a:pPr>
             <a:r>
-              <a:rPr lang="en-US" sz="1500" dirty="0">
+              <a:rPr lang="en-US" sz="1600" dirty="0">
                 <a:solidFill>
                   <a:srgbClr val="000000"/>
                 </a:solidFill>
@@ -15372,7 +15372,7 @@
               </a:rPr>
               <a:t>🎯</a:t>
             </a:r>
-            <a:endParaRPr lang="en-US" sz="1500" dirty="0"/>
+            <a:endParaRPr lang="en-US" sz="1600" dirty="0"/>
           </a:p>
         </p:txBody>
       </p:sp>
@@ -15384,8 +15384,8 @@
         </p:nvSpPr>
         <p:spPr>
           <a:xfrm>
-            <a:off x="411480" y="1700784"/>
-            <a:ext cx="1503274" cy="274320"/>
+            <a:off x="411480" y="1737360"/>
+            <a:ext cx="1503274" cy="329184"/>
           </a:xfrm>
           <a:prstGeom prst="rect">
             <a:avLst/>
@@ -15399,7 +15399,7 @@
           <a:p>
             <a:pPr algn="ctr" indent="0" marL="0">
               <a:lnSpc>
-                <a:spcPct val="110000"/>
+                <a:spcPct val="115000"/>
               </a:lnSpc>
               <a:buNone/>
             </a:pPr>
@@ -15419,7 +15419,7 @@
           <a:p>
             <a:pPr algn="ctr" indent="0" marL="0">
               <a:lnSpc>
-                <a:spcPct val="110000"/>
+                <a:spcPct val="115000"/>
               </a:lnSpc>
               <a:buNone/>
             </a:pPr>
@@ -15446,7 +15446,7 @@
         </p:nvSpPr>
         <p:spPr>
           <a:xfrm>
-            <a:off x="475488" y="1993392"/>
+            <a:off x="475488" y="2084832"/>
             <a:ext cx="1375258" cy="0"/>
           </a:xfrm>
           <a:prstGeom prst="line">
@@ -15469,8 +15469,8 @@
         </p:nvSpPr>
         <p:spPr>
           <a:xfrm>
-            <a:off x="411480" y="2039112"/>
-            <a:ext cx="1503274" cy="310896"/>
+            <a:off x="411480" y="2139696"/>
+            <a:ext cx="1503274" cy="292608"/>
           </a:xfrm>
           <a:prstGeom prst="rect">
             <a:avLst/>
@@ -15531,12 +15531,12 @@
         </p:nvSpPr>
         <p:spPr>
           <a:xfrm>
-            <a:off x="2070202" y="1060704"/>
-            <a:ext cx="1594714" cy="1170432"/>
+            <a:off x="2070202" y="1042416"/>
+            <a:ext cx="1594714" cy="1389888"/>
           </a:xfrm>
           <a:prstGeom prst="roundRect">
             <a:avLst>
-              <a:gd name="adj" fmla="val 5469"/>
+              <a:gd name="adj" fmla="val 4605"/>
             </a:avLst>
           </a:prstGeom>
           <a:solidFill>
@@ -15565,8 +15565,8 @@
         </p:nvSpPr>
         <p:spPr>
           <a:xfrm>
-            <a:off x="2070202" y="1060704"/>
-            <a:ext cx="1594714" cy="118872"/>
+            <a:off x="2070202" y="1042416"/>
+            <a:ext cx="1594714" cy="128016"/>
           </a:xfrm>
           <a:prstGeom prst="rect">
             <a:avLst/>
@@ -15590,8 +15590,8 @@
         </p:nvSpPr>
         <p:spPr>
           <a:xfrm>
-            <a:off x="2648102" y="1216152"/>
-            <a:ext cx="438912" cy="438912"/>
+            <a:off x="2638958" y="1225296"/>
+            <a:ext cx="457200" cy="457200"/>
           </a:xfrm>
           <a:prstGeom prst="ellipse">
             <a:avLst/>
@@ -15615,8 +15615,8 @@
         </p:nvSpPr>
         <p:spPr>
           <a:xfrm>
-            <a:off x="2648102" y="1216152"/>
-            <a:ext cx="438912" cy="438912"/>
+            <a:off x="2638958" y="1225296"/>
+            <a:ext cx="457200" cy="457200"/>
           </a:xfrm>
           <a:prstGeom prst="rect">
             <a:avLst/>
@@ -15632,7 +15632,7 @@
               <a:buNone/>
             </a:pPr>
             <a:r>
-              <a:rPr lang="en-US" sz="1500" dirty="0">
+              <a:rPr lang="en-US" sz="1600" dirty="0">
                 <a:solidFill>
                   <a:srgbClr val="000000"/>
                 </a:solidFill>
@@ -15642,7 +15642,7 @@
               </a:rPr>
               <a:t>⚖️</a:t>
             </a:r>
-            <a:endParaRPr lang="en-US" sz="1500" dirty="0"/>
+            <a:endParaRPr lang="en-US" sz="1600" dirty="0"/>
           </a:p>
         </p:txBody>
       </p:sp>
@@ -15654,8 +15654,8 @@
         </p:nvSpPr>
         <p:spPr>
           <a:xfrm>
-            <a:off x="2115922" y="1700784"/>
-            <a:ext cx="1503274" cy="274320"/>
+            <a:off x="2115922" y="1737360"/>
+            <a:ext cx="1503274" cy="329184"/>
           </a:xfrm>
           <a:prstGeom prst="rect">
             <a:avLst/>
@@ -15669,7 +15669,7 @@
           <a:p>
             <a:pPr algn="ctr" indent="0" marL="0">
               <a:lnSpc>
-                <a:spcPct val="110000"/>
+                <a:spcPct val="115000"/>
               </a:lnSpc>
               <a:buNone/>
             </a:pPr>
@@ -15689,7 +15689,7 @@
           <a:p>
             <a:pPr algn="ctr" indent="0" marL="0">
               <a:lnSpc>
-                <a:spcPct val="110000"/>
+                <a:spcPct val="115000"/>
               </a:lnSpc>
               <a:buNone/>
             </a:pPr>
@@ -15716,7 +15716,7 @@
         </p:nvSpPr>
         <p:spPr>
           <a:xfrm>
-            <a:off x="2179930" y="1993392"/>
+            <a:off x="2179930" y="2084832"/>
             <a:ext cx="1375258" cy="0"/>
           </a:xfrm>
           <a:prstGeom prst="line">
@@ -15739,8 +15739,8 @@
         </p:nvSpPr>
         <p:spPr>
           <a:xfrm>
-            <a:off x="2115922" y="2039112"/>
-            <a:ext cx="1503274" cy="310896"/>
+            <a:off x="2115922" y="2139696"/>
+            <a:ext cx="1503274" cy="292608"/>
           </a:xfrm>
           <a:prstGeom prst="rect">
             <a:avLst/>
@@ -15801,12 +15801,12 @@
         </p:nvSpPr>
         <p:spPr>
           <a:xfrm>
-            <a:off x="3774643" y="1060704"/>
-            <a:ext cx="1594714" cy="1170432"/>
+            <a:off x="3774643" y="1042416"/>
+            <a:ext cx="1594714" cy="1389888"/>
           </a:xfrm>
           <a:prstGeom prst="roundRect">
             <a:avLst>
-              <a:gd name="adj" fmla="val 5469"/>
+              <a:gd name="adj" fmla="val 4605"/>
             </a:avLst>
           </a:prstGeom>
           <a:solidFill>
@@ -15835,8 +15835,8 @@
         </p:nvSpPr>
         <p:spPr>
           <a:xfrm>
-            <a:off x="3774643" y="1060704"/>
-            <a:ext cx="1594714" cy="118872"/>
+            <a:off x="3774643" y="1042416"/>
+            <a:ext cx="1594714" cy="128016"/>
           </a:xfrm>
           <a:prstGeom prst="rect">
             <a:avLst/>
@@ -15860,8 +15860,8 @@
         </p:nvSpPr>
         <p:spPr>
           <a:xfrm>
-            <a:off x="4352544" y="1216152"/>
-            <a:ext cx="438912" cy="438912"/>
+            <a:off x="4343400" y="1225296"/>
+            <a:ext cx="457200" cy="457200"/>
           </a:xfrm>
           <a:prstGeom prst="ellipse">
             <a:avLst/>
@@ -15885,8 +15885,8 @@
         </p:nvSpPr>
         <p:spPr>
           <a:xfrm>
-            <a:off x="4352544" y="1216152"/>
-            <a:ext cx="438912" cy="438912"/>
+            <a:off x="4343400" y="1225296"/>
+            <a:ext cx="457200" cy="457200"/>
           </a:xfrm>
           <a:prstGeom prst="rect">
             <a:avLst/>
@@ -15902,7 +15902,7 @@
               <a:buNone/>
             </a:pPr>
             <a:r>
-              <a:rPr lang="en-US" sz="1500" dirty="0">
+              <a:rPr lang="en-US" sz="1600" dirty="0">
                 <a:solidFill>
                   <a:srgbClr val="000000"/>
                 </a:solidFill>
@@ -15912,7 +15912,7 @@
               </a:rPr>
               <a:t>🚫</a:t>
             </a:r>
-            <a:endParaRPr lang="en-US" sz="1500" dirty="0"/>
+            <a:endParaRPr lang="en-US" sz="1600" dirty="0"/>
           </a:p>
         </p:txBody>
       </p:sp>
@@ -15924,8 +15924,8 @@
         </p:nvSpPr>
         <p:spPr>
           <a:xfrm>
-            <a:off x="3820363" y="1700784"/>
-            <a:ext cx="1503274" cy="274320"/>
+            <a:off x="3820363" y="1737360"/>
+            <a:ext cx="1503274" cy="329184"/>
           </a:xfrm>
           <a:prstGeom prst="rect">
             <a:avLst/>
@@ -15939,7 +15939,7 @@
           <a:p>
             <a:pPr algn="ctr" indent="0" marL="0">
               <a:lnSpc>
-                <a:spcPct val="110000"/>
+                <a:spcPct val="115000"/>
               </a:lnSpc>
               <a:buNone/>
             </a:pPr>
@@ -15959,7 +15959,7 @@
           <a:p>
             <a:pPr algn="ctr" indent="0" marL="0">
               <a:lnSpc>
-                <a:spcPct val="110000"/>
+                <a:spcPct val="115000"/>
               </a:lnSpc>
               <a:buNone/>
             </a:pPr>
@@ -15986,7 +15986,7 @@
         </p:nvSpPr>
         <p:spPr>
           <a:xfrm>
-            <a:off x="3884371" y="1993392"/>
+            <a:off x="3884371" y="2084832"/>
             <a:ext cx="1375258" cy="0"/>
           </a:xfrm>
           <a:prstGeom prst="line">
@@ -16009,8 +16009,8 @@
         </p:nvSpPr>
         <p:spPr>
           <a:xfrm>
-            <a:off x="3820363" y="2039112"/>
-            <a:ext cx="1503274" cy="310896"/>
+            <a:off x="3820363" y="2139696"/>
+            <a:ext cx="1503274" cy="292608"/>
           </a:xfrm>
           <a:prstGeom prst="rect">
             <a:avLst/>
@@ -16071,12 +16071,12 @@
         </p:nvSpPr>
         <p:spPr>
           <a:xfrm>
-            <a:off x="5479085" y="1060704"/>
-            <a:ext cx="1594714" cy="1170432"/>
+            <a:off x="5479085" y="1042416"/>
+            <a:ext cx="1594714" cy="1389888"/>
           </a:xfrm>
           <a:prstGeom prst="roundRect">
             <a:avLst>
-              <a:gd name="adj" fmla="val 5469"/>
+              <a:gd name="adj" fmla="val 4605"/>
             </a:avLst>
           </a:prstGeom>
           <a:solidFill>
@@ -16105,8 +16105,8 @@
         </p:nvSpPr>
         <p:spPr>
           <a:xfrm>
-            <a:off x="5479085" y="1060704"/>
-            <a:ext cx="1594714" cy="118872"/>
+            <a:off x="5479085" y="1042416"/>
+            <a:ext cx="1594714" cy="128016"/>
           </a:xfrm>
           <a:prstGeom prst="rect">
             <a:avLst/>
@@ -16130,8 +16130,8 @@
         </p:nvSpPr>
         <p:spPr>
           <a:xfrm>
-            <a:off x="6056986" y="1216152"/>
-            <a:ext cx="438912" cy="438912"/>
+            <a:off x="6047842" y="1225296"/>
+            <a:ext cx="457200" cy="457200"/>
           </a:xfrm>
           <a:prstGeom prst="ellipse">
             <a:avLst/>
@@ -16155,8 +16155,8 @@
         </p:nvSpPr>
         <p:spPr>
           <a:xfrm>
-            <a:off x="6056986" y="1216152"/>
-            <a:ext cx="438912" cy="438912"/>
+            <a:off x="6047842" y="1225296"/>
+            <a:ext cx="457200" cy="457200"/>
           </a:xfrm>
           <a:prstGeom prst="rect">
             <a:avLst/>
@@ -16172,7 +16172,7 @@
               <a:buNone/>
             </a:pPr>
             <a:r>
-              <a:rPr lang="en-US" sz="1500" dirty="0">
+              <a:rPr lang="en-US" sz="1600" dirty="0">
                 <a:solidFill>
                   <a:srgbClr val="000000"/>
                 </a:solidFill>
@@ -16182,7 +16182,7 @@
               </a:rPr>
               <a:t>📈</a:t>
             </a:r>
-            <a:endParaRPr lang="en-US" sz="1500" dirty="0"/>
+            <a:endParaRPr lang="en-US" sz="1600" dirty="0"/>
           </a:p>
         </p:txBody>
       </p:sp>
@@ -16194,8 +16194,8 @@
         </p:nvSpPr>
         <p:spPr>
           <a:xfrm>
-            <a:off x="5524805" y="1700784"/>
-            <a:ext cx="1503274" cy="274320"/>
+            <a:off x="5524805" y="1737360"/>
+            <a:ext cx="1503274" cy="329184"/>
           </a:xfrm>
           <a:prstGeom prst="rect">
             <a:avLst/>
@@ -16209,7 +16209,7 @@
           <a:p>
             <a:pPr algn="ctr" indent="0" marL="0">
               <a:lnSpc>
-                <a:spcPct val="110000"/>
+                <a:spcPct val="115000"/>
               </a:lnSpc>
               <a:buNone/>
             </a:pPr>
@@ -16229,7 +16229,7 @@
           <a:p>
             <a:pPr algn="ctr" indent="0" marL="0">
               <a:lnSpc>
-                <a:spcPct val="110000"/>
+                <a:spcPct val="115000"/>
               </a:lnSpc>
               <a:buNone/>
             </a:pPr>
@@ -16256,7 +16256,7 @@
         </p:nvSpPr>
         <p:spPr>
           <a:xfrm>
-            <a:off x="5588813" y="1993392"/>
+            <a:off x="5588813" y="2084832"/>
             <a:ext cx="1375258" cy="0"/>
           </a:xfrm>
           <a:prstGeom prst="line">
@@ -16279,8 +16279,8 @@
         </p:nvSpPr>
         <p:spPr>
           <a:xfrm>
-            <a:off x="5524805" y="2039112"/>
-            <a:ext cx="1503274" cy="310896"/>
+            <a:off x="5524805" y="2139696"/>
+            <a:ext cx="1503274" cy="292608"/>
           </a:xfrm>
           <a:prstGeom prst="rect">
             <a:avLst/>
@@ -16341,12 +16341,12 @@
         </p:nvSpPr>
         <p:spPr>
           <a:xfrm>
-            <a:off x="7183526" y="1060704"/>
-            <a:ext cx="1594714" cy="1170432"/>
+            <a:off x="7183526" y="1042416"/>
+            <a:ext cx="1594714" cy="1389888"/>
           </a:xfrm>
           <a:prstGeom prst="roundRect">
             <a:avLst>
-              <a:gd name="adj" fmla="val 5469"/>
+              <a:gd name="adj" fmla="val 4605"/>
             </a:avLst>
           </a:prstGeom>
           <a:solidFill>
@@ -16375,8 +16375,8 @@
         </p:nvSpPr>
         <p:spPr>
           <a:xfrm>
-            <a:off x="7183526" y="1060704"/>
-            <a:ext cx="1594714" cy="118872"/>
+            <a:off x="7183526" y="1042416"/>
+            <a:ext cx="1594714" cy="128016"/>
           </a:xfrm>
           <a:prstGeom prst="rect">
             <a:avLst/>
@@ -16400,8 +16400,8 @@
         </p:nvSpPr>
         <p:spPr>
           <a:xfrm>
-            <a:off x="7761427" y="1216152"/>
-            <a:ext cx="438912" cy="438912"/>
+            <a:off x="7752283" y="1225296"/>
+            <a:ext cx="457200" cy="457200"/>
           </a:xfrm>
           <a:prstGeom prst="ellipse">
             <a:avLst/>
@@ -16425,8 +16425,8 @@
         </p:nvSpPr>
         <p:spPr>
           <a:xfrm>
-            <a:off x="7761427" y="1216152"/>
-            <a:ext cx="438912" cy="438912"/>
+            <a:off x="7752283" y="1225296"/>
+            <a:ext cx="457200" cy="457200"/>
           </a:xfrm>
           <a:prstGeom prst="rect">
             <a:avLst/>
@@ -16442,7 +16442,7 @@
               <a:buNone/>
             </a:pPr>
             <a:r>
-              <a:rPr lang="en-US" sz="1500" dirty="0">
+              <a:rPr lang="en-US" sz="1600" dirty="0">
                 <a:solidFill>
                   <a:srgbClr val="000000"/>
                 </a:solidFill>
@@ -16452,7 +16452,7 @@
               </a:rPr>
               <a:t>👤</a:t>
             </a:r>
-            <a:endParaRPr lang="en-US" sz="1500" dirty="0"/>
+            <a:endParaRPr lang="en-US" sz="1600" dirty="0"/>
           </a:p>
         </p:txBody>
       </p:sp>
@@ -16464,8 +16464,8 @@
         </p:nvSpPr>
         <p:spPr>
           <a:xfrm>
-            <a:off x="7229246" y="1700784"/>
-            <a:ext cx="1503274" cy="274320"/>
+            <a:off x="7229246" y="1737360"/>
+            <a:ext cx="1503274" cy="329184"/>
           </a:xfrm>
           <a:prstGeom prst="rect">
             <a:avLst/>
@@ -16479,7 +16479,7 @@
           <a:p>
             <a:pPr algn="ctr" indent="0" marL="0">
               <a:lnSpc>
-                <a:spcPct val="110000"/>
+                <a:spcPct val="115000"/>
               </a:lnSpc>
               <a:buNone/>
             </a:pPr>
@@ -16499,7 +16499,7 @@
           <a:p>
             <a:pPr algn="ctr" indent="0" marL="0">
               <a:lnSpc>
-                <a:spcPct val="110000"/>
+                <a:spcPct val="115000"/>
               </a:lnSpc>
               <a:buNone/>
             </a:pPr>
@@ -16526,7 +16526,7 @@
         </p:nvSpPr>
         <p:spPr>
           <a:xfrm>
-            <a:off x="7293254" y="1993392"/>
+            <a:off x="7293254" y="2084832"/>
             <a:ext cx="1375258" cy="0"/>
           </a:xfrm>
           <a:prstGeom prst="line">
@@ -16549,8 +16549,8 @@
         </p:nvSpPr>
         <p:spPr>
           <a:xfrm>
-            <a:off x="7229246" y="2039112"/>
-            <a:ext cx="1503274" cy="310896"/>
+            <a:off x="7229246" y="2139696"/>
+            <a:ext cx="1503274" cy="292608"/>
           </a:xfrm>
           <a:prstGeom prst="rect">
             <a:avLst/>
@@ -16611,12 +16611,12 @@
         </p:nvSpPr>
         <p:spPr>
           <a:xfrm>
-            <a:off x="365760" y="2377440"/>
-            <a:ext cx="2743200" cy="2692908"/>
+            <a:off x="365760" y="2542032"/>
+            <a:ext cx="2743200" cy="2546604"/>
           </a:xfrm>
           <a:prstGeom prst="roundRect">
             <a:avLst>
-              <a:gd name="adj" fmla="val 2377"/>
+              <a:gd name="adj" fmla="val 2513"/>
             </a:avLst>
           </a:prstGeom>
           <a:solidFill>
@@ -16645,7 +16645,7 @@
         </p:nvSpPr>
         <p:spPr>
           <a:xfrm>
-            <a:off x="365760" y="2377440"/>
+            <a:off x="365760" y="2542032"/>
             <a:ext cx="2743200" cy="310896"/>
           </a:xfrm>
           <a:prstGeom prst="roundRect">
@@ -16672,7 +16672,7 @@
         </p:nvSpPr>
         <p:spPr>
           <a:xfrm>
-            <a:off x="365760" y="2377440"/>
+            <a:off x="365760" y="2542032"/>
             <a:ext cx="2743200" cy="310896"/>
           </a:xfrm>
           <a:prstGeom prst="rect">
@@ -16711,12 +16711,12 @@
         </p:nvSpPr>
         <p:spPr>
           <a:xfrm>
-            <a:off x="457200" y="2761488"/>
-            <a:ext cx="2560320" cy="763524"/>
+            <a:off x="457200" y="2926080"/>
+            <a:ext cx="2560320" cy="678180"/>
           </a:xfrm>
           <a:prstGeom prst="roundRect">
             <a:avLst>
-              <a:gd name="adj" fmla="val 8383"/>
+              <a:gd name="adj" fmla="val 9438"/>
             </a:avLst>
           </a:prstGeom>
           <a:solidFill>
@@ -16745,8 +16745,8 @@
         </p:nvSpPr>
         <p:spPr>
           <a:xfrm>
-            <a:off x="530352" y="2816352"/>
-            <a:ext cx="2414016" cy="672084"/>
+            <a:off x="530352" y="2980944"/>
+            <a:ext cx="2414016" cy="586740"/>
           </a:xfrm>
           <a:prstGeom prst="rect">
             <a:avLst/>
@@ -16760,7 +16760,7 @@
           <a:p>
             <a:pPr indent="0" marL="0">
               <a:lnSpc>
-                <a:spcPct val="120000"/>
+                <a:spcPct val="115000"/>
               </a:lnSpc>
               <a:buNone/>
             </a:pPr>
@@ -16787,12 +16787,12 @@
         </p:nvSpPr>
         <p:spPr>
           <a:xfrm>
-            <a:off x="457200" y="3579876"/>
-            <a:ext cx="2560320" cy="763524"/>
+            <a:off x="457200" y="3659124"/>
+            <a:ext cx="2560320" cy="678180"/>
           </a:xfrm>
           <a:prstGeom prst="roundRect">
             <a:avLst>
-              <a:gd name="adj" fmla="val 8383"/>
+              <a:gd name="adj" fmla="val 9438"/>
             </a:avLst>
           </a:prstGeom>
           <a:solidFill>
@@ -16821,8 +16821,8 @@
         </p:nvSpPr>
         <p:spPr>
           <a:xfrm>
-            <a:off x="530352" y="3634740"/>
-            <a:ext cx="2414016" cy="672084"/>
+            <a:off x="530352" y="3713988"/>
+            <a:ext cx="2414016" cy="586740"/>
           </a:xfrm>
           <a:prstGeom prst="rect">
             <a:avLst/>
@@ -16836,7 +16836,7 @@
           <a:p>
             <a:pPr indent="0" marL="0">
               <a:lnSpc>
-                <a:spcPct val="120000"/>
+                <a:spcPct val="115000"/>
               </a:lnSpc>
               <a:buNone/>
             </a:pPr>
@@ -16863,12 +16863,12 @@
         </p:nvSpPr>
         <p:spPr>
           <a:xfrm>
-            <a:off x="457200" y="4398264"/>
-            <a:ext cx="2560320" cy="763524"/>
+            <a:off x="457200" y="4392168"/>
+            <a:ext cx="2560320" cy="678180"/>
           </a:xfrm>
           <a:prstGeom prst="roundRect">
             <a:avLst>
-              <a:gd name="adj" fmla="val 8383"/>
+              <a:gd name="adj" fmla="val 9438"/>
             </a:avLst>
           </a:prstGeom>
           <a:solidFill>
@@ -16897,8 +16897,8 @@
         </p:nvSpPr>
         <p:spPr>
           <a:xfrm>
-            <a:off x="530352" y="4453128"/>
-            <a:ext cx="2414016" cy="672084"/>
+            <a:off x="530352" y="4447032"/>
+            <a:ext cx="2414016" cy="586740"/>
           </a:xfrm>
           <a:prstGeom prst="rect">
             <a:avLst/>
@@ -16912,7 +16912,7 @@
           <a:p>
             <a:pPr indent="0" marL="0">
               <a:lnSpc>
-                <a:spcPct val="120000"/>
+                <a:spcPct val="115000"/>
               </a:lnSpc>
               <a:buNone/>
             </a:pPr>
@@ -16939,12 +16939,12 @@
         </p:nvSpPr>
         <p:spPr>
           <a:xfrm>
-            <a:off x="3200400" y="2377440"/>
-            <a:ext cx="2743200" cy="2692908"/>
+            <a:off x="3200400" y="2542032"/>
+            <a:ext cx="2743200" cy="2546604"/>
           </a:xfrm>
           <a:prstGeom prst="roundRect">
             <a:avLst>
-              <a:gd name="adj" fmla="val 2377"/>
+              <a:gd name="adj" fmla="val 2513"/>
             </a:avLst>
           </a:prstGeom>
           <a:solidFill>
@@ -16973,7 +16973,7 @@
         </p:nvSpPr>
         <p:spPr>
           <a:xfrm>
-            <a:off x="3200400" y="2377440"/>
+            <a:off x="3200400" y="2542032"/>
             <a:ext cx="2743200" cy="310896"/>
           </a:xfrm>
           <a:prstGeom prst="roundRect">
@@ -17000,7 +17000,7 @@
         </p:nvSpPr>
         <p:spPr>
           <a:xfrm>
-            <a:off x="3200400" y="2377440"/>
+            <a:off x="3200400" y="2542032"/>
             <a:ext cx="2743200" cy="310896"/>
           </a:xfrm>
           <a:prstGeom prst="rect">
@@ -17039,12 +17039,12 @@
         </p:nvSpPr>
         <p:spPr>
           <a:xfrm>
-            <a:off x="3291840" y="2761488"/>
-            <a:ext cx="2560320" cy="763524"/>
+            <a:off x="3291840" y="2926080"/>
+            <a:ext cx="2560320" cy="678180"/>
           </a:xfrm>
           <a:prstGeom prst="roundRect">
             <a:avLst>
-              <a:gd name="adj" fmla="val 8383"/>
+              <a:gd name="adj" fmla="val 9438"/>
             </a:avLst>
           </a:prstGeom>
           <a:solidFill>
@@ -17073,8 +17073,8 @@
         </p:nvSpPr>
         <p:spPr>
           <a:xfrm>
-            <a:off x="3364992" y="2816352"/>
-            <a:ext cx="2414016" cy="672084"/>
+            <a:off x="3364992" y="2980944"/>
+            <a:ext cx="2414016" cy="586740"/>
           </a:xfrm>
           <a:prstGeom prst="rect">
             <a:avLst/>
@@ -17088,7 +17088,7 @@
           <a:p>
             <a:pPr indent="0" marL="0">
               <a:lnSpc>
-                <a:spcPct val="120000"/>
+                <a:spcPct val="115000"/>
               </a:lnSpc>
               <a:buNone/>
             </a:pPr>
@@ -17115,12 +17115,12 @@
         </p:nvSpPr>
         <p:spPr>
           <a:xfrm>
-            <a:off x="3291840" y="3579876"/>
-            <a:ext cx="2560320" cy="763524"/>
+            <a:off x="3291840" y="3659124"/>
+            <a:ext cx="2560320" cy="678180"/>
           </a:xfrm>
           <a:prstGeom prst="roundRect">
             <a:avLst>
-              <a:gd name="adj" fmla="val 8383"/>
+              <a:gd name="adj" fmla="val 9438"/>
             </a:avLst>
           </a:prstGeom>
           <a:solidFill>
@@ -17149,8 +17149,8 @@
         </p:nvSpPr>
         <p:spPr>
           <a:xfrm>
-            <a:off x="3364992" y="3634740"/>
-            <a:ext cx="2414016" cy="672084"/>
+            <a:off x="3364992" y="3713988"/>
+            <a:ext cx="2414016" cy="586740"/>
           </a:xfrm>
           <a:prstGeom prst="rect">
             <a:avLst/>
@@ -17164,7 +17164,7 @@
           <a:p>
             <a:pPr indent="0" marL="0">
               <a:lnSpc>
-                <a:spcPct val="120000"/>
+                <a:spcPct val="115000"/>
               </a:lnSpc>
               <a:buNone/>
             </a:pPr>
@@ -17191,12 +17191,12 @@
         </p:nvSpPr>
         <p:spPr>
           <a:xfrm>
-            <a:off x="3291840" y="4398264"/>
-            <a:ext cx="2560320" cy="763524"/>
+            <a:off x="3291840" y="4392168"/>
+            <a:ext cx="2560320" cy="678180"/>
           </a:xfrm>
           <a:prstGeom prst="roundRect">
             <a:avLst>
-              <a:gd name="adj" fmla="val 8383"/>
+              <a:gd name="adj" fmla="val 9438"/>
             </a:avLst>
           </a:prstGeom>
           <a:solidFill>
@@ -17225,8 +17225,8 @@
         </p:nvSpPr>
         <p:spPr>
           <a:xfrm>
-            <a:off x="3364992" y="4453128"/>
-            <a:ext cx="2414016" cy="672084"/>
+            <a:off x="3364992" y="4447032"/>
+            <a:ext cx="2414016" cy="586740"/>
           </a:xfrm>
           <a:prstGeom prst="rect">
             <a:avLst/>
@@ -17240,7 +17240,7 @@
           <a:p>
             <a:pPr indent="0" marL="0">
               <a:lnSpc>
-                <a:spcPct val="120000"/>
+                <a:spcPct val="115000"/>
               </a:lnSpc>
               <a:buNone/>
             </a:pPr>
@@ -17267,12 +17267,12 @@
         </p:nvSpPr>
         <p:spPr>
           <a:xfrm>
-            <a:off x="6035040" y="2377440"/>
-            <a:ext cx="2743200" cy="2692908"/>
+            <a:off x="6035040" y="2542032"/>
+            <a:ext cx="2743200" cy="2546604"/>
           </a:xfrm>
           <a:prstGeom prst="roundRect">
             <a:avLst>
-              <a:gd name="adj" fmla="val 2377"/>
+              <a:gd name="adj" fmla="val 2513"/>
             </a:avLst>
           </a:prstGeom>
           <a:solidFill>
@@ -17301,7 +17301,7 @@
         </p:nvSpPr>
         <p:spPr>
           <a:xfrm>
-            <a:off x="6035040" y="2377440"/>
+            <a:off x="6035040" y="2542032"/>
             <a:ext cx="2743200" cy="310896"/>
           </a:xfrm>
           <a:prstGeom prst="roundRect">
@@ -17328,7 +17328,7 @@
         </p:nvSpPr>
         <p:spPr>
           <a:xfrm>
-            <a:off x="6035040" y="2377440"/>
+            <a:off x="6035040" y="2542032"/>
             <a:ext cx="2743200" cy="310896"/>
           </a:xfrm>
           <a:prstGeom prst="rect">
@@ -17367,12 +17367,12 @@
         </p:nvSpPr>
         <p:spPr>
           <a:xfrm>
-            <a:off x="6126480" y="2761488"/>
-            <a:ext cx="2560320" cy="763524"/>
+            <a:off x="6126480" y="2926080"/>
+            <a:ext cx="2560320" cy="678180"/>
           </a:xfrm>
           <a:prstGeom prst="roundRect">
             <a:avLst>
-              <a:gd name="adj" fmla="val 8383"/>
+              <a:gd name="adj" fmla="val 9438"/>
             </a:avLst>
           </a:prstGeom>
           <a:solidFill>
@@ -17401,8 +17401,8 @@
         </p:nvSpPr>
         <p:spPr>
           <a:xfrm>
-            <a:off x="6199632" y="2816352"/>
-            <a:ext cx="2414016" cy="672084"/>
+            <a:off x="6199632" y="2980944"/>
+            <a:ext cx="2414016" cy="586740"/>
           </a:xfrm>
           <a:prstGeom prst="rect">
             <a:avLst/>
@@ -17416,7 +17416,7 @@
           <a:p>
             <a:pPr indent="0" marL="0">
               <a:lnSpc>
-                <a:spcPct val="120000"/>
+                <a:spcPct val="115000"/>
               </a:lnSpc>
               <a:buNone/>
             </a:pPr>
@@ -17443,12 +17443,12 @@
         </p:nvSpPr>
         <p:spPr>
           <a:xfrm>
-            <a:off x="6126480" y="3579876"/>
-            <a:ext cx="2560320" cy="763524"/>
+            <a:off x="6126480" y="3659124"/>
+            <a:ext cx="2560320" cy="678180"/>
           </a:xfrm>
           <a:prstGeom prst="roundRect">
             <a:avLst>
-              <a:gd name="adj" fmla="val 8383"/>
+              <a:gd name="adj" fmla="val 9438"/>
             </a:avLst>
           </a:prstGeom>
           <a:solidFill>
@@ -17477,8 +17477,8 @@
         </p:nvSpPr>
         <p:spPr>
           <a:xfrm>
-            <a:off x="6199632" y="3634740"/>
-            <a:ext cx="2414016" cy="672084"/>
+            <a:off x="6199632" y="3713988"/>
+            <a:ext cx="2414016" cy="586740"/>
           </a:xfrm>
           <a:prstGeom prst="rect">
             <a:avLst/>
@@ -17492,7 +17492,7 @@
           <a:p>
             <a:pPr indent="0" marL="0">
               <a:lnSpc>
-                <a:spcPct val="120000"/>
+                <a:spcPct val="115000"/>
               </a:lnSpc>
               <a:buNone/>
             </a:pPr>
@@ -17519,12 +17519,12 @@
         </p:nvSpPr>
         <p:spPr>
           <a:xfrm>
-            <a:off x="6126480" y="4398264"/>
-            <a:ext cx="2560320" cy="763524"/>
+            <a:off x="6126480" y="4392168"/>
+            <a:ext cx="2560320" cy="678180"/>
           </a:xfrm>
           <a:prstGeom prst="roundRect">
             <a:avLst>
-              <a:gd name="adj" fmla="val 8383"/>
+              <a:gd name="adj" fmla="val 9438"/>
             </a:avLst>
           </a:prstGeom>
           <a:solidFill>
@@ -17553,8 +17553,8 @@
         </p:nvSpPr>
         <p:spPr>
           <a:xfrm>
-            <a:off x="6199632" y="4453128"/>
-            <a:ext cx="2414016" cy="672084"/>
+            <a:off x="6199632" y="4447032"/>
+            <a:ext cx="2414016" cy="586740"/>
           </a:xfrm>
           <a:prstGeom prst="rect">
             <a:avLst/>
@@ -17568,7 +17568,7 @@
           <a:p>
             <a:pPr indent="0" marL="0">
               <a:lnSpc>
-                <a:spcPct val="120000"/>
+                <a:spcPct val="115000"/>
               </a:lnSpc>
               <a:buNone/>
             </a:pPr>

</xml_diff>

<commit_message>
Update winnercomb.pptx - add AI learning cooperation request
</commit_message>
<xml_diff>
--- a/winnercomb.pptx
+++ b/winnercomb.pptx
@@ -13029,11 +13029,11 @@
         <p:spPr>
           <a:xfrm>
             <a:off x="365760" y="3712464"/>
-            <a:ext cx="8412480" cy="658368"/>
+            <a:ext cx="8412480" cy="475488"/>
           </a:xfrm>
           <a:prstGeom prst="roundRect">
             <a:avLst>
-              <a:gd name="adj" fmla="val 9722"/>
+              <a:gd name="adj" fmla="val 13462"/>
             </a:avLst>
           </a:prstGeom>
           <a:solidFill>
@@ -13063,7 +13063,7 @@
         <p:spPr>
           <a:xfrm>
             <a:off x="548640" y="3712464"/>
-            <a:ext cx="8046720" cy="658368"/>
+            <a:ext cx="8046720" cy="475488"/>
           </a:xfrm>
           <a:prstGeom prst="rect">
             <a:avLst/>
@@ -13079,17 +13079,356 @@
               <a:buNone/>
             </a:pPr>
             <a:r>
+              <a:rPr lang="en-US" sz="1050" b="1" dirty="0">
+                <a:solidFill>
+                  <a:srgbClr val="FFFFFF"/>
+                </a:solidFill>
+                <a:latin typeface="Noto Sans KR" pitchFamily="34" charset="0"/>
+                <a:ea typeface="Noto Sans KR" pitchFamily="34" charset="-122"/>
+                <a:cs typeface="Noto Sans KR" pitchFamily="34" charset="-120"/>
+              </a:rPr>
+              <a:t>투입부터 판정·MES 전송·분리 배출까지  전 과정 무인 자동 운영  |  별도 인력 불필요</a:t>
+            </a:r>
+            <a:endParaRPr lang="en-US" sz="1050" dirty="0"/>
+          </a:p>
+        </p:txBody>
+      </p:sp>
+      <p:sp>
+        <p:nvSpPr>
+          <p:cNvPr id="54" name="Shape 52"/>
+          <p:cNvSpPr/>
+          <p:nvPr/>
+        </p:nvSpPr>
+        <p:spPr>
+          <a:xfrm>
+            <a:off x="365760" y="4261104"/>
+            <a:ext cx="8412480" cy="768096"/>
+          </a:xfrm>
+          <a:prstGeom prst="roundRect">
+            <a:avLst>
+              <a:gd name="adj" fmla="val 8333"/>
+            </a:avLst>
+          </a:prstGeom>
+          <a:solidFill>
+            <a:srgbClr val="FFF8E7"/>
+          </a:solidFill>
+          <a:ln w="19050">
+            <a:solidFill>
+              <a:srgbClr val="F59E0B"/>
+            </a:solidFill>
+            <a:prstDash val="solid"/>
+          </a:ln>
+          <a:effectLst>
+            <a:outerShdw sx="100000" sy="100000" kx="0" ky="0" algn="bl" rotWithShape="0" blurRad="50800" dist="25400" dir="16200000">
+              <a:srgbClr val="9CA3AF">
+                <a:alpha val="15000"/>
+              </a:srgbClr>
+            </a:outerShdw>
+          </a:effectLst>
+        </p:spPr>
+      </p:sp>
+      <p:sp>
+        <p:nvSpPr>
+          <p:cNvPr id="55" name="Shape 53"/>
+          <p:cNvSpPr/>
+          <p:nvPr/>
+        </p:nvSpPr>
+        <p:spPr>
+          <a:xfrm>
+            <a:off x="365760" y="4261104"/>
+            <a:ext cx="54864" cy="768096"/>
+          </a:xfrm>
+          <a:prstGeom prst="rect">
+            <a:avLst/>
+          </a:prstGeom>
+          <a:solidFill>
+            <a:srgbClr val="F59E0B"/>
+          </a:solidFill>
+          <a:ln w="12700">
+            <a:solidFill>
+              <a:srgbClr val="F59E0B"/>
+            </a:solidFill>
+            <a:prstDash val="solid"/>
+          </a:ln>
+        </p:spPr>
+      </p:sp>
+      <p:sp>
+        <p:nvSpPr>
+          <p:cNvPr id="56" name="Shape 54"/>
+          <p:cNvSpPr/>
+          <p:nvPr/>
+        </p:nvSpPr>
+        <p:spPr>
+          <a:xfrm>
+            <a:off x="493776" y="4370832"/>
+            <a:ext cx="384048" cy="384048"/>
+          </a:xfrm>
+          <a:prstGeom prst="ellipse">
+            <a:avLst/>
+          </a:prstGeom>
+          <a:solidFill>
+            <a:srgbClr val="F59E0B"/>
+          </a:solidFill>
+          <a:ln w="12700">
+            <a:solidFill>
+              <a:srgbClr val="F59E0B"/>
+            </a:solidFill>
+            <a:prstDash val="solid"/>
+          </a:ln>
+        </p:spPr>
+      </p:sp>
+      <p:sp>
+        <p:nvSpPr>
+          <p:cNvPr id="57" name="Text 55"/>
+          <p:cNvSpPr/>
+          <p:nvPr/>
+        </p:nvSpPr>
+        <p:spPr>
+          <a:xfrm>
+            <a:off x="493776" y="4370832"/>
+            <a:ext cx="384048" cy="384048"/>
+          </a:xfrm>
+          <a:prstGeom prst="rect">
+            <a:avLst/>
+          </a:prstGeom>
+          <a:noFill/>
+          <a:ln/>
+        </p:spPr>
+        <p:txBody>
+          <a:bodyPr wrap="square" lIns="0" tIns="0" rIns="0" bIns="0" rtlCol="0" anchor="ctr"/>
+          <a:lstStyle/>
+          <a:p>
+            <a:pPr algn="ctr" indent="0" marL="0">
+              <a:buNone/>
+            </a:pPr>
+            <a:r>
+              <a:rPr lang="en-US" sz="1400" dirty="0">
+                <a:solidFill>
+                  <a:srgbClr val="000000"/>
+                </a:solidFill>
+                <a:latin typeface="Noto Sans KR" pitchFamily="34" charset="0"/>
+                <a:ea typeface="Noto Sans KR" pitchFamily="34" charset="-122"/>
+                <a:cs typeface="Noto Sans KR" pitchFamily="34" charset="-120"/>
+              </a:rPr>
+              <a:t>🤝</a:t>
+            </a:r>
+            <a:endParaRPr lang="en-US" sz="1400" dirty="0"/>
+          </a:p>
+        </p:txBody>
+      </p:sp>
+      <p:sp>
+        <p:nvSpPr>
+          <p:cNvPr id="58" name="Text 56"/>
+          <p:cNvSpPr/>
+          <p:nvPr/>
+        </p:nvSpPr>
+        <p:spPr>
+          <a:xfrm>
+            <a:off x="969264" y="4297680"/>
+            <a:ext cx="3200400" cy="256032"/>
+          </a:xfrm>
+          <a:prstGeom prst="rect">
+            <a:avLst/>
+          </a:prstGeom>
+          <a:noFill/>
+          <a:ln/>
+        </p:spPr>
+        <p:txBody>
+          <a:bodyPr wrap="square" lIns="0" tIns="0" rIns="0" bIns="0" rtlCol="0" anchor="ctr"/>
+          <a:lstStyle/>
+          <a:p>
+            <a:pPr indent="0" marL="0">
+              <a:buNone/>
+            </a:pPr>
+            <a:r>
               <a:rPr lang="en-US" sz="1100" b="1" dirty="0">
                 <a:solidFill>
-                  <a:srgbClr val="FFFFFF"/>
-                </a:solidFill>
-                <a:latin typeface="Noto Sans KR" pitchFamily="34" charset="0"/>
-                <a:ea typeface="Noto Sans KR" pitchFamily="34" charset="-122"/>
-                <a:cs typeface="Noto Sans KR" pitchFamily="34" charset="-120"/>
-              </a:rPr>
-              <a:t>투입부터 판정·MES 전송·분리 배출까지  전 과정 무인 자동 운영  |  별도 인력 불필요</a:t>
+                  <a:srgbClr val="92400E"/>
+                </a:solidFill>
+                <a:latin typeface="Noto Sans KR" pitchFamily="34" charset="0"/>
+                <a:ea typeface="Noto Sans KR" pitchFamily="34" charset="-122"/>
+                <a:cs typeface="Noto Sans KR" pitchFamily="34" charset="-120"/>
+              </a:rPr>
+              <a:t>현장 검사 데이터 제공 협조 요청</a:t>
             </a:r>
             <a:endParaRPr lang="en-US" sz="1100" dirty="0"/>
+          </a:p>
+        </p:txBody>
+      </p:sp>
+      <p:sp>
+        <p:nvSpPr>
+          <p:cNvPr id="59" name="Text 57"/>
+          <p:cNvSpPr/>
+          <p:nvPr/>
+        </p:nvSpPr>
+        <p:spPr>
+          <a:xfrm>
+            <a:off x="969264" y="4535424"/>
+            <a:ext cx="7699248" cy="438912"/>
+          </a:xfrm>
+          <a:prstGeom prst="rect">
+            <a:avLst/>
+          </a:prstGeom>
+          <a:noFill/>
+          <a:ln/>
+        </p:spPr>
+        <p:txBody>
+          <a:bodyPr wrap="square" lIns="0" tIns="0" rIns="0" bIns="0" rtlCol="0" anchor="ctr"/>
+          <a:lstStyle/>
+          <a:p>
+            <a:pPr indent="0" marL="0">
+              <a:lnSpc>
+                <a:spcPct val="130000"/>
+              </a:lnSpc>
+              <a:buNone/>
+            </a:pPr>
+            <a:r>
+              <a:rPr lang="en-US" sz="900" dirty="0">
+                <a:solidFill>
+                  <a:srgbClr val="78350F"/>
+                </a:solidFill>
+                <a:latin typeface="Noto Sans KR" pitchFamily="34" charset="0"/>
+                <a:ea typeface="Noto Sans KR" pitchFamily="34" charset="-122"/>
+                <a:cs typeface="Noto Sans KR" pitchFamily="34" charset="-120"/>
+              </a:rPr>
+              <a:t>현재 검사원이 현장에서 판별한 양품·불량 결과 데이터를 AI 딥러닝 학습에 활용합니다. 현장 검사 이력(불량 유형, 판정 결과, 이미지)을 제공해 주시면 초기 학습 정확도를 높이고 도입 기간을 단축할 수 있습니다.</a:t>
+            </a:r>
+            <a:endParaRPr lang="en-US" sz="900" dirty="0"/>
+          </a:p>
+        </p:txBody>
+      </p:sp>
+      <p:sp>
+        <p:nvSpPr>
+          <p:cNvPr id="60" name="Shape 58"/>
+          <p:cNvSpPr/>
+          <p:nvPr/>
+        </p:nvSpPr>
+        <p:spPr>
+          <a:xfrm>
+            <a:off x="6217920" y="4334256"/>
+            <a:ext cx="2487168" cy="621792"/>
+          </a:xfrm>
+          <a:prstGeom prst="roundRect">
+            <a:avLst>
+              <a:gd name="adj" fmla="val 10294"/>
+            </a:avLst>
+          </a:prstGeom>
+          <a:solidFill>
+            <a:srgbClr val="FEF3C7"/>
+          </a:solidFill>
+          <a:ln w="12700">
+            <a:solidFill>
+              <a:srgbClr val="F59E0B"/>
+            </a:solidFill>
+            <a:prstDash val="solid"/>
+          </a:ln>
+          <a:effectLst>
+            <a:outerShdw sx="100000" sy="100000" kx="0" ky="0" algn="bl" rotWithShape="0" blurRad="50800" dist="25400" dir="16200000">
+              <a:srgbClr val="9CA3AF">
+                <a:alpha val="15000"/>
+              </a:srgbClr>
+            </a:outerShdw>
+          </a:effectLst>
+        </p:spPr>
+      </p:sp>
+      <p:sp>
+        <p:nvSpPr>
+          <p:cNvPr id="61" name="Text 59"/>
+          <p:cNvSpPr/>
+          <p:nvPr/>
+        </p:nvSpPr>
+        <p:spPr>
+          <a:xfrm>
+            <a:off x="6291072" y="4370832"/>
+            <a:ext cx="2377440" cy="219456"/>
+          </a:xfrm>
+          <a:prstGeom prst="rect">
+            <a:avLst/>
+          </a:prstGeom>
+          <a:noFill/>
+          <a:ln/>
+        </p:spPr>
+        <p:txBody>
+          <a:bodyPr wrap="square" lIns="0" tIns="0" rIns="0" bIns="0" rtlCol="0" anchor="ctr"/>
+          <a:lstStyle/>
+          <a:p>
+            <a:pPr indent="0" marL="0">
+              <a:buNone/>
+            </a:pPr>
+            <a:r>
+              <a:rPr lang="en-US" sz="900" b="1" dirty="0">
+                <a:solidFill>
+                  <a:srgbClr val="92400E"/>
+                </a:solidFill>
+                <a:latin typeface="Noto Sans KR" pitchFamily="34" charset="0"/>
+                <a:ea typeface="Noto Sans KR" pitchFamily="34" charset="-122"/>
+                <a:cs typeface="Noto Sans KR" pitchFamily="34" charset="-120"/>
+              </a:rPr>
+              <a:t>📋  요청 자료</a:t>
+            </a:r>
+            <a:endParaRPr lang="en-US" sz="900" dirty="0"/>
+          </a:p>
+        </p:txBody>
+      </p:sp>
+      <p:sp>
+        <p:nvSpPr>
+          <p:cNvPr id="62" name="Text 60"/>
+          <p:cNvSpPr/>
+          <p:nvPr/>
+        </p:nvSpPr>
+        <p:spPr>
+          <a:xfrm>
+            <a:off x="6291072" y="4553712"/>
+            <a:ext cx="2377440" cy="365760"/>
+          </a:xfrm>
+          <a:prstGeom prst="rect">
+            <a:avLst/>
+          </a:prstGeom>
+          <a:noFill/>
+          <a:ln/>
+        </p:spPr>
+        <p:txBody>
+          <a:bodyPr wrap="square" lIns="0" tIns="0" rIns="0" bIns="0" rtlCol="0" anchor="ctr"/>
+          <a:lstStyle/>
+          <a:p>
+            <a:pPr indent="0" marL="0">
+              <a:lnSpc>
+                <a:spcPct val="125000"/>
+              </a:lnSpc>
+              <a:buNone/>
+            </a:pPr>
+            <a:r>
+              <a:rPr lang="en-US" sz="800" dirty="0">
+                <a:solidFill>
+                  <a:srgbClr val="78350F"/>
+                </a:solidFill>
+                <a:latin typeface="Noto Sans KR" pitchFamily="34" charset="0"/>
+                <a:ea typeface="Noto Sans KR" pitchFamily="34" charset="-122"/>
+                <a:cs typeface="Noto Sans KR" pitchFamily="34" charset="-120"/>
+              </a:rPr>
+              <a:t>불량 유형별 이미지</a:t>
+            </a:r>
+            <a:endParaRPr lang="en-US" sz="800" dirty="0"/>
+          </a:p>
+          <a:p>
+            <a:pPr indent="0" marL="0">
+              <a:lnSpc>
+                <a:spcPct val="125000"/>
+              </a:lnSpc>
+              <a:buNone/>
+            </a:pPr>
+            <a:r>
+              <a:rPr lang="en-US" sz="800" dirty="0">
+                <a:solidFill>
+                  <a:srgbClr val="78350F"/>
+                </a:solidFill>
+                <a:latin typeface="Noto Sans KR" pitchFamily="34" charset="0"/>
+                <a:ea typeface="Noto Sans KR" pitchFamily="34" charset="-122"/>
+                <a:cs typeface="Noto Sans KR" pitchFamily="34" charset="-120"/>
+              </a:rPr>
+              <a:t>현장 판정 이력  |  양품 기준 샘플</a:t>
+            </a:r>
+            <a:endParaRPr lang="en-US" sz="800" dirty="0"/>
           </a:p>
         </p:txBody>
       </p:sp>

</xml_diff>

<commit_message>
Update winnercomb.pptx - add issues & discussion slide
</commit_message>
<xml_diff>
--- a/winnercomb.pptx
+++ b/winnercomb.pptx
@@ -16,9 +16,10 @@
     <p:sldId id="264" r:id="rId10"/>
     <p:sldId id="265" r:id="rId11"/>
     <p:sldId id="266" r:id="rId12"/>
+    <p:sldId id="267" r:id="rId13"/>
   </p:sldIdLst>
   <p:notesMasterIdLst>
-    <p:notesMasterId r:id="rId13"/>
+    <p:notesMasterId r:id="rId14"/>
   </p:notesMasterIdLst>
   <p:sldSz cx="9144000" cy="5143500"/>
   <p:notesSz cx="5143500" cy="9144000"/>
@@ -730,6 +731,94 @@
 </p:notes>
 </file>
 
+<file path=ppt/notesSlides/notesSlide12.xml><?xml version="1.0" encoding="utf-8"?>
+<p:notes xmlns:a="http://schemas.openxmlformats.org/drawingml/2006/main" xmlns:r="http://schemas.openxmlformats.org/officeDocument/2006/relationships" xmlns:p="http://schemas.openxmlformats.org/presentationml/2006/main">
+  <p:cSld>
+    <p:spTree>
+      <p:nvGrpSpPr>
+        <p:cNvPr id="1" name=""/>
+        <p:cNvGrpSpPr/>
+        <p:nvPr/>
+      </p:nvGrpSpPr>
+      <p:grpSpPr>
+        <a:xfrm>
+          <a:off x="0" y="0"/>
+          <a:ext cx="0" cy="0"/>
+          <a:chOff x="0" y="0"/>
+          <a:chExt cx="0" cy="0"/>
+        </a:xfrm>
+      </p:grpSpPr>
+      <p:sp>
+        <p:nvSpPr>
+          <p:cNvPr id="2" name="Slide Image Placeholder 1"/>
+          <p:cNvSpPr>
+            <a:spLocks noGrp="1" noRot="1" noChangeAspect="1"/>
+          </p:cNvSpPr>
+          <p:nvPr>
+            <p:ph type="sldImg"/>
+          </p:nvPr>
+        </p:nvSpPr>
+        <p:spPr/>
+      </p:sp>
+      <p:sp>
+        <p:nvSpPr>
+          <p:cNvPr id="3" name="Notes Placeholder 2"/>
+          <p:cNvSpPr>
+            <a:spLocks noGrp="1"/>
+          </p:cNvSpPr>
+          <p:nvPr>
+            <p:ph type="body" idx="1"/>
+          </p:nvPr>
+        </p:nvSpPr>
+        <p:spPr/>
+        <p:txBody>
+          <a:bodyPr/>
+          <a:lstStyle/>
+          <a:p>
+            <a:r>
+              <a:rPr lang="en-US" dirty="0"/>
+              <a:t/>
+            </a:r>
+            <a:endParaRPr lang="en-US" dirty="0"/>
+          </a:p>
+        </p:txBody>
+      </p:sp>
+      <p:sp>
+        <p:nvSpPr>
+          <p:cNvPr id="4" name="Slide Number Placeholder 3"/>
+          <p:cNvSpPr>
+            <a:spLocks noGrp="1"/>
+          </p:cNvSpPr>
+          <p:nvPr>
+            <p:ph type="sldNum" sz="quarter" idx="10"/>
+          </p:nvPr>
+        </p:nvSpPr>
+        <p:spPr/>
+        <p:txBody>
+          <a:bodyPr/>
+          <a:lstStyle/>
+          <a:p>
+            <a:fld id="{F7021451-1387-4CA6-816F-3879F97B5CBC}" type="slidenum">
+              <a:rPr lang="en-US"/>
+              <a:t>12</a:t>
+            </a:fld>
+            <a:endParaRPr lang="en-US"/>
+          </a:p>
+        </p:txBody>
+      </p:sp>
+    </p:spTree>
+    <p:extLst>
+      <p:ext uri="{BB962C8B-B14F-4D97-AF65-F5344CB8AC3E}">
+        <p14:creationId xmlns:p14="http://schemas.microsoft.com/office/powerpoint/2010/main" val="1024086991"/>
+      </p:ext>
+    </p:extLst>
+  </p:cSld>
+  <p:clrMapOvr>
+    <a:masterClrMapping/>
+  </p:clrMapOvr>
+</p:notes>
+</file>
+
 <file path=ppt/notesSlides/notesSlide2.xml><?xml version="1.0" encoding="utf-8"?>
 <p:notes xmlns:a="http://schemas.openxmlformats.org/drawingml/2006/main" xmlns:r="http://schemas.openxmlformats.org/officeDocument/2006/relationships" xmlns:p="http://schemas.openxmlformats.org/presentationml/2006/main">
   <p:cSld>
@@ -4726,6 +4815,1969 @@
             <a:avLst/>
           </a:prstGeom>
           <a:solidFill>
+            <a:srgbClr val="F8FAFC"/>
+          </a:solidFill>
+          <a:ln w="12700">
+            <a:solidFill>
+              <a:srgbClr val="F8FAFC"/>
+            </a:solidFill>
+            <a:prstDash val="solid"/>
+          </a:ln>
+        </p:spPr>
+      </p:sp>
+      <p:sp>
+        <p:nvSpPr>
+          <p:cNvPr id="3" name="Shape 1"/>
+          <p:cNvSpPr/>
+          <p:nvPr/>
+        </p:nvSpPr>
+        <p:spPr>
+          <a:xfrm>
+            <a:off x="0" y="0"/>
+            <a:ext cx="9144000" cy="1005840"/>
+          </a:xfrm>
+          <a:prstGeom prst="rect">
+            <a:avLst/>
+          </a:prstGeom>
+          <a:solidFill>
+            <a:srgbClr val="1B2F5E"/>
+          </a:solidFill>
+          <a:ln w="12700">
+            <a:solidFill>
+              <a:srgbClr val="1B2F5E"/>
+            </a:solidFill>
+            <a:prstDash val="solid"/>
+          </a:ln>
+        </p:spPr>
+      </p:sp>
+      <p:sp>
+        <p:nvSpPr>
+          <p:cNvPr id="4" name="Text 2"/>
+          <p:cNvSpPr/>
+          <p:nvPr/>
+        </p:nvSpPr>
+        <p:spPr>
+          <a:xfrm>
+            <a:off x="365760" y="237744"/>
+            <a:ext cx="8412480" cy="475488"/>
+          </a:xfrm>
+          <a:prstGeom prst="rect">
+            <a:avLst/>
+          </a:prstGeom>
+          <a:noFill/>
+          <a:ln/>
+        </p:spPr>
+        <p:txBody>
+          <a:bodyPr wrap="square" lIns="0" tIns="0" rIns="0" bIns="0" rtlCol="0" anchor="ctr"/>
+          <a:lstStyle/>
+          <a:p>
+            <a:pPr indent="0" marL="0">
+              <a:buNone/>
+            </a:pPr>
+            <a:r>
+              <a:rPr lang="en-US" sz="2200" b="1" dirty="0">
+                <a:solidFill>
+                  <a:srgbClr val="FFFFFF"/>
+                </a:solidFill>
+                <a:latin typeface="Noto Sans KR" pitchFamily="34" charset="0"/>
+                <a:ea typeface="Noto Sans KR" pitchFamily="34" charset="-122"/>
+                <a:cs typeface="Noto Sans KR" pitchFamily="34" charset="-120"/>
+              </a:rPr>
+              <a:t>예상 문제점 및 협의 사항</a:t>
+            </a:r>
+            <a:endParaRPr lang="en-US" sz="2200" dirty="0"/>
+          </a:p>
+        </p:txBody>
+      </p:sp>
+      <p:sp>
+        <p:nvSpPr>
+          <p:cNvPr id="5" name="Text 3"/>
+          <p:cNvSpPr/>
+          <p:nvPr/>
+        </p:nvSpPr>
+        <p:spPr>
+          <a:xfrm>
+            <a:off x="365760" y="713232"/>
+            <a:ext cx="8412480" cy="237744"/>
+          </a:xfrm>
+          <a:prstGeom prst="rect">
+            <a:avLst/>
+          </a:prstGeom>
+          <a:noFill/>
+          <a:ln/>
+        </p:spPr>
+        <p:txBody>
+          <a:bodyPr wrap="square" lIns="0" tIns="0" rIns="0" bIns="0" rtlCol="0" anchor="ctr"/>
+          <a:lstStyle/>
+          <a:p>
+            <a:pPr indent="0" marL="0">
+              <a:buNone/>
+            </a:pPr>
+            <a:r>
+              <a:rPr lang="en-US" sz="1050" dirty="0">
+                <a:solidFill>
+                  <a:srgbClr val="A5C4F3"/>
+                </a:solidFill>
+                <a:latin typeface="Noto Sans KR" pitchFamily="34" charset="0"/>
+                <a:ea typeface="Noto Sans KR" pitchFamily="34" charset="-122"/>
+                <a:cs typeface="Noto Sans KR" pitchFamily="34" charset="-120"/>
+              </a:rPr>
+              <a:t>현장 적용 전 사전 검토가 필요한 항목입니다</a:t>
+            </a:r>
+            <a:endParaRPr lang="en-US" sz="1050" dirty="0"/>
+          </a:p>
+        </p:txBody>
+      </p:sp>
+      <p:sp>
+        <p:nvSpPr>
+          <p:cNvPr id="6" name="Shape 4"/>
+          <p:cNvSpPr/>
+          <p:nvPr/>
+        </p:nvSpPr>
+        <p:spPr>
+          <a:xfrm>
+            <a:off x="365760" y="1078992"/>
+            <a:ext cx="8412480" cy="749808"/>
+          </a:xfrm>
+          <a:prstGeom prst="roundRect">
+            <a:avLst>
+              <a:gd name="adj" fmla="val 8537"/>
+            </a:avLst>
+          </a:prstGeom>
+          <a:solidFill>
+            <a:srgbClr val="FFFFFF"/>
+          </a:solidFill>
+          <a:ln w="12700">
+            <a:solidFill>
+              <a:srgbClr val="2563EB"/>
+            </a:solidFill>
+            <a:prstDash val="solid"/>
+          </a:ln>
+          <a:effectLst>
+            <a:outerShdw sx="100000" sy="100000" kx="0" ky="0" algn="bl" rotWithShape="0" blurRad="50800" dist="25400" dir="16200000">
+              <a:srgbClr val="9CA3AF">
+                <a:alpha val="15000"/>
+              </a:srgbClr>
+            </a:outerShdw>
+          </a:effectLst>
+        </p:spPr>
+      </p:sp>
+      <p:sp>
+        <p:nvSpPr>
+          <p:cNvPr id="7" name="Shape 5"/>
+          <p:cNvSpPr/>
+          <p:nvPr/>
+        </p:nvSpPr>
+        <p:spPr>
+          <a:xfrm>
+            <a:off x="365760" y="1078992"/>
+            <a:ext cx="475488" cy="749808"/>
+          </a:xfrm>
+          <a:prstGeom prst="roundRect">
+            <a:avLst>
+              <a:gd name="adj" fmla="val 11538"/>
+            </a:avLst>
+          </a:prstGeom>
+          <a:solidFill>
+            <a:srgbClr val="2563EB"/>
+          </a:solidFill>
+          <a:ln w="12700">
+            <a:solidFill>
+              <a:srgbClr val="2563EB"/>
+            </a:solidFill>
+            <a:prstDash val="solid"/>
+          </a:ln>
+        </p:spPr>
+      </p:sp>
+      <p:sp>
+        <p:nvSpPr>
+          <p:cNvPr id="8" name="Text 6"/>
+          <p:cNvSpPr/>
+          <p:nvPr/>
+        </p:nvSpPr>
+        <p:spPr>
+          <a:xfrm>
+            <a:off x="365760" y="1078992"/>
+            <a:ext cx="475488" cy="749808"/>
+          </a:xfrm>
+          <a:prstGeom prst="rect">
+            <a:avLst/>
+          </a:prstGeom>
+          <a:noFill/>
+          <a:ln/>
+        </p:spPr>
+        <p:txBody>
+          <a:bodyPr wrap="square" lIns="0" tIns="0" rIns="0" bIns="0" rtlCol="0" anchor="ctr"/>
+          <a:lstStyle/>
+          <a:p>
+            <a:pPr algn="ctr" indent="0" marL="0">
+              <a:buNone/>
+            </a:pPr>
+            <a:r>
+              <a:rPr lang="en-US" sz="1100" b="1" dirty="0">
+                <a:solidFill>
+                  <a:srgbClr val="FFFFFF"/>
+                </a:solidFill>
+                <a:latin typeface="Noto Sans KR" pitchFamily="34" charset="0"/>
+                <a:ea typeface="Noto Sans KR" pitchFamily="34" charset="-122"/>
+                <a:cs typeface="Noto Sans KR" pitchFamily="34" charset="-120"/>
+              </a:rPr>
+              <a:t>01</a:t>
+            </a:r>
+            <a:endParaRPr lang="en-US" sz="1100" dirty="0"/>
+          </a:p>
+        </p:txBody>
+      </p:sp>
+      <p:sp>
+        <p:nvSpPr>
+          <p:cNvPr id="9" name="Shape 7"/>
+          <p:cNvSpPr/>
+          <p:nvPr/>
+        </p:nvSpPr>
+        <p:spPr>
+          <a:xfrm>
+            <a:off x="914400" y="1152144"/>
+            <a:ext cx="658368" cy="182880"/>
+          </a:xfrm>
+          <a:prstGeom prst="roundRect">
+            <a:avLst>
+              <a:gd name="adj" fmla="val 20000"/>
+            </a:avLst>
+          </a:prstGeom>
+          <a:solidFill>
+            <a:srgbClr val="DBEAFE"/>
+          </a:solidFill>
+          <a:ln w="6350">
+            <a:solidFill>
+              <a:srgbClr val="2563EB"/>
+            </a:solidFill>
+            <a:prstDash val="solid"/>
+          </a:ln>
+        </p:spPr>
+      </p:sp>
+      <p:sp>
+        <p:nvSpPr>
+          <p:cNvPr id="10" name="Text 8"/>
+          <p:cNvSpPr/>
+          <p:nvPr/>
+        </p:nvSpPr>
+        <p:spPr>
+          <a:xfrm>
+            <a:off x="914400" y="1152144"/>
+            <a:ext cx="658368" cy="182880"/>
+          </a:xfrm>
+          <a:prstGeom prst="rect">
+            <a:avLst/>
+          </a:prstGeom>
+          <a:noFill/>
+          <a:ln/>
+        </p:spPr>
+        <p:txBody>
+          <a:bodyPr wrap="square" lIns="0" tIns="0" rIns="0" bIns="0" rtlCol="0" anchor="ctr"/>
+          <a:lstStyle/>
+          <a:p>
+            <a:pPr algn="ctr" indent="0" marL="0">
+              <a:buNone/>
+            </a:pPr>
+            <a:r>
+              <a:rPr lang="en-US" sz="650" b="1" dirty="0">
+                <a:solidFill>
+                  <a:srgbClr val="2563EB"/>
+                </a:solidFill>
+                <a:latin typeface="Noto Sans KR" pitchFamily="34" charset="0"/>
+                <a:ea typeface="Noto Sans KR" pitchFamily="34" charset="-122"/>
+                <a:cs typeface="Noto Sans KR" pitchFamily="34" charset="-120"/>
+              </a:rPr>
+              <a:t>기구·지그</a:t>
+            </a:r>
+            <a:endParaRPr lang="en-US" sz="650" dirty="0"/>
+          </a:p>
+        </p:txBody>
+      </p:sp>
+      <p:sp>
+        <p:nvSpPr>
+          <p:cNvPr id="11" name="Text 9"/>
+          <p:cNvSpPr/>
+          <p:nvPr/>
+        </p:nvSpPr>
+        <p:spPr>
+          <a:xfrm>
+            <a:off x="914400" y="1353312"/>
+            <a:ext cx="4846320" cy="237744"/>
+          </a:xfrm>
+          <a:prstGeom prst="rect">
+            <a:avLst/>
+          </a:prstGeom>
+          <a:noFill/>
+          <a:ln/>
+        </p:spPr>
+        <p:txBody>
+          <a:bodyPr wrap="square" lIns="0" tIns="0" rIns="0" bIns="0" rtlCol="0" anchor="ctr"/>
+          <a:lstStyle/>
+          <a:p>
+            <a:pPr indent="0" marL="0">
+              <a:buNone/>
+            </a:pPr>
+            <a:r>
+              <a:rPr lang="en-US" sz="950" b="1" dirty="0">
+                <a:solidFill>
+                  <a:srgbClr val="1B2F5E"/>
+                </a:solidFill>
+                <a:latin typeface="Noto Sans KR" pitchFamily="34" charset="0"/>
+                <a:ea typeface="Noto Sans KR" pitchFamily="34" charset="-122"/>
+                <a:cs typeface="Noto Sans KR" pitchFamily="34" charset="-120"/>
+              </a:rPr>
+              <a:t>PCB 연결 케이블 형태 균일화 및 바코드 위치 표준화</a:t>
+            </a:r>
+            <a:endParaRPr lang="en-US" sz="950" dirty="0"/>
+          </a:p>
+        </p:txBody>
+      </p:sp>
+      <p:sp>
+        <p:nvSpPr>
+          <p:cNvPr id="12" name="Text 10"/>
+          <p:cNvSpPr/>
+          <p:nvPr/>
+        </p:nvSpPr>
+        <p:spPr>
+          <a:xfrm>
+            <a:off x="914400" y="1572768"/>
+            <a:ext cx="4846320" cy="237744"/>
+          </a:xfrm>
+          <a:prstGeom prst="rect">
+            <a:avLst/>
+          </a:prstGeom>
+          <a:noFill/>
+          <a:ln/>
+        </p:spPr>
+        <p:txBody>
+          <a:bodyPr wrap="square" lIns="0" tIns="0" rIns="0" bIns="0" rtlCol="0" anchor="ctr"/>
+          <a:lstStyle/>
+          <a:p>
+            <a:pPr indent="0" marL="0">
+              <a:lnSpc>
+                <a:spcPct val="110000"/>
+              </a:lnSpc>
+              <a:buNone/>
+            </a:pPr>
+            <a:r>
+              <a:rPr lang="en-US" sz="750" dirty="0">
+                <a:solidFill>
+                  <a:srgbClr val="475569"/>
+                </a:solidFill>
+                <a:latin typeface="Noto Sans KR" pitchFamily="34" charset="0"/>
+                <a:ea typeface="Noto Sans KR" pitchFamily="34" charset="-122"/>
+                <a:cs typeface="Noto Sans KR" pitchFamily="34" charset="-120"/>
+              </a:rPr>
+              <a:t>케이블이 PCB와 연결된 상태에서 형태가 일정하지 않으면 지그 안착 불량 및 촬영 위치 오차가 발생할 수 있습니다. 또한 바코드 부착 위치가 개체마다 다를 경우 고정식 스캐너 인식률이 저하됩니다.</a:t>
+            </a:r>
+            <a:endParaRPr lang="en-US" sz="750" dirty="0"/>
+          </a:p>
+        </p:txBody>
+      </p:sp>
+      <p:sp>
+        <p:nvSpPr>
+          <p:cNvPr id="13" name="Shape 11"/>
+          <p:cNvSpPr/>
+          <p:nvPr/>
+        </p:nvSpPr>
+        <p:spPr>
+          <a:xfrm>
+            <a:off x="5504688" y="1133856"/>
+            <a:ext cx="3200400" cy="640080"/>
+          </a:xfrm>
+          <a:prstGeom prst="roundRect">
+            <a:avLst>
+              <a:gd name="adj" fmla="val 10000"/>
+            </a:avLst>
+          </a:prstGeom>
+          <a:solidFill>
+            <a:srgbClr val="DBEAFE"/>
+          </a:solidFill>
+          <a:ln w="12700">
+            <a:solidFill>
+              <a:srgbClr val="DBEAFE"/>
+            </a:solidFill>
+            <a:prstDash val="solid"/>
+          </a:ln>
+          <a:effectLst>
+            <a:outerShdw sx="100000" sy="100000" kx="0" ky="0" algn="bl" rotWithShape="0" blurRad="50800" dist="25400" dir="16200000">
+              <a:srgbClr val="9CA3AF">
+                <a:alpha val="15000"/>
+              </a:srgbClr>
+            </a:outerShdw>
+          </a:effectLst>
+        </p:spPr>
+      </p:sp>
+      <p:sp>
+        <p:nvSpPr>
+          <p:cNvPr id="14" name="Text 12"/>
+          <p:cNvSpPr/>
+          <p:nvPr/>
+        </p:nvSpPr>
+        <p:spPr>
+          <a:xfrm>
+            <a:off x="5577840" y="1152144"/>
+            <a:ext cx="3090672" cy="182880"/>
+          </a:xfrm>
+          <a:prstGeom prst="rect">
+            <a:avLst/>
+          </a:prstGeom>
+          <a:noFill/>
+          <a:ln/>
+        </p:spPr>
+        <p:txBody>
+          <a:bodyPr wrap="square" lIns="0" tIns="0" rIns="0" bIns="0" rtlCol="0" anchor="ctr"/>
+          <a:lstStyle/>
+          <a:p>
+            <a:pPr indent="0" marL="0">
+              <a:buNone/>
+            </a:pPr>
+            <a:r>
+              <a:rPr lang="en-US" sz="750" b="1" dirty="0">
+                <a:solidFill>
+                  <a:srgbClr val="2563EB"/>
+                </a:solidFill>
+                <a:latin typeface="Noto Sans KR" pitchFamily="34" charset="0"/>
+                <a:ea typeface="Noto Sans KR" pitchFamily="34" charset="-122"/>
+                <a:cs typeface="Noto Sans KR" pitchFamily="34" charset="-120"/>
+              </a:rPr>
+              <a:t>💬 협의 요청</a:t>
+            </a:r>
+            <a:endParaRPr lang="en-US" sz="750" dirty="0"/>
+          </a:p>
+        </p:txBody>
+      </p:sp>
+      <p:sp>
+        <p:nvSpPr>
+          <p:cNvPr id="15" name="Text 13"/>
+          <p:cNvSpPr/>
+          <p:nvPr/>
+        </p:nvSpPr>
+        <p:spPr>
+          <a:xfrm>
+            <a:off x="5577840" y="1335024"/>
+            <a:ext cx="3090672" cy="438912"/>
+          </a:xfrm>
+          <a:prstGeom prst="rect">
+            <a:avLst/>
+          </a:prstGeom>
+          <a:noFill/>
+          <a:ln/>
+        </p:spPr>
+        <p:txBody>
+          <a:bodyPr wrap="square" lIns="0" tIns="0" rIns="0" bIns="0" rtlCol="0" anchor="ctr"/>
+          <a:lstStyle/>
+          <a:p>
+            <a:pPr indent="0" marL="0">
+              <a:lnSpc>
+                <a:spcPct val="120000"/>
+              </a:lnSpc>
+              <a:buNone/>
+            </a:pPr>
+            <a:r>
+              <a:rPr lang="en-US" sz="850" dirty="0">
+                <a:solidFill>
+                  <a:srgbClr val="1E293B"/>
+                </a:solidFill>
+                <a:latin typeface="Noto Sans KR" pitchFamily="34" charset="0"/>
+                <a:ea typeface="Noto Sans KR" pitchFamily="34" charset="-122"/>
+                <a:cs typeface="Noto Sans KR" pitchFamily="34" charset="-120"/>
+              </a:rPr>
+              <a:t>케이블 정형화 가능 여부 및 바코드 부착 위치 표준화 협의</a:t>
+            </a:r>
+            <a:endParaRPr lang="en-US" sz="850" dirty="0"/>
+          </a:p>
+        </p:txBody>
+      </p:sp>
+      <p:sp>
+        <p:nvSpPr>
+          <p:cNvPr id="16" name="Shape 14"/>
+          <p:cNvSpPr/>
+          <p:nvPr/>
+        </p:nvSpPr>
+        <p:spPr>
+          <a:xfrm>
+            <a:off x="365760" y="1879092"/>
+            <a:ext cx="8412480" cy="749808"/>
+          </a:xfrm>
+          <a:prstGeom prst="roundRect">
+            <a:avLst>
+              <a:gd name="adj" fmla="val 8537"/>
+            </a:avLst>
+          </a:prstGeom>
+          <a:solidFill>
+            <a:srgbClr val="FFFFFF"/>
+          </a:solidFill>
+          <a:ln w="12700">
+            <a:solidFill>
+              <a:srgbClr val="7C3AED"/>
+            </a:solidFill>
+            <a:prstDash val="solid"/>
+          </a:ln>
+          <a:effectLst>
+            <a:outerShdw sx="100000" sy="100000" kx="0" ky="0" algn="bl" rotWithShape="0" blurRad="50800" dist="25400" dir="16200000">
+              <a:srgbClr val="9CA3AF">
+                <a:alpha val="15000"/>
+              </a:srgbClr>
+            </a:outerShdw>
+          </a:effectLst>
+        </p:spPr>
+      </p:sp>
+      <p:sp>
+        <p:nvSpPr>
+          <p:cNvPr id="17" name="Shape 15"/>
+          <p:cNvSpPr/>
+          <p:nvPr/>
+        </p:nvSpPr>
+        <p:spPr>
+          <a:xfrm>
+            <a:off x="365760" y="1879092"/>
+            <a:ext cx="475488" cy="749808"/>
+          </a:xfrm>
+          <a:prstGeom prst="roundRect">
+            <a:avLst>
+              <a:gd name="adj" fmla="val 11538"/>
+            </a:avLst>
+          </a:prstGeom>
+          <a:solidFill>
+            <a:srgbClr val="7C3AED"/>
+          </a:solidFill>
+          <a:ln w="12700">
+            <a:solidFill>
+              <a:srgbClr val="7C3AED"/>
+            </a:solidFill>
+            <a:prstDash val="solid"/>
+          </a:ln>
+        </p:spPr>
+      </p:sp>
+      <p:sp>
+        <p:nvSpPr>
+          <p:cNvPr id="18" name="Text 16"/>
+          <p:cNvSpPr/>
+          <p:nvPr/>
+        </p:nvSpPr>
+        <p:spPr>
+          <a:xfrm>
+            <a:off x="365760" y="1879092"/>
+            <a:ext cx="475488" cy="749808"/>
+          </a:xfrm>
+          <a:prstGeom prst="rect">
+            <a:avLst/>
+          </a:prstGeom>
+          <a:noFill/>
+          <a:ln/>
+        </p:spPr>
+        <p:txBody>
+          <a:bodyPr wrap="square" lIns="0" tIns="0" rIns="0" bIns="0" rtlCol="0" anchor="ctr"/>
+          <a:lstStyle/>
+          <a:p>
+            <a:pPr algn="ctr" indent="0" marL="0">
+              <a:buNone/>
+            </a:pPr>
+            <a:r>
+              <a:rPr lang="en-US" sz="1100" b="1" dirty="0">
+                <a:solidFill>
+                  <a:srgbClr val="FFFFFF"/>
+                </a:solidFill>
+                <a:latin typeface="Noto Sans KR" pitchFamily="34" charset="0"/>
+                <a:ea typeface="Noto Sans KR" pitchFamily="34" charset="-122"/>
+                <a:cs typeface="Noto Sans KR" pitchFamily="34" charset="-120"/>
+              </a:rPr>
+              <a:t>02</a:t>
+            </a:r>
+            <a:endParaRPr lang="en-US" sz="1100" dirty="0"/>
+          </a:p>
+        </p:txBody>
+      </p:sp>
+      <p:sp>
+        <p:nvSpPr>
+          <p:cNvPr id="19" name="Shape 17"/>
+          <p:cNvSpPr/>
+          <p:nvPr/>
+        </p:nvSpPr>
+        <p:spPr>
+          <a:xfrm>
+            <a:off x="914400" y="1952244"/>
+            <a:ext cx="658368" cy="182880"/>
+          </a:xfrm>
+          <a:prstGeom prst="roundRect">
+            <a:avLst>
+              <a:gd name="adj" fmla="val 20000"/>
+            </a:avLst>
+          </a:prstGeom>
+          <a:solidFill>
+            <a:srgbClr val="EDE9FE"/>
+          </a:solidFill>
+          <a:ln w="6350">
+            <a:solidFill>
+              <a:srgbClr val="7C3AED"/>
+            </a:solidFill>
+            <a:prstDash val="solid"/>
+          </a:ln>
+        </p:spPr>
+      </p:sp>
+      <p:sp>
+        <p:nvSpPr>
+          <p:cNvPr id="20" name="Text 18"/>
+          <p:cNvSpPr/>
+          <p:nvPr/>
+        </p:nvSpPr>
+        <p:spPr>
+          <a:xfrm>
+            <a:off x="914400" y="1952244"/>
+            <a:ext cx="658368" cy="182880"/>
+          </a:xfrm>
+          <a:prstGeom prst="rect">
+            <a:avLst/>
+          </a:prstGeom>
+          <a:noFill/>
+          <a:ln/>
+        </p:spPr>
+        <p:txBody>
+          <a:bodyPr wrap="square" lIns="0" tIns="0" rIns="0" bIns="0" rtlCol="0" anchor="ctr"/>
+          <a:lstStyle/>
+          <a:p>
+            <a:pPr algn="ctr" indent="0" marL="0">
+              <a:buNone/>
+            </a:pPr>
+            <a:r>
+              <a:rPr lang="en-US" sz="650" b="1" dirty="0">
+                <a:solidFill>
+                  <a:srgbClr val="7C3AED"/>
+                </a:solidFill>
+                <a:latin typeface="Noto Sans KR" pitchFamily="34" charset="0"/>
+                <a:ea typeface="Noto Sans KR" pitchFamily="34" charset="-122"/>
+                <a:cs typeface="Noto Sans KR" pitchFamily="34" charset="-120"/>
+              </a:rPr>
+              <a:t>지그 운용</a:t>
+            </a:r>
+            <a:endParaRPr lang="en-US" sz="650" dirty="0"/>
+          </a:p>
+        </p:txBody>
+      </p:sp>
+      <p:sp>
+        <p:nvSpPr>
+          <p:cNvPr id="21" name="Text 19"/>
+          <p:cNvSpPr/>
+          <p:nvPr/>
+        </p:nvSpPr>
+        <p:spPr>
+          <a:xfrm>
+            <a:off x="914400" y="2153412"/>
+            <a:ext cx="4846320" cy="237744"/>
+          </a:xfrm>
+          <a:prstGeom prst="rect">
+            <a:avLst/>
+          </a:prstGeom>
+          <a:noFill/>
+          <a:ln/>
+        </p:spPr>
+        <p:txBody>
+          <a:bodyPr wrap="square" lIns="0" tIns="0" rIns="0" bIns="0" rtlCol="0" anchor="ctr"/>
+          <a:lstStyle/>
+          <a:p>
+            <a:pPr indent="0" marL="0">
+              <a:buNone/>
+            </a:pPr>
+            <a:r>
+              <a:rPr lang="en-US" sz="950" b="1" dirty="0">
+                <a:solidFill>
+                  <a:srgbClr val="1B2F5E"/>
+                </a:solidFill>
+                <a:latin typeface="Noto Sans KR" pitchFamily="34" charset="0"/>
+                <a:ea typeface="Noto Sans KR" pitchFamily="34" charset="-122"/>
+                <a:cs typeface="Noto Sans KR" pitchFamily="34" charset="-120"/>
+              </a:rPr>
+              <a:t>흐름 라인에서 안착 지그 회수 방법</a:t>
+            </a:r>
+            <a:endParaRPr lang="en-US" sz="950" dirty="0"/>
+          </a:p>
+        </p:txBody>
+      </p:sp>
+      <p:sp>
+        <p:nvSpPr>
+          <p:cNvPr id="22" name="Text 20"/>
+          <p:cNvSpPr/>
+          <p:nvPr/>
+        </p:nvSpPr>
+        <p:spPr>
+          <a:xfrm>
+            <a:off x="914400" y="2372868"/>
+            <a:ext cx="4846320" cy="237744"/>
+          </a:xfrm>
+          <a:prstGeom prst="rect">
+            <a:avLst/>
+          </a:prstGeom>
+          <a:noFill/>
+          <a:ln/>
+        </p:spPr>
+        <p:txBody>
+          <a:bodyPr wrap="square" lIns="0" tIns="0" rIns="0" bIns="0" rtlCol="0" anchor="ctr"/>
+          <a:lstStyle/>
+          <a:p>
+            <a:pPr indent="0" marL="0">
+              <a:lnSpc>
+                <a:spcPct val="110000"/>
+              </a:lnSpc>
+              <a:buNone/>
+            </a:pPr>
+            <a:r>
+              <a:rPr lang="en-US" sz="750" dirty="0">
+                <a:solidFill>
+                  <a:srgbClr val="475569"/>
+                </a:solidFill>
+                <a:latin typeface="Noto Sans KR" pitchFamily="34" charset="0"/>
+                <a:ea typeface="Noto Sans KR" pitchFamily="34" charset="-122"/>
+                <a:cs typeface="Noto Sans KR" pitchFamily="34" charset="-120"/>
+              </a:rPr>
+              <a:t>컨베어 타입 흐름 라인에 지그를 투입할 경우 검사 완료 후 지그를 투입 위치로 회수하는 방법이 필요합니다. 지그 미회수 시 라인 정체 및 추가 지그 소요 비용이 발생합니다.</a:t>
+            </a:r>
+            <a:endParaRPr lang="en-US" sz="750" dirty="0"/>
+          </a:p>
+        </p:txBody>
+      </p:sp>
+      <p:sp>
+        <p:nvSpPr>
+          <p:cNvPr id="23" name="Shape 21"/>
+          <p:cNvSpPr/>
+          <p:nvPr/>
+        </p:nvSpPr>
+        <p:spPr>
+          <a:xfrm>
+            <a:off x="5504688" y="1933956"/>
+            <a:ext cx="3200400" cy="640080"/>
+          </a:xfrm>
+          <a:prstGeom prst="roundRect">
+            <a:avLst>
+              <a:gd name="adj" fmla="val 10000"/>
+            </a:avLst>
+          </a:prstGeom>
+          <a:solidFill>
+            <a:srgbClr val="EDE9FE"/>
+          </a:solidFill>
+          <a:ln w="12700">
+            <a:solidFill>
+              <a:srgbClr val="EDE9FE"/>
+            </a:solidFill>
+            <a:prstDash val="solid"/>
+          </a:ln>
+          <a:effectLst>
+            <a:outerShdw sx="100000" sy="100000" kx="0" ky="0" algn="bl" rotWithShape="0" blurRad="50800" dist="25400" dir="16200000">
+              <a:srgbClr val="9CA3AF">
+                <a:alpha val="15000"/>
+              </a:srgbClr>
+            </a:outerShdw>
+          </a:effectLst>
+        </p:spPr>
+      </p:sp>
+      <p:sp>
+        <p:nvSpPr>
+          <p:cNvPr id="24" name="Text 22"/>
+          <p:cNvSpPr/>
+          <p:nvPr/>
+        </p:nvSpPr>
+        <p:spPr>
+          <a:xfrm>
+            <a:off x="5577840" y="1952244"/>
+            <a:ext cx="3090672" cy="182880"/>
+          </a:xfrm>
+          <a:prstGeom prst="rect">
+            <a:avLst/>
+          </a:prstGeom>
+          <a:noFill/>
+          <a:ln/>
+        </p:spPr>
+        <p:txBody>
+          <a:bodyPr wrap="square" lIns="0" tIns="0" rIns="0" bIns="0" rtlCol="0" anchor="ctr"/>
+          <a:lstStyle/>
+          <a:p>
+            <a:pPr indent="0" marL="0">
+              <a:buNone/>
+            </a:pPr>
+            <a:r>
+              <a:rPr lang="en-US" sz="750" b="1" dirty="0">
+                <a:solidFill>
+                  <a:srgbClr val="7C3AED"/>
+                </a:solidFill>
+                <a:latin typeface="Noto Sans KR" pitchFamily="34" charset="0"/>
+                <a:ea typeface="Noto Sans KR" pitchFamily="34" charset="-122"/>
+                <a:cs typeface="Noto Sans KR" pitchFamily="34" charset="-120"/>
+              </a:rPr>
+              <a:t>💬 협의 요청</a:t>
+            </a:r>
+            <a:endParaRPr lang="en-US" sz="750" dirty="0"/>
+          </a:p>
+        </p:txBody>
+      </p:sp>
+      <p:sp>
+        <p:nvSpPr>
+          <p:cNvPr id="25" name="Text 23"/>
+          <p:cNvSpPr/>
+          <p:nvPr/>
+        </p:nvSpPr>
+        <p:spPr>
+          <a:xfrm>
+            <a:off x="5577840" y="2135124"/>
+            <a:ext cx="3090672" cy="438912"/>
+          </a:xfrm>
+          <a:prstGeom prst="rect">
+            <a:avLst/>
+          </a:prstGeom>
+          <a:noFill/>
+          <a:ln/>
+        </p:spPr>
+        <p:txBody>
+          <a:bodyPr wrap="square" lIns="0" tIns="0" rIns="0" bIns="0" rtlCol="0" anchor="ctr"/>
+          <a:lstStyle/>
+          <a:p>
+            <a:pPr indent="0" marL="0">
+              <a:lnSpc>
+                <a:spcPct val="120000"/>
+              </a:lnSpc>
+              <a:buNone/>
+            </a:pPr>
+            <a:r>
+              <a:rPr lang="en-US" sz="850" dirty="0">
+                <a:solidFill>
+                  <a:srgbClr val="1E293B"/>
+                </a:solidFill>
+                <a:latin typeface="Noto Sans KR" pitchFamily="34" charset="0"/>
+                <a:ea typeface="Noto Sans KR" pitchFamily="34" charset="-122"/>
+                <a:cs typeface="Noto Sans KR" pitchFamily="34" charset="-120"/>
+              </a:rPr>
+              <a:t>지그 회수 방식(수동 회수 / 자동 리턴 구조) 및 지그 수량 협의</a:t>
+            </a:r>
+            <a:endParaRPr lang="en-US" sz="850" dirty="0"/>
+          </a:p>
+        </p:txBody>
+      </p:sp>
+      <p:sp>
+        <p:nvSpPr>
+          <p:cNvPr id="26" name="Shape 24"/>
+          <p:cNvSpPr/>
+          <p:nvPr/>
+        </p:nvSpPr>
+        <p:spPr>
+          <a:xfrm>
+            <a:off x="365760" y="2679192"/>
+            <a:ext cx="8412480" cy="749808"/>
+          </a:xfrm>
+          <a:prstGeom prst="roundRect">
+            <a:avLst>
+              <a:gd name="adj" fmla="val 8537"/>
+            </a:avLst>
+          </a:prstGeom>
+          <a:solidFill>
+            <a:srgbClr val="FFFFFF"/>
+          </a:solidFill>
+          <a:ln w="12700">
+            <a:solidFill>
+              <a:srgbClr val="0D9488"/>
+            </a:solidFill>
+            <a:prstDash val="solid"/>
+          </a:ln>
+          <a:effectLst>
+            <a:outerShdw sx="100000" sy="100000" kx="0" ky="0" algn="bl" rotWithShape="0" blurRad="50800" dist="25400" dir="16200000">
+              <a:srgbClr val="9CA3AF">
+                <a:alpha val="15000"/>
+              </a:srgbClr>
+            </a:outerShdw>
+          </a:effectLst>
+        </p:spPr>
+      </p:sp>
+      <p:sp>
+        <p:nvSpPr>
+          <p:cNvPr id="27" name="Shape 25"/>
+          <p:cNvSpPr/>
+          <p:nvPr/>
+        </p:nvSpPr>
+        <p:spPr>
+          <a:xfrm>
+            <a:off x="365760" y="2679192"/>
+            <a:ext cx="475488" cy="749808"/>
+          </a:xfrm>
+          <a:prstGeom prst="roundRect">
+            <a:avLst>
+              <a:gd name="adj" fmla="val 11538"/>
+            </a:avLst>
+          </a:prstGeom>
+          <a:solidFill>
+            <a:srgbClr val="0D9488"/>
+          </a:solidFill>
+          <a:ln w="12700">
+            <a:solidFill>
+              <a:srgbClr val="0D9488"/>
+            </a:solidFill>
+            <a:prstDash val="solid"/>
+          </a:ln>
+        </p:spPr>
+      </p:sp>
+      <p:sp>
+        <p:nvSpPr>
+          <p:cNvPr id="28" name="Text 26"/>
+          <p:cNvSpPr/>
+          <p:nvPr/>
+        </p:nvSpPr>
+        <p:spPr>
+          <a:xfrm>
+            <a:off x="365760" y="2679192"/>
+            <a:ext cx="475488" cy="749808"/>
+          </a:xfrm>
+          <a:prstGeom prst="rect">
+            <a:avLst/>
+          </a:prstGeom>
+          <a:noFill/>
+          <a:ln/>
+        </p:spPr>
+        <p:txBody>
+          <a:bodyPr wrap="square" lIns="0" tIns="0" rIns="0" bIns="0" rtlCol="0" anchor="ctr"/>
+          <a:lstStyle/>
+          <a:p>
+            <a:pPr algn="ctr" indent="0" marL="0">
+              <a:buNone/>
+            </a:pPr>
+            <a:r>
+              <a:rPr lang="en-US" sz="1100" b="1" dirty="0">
+                <a:solidFill>
+                  <a:srgbClr val="FFFFFF"/>
+                </a:solidFill>
+                <a:latin typeface="Noto Sans KR" pitchFamily="34" charset="0"/>
+                <a:ea typeface="Noto Sans KR" pitchFamily="34" charset="-122"/>
+                <a:cs typeface="Noto Sans KR" pitchFamily="34" charset="-120"/>
+              </a:rPr>
+              <a:t>03</a:t>
+            </a:r>
+            <a:endParaRPr lang="en-US" sz="1100" dirty="0"/>
+          </a:p>
+        </p:txBody>
+      </p:sp>
+      <p:sp>
+        <p:nvSpPr>
+          <p:cNvPr id="29" name="Shape 27"/>
+          <p:cNvSpPr/>
+          <p:nvPr/>
+        </p:nvSpPr>
+        <p:spPr>
+          <a:xfrm>
+            <a:off x="914400" y="2752344"/>
+            <a:ext cx="658368" cy="182880"/>
+          </a:xfrm>
+          <a:prstGeom prst="roundRect">
+            <a:avLst>
+              <a:gd name="adj" fmla="val 20000"/>
+            </a:avLst>
+          </a:prstGeom>
+          <a:solidFill>
+            <a:srgbClr val="CCFBF1"/>
+          </a:solidFill>
+          <a:ln w="6350">
+            <a:solidFill>
+              <a:srgbClr val="0D9488"/>
+            </a:solidFill>
+            <a:prstDash val="solid"/>
+          </a:ln>
+        </p:spPr>
+      </p:sp>
+      <p:sp>
+        <p:nvSpPr>
+          <p:cNvPr id="30" name="Text 28"/>
+          <p:cNvSpPr/>
+          <p:nvPr/>
+        </p:nvSpPr>
+        <p:spPr>
+          <a:xfrm>
+            <a:off x="914400" y="2752344"/>
+            <a:ext cx="658368" cy="182880"/>
+          </a:xfrm>
+          <a:prstGeom prst="rect">
+            <a:avLst/>
+          </a:prstGeom>
+          <a:noFill/>
+          <a:ln/>
+        </p:spPr>
+        <p:txBody>
+          <a:bodyPr wrap="square" lIns="0" tIns="0" rIns="0" bIns="0" rtlCol="0" anchor="ctr"/>
+          <a:lstStyle/>
+          <a:p>
+            <a:pPr algn="ctr" indent="0" marL="0">
+              <a:buNone/>
+            </a:pPr>
+            <a:r>
+              <a:rPr lang="en-US" sz="650" b="1" dirty="0">
+                <a:solidFill>
+                  <a:srgbClr val="0D9488"/>
+                </a:solidFill>
+                <a:latin typeface="Noto Sans KR" pitchFamily="34" charset="0"/>
+                <a:ea typeface="Noto Sans KR" pitchFamily="34" charset="-122"/>
+                <a:cs typeface="Noto Sans KR" pitchFamily="34" charset="-120"/>
+              </a:rPr>
+              <a:t>처리량</a:t>
+            </a:r>
+            <a:endParaRPr lang="en-US" sz="650" dirty="0"/>
+          </a:p>
+        </p:txBody>
+      </p:sp>
+      <p:sp>
+        <p:nvSpPr>
+          <p:cNvPr id="31" name="Text 29"/>
+          <p:cNvSpPr/>
+          <p:nvPr/>
+        </p:nvSpPr>
+        <p:spPr>
+          <a:xfrm>
+            <a:off x="914400" y="2953512"/>
+            <a:ext cx="4846320" cy="237744"/>
+          </a:xfrm>
+          <a:prstGeom prst="rect">
+            <a:avLst/>
+          </a:prstGeom>
+          <a:noFill/>
+          <a:ln/>
+        </p:spPr>
+        <p:txBody>
+          <a:bodyPr wrap="square" lIns="0" tIns="0" rIns="0" bIns="0" rtlCol="0" anchor="ctr"/>
+          <a:lstStyle/>
+          <a:p>
+            <a:pPr indent="0" marL="0">
+              <a:buNone/>
+            </a:pPr>
+            <a:r>
+              <a:rPr lang="en-US" sz="950" b="1" dirty="0">
+                <a:solidFill>
+                  <a:srgbClr val="1B2F5E"/>
+                </a:solidFill>
+                <a:latin typeface="Noto Sans KR" pitchFamily="34" charset="0"/>
+                <a:ea typeface="Noto Sans KR" pitchFamily="34" charset="-122"/>
+                <a:cs typeface="Noto Sans KR" pitchFamily="34" charset="-120"/>
+              </a:rPr>
+              <a:t>다수 검사품 동시 안착 가능 여부</a:t>
+            </a:r>
+            <a:endParaRPr lang="en-US" sz="950" dirty="0"/>
+          </a:p>
+        </p:txBody>
+      </p:sp>
+      <p:sp>
+        <p:nvSpPr>
+          <p:cNvPr id="32" name="Text 30"/>
+          <p:cNvSpPr/>
+          <p:nvPr/>
+        </p:nvSpPr>
+        <p:spPr>
+          <a:xfrm>
+            <a:off x="914400" y="3172968"/>
+            <a:ext cx="4846320" cy="237744"/>
+          </a:xfrm>
+          <a:prstGeom prst="rect">
+            <a:avLst/>
+          </a:prstGeom>
+          <a:noFill/>
+          <a:ln/>
+        </p:spPr>
+        <p:txBody>
+          <a:bodyPr wrap="square" lIns="0" tIns="0" rIns="0" bIns="0" rtlCol="0" anchor="ctr"/>
+          <a:lstStyle/>
+          <a:p>
+            <a:pPr indent="0" marL="0">
+              <a:lnSpc>
+                <a:spcPct val="110000"/>
+              </a:lnSpc>
+              <a:buNone/>
+            </a:pPr>
+            <a:r>
+              <a:rPr lang="en-US" sz="750" dirty="0">
+                <a:solidFill>
+                  <a:srgbClr val="475569"/>
+                </a:solidFill>
+                <a:latin typeface="Noto Sans KR" pitchFamily="34" charset="0"/>
+                <a:ea typeface="Noto Sans KR" pitchFamily="34" charset="-122"/>
+                <a:cs typeface="Noto Sans KR" pitchFamily="34" charset="-120"/>
+              </a:rPr>
+              <a:t>02항의 지그 회수 방식에 따라 복수의 검사품을 동시에 지그에 올려두는 멀티 안착 구조가 가능한지 검토가 필요합니다. 동시 처리 수량에 따라 검사기 설계 규모와 S/T가 결정됩니다.</a:t>
+            </a:r>
+            <a:endParaRPr lang="en-US" sz="750" dirty="0"/>
+          </a:p>
+        </p:txBody>
+      </p:sp>
+      <p:sp>
+        <p:nvSpPr>
+          <p:cNvPr id="33" name="Shape 31"/>
+          <p:cNvSpPr/>
+          <p:nvPr/>
+        </p:nvSpPr>
+        <p:spPr>
+          <a:xfrm>
+            <a:off x="5504688" y="2734056"/>
+            <a:ext cx="3200400" cy="640080"/>
+          </a:xfrm>
+          <a:prstGeom prst="roundRect">
+            <a:avLst>
+              <a:gd name="adj" fmla="val 10000"/>
+            </a:avLst>
+          </a:prstGeom>
+          <a:solidFill>
+            <a:srgbClr val="CCFBF1"/>
+          </a:solidFill>
+          <a:ln w="12700">
+            <a:solidFill>
+              <a:srgbClr val="CCFBF1"/>
+            </a:solidFill>
+            <a:prstDash val="solid"/>
+          </a:ln>
+          <a:effectLst>
+            <a:outerShdw sx="100000" sy="100000" kx="0" ky="0" algn="bl" rotWithShape="0" blurRad="50800" dist="25400" dir="16200000">
+              <a:srgbClr val="9CA3AF">
+                <a:alpha val="15000"/>
+              </a:srgbClr>
+            </a:outerShdw>
+          </a:effectLst>
+        </p:spPr>
+      </p:sp>
+      <p:sp>
+        <p:nvSpPr>
+          <p:cNvPr id="34" name="Text 32"/>
+          <p:cNvSpPr/>
+          <p:nvPr/>
+        </p:nvSpPr>
+        <p:spPr>
+          <a:xfrm>
+            <a:off x="5577840" y="2752344"/>
+            <a:ext cx="3090672" cy="182880"/>
+          </a:xfrm>
+          <a:prstGeom prst="rect">
+            <a:avLst/>
+          </a:prstGeom>
+          <a:noFill/>
+          <a:ln/>
+        </p:spPr>
+        <p:txBody>
+          <a:bodyPr wrap="square" lIns="0" tIns="0" rIns="0" bIns="0" rtlCol="0" anchor="ctr"/>
+          <a:lstStyle/>
+          <a:p>
+            <a:pPr indent="0" marL="0">
+              <a:buNone/>
+            </a:pPr>
+            <a:r>
+              <a:rPr lang="en-US" sz="750" b="1" dirty="0">
+                <a:solidFill>
+                  <a:srgbClr val="0D9488"/>
+                </a:solidFill>
+                <a:latin typeface="Noto Sans KR" pitchFamily="34" charset="0"/>
+                <a:ea typeface="Noto Sans KR" pitchFamily="34" charset="-122"/>
+                <a:cs typeface="Noto Sans KR" pitchFamily="34" charset="-120"/>
+              </a:rPr>
+              <a:t>💬 협의 요청</a:t>
+            </a:r>
+            <a:endParaRPr lang="en-US" sz="750" dirty="0"/>
+          </a:p>
+        </p:txBody>
+      </p:sp>
+      <p:sp>
+        <p:nvSpPr>
+          <p:cNvPr id="35" name="Text 33"/>
+          <p:cNvSpPr/>
+          <p:nvPr/>
+        </p:nvSpPr>
+        <p:spPr>
+          <a:xfrm>
+            <a:off x="5577840" y="2935224"/>
+            <a:ext cx="3090672" cy="438912"/>
+          </a:xfrm>
+          <a:prstGeom prst="rect">
+            <a:avLst/>
+          </a:prstGeom>
+          <a:noFill/>
+          <a:ln/>
+        </p:spPr>
+        <p:txBody>
+          <a:bodyPr wrap="square" lIns="0" tIns="0" rIns="0" bIns="0" rtlCol="0" anchor="ctr"/>
+          <a:lstStyle/>
+          <a:p>
+            <a:pPr indent="0" marL="0">
+              <a:lnSpc>
+                <a:spcPct val="120000"/>
+              </a:lnSpc>
+              <a:buNone/>
+            </a:pPr>
+            <a:r>
+              <a:rPr lang="en-US" sz="850" dirty="0">
+                <a:solidFill>
+                  <a:srgbClr val="1E293B"/>
+                </a:solidFill>
+                <a:latin typeface="Noto Sans KR" pitchFamily="34" charset="0"/>
+                <a:ea typeface="Noto Sans KR" pitchFamily="34" charset="-122"/>
+                <a:cs typeface="Noto Sans KR" pitchFamily="34" charset="-120"/>
+              </a:rPr>
+              <a:t>라인 생산 속도 및 동시 처리 목표 수량 공유 요청</a:t>
+            </a:r>
+            <a:endParaRPr lang="en-US" sz="850" dirty="0"/>
+          </a:p>
+        </p:txBody>
+      </p:sp>
+      <p:sp>
+        <p:nvSpPr>
+          <p:cNvPr id="36" name="Shape 34"/>
+          <p:cNvSpPr/>
+          <p:nvPr/>
+        </p:nvSpPr>
+        <p:spPr>
+          <a:xfrm>
+            <a:off x="365760" y="3479292"/>
+            <a:ext cx="8412480" cy="749808"/>
+          </a:xfrm>
+          <a:prstGeom prst="roundRect">
+            <a:avLst>
+              <a:gd name="adj" fmla="val 8537"/>
+            </a:avLst>
+          </a:prstGeom>
+          <a:solidFill>
+            <a:srgbClr val="FFFFFF"/>
+          </a:solidFill>
+          <a:ln w="12700">
+            <a:solidFill>
+              <a:srgbClr val="D97706"/>
+            </a:solidFill>
+            <a:prstDash val="solid"/>
+          </a:ln>
+          <a:effectLst>
+            <a:outerShdw sx="100000" sy="100000" kx="0" ky="0" algn="bl" rotWithShape="0" blurRad="50800" dist="25400" dir="16200000">
+              <a:srgbClr val="9CA3AF">
+                <a:alpha val="15000"/>
+              </a:srgbClr>
+            </a:outerShdw>
+          </a:effectLst>
+        </p:spPr>
+      </p:sp>
+      <p:sp>
+        <p:nvSpPr>
+          <p:cNvPr id="37" name="Shape 35"/>
+          <p:cNvSpPr/>
+          <p:nvPr/>
+        </p:nvSpPr>
+        <p:spPr>
+          <a:xfrm>
+            <a:off x="365760" y="3479292"/>
+            <a:ext cx="475488" cy="749808"/>
+          </a:xfrm>
+          <a:prstGeom prst="roundRect">
+            <a:avLst>
+              <a:gd name="adj" fmla="val 11538"/>
+            </a:avLst>
+          </a:prstGeom>
+          <a:solidFill>
+            <a:srgbClr val="D97706"/>
+          </a:solidFill>
+          <a:ln w="12700">
+            <a:solidFill>
+              <a:srgbClr val="D97706"/>
+            </a:solidFill>
+            <a:prstDash val="solid"/>
+          </a:ln>
+        </p:spPr>
+      </p:sp>
+      <p:sp>
+        <p:nvSpPr>
+          <p:cNvPr id="38" name="Text 36"/>
+          <p:cNvSpPr/>
+          <p:nvPr/>
+        </p:nvSpPr>
+        <p:spPr>
+          <a:xfrm>
+            <a:off x="365760" y="3479292"/>
+            <a:ext cx="475488" cy="749808"/>
+          </a:xfrm>
+          <a:prstGeom prst="rect">
+            <a:avLst/>
+          </a:prstGeom>
+          <a:noFill/>
+          <a:ln/>
+        </p:spPr>
+        <p:txBody>
+          <a:bodyPr wrap="square" lIns="0" tIns="0" rIns="0" bIns="0" rtlCol="0" anchor="ctr"/>
+          <a:lstStyle/>
+          <a:p>
+            <a:pPr algn="ctr" indent="0" marL="0">
+              <a:buNone/>
+            </a:pPr>
+            <a:r>
+              <a:rPr lang="en-US" sz="1100" b="1" dirty="0">
+                <a:solidFill>
+                  <a:srgbClr val="FFFFFF"/>
+                </a:solidFill>
+                <a:latin typeface="Noto Sans KR" pitchFamily="34" charset="0"/>
+                <a:ea typeface="Noto Sans KR" pitchFamily="34" charset="-122"/>
+                <a:cs typeface="Noto Sans KR" pitchFamily="34" charset="-120"/>
+              </a:rPr>
+              <a:t>04</a:t>
+            </a:r>
+            <a:endParaRPr lang="en-US" sz="1100" dirty="0"/>
+          </a:p>
+        </p:txBody>
+      </p:sp>
+      <p:sp>
+        <p:nvSpPr>
+          <p:cNvPr id="39" name="Shape 37"/>
+          <p:cNvSpPr/>
+          <p:nvPr/>
+        </p:nvSpPr>
+        <p:spPr>
+          <a:xfrm>
+            <a:off x="914400" y="3552444"/>
+            <a:ext cx="658368" cy="182880"/>
+          </a:xfrm>
+          <a:prstGeom prst="roundRect">
+            <a:avLst>
+              <a:gd name="adj" fmla="val 20000"/>
+            </a:avLst>
+          </a:prstGeom>
+          <a:solidFill>
+            <a:srgbClr val="FEF3C7"/>
+          </a:solidFill>
+          <a:ln w="6350">
+            <a:solidFill>
+              <a:srgbClr val="D97706"/>
+            </a:solidFill>
+            <a:prstDash val="solid"/>
+          </a:ln>
+        </p:spPr>
+      </p:sp>
+      <p:sp>
+        <p:nvSpPr>
+          <p:cNvPr id="40" name="Text 38"/>
+          <p:cNvSpPr/>
+          <p:nvPr/>
+        </p:nvSpPr>
+        <p:spPr>
+          <a:xfrm>
+            <a:off x="914400" y="3552444"/>
+            <a:ext cx="658368" cy="182880"/>
+          </a:xfrm>
+          <a:prstGeom prst="rect">
+            <a:avLst/>
+          </a:prstGeom>
+          <a:noFill/>
+          <a:ln/>
+        </p:spPr>
+        <p:txBody>
+          <a:bodyPr wrap="square" lIns="0" tIns="0" rIns="0" bIns="0" rtlCol="0" anchor="ctr"/>
+          <a:lstStyle/>
+          <a:p>
+            <a:pPr algn="ctr" indent="0" marL="0">
+              <a:buNone/>
+            </a:pPr>
+            <a:r>
+              <a:rPr lang="en-US" sz="650" b="1" dirty="0">
+                <a:solidFill>
+                  <a:srgbClr val="D97706"/>
+                </a:solidFill>
+                <a:latin typeface="Noto Sans KR" pitchFamily="34" charset="0"/>
+                <a:ea typeface="Noto Sans KR" pitchFamily="34" charset="-122"/>
+                <a:cs typeface="Noto Sans KR" pitchFamily="34" charset="-120"/>
+              </a:rPr>
+              <a:t>장비 설계</a:t>
+            </a:r>
+            <a:endParaRPr lang="en-US" sz="650" dirty="0"/>
+          </a:p>
+        </p:txBody>
+      </p:sp>
+      <p:sp>
+        <p:nvSpPr>
+          <p:cNvPr id="41" name="Text 39"/>
+          <p:cNvSpPr/>
+          <p:nvPr/>
+        </p:nvSpPr>
+        <p:spPr>
+          <a:xfrm>
+            <a:off x="914400" y="3753612"/>
+            <a:ext cx="4846320" cy="237744"/>
+          </a:xfrm>
+          <a:prstGeom prst="rect">
+            <a:avLst/>
+          </a:prstGeom>
+          <a:noFill/>
+          <a:ln/>
+        </p:spPr>
+        <p:txBody>
+          <a:bodyPr wrap="square" lIns="0" tIns="0" rIns="0" bIns="0" rtlCol="0" anchor="ctr"/>
+          <a:lstStyle/>
+          <a:p>
+            <a:pPr indent="0" marL="0">
+              <a:buNone/>
+            </a:pPr>
+            <a:r>
+              <a:rPr lang="en-US" sz="950" b="1" dirty="0">
+                <a:solidFill>
+                  <a:srgbClr val="1B2F5E"/>
+                </a:solidFill>
+                <a:latin typeface="Noto Sans KR" pitchFamily="34" charset="0"/>
+                <a:ea typeface="Noto Sans KR" pitchFamily="34" charset="-122"/>
+                <a:cs typeface="Noto Sans KR" pitchFamily="34" charset="-120"/>
+              </a:rPr>
+              <a:t>03항 가능 시 — 검사기 내부 지그 리턴 구조 추가</a:t>
+            </a:r>
+            <a:endParaRPr lang="en-US" sz="950" dirty="0"/>
+          </a:p>
+        </p:txBody>
+      </p:sp>
+      <p:sp>
+        <p:nvSpPr>
+          <p:cNvPr id="42" name="Text 40"/>
+          <p:cNvSpPr/>
+          <p:nvPr/>
+        </p:nvSpPr>
+        <p:spPr>
+          <a:xfrm>
+            <a:off x="914400" y="3973068"/>
+            <a:ext cx="4846320" cy="237744"/>
+          </a:xfrm>
+          <a:prstGeom prst="rect">
+            <a:avLst/>
+          </a:prstGeom>
+          <a:noFill/>
+          <a:ln/>
+        </p:spPr>
+        <p:txBody>
+          <a:bodyPr wrap="square" lIns="0" tIns="0" rIns="0" bIns="0" rtlCol="0" anchor="ctr"/>
+          <a:lstStyle/>
+          <a:p>
+            <a:pPr indent="0" marL="0">
+              <a:lnSpc>
+                <a:spcPct val="110000"/>
+              </a:lnSpc>
+              <a:buNone/>
+            </a:pPr>
+            <a:r>
+              <a:rPr lang="en-US" sz="750" dirty="0">
+                <a:solidFill>
+                  <a:srgbClr val="475569"/>
+                </a:solidFill>
+                <a:latin typeface="Noto Sans KR" pitchFamily="34" charset="0"/>
+                <a:ea typeface="Noto Sans KR" pitchFamily="34" charset="-122"/>
+                <a:cs typeface="Noto Sans KR" pitchFamily="34" charset="-120"/>
+              </a:rPr>
+              <a:t>다수 동시 안착이 가능하다면 검사기 내부에 지그 자동 리턴 구조를 설계에 포함합니다. 이 경우 장비 규모와 제작 기간·비용이 증가하므로 효용성을 함께 검토해야 합니다.</a:t>
+            </a:r>
+            <a:endParaRPr lang="en-US" sz="750" dirty="0"/>
+          </a:p>
+        </p:txBody>
+      </p:sp>
+      <p:sp>
+        <p:nvSpPr>
+          <p:cNvPr id="43" name="Shape 41"/>
+          <p:cNvSpPr/>
+          <p:nvPr/>
+        </p:nvSpPr>
+        <p:spPr>
+          <a:xfrm>
+            <a:off x="5504688" y="3534156"/>
+            <a:ext cx="3200400" cy="640080"/>
+          </a:xfrm>
+          <a:prstGeom prst="roundRect">
+            <a:avLst>
+              <a:gd name="adj" fmla="val 10000"/>
+            </a:avLst>
+          </a:prstGeom>
+          <a:solidFill>
+            <a:srgbClr val="FEF3C7"/>
+          </a:solidFill>
+          <a:ln w="12700">
+            <a:solidFill>
+              <a:srgbClr val="FEF3C7"/>
+            </a:solidFill>
+            <a:prstDash val="solid"/>
+          </a:ln>
+          <a:effectLst>
+            <a:outerShdw sx="100000" sy="100000" kx="0" ky="0" algn="bl" rotWithShape="0" blurRad="50800" dist="25400" dir="16200000">
+              <a:srgbClr val="9CA3AF">
+                <a:alpha val="15000"/>
+              </a:srgbClr>
+            </a:outerShdw>
+          </a:effectLst>
+        </p:spPr>
+      </p:sp>
+      <p:sp>
+        <p:nvSpPr>
+          <p:cNvPr id="44" name="Text 42"/>
+          <p:cNvSpPr/>
+          <p:nvPr/>
+        </p:nvSpPr>
+        <p:spPr>
+          <a:xfrm>
+            <a:off x="5577840" y="3552444"/>
+            <a:ext cx="3090672" cy="182880"/>
+          </a:xfrm>
+          <a:prstGeom prst="rect">
+            <a:avLst/>
+          </a:prstGeom>
+          <a:noFill/>
+          <a:ln/>
+        </p:spPr>
+        <p:txBody>
+          <a:bodyPr wrap="square" lIns="0" tIns="0" rIns="0" bIns="0" rtlCol="0" anchor="ctr"/>
+          <a:lstStyle/>
+          <a:p>
+            <a:pPr indent="0" marL="0">
+              <a:buNone/>
+            </a:pPr>
+            <a:r>
+              <a:rPr lang="en-US" sz="750" b="1" dirty="0">
+                <a:solidFill>
+                  <a:srgbClr val="D97706"/>
+                </a:solidFill>
+                <a:latin typeface="Noto Sans KR" pitchFamily="34" charset="0"/>
+                <a:ea typeface="Noto Sans KR" pitchFamily="34" charset="-122"/>
+                <a:cs typeface="Noto Sans KR" pitchFamily="34" charset="-120"/>
+              </a:rPr>
+              <a:t>💬 협의 요청</a:t>
+            </a:r>
+            <a:endParaRPr lang="en-US" sz="750" dirty="0"/>
+          </a:p>
+        </p:txBody>
+      </p:sp>
+      <p:sp>
+        <p:nvSpPr>
+          <p:cNvPr id="45" name="Text 43"/>
+          <p:cNvSpPr/>
+          <p:nvPr/>
+        </p:nvSpPr>
+        <p:spPr>
+          <a:xfrm>
+            <a:off x="5577840" y="3735324"/>
+            <a:ext cx="3090672" cy="438912"/>
+          </a:xfrm>
+          <a:prstGeom prst="rect">
+            <a:avLst/>
+          </a:prstGeom>
+          <a:noFill/>
+          <a:ln/>
+        </p:spPr>
+        <p:txBody>
+          <a:bodyPr wrap="square" lIns="0" tIns="0" rIns="0" bIns="0" rtlCol="0" anchor="ctr"/>
+          <a:lstStyle/>
+          <a:p>
+            <a:pPr indent="0" marL="0">
+              <a:lnSpc>
+                <a:spcPct val="120000"/>
+              </a:lnSpc>
+              <a:buNone/>
+            </a:pPr>
+            <a:r>
+              <a:rPr lang="en-US" sz="850" dirty="0">
+                <a:solidFill>
+                  <a:srgbClr val="1E293B"/>
+                </a:solidFill>
+                <a:latin typeface="Noto Sans KR" pitchFamily="34" charset="0"/>
+                <a:ea typeface="Noto Sans KR" pitchFamily="34" charset="-122"/>
+                <a:cs typeface="Noto Sans KR" pitchFamily="34" charset="-120"/>
+              </a:rPr>
+              <a:t>리턴 구조 포함 여부 및 설치 공간·예산 범위 사전 협의</a:t>
+            </a:r>
+            <a:endParaRPr lang="en-US" sz="850" dirty="0"/>
+          </a:p>
+        </p:txBody>
+      </p:sp>
+      <p:sp>
+        <p:nvSpPr>
+          <p:cNvPr id="46" name="Shape 44"/>
+          <p:cNvSpPr/>
+          <p:nvPr/>
+        </p:nvSpPr>
+        <p:spPr>
+          <a:xfrm>
+            <a:off x="365760" y="4279392"/>
+            <a:ext cx="8412480" cy="749808"/>
+          </a:xfrm>
+          <a:prstGeom prst="roundRect">
+            <a:avLst>
+              <a:gd name="adj" fmla="val 8537"/>
+            </a:avLst>
+          </a:prstGeom>
+          <a:solidFill>
+            <a:srgbClr val="FFFFFF"/>
+          </a:solidFill>
+          <a:ln w="12700">
+            <a:solidFill>
+              <a:srgbClr val="059669"/>
+            </a:solidFill>
+            <a:prstDash val="solid"/>
+          </a:ln>
+          <a:effectLst>
+            <a:outerShdw sx="100000" sy="100000" kx="0" ky="0" algn="bl" rotWithShape="0" blurRad="50800" dist="25400" dir="16200000">
+              <a:srgbClr val="9CA3AF">
+                <a:alpha val="15000"/>
+              </a:srgbClr>
+            </a:outerShdw>
+          </a:effectLst>
+        </p:spPr>
+      </p:sp>
+      <p:sp>
+        <p:nvSpPr>
+          <p:cNvPr id="47" name="Shape 45"/>
+          <p:cNvSpPr/>
+          <p:nvPr/>
+        </p:nvSpPr>
+        <p:spPr>
+          <a:xfrm>
+            <a:off x="365760" y="4279392"/>
+            <a:ext cx="475488" cy="749808"/>
+          </a:xfrm>
+          <a:prstGeom prst="roundRect">
+            <a:avLst>
+              <a:gd name="adj" fmla="val 11538"/>
+            </a:avLst>
+          </a:prstGeom>
+          <a:solidFill>
+            <a:srgbClr val="059669"/>
+          </a:solidFill>
+          <a:ln w="12700">
+            <a:solidFill>
+              <a:srgbClr val="059669"/>
+            </a:solidFill>
+            <a:prstDash val="solid"/>
+          </a:ln>
+        </p:spPr>
+      </p:sp>
+      <p:sp>
+        <p:nvSpPr>
+          <p:cNvPr id="48" name="Text 46"/>
+          <p:cNvSpPr/>
+          <p:nvPr/>
+        </p:nvSpPr>
+        <p:spPr>
+          <a:xfrm>
+            <a:off x="365760" y="4279392"/>
+            <a:ext cx="475488" cy="749808"/>
+          </a:xfrm>
+          <a:prstGeom prst="rect">
+            <a:avLst/>
+          </a:prstGeom>
+          <a:noFill/>
+          <a:ln/>
+        </p:spPr>
+        <p:txBody>
+          <a:bodyPr wrap="square" lIns="0" tIns="0" rIns="0" bIns="0" rtlCol="0" anchor="ctr"/>
+          <a:lstStyle/>
+          <a:p>
+            <a:pPr algn="ctr" indent="0" marL="0">
+              <a:buNone/>
+            </a:pPr>
+            <a:r>
+              <a:rPr lang="en-US" sz="1100" b="1" dirty="0">
+                <a:solidFill>
+                  <a:srgbClr val="FFFFFF"/>
+                </a:solidFill>
+                <a:latin typeface="Noto Sans KR" pitchFamily="34" charset="0"/>
+                <a:ea typeface="Noto Sans KR" pitchFamily="34" charset="-122"/>
+                <a:cs typeface="Noto Sans KR" pitchFamily="34" charset="-120"/>
+              </a:rPr>
+              <a:t>05</a:t>
+            </a:r>
+            <a:endParaRPr lang="en-US" sz="1100" dirty="0"/>
+          </a:p>
+        </p:txBody>
+      </p:sp>
+      <p:sp>
+        <p:nvSpPr>
+          <p:cNvPr id="49" name="Shape 47"/>
+          <p:cNvSpPr/>
+          <p:nvPr/>
+        </p:nvSpPr>
+        <p:spPr>
+          <a:xfrm>
+            <a:off x="914400" y="4352544"/>
+            <a:ext cx="658368" cy="182880"/>
+          </a:xfrm>
+          <a:prstGeom prst="roundRect">
+            <a:avLst>
+              <a:gd name="adj" fmla="val 20000"/>
+            </a:avLst>
+          </a:prstGeom>
+          <a:solidFill>
+            <a:srgbClr val="D1FAE5"/>
+          </a:solidFill>
+          <a:ln w="6350">
+            <a:solidFill>
+              <a:srgbClr val="059669"/>
+            </a:solidFill>
+            <a:prstDash val="solid"/>
+          </a:ln>
+        </p:spPr>
+      </p:sp>
+      <p:sp>
+        <p:nvSpPr>
+          <p:cNvPr id="50" name="Text 48"/>
+          <p:cNvSpPr/>
+          <p:nvPr/>
+        </p:nvSpPr>
+        <p:spPr>
+          <a:xfrm>
+            <a:off x="914400" y="4352544"/>
+            <a:ext cx="658368" cy="182880"/>
+          </a:xfrm>
+          <a:prstGeom prst="rect">
+            <a:avLst/>
+          </a:prstGeom>
+          <a:noFill/>
+          <a:ln/>
+        </p:spPr>
+        <p:txBody>
+          <a:bodyPr wrap="square" lIns="0" tIns="0" rIns="0" bIns="0" rtlCol="0" anchor="ctr"/>
+          <a:lstStyle/>
+          <a:p>
+            <a:pPr algn="ctr" indent="0" marL="0">
+              <a:buNone/>
+            </a:pPr>
+            <a:r>
+              <a:rPr lang="en-US" sz="650" b="1" dirty="0">
+                <a:solidFill>
+                  <a:srgbClr val="059669"/>
+                </a:solidFill>
+                <a:latin typeface="Noto Sans KR" pitchFamily="34" charset="0"/>
+                <a:ea typeface="Noto Sans KR" pitchFamily="34" charset="-122"/>
+                <a:cs typeface="Noto Sans KR" pitchFamily="34" charset="-120"/>
+              </a:rPr>
+              <a:t>데이터 협조</a:t>
+            </a:r>
+            <a:endParaRPr lang="en-US" sz="650" dirty="0"/>
+          </a:p>
+        </p:txBody>
+      </p:sp>
+      <p:sp>
+        <p:nvSpPr>
+          <p:cNvPr id="51" name="Text 49"/>
+          <p:cNvSpPr/>
+          <p:nvPr/>
+        </p:nvSpPr>
+        <p:spPr>
+          <a:xfrm>
+            <a:off x="914400" y="4553712"/>
+            <a:ext cx="4846320" cy="237744"/>
+          </a:xfrm>
+          <a:prstGeom prst="rect">
+            <a:avLst/>
+          </a:prstGeom>
+          <a:noFill/>
+          <a:ln/>
+        </p:spPr>
+        <p:txBody>
+          <a:bodyPr wrap="square" lIns="0" tIns="0" rIns="0" bIns="0" rtlCol="0" anchor="ctr"/>
+          <a:lstStyle/>
+          <a:p>
+            <a:pPr indent="0" marL="0">
+              <a:buNone/>
+            </a:pPr>
+            <a:r>
+              <a:rPr lang="en-US" sz="950" b="1" dirty="0">
+                <a:solidFill>
+                  <a:srgbClr val="1B2F5E"/>
+                </a:solidFill>
+                <a:latin typeface="Noto Sans KR" pitchFamily="34" charset="0"/>
+                <a:ea typeface="Noto Sans KR" pitchFamily="34" charset="-122"/>
+                <a:cs typeface="Noto Sans KR" pitchFamily="34" charset="-120"/>
+              </a:rPr>
+              <a:t>기존 육안검사 경험 데이터의 딥러닝 학습 적용</a:t>
+            </a:r>
+            <a:endParaRPr lang="en-US" sz="950" dirty="0"/>
+          </a:p>
+        </p:txBody>
+      </p:sp>
+      <p:sp>
+        <p:nvSpPr>
+          <p:cNvPr id="52" name="Text 50"/>
+          <p:cNvSpPr/>
+          <p:nvPr/>
+        </p:nvSpPr>
+        <p:spPr>
+          <a:xfrm>
+            <a:off x="914400" y="4773168"/>
+            <a:ext cx="4846320" cy="237744"/>
+          </a:xfrm>
+          <a:prstGeom prst="rect">
+            <a:avLst/>
+          </a:prstGeom>
+          <a:noFill/>
+          <a:ln/>
+        </p:spPr>
+        <p:txBody>
+          <a:bodyPr wrap="square" lIns="0" tIns="0" rIns="0" bIns="0" rtlCol="0" anchor="ctr"/>
+          <a:lstStyle/>
+          <a:p>
+            <a:pPr indent="0" marL="0">
+              <a:lnSpc>
+                <a:spcPct val="110000"/>
+              </a:lnSpc>
+              <a:buNone/>
+            </a:pPr>
+            <a:r>
+              <a:rPr lang="en-US" sz="750" dirty="0">
+                <a:solidFill>
+                  <a:srgbClr val="475569"/>
+                </a:solidFill>
+                <a:latin typeface="Noto Sans KR" pitchFamily="34" charset="0"/>
+                <a:ea typeface="Noto Sans KR" pitchFamily="34" charset="-122"/>
+                <a:cs typeface="Noto Sans KR" pitchFamily="34" charset="-120"/>
+              </a:rPr>
+              <a:t>비전검사기 도입 이전 검사원들이 육안으로 판별하며 축적한 불량 사례·판정 기준 데이터를 딥러닝 초기 학습에 활용하면 검출 정확도를 빠르게 높일 수 있습니다. 학습 데이터가 많을수록 도입 초기 성능이 향상됩니다.</a:t>
+            </a:r>
+            <a:endParaRPr lang="en-US" sz="750" dirty="0"/>
+          </a:p>
+        </p:txBody>
+      </p:sp>
+      <p:sp>
+        <p:nvSpPr>
+          <p:cNvPr id="53" name="Shape 51"/>
+          <p:cNvSpPr/>
+          <p:nvPr/>
+        </p:nvSpPr>
+        <p:spPr>
+          <a:xfrm>
+            <a:off x="5504688" y="4334256"/>
+            <a:ext cx="3200400" cy="640080"/>
+          </a:xfrm>
+          <a:prstGeom prst="roundRect">
+            <a:avLst>
+              <a:gd name="adj" fmla="val 10000"/>
+            </a:avLst>
+          </a:prstGeom>
+          <a:solidFill>
+            <a:srgbClr val="D1FAE5"/>
+          </a:solidFill>
+          <a:ln w="12700">
+            <a:solidFill>
+              <a:srgbClr val="D1FAE5"/>
+            </a:solidFill>
+            <a:prstDash val="solid"/>
+          </a:ln>
+          <a:effectLst>
+            <a:outerShdw sx="100000" sy="100000" kx="0" ky="0" algn="bl" rotWithShape="0" blurRad="50800" dist="25400" dir="16200000">
+              <a:srgbClr val="9CA3AF">
+                <a:alpha val="15000"/>
+              </a:srgbClr>
+            </a:outerShdw>
+          </a:effectLst>
+        </p:spPr>
+      </p:sp>
+      <p:sp>
+        <p:nvSpPr>
+          <p:cNvPr id="54" name="Text 52"/>
+          <p:cNvSpPr/>
+          <p:nvPr/>
+        </p:nvSpPr>
+        <p:spPr>
+          <a:xfrm>
+            <a:off x="5577840" y="4352544"/>
+            <a:ext cx="3090672" cy="182880"/>
+          </a:xfrm>
+          <a:prstGeom prst="rect">
+            <a:avLst/>
+          </a:prstGeom>
+          <a:noFill/>
+          <a:ln/>
+        </p:spPr>
+        <p:txBody>
+          <a:bodyPr wrap="square" lIns="0" tIns="0" rIns="0" bIns="0" rtlCol="0" anchor="ctr"/>
+          <a:lstStyle/>
+          <a:p>
+            <a:pPr indent="0" marL="0">
+              <a:buNone/>
+            </a:pPr>
+            <a:r>
+              <a:rPr lang="en-US" sz="750" b="1" dirty="0">
+                <a:solidFill>
+                  <a:srgbClr val="059669"/>
+                </a:solidFill>
+                <a:latin typeface="Noto Sans KR" pitchFamily="34" charset="0"/>
+                <a:ea typeface="Noto Sans KR" pitchFamily="34" charset="-122"/>
+                <a:cs typeface="Noto Sans KR" pitchFamily="34" charset="-120"/>
+              </a:rPr>
+              <a:t>💬 협의 요청</a:t>
+            </a:r>
+            <a:endParaRPr lang="en-US" sz="750" dirty="0"/>
+          </a:p>
+        </p:txBody>
+      </p:sp>
+      <p:sp>
+        <p:nvSpPr>
+          <p:cNvPr id="55" name="Text 53"/>
+          <p:cNvSpPr/>
+          <p:nvPr/>
+        </p:nvSpPr>
+        <p:spPr>
+          <a:xfrm>
+            <a:off x="5577840" y="4535424"/>
+            <a:ext cx="3090672" cy="438912"/>
+          </a:xfrm>
+          <a:prstGeom prst="rect">
+            <a:avLst/>
+          </a:prstGeom>
+          <a:noFill/>
+          <a:ln/>
+        </p:spPr>
+        <p:txBody>
+          <a:bodyPr wrap="square" lIns="0" tIns="0" rIns="0" bIns="0" rtlCol="0" anchor="ctr"/>
+          <a:lstStyle/>
+          <a:p>
+            <a:pPr indent="0" marL="0">
+              <a:lnSpc>
+                <a:spcPct val="120000"/>
+              </a:lnSpc>
+              <a:buNone/>
+            </a:pPr>
+            <a:r>
+              <a:rPr lang="en-US" sz="850" dirty="0">
+                <a:solidFill>
+                  <a:srgbClr val="1E293B"/>
+                </a:solidFill>
+                <a:latin typeface="Noto Sans KR" pitchFamily="34" charset="0"/>
+                <a:ea typeface="Noto Sans KR" pitchFamily="34" charset="-122"/>
+                <a:cs typeface="Noto Sans KR" pitchFamily="34" charset="-120"/>
+              </a:rPr>
+              <a:t>기존 불량 이미지·판정 이력 데이터 제공 여부 및 범위 협의</a:t>
+            </a:r>
+            <a:endParaRPr lang="en-US" sz="850" dirty="0"/>
+          </a:p>
+        </p:txBody>
+      </p:sp>
+    </p:spTree>
+  </p:cSld>
+  <p:clrMapOvr>
+    <a:masterClrMapping/>
+  </p:clrMapOvr>
+</p:sld>
+</file>
+
+<file path=ppt/slides/slide12.xml><?xml version="1.0" encoding="utf-8"?>
+<p:sld xmlns:a="http://schemas.openxmlformats.org/drawingml/2006/main" xmlns:r="http://schemas.openxmlformats.org/officeDocument/2006/relationships" xmlns:p="http://schemas.openxmlformats.org/presentationml/2006/main">
+  <p:cSld name="Slide 12">
+    <p:spTree>
+      <p:nvGrpSpPr>
+        <p:cNvPr id="1" name=""/>
+        <p:cNvGrpSpPr/>
+        <p:nvPr/>
+      </p:nvGrpSpPr>
+      <p:grpSpPr>
+        <a:xfrm>
+          <a:off x="0" y="0"/>
+          <a:ext cx="0" cy="0"/>
+          <a:chOff x="0" y="0"/>
+          <a:chExt cx="0" cy="0"/>
+        </a:xfrm>
+      </p:grpSpPr>
+      <p:sp>
+        <p:nvSpPr>
+          <p:cNvPr id="2" name="Shape 0"/>
+          <p:cNvSpPr/>
+          <p:nvPr/>
+        </p:nvSpPr>
+        <p:spPr>
+          <a:xfrm>
+            <a:off x="0" y="0"/>
+            <a:ext cx="9144000" cy="5143500"/>
+          </a:xfrm>
+          <a:prstGeom prst="rect">
+            <a:avLst/>
+          </a:prstGeom>
+          <a:solidFill>
             <a:srgbClr val="1B2F5E"/>
           </a:solidFill>
           <a:ln w="12700">
@@ -6593,6 +8645,118 @@
         <p:spPr>
           <a:xfrm>
             <a:off x="822960" y="3227832"/>
+            <a:ext cx="3547872" cy="256032"/>
+          </a:xfrm>
+          <a:prstGeom prst="rect">
+            <a:avLst/>
+          </a:prstGeom>
+          <a:noFill/>
+          <a:ln/>
+        </p:spPr>
+        <p:txBody>
+          <a:bodyPr wrap="square" lIns="0" tIns="0" rIns="0" bIns="0" rtlCol="0" anchor="ctr"/>
+          <a:lstStyle/>
+          <a:p>
+            <a:pPr indent="0" marL="0">
+              <a:buNone/>
+            </a:pPr>
+            <a:r>
+              <a:rPr lang="en-US" sz="1150" dirty="0">
+                <a:solidFill>
+                  <a:srgbClr val="1E293B"/>
+                </a:solidFill>
+                <a:latin typeface="Noto Sans KR" pitchFamily="34" charset="0"/>
+                <a:ea typeface="Noto Sans KR" pitchFamily="34" charset="-122"/>
+                <a:cs typeface="Noto Sans KR" pitchFamily="34" charset="-120"/>
+              </a:rPr>
+              <a:t>예상 문제점 및 협의 사항</a:t>
+            </a:r>
+            <a:endParaRPr lang="en-US" sz="1150" dirty="0"/>
+          </a:p>
+        </p:txBody>
+      </p:sp>
+      <p:sp>
+        <p:nvSpPr>
+          <p:cNvPr id="33" name="Shape 31"/>
+          <p:cNvSpPr/>
+          <p:nvPr/>
+        </p:nvSpPr>
+        <p:spPr>
+          <a:xfrm>
+            <a:off x="4663440" y="3145536"/>
+            <a:ext cx="4114800" cy="420624"/>
+          </a:xfrm>
+          <a:prstGeom prst="roundRect">
+            <a:avLst>
+              <a:gd name="adj" fmla="val 15217"/>
+            </a:avLst>
+          </a:prstGeom>
+          <a:solidFill>
+            <a:srgbClr val="FFFFFF"/>
+          </a:solidFill>
+          <a:ln w="12700">
+            <a:solidFill>
+              <a:srgbClr val="E2E8F0"/>
+            </a:solidFill>
+            <a:prstDash val="solid"/>
+          </a:ln>
+          <a:effectLst>
+            <a:outerShdw sx="100000" sy="100000" kx="0" ky="0" algn="bl" rotWithShape="0" blurRad="50800" dist="25400" dir="16200000">
+              <a:srgbClr val="9CA3AF">
+                <a:alpha val="15000"/>
+              </a:srgbClr>
+            </a:outerShdw>
+          </a:effectLst>
+        </p:spPr>
+      </p:sp>
+      <p:sp>
+        <p:nvSpPr>
+          <p:cNvPr id="34" name="Text 32"/>
+          <p:cNvSpPr/>
+          <p:nvPr/>
+        </p:nvSpPr>
+        <p:spPr>
+          <a:xfrm>
+            <a:off x="4773168" y="3227832"/>
+            <a:ext cx="329184" cy="256032"/>
+          </a:xfrm>
+          <a:prstGeom prst="rect">
+            <a:avLst/>
+          </a:prstGeom>
+          <a:noFill/>
+          <a:ln/>
+        </p:spPr>
+        <p:txBody>
+          <a:bodyPr wrap="square" lIns="0" tIns="0" rIns="0" bIns="0" rtlCol="0" anchor="ctr"/>
+          <a:lstStyle/>
+          <a:p>
+            <a:pPr indent="0" marL="0">
+              <a:buNone/>
+            </a:pPr>
+            <a:r>
+              <a:rPr lang="en-US" sz="1200" b="1" dirty="0">
+                <a:solidFill>
+                  <a:srgbClr val="2563EB"/>
+                </a:solidFill>
+                <a:latin typeface="Noto Sans KR" pitchFamily="34" charset="0"/>
+                <a:ea typeface="Noto Sans KR" pitchFamily="34" charset="-122"/>
+                <a:cs typeface="Noto Sans KR" pitchFamily="34" charset="-120"/>
+              </a:rPr>
+              <a:t>10</a:t>
+            </a:r>
+            <a:endParaRPr lang="en-US" sz="1200" dirty="0"/>
+          </a:p>
+        </p:txBody>
+      </p:sp>
+      <p:sp>
+        <p:nvSpPr>
+          <p:cNvPr id="35" name="Text 33"/>
+          <p:cNvSpPr/>
+          <p:nvPr/>
+        </p:nvSpPr>
+        <p:spPr>
+          <a:xfrm>
+            <a:off x="5120640" y="3227832"/>
             <a:ext cx="3547872" cy="256032"/>
           </a:xfrm>
           <a:prstGeom prst="rect">

</xml_diff>

<commit_message>
Update winnercomb.pptx - fix 4 layout issues
</commit_message>
<xml_diff>
--- a/winnercomb.pptx
+++ b/winnercomb.pptx
@@ -5103,7 +5103,7 @@
         <p:spPr>
           <a:xfrm>
             <a:off x="914400" y="1353312"/>
-            <a:ext cx="4846320" cy="237744"/>
+            <a:ext cx="4572000" cy="237744"/>
           </a:xfrm>
           <a:prstGeom prst="rect">
             <a:avLst/>
@@ -5142,7 +5142,7 @@
         <p:spPr>
           <a:xfrm>
             <a:off x="914400" y="1572768"/>
-            <a:ext cx="4846320" cy="237744"/>
+            <a:ext cx="4572000" cy="237744"/>
           </a:xfrm>
           <a:prstGeom prst="rect">
             <a:avLst/>
@@ -5183,8 +5183,8 @@
         </p:nvSpPr>
         <p:spPr>
           <a:xfrm>
-            <a:off x="5504688" y="1133856"/>
-            <a:ext cx="3200400" cy="640080"/>
+            <a:off x="5943600" y="1133856"/>
+            <a:ext cx="2834640" cy="640080"/>
           </a:xfrm>
           <a:prstGeom prst="roundRect">
             <a:avLst>
@@ -5217,8 +5217,8 @@
         </p:nvSpPr>
         <p:spPr>
           <a:xfrm>
-            <a:off x="5577840" y="1152144"/>
-            <a:ext cx="3090672" cy="182880"/>
+            <a:off x="6035040" y="1170432"/>
+            <a:ext cx="2706624" cy="182880"/>
           </a:xfrm>
           <a:prstGeom prst="rect">
             <a:avLst/>
@@ -5256,8 +5256,8 @@
         </p:nvSpPr>
         <p:spPr>
           <a:xfrm>
-            <a:off x="5577840" y="1335024"/>
-            <a:ext cx="3090672" cy="438912"/>
+            <a:off x="6035040" y="1353312"/>
+            <a:ext cx="2706624" cy="438912"/>
           </a:xfrm>
           <a:prstGeom prst="rect">
             <a:avLst/>
@@ -5271,12 +5271,12 @@
           <a:p>
             <a:pPr indent="0" marL="0">
               <a:lnSpc>
-                <a:spcPct val="120000"/>
+                <a:spcPct val="130000"/>
               </a:lnSpc>
               <a:buNone/>
             </a:pPr>
             <a:r>
-              <a:rPr lang="en-US" sz="850" dirty="0">
+              <a:rPr lang="en-US" sz="800" dirty="0">
                 <a:solidFill>
                   <a:srgbClr val="1E293B"/>
                 </a:solidFill>
@@ -5286,7 +5286,7 @@
               </a:rPr>
               <a:t>케이블 정형화 가능 여부 및 바코드 부착 위치 표준화 협의</a:t>
             </a:r>
-            <a:endParaRPr lang="en-US" sz="850" dirty="0"/>
+            <a:endParaRPr lang="en-US" sz="800" dirty="0"/>
           </a:p>
         </p:txBody>
       </p:sp>
@@ -5465,7 +5465,7 @@
         <p:spPr>
           <a:xfrm>
             <a:off x="914400" y="2153412"/>
-            <a:ext cx="4846320" cy="237744"/>
+            <a:ext cx="4572000" cy="237744"/>
           </a:xfrm>
           <a:prstGeom prst="rect">
             <a:avLst/>
@@ -5504,7 +5504,7 @@
         <p:spPr>
           <a:xfrm>
             <a:off x="914400" y="2372868"/>
-            <a:ext cx="4846320" cy="237744"/>
+            <a:ext cx="4572000" cy="237744"/>
           </a:xfrm>
           <a:prstGeom prst="rect">
             <a:avLst/>
@@ -5545,8 +5545,8 @@
         </p:nvSpPr>
         <p:spPr>
           <a:xfrm>
-            <a:off x="5504688" y="1933956"/>
-            <a:ext cx="3200400" cy="640080"/>
+            <a:off x="5943600" y="1933956"/>
+            <a:ext cx="2834640" cy="640080"/>
           </a:xfrm>
           <a:prstGeom prst="roundRect">
             <a:avLst>
@@ -5579,8 +5579,8 @@
         </p:nvSpPr>
         <p:spPr>
           <a:xfrm>
-            <a:off x="5577840" y="1952244"/>
-            <a:ext cx="3090672" cy="182880"/>
+            <a:off x="6035040" y="1970532"/>
+            <a:ext cx="2706624" cy="182880"/>
           </a:xfrm>
           <a:prstGeom prst="rect">
             <a:avLst/>
@@ -5618,8 +5618,8 @@
         </p:nvSpPr>
         <p:spPr>
           <a:xfrm>
-            <a:off x="5577840" y="2135124"/>
-            <a:ext cx="3090672" cy="438912"/>
+            <a:off x="6035040" y="2153412"/>
+            <a:ext cx="2706624" cy="438912"/>
           </a:xfrm>
           <a:prstGeom prst="rect">
             <a:avLst/>
@@ -5633,12 +5633,12 @@
           <a:p>
             <a:pPr indent="0" marL="0">
               <a:lnSpc>
-                <a:spcPct val="120000"/>
+                <a:spcPct val="130000"/>
               </a:lnSpc>
               <a:buNone/>
             </a:pPr>
             <a:r>
-              <a:rPr lang="en-US" sz="850" dirty="0">
+              <a:rPr lang="en-US" sz="800" dirty="0">
                 <a:solidFill>
                   <a:srgbClr val="1E293B"/>
                 </a:solidFill>
@@ -5648,7 +5648,7 @@
               </a:rPr>
               <a:t>지그 회수 방식(수동 회수 / 자동 리턴 구조) 및 지그 수량 협의</a:t>
             </a:r>
-            <a:endParaRPr lang="en-US" sz="850" dirty="0"/>
+            <a:endParaRPr lang="en-US" sz="800" dirty="0"/>
           </a:p>
         </p:txBody>
       </p:sp>
@@ -5827,7 +5827,7 @@
         <p:spPr>
           <a:xfrm>
             <a:off x="914400" y="2953512"/>
-            <a:ext cx="4846320" cy="237744"/>
+            <a:ext cx="4572000" cy="237744"/>
           </a:xfrm>
           <a:prstGeom prst="rect">
             <a:avLst/>
@@ -5866,7 +5866,7 @@
         <p:spPr>
           <a:xfrm>
             <a:off x="914400" y="3172968"/>
-            <a:ext cx="4846320" cy="237744"/>
+            <a:ext cx="4572000" cy="237744"/>
           </a:xfrm>
           <a:prstGeom prst="rect">
             <a:avLst/>
@@ -5907,8 +5907,8 @@
         </p:nvSpPr>
         <p:spPr>
           <a:xfrm>
-            <a:off x="5504688" y="2734056"/>
-            <a:ext cx="3200400" cy="640080"/>
+            <a:off x="5943600" y="2734056"/>
+            <a:ext cx="2834640" cy="640080"/>
           </a:xfrm>
           <a:prstGeom prst="roundRect">
             <a:avLst>
@@ -5941,8 +5941,8 @@
         </p:nvSpPr>
         <p:spPr>
           <a:xfrm>
-            <a:off x="5577840" y="2752344"/>
-            <a:ext cx="3090672" cy="182880"/>
+            <a:off x="6035040" y="2770632"/>
+            <a:ext cx="2706624" cy="182880"/>
           </a:xfrm>
           <a:prstGeom prst="rect">
             <a:avLst/>
@@ -5980,8 +5980,8 @@
         </p:nvSpPr>
         <p:spPr>
           <a:xfrm>
-            <a:off x="5577840" y="2935224"/>
-            <a:ext cx="3090672" cy="438912"/>
+            <a:off x="6035040" y="2953512"/>
+            <a:ext cx="2706624" cy="438912"/>
           </a:xfrm>
           <a:prstGeom prst="rect">
             <a:avLst/>
@@ -5995,12 +5995,12 @@
           <a:p>
             <a:pPr indent="0" marL="0">
               <a:lnSpc>
-                <a:spcPct val="120000"/>
+                <a:spcPct val="130000"/>
               </a:lnSpc>
               <a:buNone/>
             </a:pPr>
             <a:r>
-              <a:rPr lang="en-US" sz="850" dirty="0">
+              <a:rPr lang="en-US" sz="800" dirty="0">
                 <a:solidFill>
                   <a:srgbClr val="1E293B"/>
                 </a:solidFill>
@@ -6010,7 +6010,7 @@
               </a:rPr>
               <a:t>라인 생산 속도 및 동시 처리 목표 수량 공유 요청</a:t>
             </a:r>
-            <a:endParaRPr lang="en-US" sz="850" dirty="0"/>
+            <a:endParaRPr lang="en-US" sz="800" dirty="0"/>
           </a:p>
         </p:txBody>
       </p:sp>
@@ -6189,7 +6189,7 @@
         <p:spPr>
           <a:xfrm>
             <a:off x="914400" y="3753612"/>
-            <a:ext cx="4846320" cy="237744"/>
+            <a:ext cx="4572000" cy="237744"/>
           </a:xfrm>
           <a:prstGeom prst="rect">
             <a:avLst/>
@@ -6228,7 +6228,7 @@
         <p:spPr>
           <a:xfrm>
             <a:off x="914400" y="3973068"/>
-            <a:ext cx="4846320" cy="237744"/>
+            <a:ext cx="4572000" cy="237744"/>
           </a:xfrm>
           <a:prstGeom prst="rect">
             <a:avLst/>
@@ -6269,8 +6269,8 @@
         </p:nvSpPr>
         <p:spPr>
           <a:xfrm>
-            <a:off x="5504688" y="3534156"/>
-            <a:ext cx="3200400" cy="640080"/>
+            <a:off x="5943600" y="3534156"/>
+            <a:ext cx="2834640" cy="640080"/>
           </a:xfrm>
           <a:prstGeom prst="roundRect">
             <a:avLst>
@@ -6303,8 +6303,8 @@
         </p:nvSpPr>
         <p:spPr>
           <a:xfrm>
-            <a:off x="5577840" y="3552444"/>
-            <a:ext cx="3090672" cy="182880"/>
+            <a:off x="6035040" y="3570732"/>
+            <a:ext cx="2706624" cy="182880"/>
           </a:xfrm>
           <a:prstGeom prst="rect">
             <a:avLst/>
@@ -6342,8 +6342,8 @@
         </p:nvSpPr>
         <p:spPr>
           <a:xfrm>
-            <a:off x="5577840" y="3735324"/>
-            <a:ext cx="3090672" cy="438912"/>
+            <a:off x="6035040" y="3753612"/>
+            <a:ext cx="2706624" cy="438912"/>
           </a:xfrm>
           <a:prstGeom prst="rect">
             <a:avLst/>
@@ -6357,12 +6357,12 @@
           <a:p>
             <a:pPr indent="0" marL="0">
               <a:lnSpc>
-                <a:spcPct val="120000"/>
+                <a:spcPct val="130000"/>
               </a:lnSpc>
               <a:buNone/>
             </a:pPr>
             <a:r>
-              <a:rPr lang="en-US" sz="850" dirty="0">
+              <a:rPr lang="en-US" sz="800" dirty="0">
                 <a:solidFill>
                   <a:srgbClr val="1E293B"/>
                 </a:solidFill>
@@ -6372,7 +6372,7 @@
               </a:rPr>
               <a:t>리턴 구조 포함 여부 및 설치 공간·예산 범위 사전 협의</a:t>
             </a:r>
-            <a:endParaRPr lang="en-US" sz="850" dirty="0"/>
+            <a:endParaRPr lang="en-US" sz="800" dirty="0"/>
           </a:p>
         </p:txBody>
       </p:sp>
@@ -6551,7 +6551,7 @@
         <p:spPr>
           <a:xfrm>
             <a:off x="914400" y="4553712"/>
-            <a:ext cx="4846320" cy="237744"/>
+            <a:ext cx="4572000" cy="237744"/>
           </a:xfrm>
           <a:prstGeom prst="rect">
             <a:avLst/>
@@ -6590,7 +6590,7 @@
         <p:spPr>
           <a:xfrm>
             <a:off x="914400" y="4773168"/>
-            <a:ext cx="4846320" cy="237744"/>
+            <a:ext cx="4572000" cy="237744"/>
           </a:xfrm>
           <a:prstGeom prst="rect">
             <a:avLst/>
@@ -6631,8 +6631,8 @@
         </p:nvSpPr>
         <p:spPr>
           <a:xfrm>
-            <a:off x="5504688" y="4334256"/>
-            <a:ext cx="3200400" cy="640080"/>
+            <a:off x="5943600" y="4334256"/>
+            <a:ext cx="2834640" cy="640080"/>
           </a:xfrm>
           <a:prstGeom prst="roundRect">
             <a:avLst>
@@ -6665,8 +6665,8 @@
         </p:nvSpPr>
         <p:spPr>
           <a:xfrm>
-            <a:off x="5577840" y="4352544"/>
-            <a:ext cx="3090672" cy="182880"/>
+            <a:off x="6035040" y="4370832"/>
+            <a:ext cx="2706624" cy="182880"/>
           </a:xfrm>
           <a:prstGeom prst="rect">
             <a:avLst/>
@@ -6704,8 +6704,8 @@
         </p:nvSpPr>
         <p:spPr>
           <a:xfrm>
-            <a:off x="5577840" y="4535424"/>
-            <a:ext cx="3090672" cy="438912"/>
+            <a:off x="6035040" y="4553712"/>
+            <a:ext cx="2706624" cy="438912"/>
           </a:xfrm>
           <a:prstGeom prst="rect">
             <a:avLst/>
@@ -6719,12 +6719,12 @@
           <a:p>
             <a:pPr indent="0" marL="0">
               <a:lnSpc>
-                <a:spcPct val="120000"/>
+                <a:spcPct val="130000"/>
               </a:lnSpc>
               <a:buNone/>
             </a:pPr>
             <a:r>
-              <a:rPr lang="en-US" sz="850" dirty="0">
+              <a:rPr lang="en-US" sz="800" dirty="0">
                 <a:solidFill>
                   <a:srgbClr val="1E293B"/>
                 </a:solidFill>
@@ -6734,7 +6734,7 @@
               </a:rPr>
               <a:t>기존 불량 이미지·판정 이력 데이터 제공 여부 및 범위 협의</a:t>
             </a:r>
-            <a:endParaRPr lang="en-US" sz="850" dirty="0"/>
+            <a:endParaRPr lang="en-US" sz="800" dirty="0"/>
           </a:p>
         </p:txBody>
       </p:sp>
@@ -14729,8 +14729,8 @@
         </p:nvSpPr>
         <p:spPr>
           <a:xfrm>
-            <a:off x="5175504" y="1828800"/>
-            <a:ext cx="3749040" cy="402336"/>
+            <a:off x="5175504" y="1810512"/>
+            <a:ext cx="3566160" cy="438912"/>
           </a:xfrm>
           <a:prstGeom prst="rect">
             <a:avLst/>
@@ -14744,7 +14744,7 @@
           <a:p>
             <a:pPr indent="0" marL="0">
               <a:lnSpc>
-                <a:spcPct val="125000"/>
+                <a:spcPct val="130000"/>
               </a:lnSpc>
               <a:buNone/>
             </a:pPr>
@@ -14757,7 +14757,27 @@
                 <a:ea typeface="Noto Sans KR" pitchFamily="34" charset="-122"/>
                 <a:cs typeface="Noto Sans KR" pitchFamily="34" charset="-120"/>
               </a:rPr>
-              <a:t>투입을 인식한 검사기가 S/T 기준으로 이송하며 자동 촬영·딥러닝 판정을 수행합니다.</a:t>
+              <a:t>투입을 인식한 검사기가 S/T 기준으로 이송하며</a:t>
+            </a:r>
+            <a:endParaRPr lang="en-US" sz="950" dirty="0"/>
+          </a:p>
+          <a:p>
+            <a:pPr indent="0" marL="0">
+              <a:lnSpc>
+                <a:spcPct val="130000"/>
+              </a:lnSpc>
+              <a:buNone/>
+            </a:pPr>
+            <a:r>
+              <a:rPr lang="en-US" sz="950" dirty="0">
+                <a:solidFill>
+                  <a:srgbClr val="1E293B"/>
+                </a:solidFill>
+                <a:latin typeface="Noto Sans KR" pitchFamily="34" charset="0"/>
+                <a:ea typeface="Noto Sans KR" pitchFamily="34" charset="-122"/>
+                <a:cs typeface="Noto Sans KR" pitchFamily="34" charset="-120"/>
+              </a:rPr>
+              <a:t>자동 촬영·딥러닝 판정을 수행합니다.</a:t>
             </a:r>
             <a:endParaRPr lang="en-US" sz="950" dirty="0"/>
           </a:p>
@@ -15389,7 +15409,7 @@
         <p:spPr>
           <a:xfrm>
             <a:off x="969264" y="4297680"/>
-            <a:ext cx="3200400" cy="256032"/>
+            <a:ext cx="3474720" cy="256032"/>
           </a:xfrm>
           <a:prstGeom prst="rect">
             <a:avLst/>
@@ -15428,7 +15448,7 @@
         <p:spPr>
           <a:xfrm>
             <a:off x="969264" y="4535424"/>
-            <a:ext cx="7699248" cy="438912"/>
+            <a:ext cx="4206240" cy="438912"/>
           </a:xfrm>
           <a:prstGeom prst="rect">
             <a:avLst/>
@@ -15447,7 +15467,7 @@
               <a:buNone/>
             </a:pPr>
             <a:r>
-              <a:rPr lang="en-US" sz="900" dirty="0">
+              <a:rPr lang="en-US" sz="850" dirty="0">
                 <a:solidFill>
                   <a:srgbClr val="78350F"/>
                 </a:solidFill>
@@ -15455,9 +15475,29 @@
                 <a:ea typeface="Noto Sans KR" pitchFamily="34" charset="-122"/>
                 <a:cs typeface="Noto Sans KR" pitchFamily="34" charset="-120"/>
               </a:rPr>
-              <a:t>현재 검사원이 현장에서 판별한 양품·불량 결과 데이터를 AI 딥러닝 학습에 활용합니다. 현장 검사 이력(불량 유형, 판정 결과, 이미지)을 제공해 주시면 초기 학습 정확도를 높이고 도입 기간을 단축할 수 있습니다.</a:t>
-            </a:r>
-            <a:endParaRPr lang="en-US" sz="900" dirty="0"/>
+              <a:t>현재 검사원이 현장에서 판별한 양품·불량 결과 데이터를 AI 딥러닝 학습에 활용합니다.</a:t>
+            </a:r>
+            <a:endParaRPr lang="en-US" sz="850" dirty="0"/>
+          </a:p>
+          <a:p>
+            <a:pPr indent="0" marL="0">
+              <a:lnSpc>
+                <a:spcPct val="130000"/>
+              </a:lnSpc>
+              <a:buNone/>
+            </a:pPr>
+            <a:r>
+              <a:rPr lang="en-US" sz="850" dirty="0">
+                <a:solidFill>
+                  <a:srgbClr val="78350F"/>
+                </a:solidFill>
+                <a:latin typeface="Noto Sans KR" pitchFamily="34" charset="0"/>
+                <a:ea typeface="Noto Sans KR" pitchFamily="34" charset="-122"/>
+                <a:cs typeface="Noto Sans KR" pitchFamily="34" charset="-120"/>
+              </a:rPr>
+              <a:t>현장 검사 이력(불량 유형, 판정 결과, 이미지)을 제공해 주시면 초기 학습 정확도를 높이고 도입 기간을 단축할 수 있습니다.</a:t>
+            </a:r>
+            <a:endParaRPr lang="en-US" sz="850" dirty="0"/>
           </a:p>
         </p:txBody>
       </p:sp>
@@ -15469,12 +15509,12 @@
         </p:nvSpPr>
         <p:spPr>
           <a:xfrm>
-            <a:off x="6217920" y="4334256"/>
-            <a:ext cx="2487168" cy="621792"/>
+            <a:off x="6126480" y="4315968"/>
+            <a:ext cx="2578608" cy="640080"/>
           </a:xfrm>
           <a:prstGeom prst="roundRect">
             <a:avLst>
-              <a:gd name="adj" fmla="val 10294"/>
+              <a:gd name="adj" fmla="val 10000"/>
             </a:avLst>
           </a:prstGeom>
           <a:solidFill>
@@ -15503,8 +15543,8 @@
         </p:nvSpPr>
         <p:spPr>
           <a:xfrm>
-            <a:off x="6291072" y="4370832"/>
-            <a:ext cx="2377440" cy="219456"/>
+            <a:off x="6199632" y="4352544"/>
+            <a:ext cx="2468880" cy="201168"/>
           </a:xfrm>
           <a:prstGeom prst="rect">
             <a:avLst/>
@@ -15542,8 +15582,8 @@
         </p:nvSpPr>
         <p:spPr>
           <a:xfrm>
-            <a:off x="6291072" y="4553712"/>
-            <a:ext cx="2377440" cy="365760"/>
+            <a:off x="6199632" y="4535424"/>
+            <a:ext cx="2468880" cy="384048"/>
           </a:xfrm>
           <a:prstGeom prst="rect">
             <a:avLst/>
@@ -15557,7 +15597,7 @@
           <a:p>
             <a:pPr indent="0" marL="0">
               <a:lnSpc>
-                <a:spcPct val="125000"/>
+                <a:spcPct val="130000"/>
               </a:lnSpc>
               <a:buNone/>
             </a:pPr>
@@ -15570,14 +15610,14 @@
                 <a:ea typeface="Noto Sans KR" pitchFamily="34" charset="-122"/>
                 <a:cs typeface="Noto Sans KR" pitchFamily="34" charset="-120"/>
               </a:rPr>
-              <a:t>불량 유형별 이미지</a:t>
+              <a:t>· 불량 유형별 이미지</a:t>
             </a:r>
             <a:endParaRPr lang="en-US" sz="800" dirty="0"/>
           </a:p>
           <a:p>
             <a:pPr indent="0" marL="0">
               <a:lnSpc>
-                <a:spcPct val="125000"/>
+                <a:spcPct val="130000"/>
               </a:lnSpc>
               <a:buNone/>
             </a:pPr>
@@ -15590,7 +15630,27 @@
                 <a:ea typeface="Noto Sans KR" pitchFamily="34" charset="-122"/>
                 <a:cs typeface="Noto Sans KR" pitchFamily="34" charset="-120"/>
               </a:rPr>
-              <a:t>현장 판정 이력  |  양품 기준 샘플</a:t>
+              <a:t>· 현장 판정 이력</a:t>
+            </a:r>
+            <a:endParaRPr lang="en-US" sz="800" dirty="0"/>
+          </a:p>
+          <a:p>
+            <a:pPr indent="0" marL="0">
+              <a:lnSpc>
+                <a:spcPct val="130000"/>
+              </a:lnSpc>
+              <a:buNone/>
+            </a:pPr>
+            <a:r>
+              <a:rPr lang="en-US" sz="800" dirty="0">
+                <a:solidFill>
+                  <a:srgbClr val="78350F"/>
+                </a:solidFill>
+                <a:latin typeface="Noto Sans KR" pitchFamily="34" charset="0"/>
+                <a:ea typeface="Noto Sans KR" pitchFamily="34" charset="-122"/>
+                <a:cs typeface="Noto Sans KR" pitchFamily="34" charset="-120"/>
+              </a:rPr>
+              <a:t>· 양품 기준 샘플</a:t>
             </a:r>
             <a:endParaRPr lang="en-US" sz="800" dirty="0"/>
           </a:p>
@@ -17765,11 +17825,11 @@
         <p:spPr>
           <a:xfrm>
             <a:off x="365760" y="1042416"/>
-            <a:ext cx="1594714" cy="1389888"/>
+            <a:ext cx="1594714" cy="1170432"/>
           </a:xfrm>
           <a:prstGeom prst="roundRect">
             <a:avLst>
-              <a:gd name="adj" fmla="val 4605"/>
+              <a:gd name="adj" fmla="val 5469"/>
             </a:avLst>
           </a:prstGeom>
           <a:solidFill>
@@ -17799,7 +17859,7 @@
         <p:spPr>
           <a:xfrm>
             <a:off x="365760" y="1042416"/>
-            <a:ext cx="1594714" cy="128016"/>
+            <a:ext cx="1594714" cy="118872"/>
           </a:xfrm>
           <a:prstGeom prst="rect">
             <a:avLst/>
@@ -17823,8 +17883,8 @@
         </p:nvSpPr>
         <p:spPr>
           <a:xfrm>
-            <a:off x="934517" y="1225296"/>
-            <a:ext cx="457200" cy="457200"/>
+            <a:off x="943661" y="1207008"/>
+            <a:ext cx="438912" cy="438912"/>
           </a:xfrm>
           <a:prstGeom prst="ellipse">
             <a:avLst/>
@@ -17848,8 +17908,8 @@
         </p:nvSpPr>
         <p:spPr>
           <a:xfrm>
-            <a:off x="934517" y="1225296"/>
-            <a:ext cx="457200" cy="457200"/>
+            <a:off x="943661" y="1207008"/>
+            <a:ext cx="438912" cy="438912"/>
           </a:xfrm>
           <a:prstGeom prst="rect">
             <a:avLst/>
@@ -17865,7 +17925,7 @@
               <a:buNone/>
             </a:pPr>
             <a:r>
-              <a:rPr lang="en-US" sz="1600" dirty="0">
+              <a:rPr lang="en-US" sz="1500" dirty="0">
                 <a:solidFill>
                   <a:srgbClr val="000000"/>
                 </a:solidFill>
@@ -17875,7 +17935,7 @@
               </a:rPr>
               <a:t>🎯</a:t>
             </a:r>
-            <a:endParaRPr lang="en-US" sz="1600" dirty="0"/>
+            <a:endParaRPr lang="en-US" sz="1500" dirty="0"/>
           </a:p>
         </p:txBody>
       </p:sp>
@@ -17887,8 +17947,8 @@
         </p:nvSpPr>
         <p:spPr>
           <a:xfrm>
-            <a:off x="411480" y="1737360"/>
-            <a:ext cx="1503274" cy="329184"/>
+            <a:off x="411480" y="1719072"/>
+            <a:ext cx="1503274" cy="274320"/>
           </a:xfrm>
           <a:prstGeom prst="rect">
             <a:avLst/>
@@ -17902,7 +17962,7 @@
           <a:p>
             <a:pPr algn="ctr" indent="0" marL="0">
               <a:lnSpc>
-                <a:spcPct val="115000"/>
+                <a:spcPct val="110000"/>
               </a:lnSpc>
               <a:buNone/>
             </a:pPr>
@@ -17922,7 +17982,7 @@
           <a:p>
             <a:pPr algn="ctr" indent="0" marL="0">
               <a:lnSpc>
-                <a:spcPct val="115000"/>
+                <a:spcPct val="110000"/>
               </a:lnSpc>
               <a:buNone/>
             </a:pPr>
@@ -17949,7 +18009,7 @@
         </p:nvSpPr>
         <p:spPr>
           <a:xfrm>
-            <a:off x="475488" y="2084832"/>
+            <a:off x="475488" y="2011680"/>
             <a:ext cx="1375258" cy="0"/>
           </a:xfrm>
           <a:prstGeom prst="line">
@@ -17972,8 +18032,8 @@
         </p:nvSpPr>
         <p:spPr>
           <a:xfrm>
-            <a:off x="411480" y="2139696"/>
-            <a:ext cx="1503274" cy="292608"/>
+            <a:off x="411480" y="2066544"/>
+            <a:ext cx="1503274" cy="274320"/>
           </a:xfrm>
           <a:prstGeom prst="rect">
             <a:avLst/>
@@ -18035,11 +18095,11 @@
         <p:spPr>
           <a:xfrm>
             <a:off x="2070202" y="1042416"/>
-            <a:ext cx="1594714" cy="1389888"/>
+            <a:ext cx="1594714" cy="1170432"/>
           </a:xfrm>
           <a:prstGeom prst="roundRect">
             <a:avLst>
-              <a:gd name="adj" fmla="val 4605"/>
+              <a:gd name="adj" fmla="val 5469"/>
             </a:avLst>
           </a:prstGeom>
           <a:solidFill>
@@ -18069,7 +18129,7 @@
         <p:spPr>
           <a:xfrm>
             <a:off x="2070202" y="1042416"/>
-            <a:ext cx="1594714" cy="128016"/>
+            <a:ext cx="1594714" cy="118872"/>
           </a:xfrm>
           <a:prstGeom prst="rect">
             <a:avLst/>
@@ -18093,8 +18153,8 @@
         </p:nvSpPr>
         <p:spPr>
           <a:xfrm>
-            <a:off x="2638958" y="1225296"/>
-            <a:ext cx="457200" cy="457200"/>
+            <a:off x="2648102" y="1207008"/>
+            <a:ext cx="438912" cy="438912"/>
           </a:xfrm>
           <a:prstGeom prst="ellipse">
             <a:avLst/>
@@ -18118,8 +18178,8 @@
         </p:nvSpPr>
         <p:spPr>
           <a:xfrm>
-            <a:off x="2638958" y="1225296"/>
-            <a:ext cx="457200" cy="457200"/>
+            <a:off x="2648102" y="1207008"/>
+            <a:ext cx="438912" cy="438912"/>
           </a:xfrm>
           <a:prstGeom prst="rect">
             <a:avLst/>
@@ -18135,7 +18195,7 @@
               <a:buNone/>
             </a:pPr>
             <a:r>
-              <a:rPr lang="en-US" sz="1600" dirty="0">
+              <a:rPr lang="en-US" sz="1500" dirty="0">
                 <a:solidFill>
                   <a:srgbClr val="000000"/>
                 </a:solidFill>
@@ -18145,7 +18205,7 @@
               </a:rPr>
               <a:t>⚖️</a:t>
             </a:r>
-            <a:endParaRPr lang="en-US" sz="1600" dirty="0"/>
+            <a:endParaRPr lang="en-US" sz="1500" dirty="0"/>
           </a:p>
         </p:txBody>
       </p:sp>
@@ -18157,8 +18217,8 @@
         </p:nvSpPr>
         <p:spPr>
           <a:xfrm>
-            <a:off x="2115922" y="1737360"/>
-            <a:ext cx="1503274" cy="329184"/>
+            <a:off x="2115922" y="1719072"/>
+            <a:ext cx="1503274" cy="274320"/>
           </a:xfrm>
           <a:prstGeom prst="rect">
             <a:avLst/>
@@ -18172,7 +18232,7 @@
           <a:p>
             <a:pPr algn="ctr" indent="0" marL="0">
               <a:lnSpc>
-                <a:spcPct val="115000"/>
+                <a:spcPct val="110000"/>
               </a:lnSpc>
               <a:buNone/>
             </a:pPr>
@@ -18192,7 +18252,7 @@
           <a:p>
             <a:pPr algn="ctr" indent="0" marL="0">
               <a:lnSpc>
-                <a:spcPct val="115000"/>
+                <a:spcPct val="110000"/>
               </a:lnSpc>
               <a:buNone/>
             </a:pPr>
@@ -18219,7 +18279,7 @@
         </p:nvSpPr>
         <p:spPr>
           <a:xfrm>
-            <a:off x="2179930" y="2084832"/>
+            <a:off x="2179930" y="2011680"/>
             <a:ext cx="1375258" cy="0"/>
           </a:xfrm>
           <a:prstGeom prst="line">
@@ -18242,8 +18302,8 @@
         </p:nvSpPr>
         <p:spPr>
           <a:xfrm>
-            <a:off x="2115922" y="2139696"/>
-            <a:ext cx="1503274" cy="292608"/>
+            <a:off x="2115922" y="2066544"/>
+            <a:ext cx="1503274" cy="274320"/>
           </a:xfrm>
           <a:prstGeom prst="rect">
             <a:avLst/>
@@ -18305,11 +18365,11 @@
         <p:spPr>
           <a:xfrm>
             <a:off x="3774643" y="1042416"/>
-            <a:ext cx="1594714" cy="1389888"/>
+            <a:ext cx="1594714" cy="1170432"/>
           </a:xfrm>
           <a:prstGeom prst="roundRect">
             <a:avLst>
-              <a:gd name="adj" fmla="val 4605"/>
+              <a:gd name="adj" fmla="val 5469"/>
             </a:avLst>
           </a:prstGeom>
           <a:solidFill>
@@ -18339,7 +18399,7 @@
         <p:spPr>
           <a:xfrm>
             <a:off x="3774643" y="1042416"/>
-            <a:ext cx="1594714" cy="128016"/>
+            <a:ext cx="1594714" cy="118872"/>
           </a:xfrm>
           <a:prstGeom prst="rect">
             <a:avLst/>
@@ -18363,8 +18423,8 @@
         </p:nvSpPr>
         <p:spPr>
           <a:xfrm>
-            <a:off x="4343400" y="1225296"/>
-            <a:ext cx="457200" cy="457200"/>
+            <a:off x="4352544" y="1207008"/>
+            <a:ext cx="438912" cy="438912"/>
           </a:xfrm>
           <a:prstGeom prst="ellipse">
             <a:avLst/>
@@ -18388,8 +18448,8 @@
         </p:nvSpPr>
         <p:spPr>
           <a:xfrm>
-            <a:off x="4343400" y="1225296"/>
-            <a:ext cx="457200" cy="457200"/>
+            <a:off x="4352544" y="1207008"/>
+            <a:ext cx="438912" cy="438912"/>
           </a:xfrm>
           <a:prstGeom prst="rect">
             <a:avLst/>
@@ -18405,7 +18465,7 @@
               <a:buNone/>
             </a:pPr>
             <a:r>
-              <a:rPr lang="en-US" sz="1600" dirty="0">
+              <a:rPr lang="en-US" sz="1500" dirty="0">
                 <a:solidFill>
                   <a:srgbClr val="000000"/>
                 </a:solidFill>
@@ -18415,7 +18475,7 @@
               </a:rPr>
               <a:t>🚫</a:t>
             </a:r>
-            <a:endParaRPr lang="en-US" sz="1600" dirty="0"/>
+            <a:endParaRPr lang="en-US" sz="1500" dirty="0"/>
           </a:p>
         </p:txBody>
       </p:sp>
@@ -18427,8 +18487,8 @@
         </p:nvSpPr>
         <p:spPr>
           <a:xfrm>
-            <a:off x="3820363" y="1737360"/>
-            <a:ext cx="1503274" cy="329184"/>
+            <a:off x="3820363" y="1719072"/>
+            <a:ext cx="1503274" cy="274320"/>
           </a:xfrm>
           <a:prstGeom prst="rect">
             <a:avLst/>
@@ -18442,7 +18502,7 @@
           <a:p>
             <a:pPr algn="ctr" indent="0" marL="0">
               <a:lnSpc>
-                <a:spcPct val="115000"/>
+                <a:spcPct val="110000"/>
               </a:lnSpc>
               <a:buNone/>
             </a:pPr>
@@ -18462,7 +18522,7 @@
           <a:p>
             <a:pPr algn="ctr" indent="0" marL="0">
               <a:lnSpc>
-                <a:spcPct val="115000"/>
+                <a:spcPct val="110000"/>
               </a:lnSpc>
               <a:buNone/>
             </a:pPr>
@@ -18489,7 +18549,7 @@
         </p:nvSpPr>
         <p:spPr>
           <a:xfrm>
-            <a:off x="3884371" y="2084832"/>
+            <a:off x="3884371" y="2011680"/>
             <a:ext cx="1375258" cy="0"/>
           </a:xfrm>
           <a:prstGeom prst="line">
@@ -18512,8 +18572,8 @@
         </p:nvSpPr>
         <p:spPr>
           <a:xfrm>
-            <a:off x="3820363" y="2139696"/>
-            <a:ext cx="1503274" cy="292608"/>
+            <a:off x="3820363" y="2066544"/>
+            <a:ext cx="1503274" cy="274320"/>
           </a:xfrm>
           <a:prstGeom prst="rect">
             <a:avLst/>
@@ -18575,11 +18635,11 @@
         <p:spPr>
           <a:xfrm>
             <a:off x="5479085" y="1042416"/>
-            <a:ext cx="1594714" cy="1389888"/>
+            <a:ext cx="1594714" cy="1170432"/>
           </a:xfrm>
           <a:prstGeom prst="roundRect">
             <a:avLst>
-              <a:gd name="adj" fmla="val 4605"/>
+              <a:gd name="adj" fmla="val 5469"/>
             </a:avLst>
           </a:prstGeom>
           <a:solidFill>
@@ -18609,7 +18669,7 @@
         <p:spPr>
           <a:xfrm>
             <a:off x="5479085" y="1042416"/>
-            <a:ext cx="1594714" cy="128016"/>
+            <a:ext cx="1594714" cy="118872"/>
           </a:xfrm>
           <a:prstGeom prst="rect">
             <a:avLst/>
@@ -18633,8 +18693,8 @@
         </p:nvSpPr>
         <p:spPr>
           <a:xfrm>
-            <a:off x="6047842" y="1225296"/>
-            <a:ext cx="457200" cy="457200"/>
+            <a:off x="6056986" y="1207008"/>
+            <a:ext cx="438912" cy="438912"/>
           </a:xfrm>
           <a:prstGeom prst="ellipse">
             <a:avLst/>
@@ -18658,8 +18718,8 @@
         </p:nvSpPr>
         <p:spPr>
           <a:xfrm>
-            <a:off x="6047842" y="1225296"/>
-            <a:ext cx="457200" cy="457200"/>
+            <a:off x="6056986" y="1207008"/>
+            <a:ext cx="438912" cy="438912"/>
           </a:xfrm>
           <a:prstGeom prst="rect">
             <a:avLst/>
@@ -18675,7 +18735,7 @@
               <a:buNone/>
             </a:pPr>
             <a:r>
-              <a:rPr lang="en-US" sz="1600" dirty="0">
+              <a:rPr lang="en-US" sz="1500" dirty="0">
                 <a:solidFill>
                   <a:srgbClr val="000000"/>
                 </a:solidFill>
@@ -18685,7 +18745,7 @@
               </a:rPr>
               <a:t>📈</a:t>
             </a:r>
-            <a:endParaRPr lang="en-US" sz="1600" dirty="0"/>
+            <a:endParaRPr lang="en-US" sz="1500" dirty="0"/>
           </a:p>
         </p:txBody>
       </p:sp>
@@ -18697,8 +18757,8 @@
         </p:nvSpPr>
         <p:spPr>
           <a:xfrm>
-            <a:off x="5524805" y="1737360"/>
-            <a:ext cx="1503274" cy="329184"/>
+            <a:off x="5524805" y="1719072"/>
+            <a:ext cx="1503274" cy="274320"/>
           </a:xfrm>
           <a:prstGeom prst="rect">
             <a:avLst/>
@@ -18712,7 +18772,7 @@
           <a:p>
             <a:pPr algn="ctr" indent="0" marL="0">
               <a:lnSpc>
-                <a:spcPct val="115000"/>
+                <a:spcPct val="110000"/>
               </a:lnSpc>
               <a:buNone/>
             </a:pPr>
@@ -18732,7 +18792,7 @@
           <a:p>
             <a:pPr algn="ctr" indent="0" marL="0">
               <a:lnSpc>
-                <a:spcPct val="115000"/>
+                <a:spcPct val="110000"/>
               </a:lnSpc>
               <a:buNone/>
             </a:pPr>
@@ -18759,7 +18819,7 @@
         </p:nvSpPr>
         <p:spPr>
           <a:xfrm>
-            <a:off x="5588813" y="2084832"/>
+            <a:off x="5588813" y="2011680"/>
             <a:ext cx="1375258" cy="0"/>
           </a:xfrm>
           <a:prstGeom prst="line">
@@ -18782,8 +18842,8 @@
         </p:nvSpPr>
         <p:spPr>
           <a:xfrm>
-            <a:off x="5524805" y="2139696"/>
-            <a:ext cx="1503274" cy="292608"/>
+            <a:off x="5524805" y="2066544"/>
+            <a:ext cx="1503274" cy="274320"/>
           </a:xfrm>
           <a:prstGeom prst="rect">
             <a:avLst/>
@@ -18845,11 +18905,11 @@
         <p:spPr>
           <a:xfrm>
             <a:off x="7183526" y="1042416"/>
-            <a:ext cx="1594714" cy="1389888"/>
+            <a:ext cx="1594714" cy="1170432"/>
           </a:xfrm>
           <a:prstGeom prst="roundRect">
             <a:avLst>
-              <a:gd name="adj" fmla="val 4605"/>
+              <a:gd name="adj" fmla="val 5469"/>
             </a:avLst>
           </a:prstGeom>
           <a:solidFill>
@@ -18879,7 +18939,7 @@
         <p:spPr>
           <a:xfrm>
             <a:off x="7183526" y="1042416"/>
-            <a:ext cx="1594714" cy="128016"/>
+            <a:ext cx="1594714" cy="118872"/>
           </a:xfrm>
           <a:prstGeom prst="rect">
             <a:avLst/>
@@ -18903,8 +18963,8 @@
         </p:nvSpPr>
         <p:spPr>
           <a:xfrm>
-            <a:off x="7752283" y="1225296"/>
-            <a:ext cx="457200" cy="457200"/>
+            <a:off x="7761427" y="1207008"/>
+            <a:ext cx="438912" cy="438912"/>
           </a:xfrm>
           <a:prstGeom prst="ellipse">
             <a:avLst/>
@@ -18928,8 +18988,8 @@
         </p:nvSpPr>
         <p:spPr>
           <a:xfrm>
-            <a:off x="7752283" y="1225296"/>
-            <a:ext cx="457200" cy="457200"/>
+            <a:off x="7761427" y="1207008"/>
+            <a:ext cx="438912" cy="438912"/>
           </a:xfrm>
           <a:prstGeom prst="rect">
             <a:avLst/>
@@ -18945,7 +19005,7 @@
               <a:buNone/>
             </a:pPr>
             <a:r>
-              <a:rPr lang="en-US" sz="1600" dirty="0">
+              <a:rPr lang="en-US" sz="1500" dirty="0">
                 <a:solidFill>
                   <a:srgbClr val="000000"/>
                 </a:solidFill>
@@ -18955,7 +19015,7 @@
               </a:rPr>
               <a:t>👤</a:t>
             </a:r>
-            <a:endParaRPr lang="en-US" sz="1600" dirty="0"/>
+            <a:endParaRPr lang="en-US" sz="1500" dirty="0"/>
           </a:p>
         </p:txBody>
       </p:sp>
@@ -18967,8 +19027,8 @@
         </p:nvSpPr>
         <p:spPr>
           <a:xfrm>
-            <a:off x="7229246" y="1737360"/>
-            <a:ext cx="1503274" cy="329184"/>
+            <a:off x="7229246" y="1719072"/>
+            <a:ext cx="1503274" cy="274320"/>
           </a:xfrm>
           <a:prstGeom prst="rect">
             <a:avLst/>
@@ -18982,7 +19042,7 @@
           <a:p>
             <a:pPr algn="ctr" indent="0" marL="0">
               <a:lnSpc>
-                <a:spcPct val="115000"/>
+                <a:spcPct val="110000"/>
               </a:lnSpc>
               <a:buNone/>
             </a:pPr>
@@ -19002,7 +19062,7 @@
           <a:p>
             <a:pPr algn="ctr" indent="0" marL="0">
               <a:lnSpc>
-                <a:spcPct val="115000"/>
+                <a:spcPct val="110000"/>
               </a:lnSpc>
               <a:buNone/>
             </a:pPr>
@@ -19029,7 +19089,7 @@
         </p:nvSpPr>
         <p:spPr>
           <a:xfrm>
-            <a:off x="7293254" y="2084832"/>
+            <a:off x="7293254" y="2011680"/>
             <a:ext cx="1375258" cy="0"/>
           </a:xfrm>
           <a:prstGeom prst="line">
@@ -19052,8 +19112,8 @@
         </p:nvSpPr>
         <p:spPr>
           <a:xfrm>
-            <a:off x="7229246" y="2139696"/>
-            <a:ext cx="1503274" cy="292608"/>
+            <a:off x="7229246" y="2066544"/>
+            <a:ext cx="1503274" cy="274320"/>
           </a:xfrm>
           <a:prstGeom prst="rect">
             <a:avLst/>
@@ -19114,12 +19174,12 @@
         </p:nvSpPr>
         <p:spPr>
           <a:xfrm>
-            <a:off x="365760" y="2542032"/>
-            <a:ext cx="2743200" cy="2546604"/>
+            <a:off x="365760" y="2304288"/>
+            <a:ext cx="2743200" cy="2793492"/>
           </a:xfrm>
           <a:prstGeom prst="roundRect">
             <a:avLst>
-              <a:gd name="adj" fmla="val 2513"/>
+              <a:gd name="adj" fmla="val 2333"/>
             </a:avLst>
           </a:prstGeom>
           <a:solidFill>
@@ -19148,12 +19208,12 @@
         </p:nvSpPr>
         <p:spPr>
           <a:xfrm>
-            <a:off x="365760" y="2542032"/>
-            <a:ext cx="2743200" cy="310896"/>
+            <a:off x="365760" y="2304288"/>
+            <a:ext cx="2743200" cy="347472"/>
           </a:xfrm>
           <a:prstGeom prst="roundRect">
             <a:avLst>
-              <a:gd name="adj" fmla="val 20588"/>
+              <a:gd name="adj" fmla="val 18421"/>
             </a:avLst>
           </a:prstGeom>
           <a:solidFill>
@@ -19175,8 +19235,8 @@
         </p:nvSpPr>
         <p:spPr>
           <a:xfrm>
-            <a:off x="365760" y="2542032"/>
-            <a:ext cx="2743200" cy="310896"/>
+            <a:off x="365760" y="2304288"/>
+            <a:ext cx="2743200" cy="347472"/>
           </a:xfrm>
           <a:prstGeom prst="rect">
             <a:avLst/>
@@ -19192,7 +19252,7 @@
               <a:buNone/>
             </a:pPr>
             <a:r>
-              <a:rPr lang="en-US" sz="1150" b="1" dirty="0">
+              <a:rPr lang="en-US" sz="1200" b="1" dirty="0">
                 <a:solidFill>
                   <a:srgbClr val="FFFFFF"/>
                 </a:solidFill>
@@ -19202,7 +19262,7 @@
               </a:rPr>
               <a:t>품질</a:t>
             </a:r>
-            <a:endParaRPr lang="en-US" sz="1150" dirty="0"/>
+            <a:endParaRPr lang="en-US" sz="1200" dirty="0"/>
           </a:p>
         </p:txBody>
       </p:sp>
@@ -19214,12 +19274,12 @@
         </p:nvSpPr>
         <p:spPr>
           <a:xfrm>
-            <a:off x="457200" y="2926080"/>
-            <a:ext cx="2560320" cy="678180"/>
+            <a:off x="457200" y="2706624"/>
+            <a:ext cx="2560320" cy="760476"/>
           </a:xfrm>
           <a:prstGeom prst="roundRect">
             <a:avLst>
-              <a:gd name="adj" fmla="val 9438"/>
+              <a:gd name="adj" fmla="val 8417"/>
             </a:avLst>
           </a:prstGeom>
           <a:solidFill>
@@ -19248,8 +19308,8 @@
         </p:nvSpPr>
         <p:spPr>
           <a:xfrm>
-            <a:off x="530352" y="2980944"/>
-            <a:ext cx="2414016" cy="586740"/>
+            <a:off x="530352" y="2761488"/>
+            <a:ext cx="2414016" cy="669036"/>
           </a:xfrm>
           <a:prstGeom prst="rect">
             <a:avLst/>
@@ -19263,12 +19323,12 @@
           <a:p>
             <a:pPr indent="0" marL="0">
               <a:lnSpc>
-                <a:spcPct val="115000"/>
+                <a:spcPct val="120000"/>
               </a:lnSpc>
               <a:buNone/>
             </a:pPr>
             <a:r>
-              <a:rPr lang="en-US" sz="900" dirty="0">
+              <a:rPr lang="en-US" sz="950" dirty="0">
                 <a:solidFill>
                   <a:srgbClr val="1E293B"/>
                 </a:solidFill>
@@ -19276,9 +19336,29 @@
                 <a:ea typeface="Noto Sans KR" pitchFamily="34" charset="-122"/>
                 <a:cs typeface="Noto Sans KR" pitchFamily="34" charset="-120"/>
               </a:rPr>
-              <a:t>불량 검출율 지속 향상 (딥러닝 누적 학습)</a:t>
-            </a:r>
-            <a:endParaRPr lang="en-US" sz="900" dirty="0"/>
+              <a:t>불량 검출율 지속 향상</a:t>
+            </a:r>
+            <a:endParaRPr lang="en-US" sz="950" dirty="0"/>
+          </a:p>
+          <a:p>
+            <a:pPr indent="0" marL="0">
+              <a:lnSpc>
+                <a:spcPct val="120000"/>
+              </a:lnSpc>
+              <a:buNone/>
+            </a:pPr>
+            <a:r>
+              <a:rPr lang="en-US" sz="950" dirty="0">
+                <a:solidFill>
+                  <a:srgbClr val="1E293B"/>
+                </a:solidFill>
+                <a:latin typeface="Noto Sans KR" pitchFamily="34" charset="0"/>
+                <a:ea typeface="Noto Sans KR" pitchFamily="34" charset="-122"/>
+                <a:cs typeface="Noto Sans KR" pitchFamily="34" charset="-120"/>
+              </a:rPr>
+              <a:t>(딥러닝 누적 학습)</a:t>
+            </a:r>
+            <a:endParaRPr lang="en-US" sz="950" dirty="0"/>
           </a:p>
         </p:txBody>
       </p:sp>
@@ -19290,12 +19370,12 @@
         </p:nvSpPr>
         <p:spPr>
           <a:xfrm>
-            <a:off x="457200" y="3659124"/>
-            <a:ext cx="2560320" cy="678180"/>
+            <a:off x="457200" y="3512820"/>
+            <a:ext cx="2560320" cy="760476"/>
           </a:xfrm>
           <a:prstGeom prst="roundRect">
             <a:avLst>
-              <a:gd name="adj" fmla="val 9438"/>
+              <a:gd name="adj" fmla="val 8417"/>
             </a:avLst>
           </a:prstGeom>
           <a:solidFill>
@@ -19324,8 +19404,8 @@
         </p:nvSpPr>
         <p:spPr>
           <a:xfrm>
-            <a:off x="530352" y="3713988"/>
-            <a:ext cx="2414016" cy="586740"/>
+            <a:off x="530352" y="3567684"/>
+            <a:ext cx="2414016" cy="669036"/>
           </a:xfrm>
           <a:prstGeom prst="rect">
             <a:avLst/>
@@ -19339,12 +19419,12 @@
           <a:p>
             <a:pPr indent="0" marL="0">
               <a:lnSpc>
-                <a:spcPct val="115000"/>
+                <a:spcPct val="120000"/>
               </a:lnSpc>
               <a:buNone/>
             </a:pPr>
             <a:r>
-              <a:rPr lang="en-US" sz="900" dirty="0">
+              <a:rPr lang="en-US" sz="950" dirty="0">
                 <a:solidFill>
                   <a:srgbClr val="1E293B"/>
                 </a:solidFill>
@@ -19354,7 +19434,7 @@
               </a:rPr>
               <a:t>불량 유형별 자동 분류·통계 제공</a:t>
             </a:r>
-            <a:endParaRPr lang="en-US" sz="900" dirty="0"/>
+            <a:endParaRPr lang="en-US" sz="950" dirty="0"/>
           </a:p>
         </p:txBody>
       </p:sp>
@@ -19366,12 +19446,12 @@
         </p:nvSpPr>
         <p:spPr>
           <a:xfrm>
-            <a:off x="457200" y="4392168"/>
-            <a:ext cx="2560320" cy="678180"/>
+            <a:off x="457200" y="4319016"/>
+            <a:ext cx="2560320" cy="760476"/>
           </a:xfrm>
           <a:prstGeom prst="roundRect">
             <a:avLst>
-              <a:gd name="adj" fmla="val 9438"/>
+              <a:gd name="adj" fmla="val 8417"/>
             </a:avLst>
           </a:prstGeom>
           <a:solidFill>
@@ -19400,8 +19480,8 @@
         </p:nvSpPr>
         <p:spPr>
           <a:xfrm>
-            <a:off x="530352" y="4447032"/>
-            <a:ext cx="2414016" cy="586740"/>
+            <a:off x="530352" y="4373880"/>
+            <a:ext cx="2414016" cy="669036"/>
           </a:xfrm>
           <a:prstGeom prst="rect">
             <a:avLst/>
@@ -19415,12 +19495,12 @@
           <a:p>
             <a:pPr indent="0" marL="0">
               <a:lnSpc>
-                <a:spcPct val="115000"/>
+                <a:spcPct val="120000"/>
               </a:lnSpc>
               <a:buNone/>
             </a:pPr>
             <a:r>
-              <a:rPr lang="en-US" sz="900" dirty="0">
+              <a:rPr lang="en-US" sz="950" dirty="0">
                 <a:solidFill>
                   <a:srgbClr val="1E293B"/>
                 </a:solidFill>
@@ -19430,7 +19510,7 @@
               </a:rPr>
               <a:t>후공정 불량 혼입 원천 차단</a:t>
             </a:r>
-            <a:endParaRPr lang="en-US" sz="900" dirty="0"/>
+            <a:endParaRPr lang="en-US" sz="950" dirty="0"/>
           </a:p>
         </p:txBody>
       </p:sp>
@@ -19442,12 +19522,12 @@
         </p:nvSpPr>
         <p:spPr>
           <a:xfrm>
-            <a:off x="3200400" y="2542032"/>
-            <a:ext cx="2743200" cy="2546604"/>
+            <a:off x="3200400" y="2304288"/>
+            <a:ext cx="2743200" cy="2793492"/>
           </a:xfrm>
           <a:prstGeom prst="roundRect">
             <a:avLst>
-              <a:gd name="adj" fmla="val 2513"/>
+              <a:gd name="adj" fmla="val 2333"/>
             </a:avLst>
           </a:prstGeom>
           <a:solidFill>
@@ -19476,12 +19556,12 @@
         </p:nvSpPr>
         <p:spPr>
           <a:xfrm>
-            <a:off x="3200400" y="2542032"/>
-            <a:ext cx="2743200" cy="310896"/>
+            <a:off x="3200400" y="2304288"/>
+            <a:ext cx="2743200" cy="347472"/>
           </a:xfrm>
           <a:prstGeom prst="roundRect">
             <a:avLst>
-              <a:gd name="adj" fmla="val 20588"/>
+              <a:gd name="adj" fmla="val 18421"/>
             </a:avLst>
           </a:prstGeom>
           <a:solidFill>
@@ -19503,8 +19583,8 @@
         </p:nvSpPr>
         <p:spPr>
           <a:xfrm>
-            <a:off x="3200400" y="2542032"/>
-            <a:ext cx="2743200" cy="310896"/>
+            <a:off x="3200400" y="2304288"/>
+            <a:ext cx="2743200" cy="347472"/>
           </a:xfrm>
           <a:prstGeom prst="rect">
             <a:avLst/>
@@ -19520,7 +19600,7 @@
               <a:buNone/>
             </a:pPr>
             <a:r>
-              <a:rPr lang="en-US" sz="1150" b="1" dirty="0">
+              <a:rPr lang="en-US" sz="1200" b="1" dirty="0">
                 <a:solidFill>
                   <a:srgbClr val="FFFFFF"/>
                 </a:solidFill>
@@ -19530,7 +19610,7 @@
               </a:rPr>
               <a:t>운영</a:t>
             </a:r>
-            <a:endParaRPr lang="en-US" sz="1150" dirty="0"/>
+            <a:endParaRPr lang="en-US" sz="1200" dirty="0"/>
           </a:p>
         </p:txBody>
       </p:sp>
@@ -19542,12 +19622,12 @@
         </p:nvSpPr>
         <p:spPr>
           <a:xfrm>
-            <a:off x="3291840" y="2926080"/>
-            <a:ext cx="2560320" cy="678180"/>
+            <a:off x="3291840" y="2706624"/>
+            <a:ext cx="2560320" cy="760476"/>
           </a:xfrm>
           <a:prstGeom prst="roundRect">
             <a:avLst>
-              <a:gd name="adj" fmla="val 9438"/>
+              <a:gd name="adj" fmla="val 8417"/>
             </a:avLst>
           </a:prstGeom>
           <a:solidFill>
@@ -19576,8 +19656,8 @@
         </p:nvSpPr>
         <p:spPr>
           <a:xfrm>
-            <a:off x="3364992" y="2980944"/>
-            <a:ext cx="2414016" cy="586740"/>
+            <a:off x="3364992" y="2761488"/>
+            <a:ext cx="2414016" cy="669036"/>
           </a:xfrm>
           <a:prstGeom prst="rect">
             <a:avLst/>
@@ -19591,12 +19671,12 @@
           <a:p>
             <a:pPr indent="0" marL="0">
               <a:lnSpc>
-                <a:spcPct val="115000"/>
+                <a:spcPct val="120000"/>
               </a:lnSpc>
               <a:buNone/>
             </a:pPr>
             <a:r>
-              <a:rPr lang="en-US" sz="900" dirty="0">
+              <a:rPr lang="en-US" sz="950" dirty="0">
                 <a:solidFill>
                   <a:srgbClr val="1E293B"/>
                 </a:solidFill>
@@ -19606,7 +19686,7 @@
               </a:rPr>
               <a:t>검사 공정 무인 자동 운영</a:t>
             </a:r>
-            <a:endParaRPr lang="en-US" sz="900" dirty="0"/>
+            <a:endParaRPr lang="en-US" sz="950" dirty="0"/>
           </a:p>
         </p:txBody>
       </p:sp>
@@ -19618,12 +19698,12 @@
         </p:nvSpPr>
         <p:spPr>
           <a:xfrm>
-            <a:off x="3291840" y="3659124"/>
-            <a:ext cx="2560320" cy="678180"/>
+            <a:off x="3291840" y="3512820"/>
+            <a:ext cx="2560320" cy="760476"/>
           </a:xfrm>
           <a:prstGeom prst="roundRect">
             <a:avLst>
-              <a:gd name="adj" fmla="val 9438"/>
+              <a:gd name="adj" fmla="val 8417"/>
             </a:avLst>
           </a:prstGeom>
           <a:solidFill>
@@ -19652,8 +19732,8 @@
         </p:nvSpPr>
         <p:spPr>
           <a:xfrm>
-            <a:off x="3364992" y="3713988"/>
-            <a:ext cx="2414016" cy="586740"/>
+            <a:off x="3364992" y="3567684"/>
+            <a:ext cx="2414016" cy="669036"/>
           </a:xfrm>
           <a:prstGeom prst="rect">
             <a:avLst/>
@@ -19667,12 +19747,12 @@
           <a:p>
             <a:pPr indent="0" marL="0">
               <a:lnSpc>
-                <a:spcPct val="115000"/>
+                <a:spcPct val="120000"/>
               </a:lnSpc>
               <a:buNone/>
             </a:pPr>
             <a:r>
-              <a:rPr lang="en-US" sz="900" dirty="0">
+              <a:rPr lang="en-US" sz="950" dirty="0">
                 <a:solidFill>
                   <a:srgbClr val="1E293B"/>
                 </a:solidFill>
@@ -19682,7 +19762,7 @@
               </a:rPr>
               <a:t>검사 인력 생산 공정 재배치</a:t>
             </a:r>
-            <a:endParaRPr lang="en-US" sz="900" dirty="0"/>
+            <a:endParaRPr lang="en-US" sz="950" dirty="0"/>
           </a:p>
         </p:txBody>
       </p:sp>
@@ -19694,12 +19774,12 @@
         </p:nvSpPr>
         <p:spPr>
           <a:xfrm>
-            <a:off x="3291840" y="4392168"/>
-            <a:ext cx="2560320" cy="678180"/>
+            <a:off x="3291840" y="4319016"/>
+            <a:ext cx="2560320" cy="760476"/>
           </a:xfrm>
           <a:prstGeom prst="roundRect">
             <a:avLst>
-              <a:gd name="adj" fmla="val 9438"/>
+              <a:gd name="adj" fmla="val 8417"/>
             </a:avLst>
           </a:prstGeom>
           <a:solidFill>
@@ -19728,8 +19808,8 @@
         </p:nvSpPr>
         <p:spPr>
           <a:xfrm>
-            <a:off x="3364992" y="4447032"/>
-            <a:ext cx="2414016" cy="586740"/>
+            <a:off x="3364992" y="4373880"/>
+            <a:ext cx="2414016" cy="669036"/>
           </a:xfrm>
           <a:prstGeom prst="rect">
             <a:avLst/>
@@ -19743,12 +19823,12 @@
           <a:p>
             <a:pPr indent="0" marL="0">
               <a:lnSpc>
-                <a:spcPct val="115000"/>
+                <a:spcPct val="120000"/>
               </a:lnSpc>
               <a:buNone/>
             </a:pPr>
             <a:r>
-              <a:rPr lang="en-US" sz="900" dirty="0">
+              <a:rPr lang="en-US" sz="950" dirty="0">
                 <a:solidFill>
                   <a:srgbClr val="1E293B"/>
                 </a:solidFill>
@@ -19758,7 +19838,7 @@
               </a:rPr>
               <a:t>품질 편차 완전 제거</a:t>
             </a:r>
-            <a:endParaRPr lang="en-US" sz="900" dirty="0"/>
+            <a:endParaRPr lang="en-US" sz="950" dirty="0"/>
           </a:p>
         </p:txBody>
       </p:sp>
@@ -19770,12 +19850,12 @@
         </p:nvSpPr>
         <p:spPr>
           <a:xfrm>
-            <a:off x="6035040" y="2542032"/>
-            <a:ext cx="2743200" cy="2546604"/>
+            <a:off x="6035040" y="2304288"/>
+            <a:ext cx="2743200" cy="2793492"/>
           </a:xfrm>
           <a:prstGeom prst="roundRect">
             <a:avLst>
-              <a:gd name="adj" fmla="val 2513"/>
+              <a:gd name="adj" fmla="val 2333"/>
             </a:avLst>
           </a:prstGeom>
           <a:solidFill>
@@ -19804,12 +19884,12 @@
         </p:nvSpPr>
         <p:spPr>
           <a:xfrm>
-            <a:off x="6035040" y="2542032"/>
-            <a:ext cx="2743200" cy="310896"/>
+            <a:off x="6035040" y="2304288"/>
+            <a:ext cx="2743200" cy="347472"/>
           </a:xfrm>
           <a:prstGeom prst="roundRect">
             <a:avLst>
-              <a:gd name="adj" fmla="val 20588"/>
+              <a:gd name="adj" fmla="val 18421"/>
             </a:avLst>
           </a:prstGeom>
           <a:solidFill>
@@ -19831,8 +19911,8 @@
         </p:nvSpPr>
         <p:spPr>
           <a:xfrm>
-            <a:off x="6035040" y="2542032"/>
-            <a:ext cx="2743200" cy="310896"/>
+            <a:off x="6035040" y="2304288"/>
+            <a:ext cx="2743200" cy="347472"/>
           </a:xfrm>
           <a:prstGeom prst="rect">
             <a:avLst/>
@@ -19848,7 +19928,7 @@
               <a:buNone/>
             </a:pPr>
             <a:r>
-              <a:rPr lang="en-US" sz="1150" b="1" dirty="0">
+              <a:rPr lang="en-US" sz="1200" b="1" dirty="0">
                 <a:solidFill>
                   <a:srgbClr val="FFFFFF"/>
                 </a:solidFill>
@@ -19858,7 +19938,7 @@
               </a:rPr>
               <a:t>경쟁력</a:t>
             </a:r>
-            <a:endParaRPr lang="en-US" sz="1150" dirty="0"/>
+            <a:endParaRPr lang="en-US" sz="1200" dirty="0"/>
           </a:p>
         </p:txBody>
       </p:sp>
@@ -19870,12 +19950,12 @@
         </p:nvSpPr>
         <p:spPr>
           <a:xfrm>
-            <a:off x="6126480" y="2926080"/>
-            <a:ext cx="2560320" cy="678180"/>
+            <a:off x="6126480" y="2706624"/>
+            <a:ext cx="2560320" cy="760476"/>
           </a:xfrm>
           <a:prstGeom prst="roundRect">
             <a:avLst>
-              <a:gd name="adj" fmla="val 9438"/>
+              <a:gd name="adj" fmla="val 8417"/>
             </a:avLst>
           </a:prstGeom>
           <a:solidFill>
@@ -19904,8 +19984,8 @@
         </p:nvSpPr>
         <p:spPr>
           <a:xfrm>
-            <a:off x="6199632" y="2980944"/>
-            <a:ext cx="2414016" cy="586740"/>
+            <a:off x="6199632" y="2761488"/>
+            <a:ext cx="2414016" cy="669036"/>
           </a:xfrm>
           <a:prstGeom prst="rect">
             <a:avLst/>
@@ -19919,12 +19999,12 @@
           <a:p>
             <a:pPr indent="0" marL="0">
               <a:lnSpc>
-                <a:spcPct val="115000"/>
+                <a:spcPct val="120000"/>
               </a:lnSpc>
               <a:buNone/>
             </a:pPr>
             <a:r>
-              <a:rPr lang="en-US" sz="900" dirty="0">
+              <a:rPr lang="en-US" sz="950" dirty="0">
                 <a:solidFill>
                   <a:srgbClr val="1E293B"/>
                 </a:solidFill>
@@ -19934,7 +20014,7 @@
               </a:rPr>
               <a:t>납품처 신뢰도 향상</a:t>
             </a:r>
-            <a:endParaRPr lang="en-US" sz="900" dirty="0"/>
+            <a:endParaRPr lang="en-US" sz="950" dirty="0"/>
           </a:p>
         </p:txBody>
       </p:sp>
@@ -19946,12 +20026,12 @@
         </p:nvSpPr>
         <p:spPr>
           <a:xfrm>
-            <a:off x="6126480" y="3659124"/>
-            <a:ext cx="2560320" cy="678180"/>
+            <a:off x="6126480" y="3512820"/>
+            <a:ext cx="2560320" cy="760476"/>
           </a:xfrm>
           <a:prstGeom prst="roundRect">
             <a:avLst>
-              <a:gd name="adj" fmla="val 9438"/>
+              <a:gd name="adj" fmla="val 8417"/>
             </a:avLst>
           </a:prstGeom>
           <a:solidFill>
@@ -19980,8 +20060,8 @@
         </p:nvSpPr>
         <p:spPr>
           <a:xfrm>
-            <a:off x="6199632" y="3713988"/>
-            <a:ext cx="2414016" cy="586740"/>
+            <a:off x="6199632" y="3567684"/>
+            <a:ext cx="2414016" cy="669036"/>
           </a:xfrm>
           <a:prstGeom prst="rect">
             <a:avLst/>
@@ -19995,12 +20075,12 @@
           <a:p>
             <a:pPr indent="0" marL="0">
               <a:lnSpc>
-                <a:spcPct val="115000"/>
+                <a:spcPct val="120000"/>
               </a:lnSpc>
               <a:buNone/>
             </a:pPr>
             <a:r>
-              <a:rPr lang="en-US" sz="900" dirty="0">
+              <a:rPr lang="en-US" sz="950" dirty="0">
                 <a:solidFill>
                   <a:srgbClr val="1E293B"/>
                 </a:solidFill>
@@ -20008,9 +20088,29 @@
                 <a:ea typeface="Noto Sans KR" pitchFamily="34" charset="-122"/>
                 <a:cs typeface="Noto Sans KR" pitchFamily="34" charset="-120"/>
               </a:rPr>
-              <a:t>클레임 대응 근거 데이터 확보</a:t>
-            </a:r>
-            <a:endParaRPr lang="en-US" sz="900" dirty="0"/>
+              <a:t>클레임 대응 근거</a:t>
+            </a:r>
+            <a:endParaRPr lang="en-US" sz="950" dirty="0"/>
+          </a:p>
+          <a:p>
+            <a:pPr indent="0" marL="0">
+              <a:lnSpc>
+                <a:spcPct val="120000"/>
+              </a:lnSpc>
+              <a:buNone/>
+            </a:pPr>
+            <a:r>
+              <a:rPr lang="en-US" sz="950" dirty="0">
+                <a:solidFill>
+                  <a:srgbClr val="1E293B"/>
+                </a:solidFill>
+                <a:latin typeface="Noto Sans KR" pitchFamily="34" charset="0"/>
+                <a:ea typeface="Noto Sans KR" pitchFamily="34" charset="-122"/>
+                <a:cs typeface="Noto Sans KR" pitchFamily="34" charset="-120"/>
+              </a:rPr>
+              <a:t>데이터 확보</a:t>
+            </a:r>
+            <a:endParaRPr lang="en-US" sz="950" dirty="0"/>
           </a:p>
         </p:txBody>
       </p:sp>
@@ -20022,12 +20122,12 @@
         </p:nvSpPr>
         <p:spPr>
           <a:xfrm>
-            <a:off x="6126480" y="4392168"/>
-            <a:ext cx="2560320" cy="678180"/>
+            <a:off x="6126480" y="4319016"/>
+            <a:ext cx="2560320" cy="760476"/>
           </a:xfrm>
           <a:prstGeom prst="roundRect">
             <a:avLst>
-              <a:gd name="adj" fmla="val 9438"/>
+              <a:gd name="adj" fmla="val 8417"/>
             </a:avLst>
           </a:prstGeom>
           <a:solidFill>
@@ -20056,8 +20156,8 @@
         </p:nvSpPr>
         <p:spPr>
           <a:xfrm>
-            <a:off x="6199632" y="4447032"/>
-            <a:ext cx="2414016" cy="586740"/>
+            <a:off x="6199632" y="4373880"/>
+            <a:ext cx="2414016" cy="669036"/>
           </a:xfrm>
           <a:prstGeom prst="rect">
             <a:avLst/>
@@ -20071,12 +20171,12 @@
           <a:p>
             <a:pPr indent="0" marL="0">
               <a:lnSpc>
-                <a:spcPct val="115000"/>
+                <a:spcPct val="120000"/>
               </a:lnSpc>
               <a:buNone/>
             </a:pPr>
             <a:r>
-              <a:rPr lang="en-US" sz="900" dirty="0">
+              <a:rPr lang="en-US" sz="950" dirty="0">
                 <a:solidFill>
                   <a:srgbClr val="1E293B"/>
                 </a:solidFill>
@@ -20086,7 +20186,7 @@
               </a:rPr>
               <a:t>수주 경쟁력 강화</a:t>
             </a:r>
-            <a:endParaRPr lang="en-US" sz="900" dirty="0"/>
+            <a:endParaRPr lang="en-US" sz="950" dirty="0"/>
           </a:p>
         </p:txBody>
       </p:sp>

</xml_diff>

<commit_message>
Update winnercomb.pptx - concept image ratio fix
</commit_message>
<xml_diff>
--- a/winnercomb.pptx
+++ b/winnercomb.pptx
@@ -14069,7 +14069,7 @@
         <p:spPr>
           <a:xfrm>
             <a:off x="0" y="0"/>
-            <a:ext cx="9144000" cy="1005840"/>
+            <a:ext cx="9144000" cy="420624"/>
           </a:xfrm>
           <a:prstGeom prst="rect">
             <a:avLst/>
@@ -14093,8 +14093,8 @@
         </p:nvSpPr>
         <p:spPr>
           <a:xfrm>
-            <a:off x="365760" y="237744"/>
-            <a:ext cx="8412480" cy="475488"/>
+            <a:off x="365760" y="0"/>
+            <a:ext cx="8412480" cy="420624"/>
           </a:xfrm>
           <a:prstGeom prst="rect">
             <a:avLst/>
@@ -14110,7 +14110,7 @@
               <a:buNone/>
             </a:pPr>
             <a:r>
-              <a:rPr lang="en-US" sz="2200" b="1" dirty="0">
+              <a:rPr lang="en-US" sz="1800" b="1" dirty="0">
                 <a:solidFill>
                   <a:srgbClr val="FFFFFF"/>
                 </a:solidFill>
@@ -14120,52 +14120,13 @@
               </a:rPr>
               <a:t>설비 컨셉트 이미지</a:t>
             </a:r>
-            <a:endParaRPr lang="en-US" sz="2200" dirty="0"/>
-          </a:p>
-        </p:txBody>
-      </p:sp>
-      <p:sp>
-        <p:nvSpPr>
-          <p:cNvPr id="5" name="Text 3"/>
-          <p:cNvSpPr/>
-          <p:nvPr/>
-        </p:nvSpPr>
-        <p:spPr>
-          <a:xfrm>
-            <a:off x="365760" y="713232"/>
-            <a:ext cx="8412480" cy="237744"/>
-          </a:xfrm>
-          <a:prstGeom prst="rect">
-            <a:avLst/>
-          </a:prstGeom>
-          <a:noFill/>
-          <a:ln/>
-        </p:spPr>
-        <p:txBody>
-          <a:bodyPr wrap="square" lIns="0" tIns="0" rIns="0" bIns="0" rtlCol="0" anchor="ctr"/>
-          <a:lstStyle/>
-          <a:p>
-            <a:pPr indent="0" marL="0">
-              <a:buNone/>
-            </a:pPr>
-            <a:r>
-              <a:rPr lang="en-US" sz="1050" dirty="0">
-                <a:solidFill>
-                  <a:srgbClr val="A5C4F3"/>
-                </a:solidFill>
-                <a:latin typeface="Noto Sans KR" pitchFamily="34" charset="0"/>
-                <a:ea typeface="Noto Sans KR" pitchFamily="34" charset="-122"/>
-                <a:cs typeface="Noto Sans KR" pitchFamily="34" charset="-120"/>
-              </a:rPr>
-              <a:t>AI 딥러닝 비전검사기 (자동차용 샤크 안테나 PCB) — 실제 사양은 현장 실사 후 확정</a:t>
-            </a:r>
-            <a:endParaRPr lang="en-US" sz="1050" dirty="0"/>
+            <a:endParaRPr lang="en-US" sz="1800" dirty="0"/>
           </a:p>
         </p:txBody>
       </p:sp>
       <p:pic>
         <p:nvPicPr>
-          <p:cNvPr id="6" name="Image 0" descr="preencoded.png">    </p:cNvPr>
+          <p:cNvPr id="5" name="Image 0" descr="preencoded.png">    </p:cNvPr>
           <p:cNvPicPr>
             <a:picLocks noChangeAspect="1"/>
           </p:cNvPicPr>
@@ -14173,14 +14134,13 @@
         </p:nvPicPr>
         <p:blipFill>
           <a:blip r:embed="rId1"/>
-          <a:stretch>
-            <a:fillRect/>
-          </a:stretch>
+          <a:srcRect l="0" r="0" t="0" b="0"/>
+          <a:stretch/>
         </p:blipFill>
         <p:spPr>
           <a:xfrm>
-            <a:off x="365760" y="1078992"/>
-            <a:ext cx="8412480" cy="3973068"/>
+            <a:off x="1057229" y="438912"/>
+            <a:ext cx="7029450" cy="4686300"/>
           </a:xfrm>
           <a:prstGeom prst="rect">
             <a:avLst/>

</xml_diff>

<commit_message>
Update winnercomb.pptx - remove 생산팀 from 위너콤
</commit_message>
<xml_diff>
--- a/winnercomb.pptx
+++ b/winnercomb.pptx
@@ -2118,7 +2118,7 @@
                 <a:ea typeface="Noto Sans KR" pitchFamily="34" charset="-122"/>
                 <a:cs typeface="Noto Sans KR" pitchFamily="34" charset="-120"/>
               </a:rPr>
-              <a:t>수신: 위너콤 생산팀  |  2026년 7월</a:t>
+              <a:t>수신: 위너콤  |  2026년 7월</a:t>
             </a:r>
             <a:endParaRPr lang="en-US" sz="1100" dirty="0"/>
           </a:p>
@@ -7508,7 +7508,7 @@
                 <a:ea typeface="Noto Sans KR" pitchFamily="34" charset="-122"/>
                 <a:cs typeface="Noto Sans KR" pitchFamily="34" charset="-120"/>
               </a:rPr>
-              <a:t>위너콤 생산팀의 품질 경쟁력을 인시스가 함께 높이겠습니다.</a:t>
+              <a:t>위너콤의 품질 경쟁력을 인시스가 함께 높이겠습니다.</a:t>
             </a:r>
             <a:endParaRPr lang="en-US" sz="1300" dirty="0"/>
           </a:p>

</xml_diff>

<commit_message>
Update winnercomb.pptx - slide8 card spacing fix
</commit_message>
<xml_diff>
--- a/winnercomb.pptx
+++ b/winnercomb.pptx
@@ -16316,11 +16316,11 @@
         <p:spPr>
           <a:xfrm>
             <a:off x="365760" y="1042416"/>
-            <a:ext cx="1594714" cy="1170432"/>
+            <a:ext cx="1594714" cy="1078992"/>
           </a:xfrm>
           <a:prstGeom prst="roundRect">
             <a:avLst>
-              <a:gd name="adj" fmla="val 5469"/>
+              <a:gd name="adj" fmla="val 5932"/>
             </a:avLst>
           </a:prstGeom>
           <a:solidFill>
@@ -16350,7 +16350,7 @@
         <p:spPr>
           <a:xfrm>
             <a:off x="365760" y="1042416"/>
-            <a:ext cx="1594714" cy="118872"/>
+            <a:ext cx="1594714" cy="109728"/>
           </a:xfrm>
           <a:prstGeom prst="rect">
             <a:avLst/>
@@ -16374,8 +16374,8 @@
         </p:nvSpPr>
         <p:spPr>
           <a:xfrm>
-            <a:off x="943661" y="1207008"/>
-            <a:ext cx="438912" cy="438912"/>
+            <a:off x="961949" y="1188720"/>
+            <a:ext cx="402336" cy="402336"/>
           </a:xfrm>
           <a:prstGeom prst="ellipse">
             <a:avLst/>
@@ -16399,8 +16399,8 @@
         </p:nvSpPr>
         <p:spPr>
           <a:xfrm>
-            <a:off x="943661" y="1207008"/>
-            <a:ext cx="438912" cy="438912"/>
+            <a:off x="961949" y="1188720"/>
+            <a:ext cx="402336" cy="402336"/>
           </a:xfrm>
           <a:prstGeom prst="rect">
             <a:avLst/>
@@ -16416,7 +16416,7 @@
               <a:buNone/>
             </a:pPr>
             <a:r>
-              <a:rPr lang="en-US" sz="1500" dirty="0">
+              <a:rPr lang="en-US" sz="1400" dirty="0">
                 <a:solidFill>
                   <a:srgbClr val="000000"/>
                 </a:solidFill>
@@ -16426,7 +16426,7 @@
               </a:rPr>
               <a:t>🎯</a:t>
             </a:r>
-            <a:endParaRPr lang="en-US" sz="1500" dirty="0"/>
+            <a:endParaRPr lang="en-US" sz="1400" dirty="0"/>
           </a:p>
         </p:txBody>
       </p:sp>
@@ -16438,8 +16438,8 @@
         </p:nvSpPr>
         <p:spPr>
           <a:xfrm>
-            <a:off x="411480" y="1719072"/>
-            <a:ext cx="1503274" cy="274320"/>
+            <a:off x="411480" y="1682496"/>
+            <a:ext cx="1503274" cy="256032"/>
           </a:xfrm>
           <a:prstGeom prst="rect">
             <a:avLst/>
@@ -16458,7 +16458,7 @@
               <a:buNone/>
             </a:pPr>
             <a:r>
-              <a:rPr lang="en-US" sz="850" b="1" dirty="0">
+              <a:rPr lang="en-US" sz="800" b="1" dirty="0">
                 <a:solidFill>
                   <a:srgbClr val="1B2F5E"/>
                 </a:solidFill>
@@ -16468,7 +16468,7 @@
               </a:rPr>
               <a:t>딥러닝</a:t>
             </a:r>
-            <a:endParaRPr lang="en-US" sz="850" dirty="0"/>
+            <a:endParaRPr lang="en-US" sz="800" dirty="0"/>
           </a:p>
           <a:p>
             <a:pPr algn="ctr" indent="0" marL="0">
@@ -16478,7 +16478,7 @@
               <a:buNone/>
             </a:pPr>
             <a:r>
-              <a:rPr lang="en-US" sz="850" b="1" dirty="0">
+              <a:rPr lang="en-US" sz="800" b="1" dirty="0">
                 <a:solidFill>
                   <a:srgbClr val="1B2F5E"/>
                 </a:solidFill>
@@ -16488,7 +16488,7 @@
               </a:rPr>
               <a:t>자동학습</a:t>
             </a:r>
-            <a:endParaRPr lang="en-US" sz="850" dirty="0"/>
+            <a:endParaRPr lang="en-US" sz="800" dirty="0"/>
           </a:p>
         </p:txBody>
       </p:sp>
@@ -16500,7 +16500,7 @@
         </p:nvSpPr>
         <p:spPr>
           <a:xfrm>
-            <a:off x="475488" y="2011680"/>
+            <a:off x="475488" y="1956816"/>
             <a:ext cx="1375258" cy="0"/>
           </a:xfrm>
           <a:prstGeom prst="line">
@@ -16523,8 +16523,8 @@
         </p:nvSpPr>
         <p:spPr>
           <a:xfrm>
-            <a:off x="411480" y="2066544"/>
-            <a:ext cx="1503274" cy="274320"/>
+            <a:off x="411480" y="2002536"/>
+            <a:ext cx="1503274" cy="237744"/>
           </a:xfrm>
           <a:prstGeom prst="rect">
             <a:avLst/>
@@ -16538,12 +16538,12 @@
           <a:p>
             <a:pPr algn="ctr" indent="0" marL="0">
               <a:lnSpc>
-                <a:spcPct val="120000"/>
+                <a:spcPct val="115000"/>
               </a:lnSpc>
               <a:buNone/>
             </a:pPr>
             <a:r>
-              <a:rPr lang="en-US" sz="750" dirty="0">
+              <a:rPr lang="en-US" sz="700" dirty="0">
                 <a:solidFill>
                   <a:srgbClr val="475569"/>
                 </a:solidFill>
@@ -16553,17 +16553,17 @@
               </a:rPr>
               <a:t>데이터 누적</a:t>
             </a:r>
-            <a:endParaRPr lang="en-US" sz="750" dirty="0"/>
+            <a:endParaRPr lang="en-US" sz="700" dirty="0"/>
           </a:p>
           <a:p>
             <a:pPr algn="ctr" indent="0" marL="0">
               <a:lnSpc>
-                <a:spcPct val="120000"/>
+                <a:spcPct val="115000"/>
               </a:lnSpc>
               <a:buNone/>
             </a:pPr>
             <a:r>
-              <a:rPr lang="en-US" sz="750" dirty="0">
+              <a:rPr lang="en-US" sz="700" dirty="0">
                 <a:solidFill>
                   <a:srgbClr val="475569"/>
                 </a:solidFill>
@@ -16573,7 +16573,7 @@
               </a:rPr>
               <a:t>→ 정확도 지속 향상</a:t>
             </a:r>
-            <a:endParaRPr lang="en-US" sz="750" dirty="0"/>
+            <a:endParaRPr lang="en-US" sz="700" dirty="0"/>
           </a:p>
         </p:txBody>
       </p:sp>
@@ -16586,11 +16586,11 @@
         <p:spPr>
           <a:xfrm>
             <a:off x="2070202" y="1042416"/>
-            <a:ext cx="1594714" cy="1170432"/>
+            <a:ext cx="1594714" cy="1078992"/>
           </a:xfrm>
           <a:prstGeom prst="roundRect">
             <a:avLst>
-              <a:gd name="adj" fmla="val 5469"/>
+              <a:gd name="adj" fmla="val 5932"/>
             </a:avLst>
           </a:prstGeom>
           <a:solidFill>
@@ -16620,7 +16620,7 @@
         <p:spPr>
           <a:xfrm>
             <a:off x="2070202" y="1042416"/>
-            <a:ext cx="1594714" cy="118872"/>
+            <a:ext cx="1594714" cy="109728"/>
           </a:xfrm>
           <a:prstGeom prst="rect">
             <a:avLst/>
@@ -16644,8 +16644,8 @@
         </p:nvSpPr>
         <p:spPr>
           <a:xfrm>
-            <a:off x="2648102" y="1207008"/>
-            <a:ext cx="438912" cy="438912"/>
+            <a:off x="2666390" y="1188720"/>
+            <a:ext cx="402336" cy="402336"/>
           </a:xfrm>
           <a:prstGeom prst="ellipse">
             <a:avLst/>
@@ -16669,8 +16669,8 @@
         </p:nvSpPr>
         <p:spPr>
           <a:xfrm>
-            <a:off x="2648102" y="1207008"/>
-            <a:ext cx="438912" cy="438912"/>
+            <a:off x="2666390" y="1188720"/>
+            <a:ext cx="402336" cy="402336"/>
           </a:xfrm>
           <a:prstGeom prst="rect">
             <a:avLst/>
@@ -16686,7 +16686,7 @@
               <a:buNone/>
             </a:pPr>
             <a:r>
-              <a:rPr lang="en-US" sz="1500" dirty="0">
+              <a:rPr lang="en-US" sz="1400" dirty="0">
                 <a:solidFill>
                   <a:srgbClr val="000000"/>
                 </a:solidFill>
@@ -16696,7 +16696,7 @@
               </a:rPr>
               <a:t>⚖️</a:t>
             </a:r>
-            <a:endParaRPr lang="en-US" sz="1500" dirty="0"/>
+            <a:endParaRPr lang="en-US" sz="1400" dirty="0"/>
           </a:p>
         </p:txBody>
       </p:sp>
@@ -16708,8 +16708,8 @@
         </p:nvSpPr>
         <p:spPr>
           <a:xfrm>
-            <a:off x="2115922" y="1719072"/>
-            <a:ext cx="1503274" cy="274320"/>
+            <a:off x="2115922" y="1682496"/>
+            <a:ext cx="1503274" cy="256032"/>
           </a:xfrm>
           <a:prstGeom prst="rect">
             <a:avLst/>
@@ -16728,7 +16728,7 @@
               <a:buNone/>
             </a:pPr>
             <a:r>
-              <a:rPr lang="en-US" sz="850" b="1" dirty="0">
+              <a:rPr lang="en-US" sz="800" b="1" dirty="0">
                 <a:solidFill>
                   <a:srgbClr val="1B2F5E"/>
                 </a:solidFill>
@@ -16738,7 +16738,7 @@
               </a:rPr>
               <a:t>일관된</a:t>
             </a:r>
-            <a:endParaRPr lang="en-US" sz="850" dirty="0"/>
+            <a:endParaRPr lang="en-US" sz="800" dirty="0"/>
           </a:p>
           <a:p>
             <a:pPr algn="ctr" indent="0" marL="0">
@@ -16748,7 +16748,7 @@
               <a:buNone/>
             </a:pPr>
             <a:r>
-              <a:rPr lang="en-US" sz="850" b="1" dirty="0">
+              <a:rPr lang="en-US" sz="800" b="1" dirty="0">
                 <a:solidFill>
                   <a:srgbClr val="1B2F5E"/>
                 </a:solidFill>
@@ -16758,7 +16758,7 @@
               </a:rPr>
               <a:t>검사 기준</a:t>
             </a:r>
-            <a:endParaRPr lang="en-US" sz="850" dirty="0"/>
+            <a:endParaRPr lang="en-US" sz="800" dirty="0"/>
           </a:p>
         </p:txBody>
       </p:sp>
@@ -16770,7 +16770,7 @@
         </p:nvSpPr>
         <p:spPr>
           <a:xfrm>
-            <a:off x="2179930" y="2011680"/>
+            <a:off x="2179930" y="1956816"/>
             <a:ext cx="1375258" cy="0"/>
           </a:xfrm>
           <a:prstGeom prst="line">
@@ -16793,8 +16793,8 @@
         </p:nvSpPr>
         <p:spPr>
           <a:xfrm>
-            <a:off x="2115922" y="2066544"/>
-            <a:ext cx="1503274" cy="274320"/>
+            <a:off x="2115922" y="2002536"/>
+            <a:ext cx="1503274" cy="237744"/>
           </a:xfrm>
           <a:prstGeom prst="rect">
             <a:avLst/>
@@ -16808,12 +16808,12 @@
           <a:p>
             <a:pPr algn="ctr" indent="0" marL="0">
               <a:lnSpc>
-                <a:spcPct val="120000"/>
+                <a:spcPct val="115000"/>
               </a:lnSpc>
               <a:buNone/>
             </a:pPr>
             <a:r>
-              <a:rPr lang="en-US" sz="750" dirty="0">
+              <a:rPr lang="en-US" sz="700" dirty="0">
                 <a:solidFill>
                   <a:srgbClr val="475569"/>
                 </a:solidFill>
@@ -16823,17 +16823,17 @@
               </a:rPr>
               <a:t>컨디션 무관</a:t>
             </a:r>
-            <a:endParaRPr lang="en-US" sz="750" dirty="0"/>
+            <a:endParaRPr lang="en-US" sz="700" dirty="0"/>
           </a:p>
           <a:p>
             <a:pPr algn="ctr" indent="0" marL="0">
               <a:lnSpc>
-                <a:spcPct val="120000"/>
+                <a:spcPct val="115000"/>
               </a:lnSpc>
               <a:buNone/>
             </a:pPr>
             <a:r>
-              <a:rPr lang="en-US" sz="750" dirty="0">
+              <a:rPr lang="en-US" sz="700" dirty="0">
                 <a:solidFill>
                   <a:srgbClr val="475569"/>
                 </a:solidFill>
@@ -16843,7 +16843,7 @@
               </a:rPr>
               <a:t>동일 기준 판정</a:t>
             </a:r>
-            <a:endParaRPr lang="en-US" sz="750" dirty="0"/>
+            <a:endParaRPr lang="en-US" sz="700" dirty="0"/>
           </a:p>
         </p:txBody>
       </p:sp>
@@ -16856,11 +16856,11 @@
         <p:spPr>
           <a:xfrm>
             <a:off x="3774643" y="1042416"/>
-            <a:ext cx="1594714" cy="1170432"/>
+            <a:ext cx="1594714" cy="1078992"/>
           </a:xfrm>
           <a:prstGeom prst="roundRect">
             <a:avLst>
-              <a:gd name="adj" fmla="val 5469"/>
+              <a:gd name="adj" fmla="val 5932"/>
             </a:avLst>
           </a:prstGeom>
           <a:solidFill>
@@ -16890,7 +16890,7 @@
         <p:spPr>
           <a:xfrm>
             <a:off x="3774643" y="1042416"/>
-            <a:ext cx="1594714" cy="118872"/>
+            <a:ext cx="1594714" cy="109728"/>
           </a:xfrm>
           <a:prstGeom prst="rect">
             <a:avLst/>
@@ -16914,8 +16914,8 @@
         </p:nvSpPr>
         <p:spPr>
           <a:xfrm>
-            <a:off x="4352544" y="1207008"/>
-            <a:ext cx="438912" cy="438912"/>
+            <a:off x="4370832" y="1188720"/>
+            <a:ext cx="402336" cy="402336"/>
           </a:xfrm>
           <a:prstGeom prst="ellipse">
             <a:avLst/>
@@ -16939,8 +16939,8 @@
         </p:nvSpPr>
         <p:spPr>
           <a:xfrm>
-            <a:off x="4352544" y="1207008"/>
-            <a:ext cx="438912" cy="438912"/>
+            <a:off x="4370832" y="1188720"/>
+            <a:ext cx="402336" cy="402336"/>
           </a:xfrm>
           <a:prstGeom prst="rect">
             <a:avLst/>
@@ -16956,7 +16956,7 @@
               <a:buNone/>
             </a:pPr>
             <a:r>
-              <a:rPr lang="en-US" sz="1500" dirty="0">
+              <a:rPr lang="en-US" sz="1400" dirty="0">
                 <a:solidFill>
                   <a:srgbClr val="000000"/>
                 </a:solidFill>
@@ -16966,7 +16966,7 @@
               </a:rPr>
               <a:t>🚫</a:t>
             </a:r>
-            <a:endParaRPr lang="en-US" sz="1500" dirty="0"/>
+            <a:endParaRPr lang="en-US" sz="1400" dirty="0"/>
           </a:p>
         </p:txBody>
       </p:sp>
@@ -16978,8 +16978,8 @@
         </p:nvSpPr>
         <p:spPr>
           <a:xfrm>
-            <a:off x="3820363" y="1719072"/>
-            <a:ext cx="1503274" cy="274320"/>
+            <a:off x="3820363" y="1682496"/>
+            <a:ext cx="1503274" cy="256032"/>
           </a:xfrm>
           <a:prstGeom prst="rect">
             <a:avLst/>
@@ -16998,7 +16998,7 @@
               <a:buNone/>
             </a:pPr>
             <a:r>
-              <a:rPr lang="en-US" sz="850" b="1" dirty="0">
+              <a:rPr lang="en-US" sz="800" b="1" dirty="0">
                 <a:solidFill>
                   <a:srgbClr val="1B2F5E"/>
                 </a:solidFill>
@@ -17008,7 +17008,7 @@
               </a:rPr>
               <a:t>불량 혼입</a:t>
             </a:r>
-            <a:endParaRPr lang="en-US" sz="850" dirty="0"/>
+            <a:endParaRPr lang="en-US" sz="800" dirty="0"/>
           </a:p>
           <a:p>
             <a:pPr algn="ctr" indent="0" marL="0">
@@ -17018,7 +17018,7 @@
               <a:buNone/>
             </a:pPr>
             <a:r>
-              <a:rPr lang="en-US" sz="850" b="1" dirty="0">
+              <a:rPr lang="en-US" sz="800" b="1" dirty="0">
                 <a:solidFill>
                   <a:srgbClr val="1B2F5E"/>
                 </a:solidFill>
@@ -17028,7 +17028,7 @@
               </a:rPr>
               <a:t>원천 차단</a:t>
             </a:r>
-            <a:endParaRPr lang="en-US" sz="850" dirty="0"/>
+            <a:endParaRPr lang="en-US" sz="800" dirty="0"/>
           </a:p>
         </p:txBody>
       </p:sp>
@@ -17040,7 +17040,7 @@
         </p:nvSpPr>
         <p:spPr>
           <a:xfrm>
-            <a:off x="3884371" y="2011680"/>
+            <a:off x="3884371" y="1956816"/>
             <a:ext cx="1375258" cy="0"/>
           </a:xfrm>
           <a:prstGeom prst="line">
@@ -17063,8 +17063,8 @@
         </p:nvSpPr>
         <p:spPr>
           <a:xfrm>
-            <a:off x="3820363" y="2066544"/>
-            <a:ext cx="1503274" cy="274320"/>
+            <a:off x="3820363" y="2002536"/>
+            <a:ext cx="1503274" cy="237744"/>
           </a:xfrm>
           <a:prstGeom prst="rect">
             <a:avLst/>
@@ -17078,12 +17078,12 @@
           <a:p>
             <a:pPr algn="ctr" indent="0" marL="0">
               <a:lnSpc>
-                <a:spcPct val="120000"/>
+                <a:spcPct val="115000"/>
               </a:lnSpc>
               <a:buNone/>
             </a:pPr>
             <a:r>
-              <a:rPr lang="en-US" sz="750" dirty="0">
+              <a:rPr lang="en-US" sz="700" dirty="0">
                 <a:solidFill>
                   <a:srgbClr val="475569"/>
                 </a:solidFill>
@@ -17093,17 +17093,17 @@
               </a:rPr>
               <a:t>자동 분리 배출</a:t>
             </a:r>
-            <a:endParaRPr lang="en-US" sz="750" dirty="0"/>
+            <a:endParaRPr lang="en-US" sz="700" dirty="0"/>
           </a:p>
           <a:p>
             <a:pPr algn="ctr" indent="0" marL="0">
               <a:lnSpc>
-                <a:spcPct val="120000"/>
+                <a:spcPct val="115000"/>
               </a:lnSpc>
               <a:buNone/>
             </a:pPr>
             <a:r>
-              <a:rPr lang="en-US" sz="750" dirty="0">
+              <a:rPr lang="en-US" sz="700" dirty="0">
                 <a:solidFill>
                   <a:srgbClr val="475569"/>
                 </a:solidFill>
@@ -17113,7 +17113,7 @@
               </a:rPr>
               <a:t>재검사 불필요</a:t>
             </a:r>
-            <a:endParaRPr lang="en-US" sz="750" dirty="0"/>
+            <a:endParaRPr lang="en-US" sz="700" dirty="0"/>
           </a:p>
         </p:txBody>
       </p:sp>
@@ -17126,11 +17126,11 @@
         <p:spPr>
           <a:xfrm>
             <a:off x="5479085" y="1042416"/>
-            <a:ext cx="1594714" cy="1170432"/>
+            <a:ext cx="1594714" cy="1078992"/>
           </a:xfrm>
           <a:prstGeom prst="roundRect">
             <a:avLst>
-              <a:gd name="adj" fmla="val 5469"/>
+              <a:gd name="adj" fmla="val 5932"/>
             </a:avLst>
           </a:prstGeom>
           <a:solidFill>
@@ -17160,7 +17160,7 @@
         <p:spPr>
           <a:xfrm>
             <a:off x="5479085" y="1042416"/>
-            <a:ext cx="1594714" cy="118872"/>
+            <a:ext cx="1594714" cy="109728"/>
           </a:xfrm>
           <a:prstGeom prst="rect">
             <a:avLst/>
@@ -17184,8 +17184,8 @@
         </p:nvSpPr>
         <p:spPr>
           <a:xfrm>
-            <a:off x="6056986" y="1207008"/>
-            <a:ext cx="438912" cy="438912"/>
+            <a:off x="6075274" y="1188720"/>
+            <a:ext cx="402336" cy="402336"/>
           </a:xfrm>
           <a:prstGeom prst="ellipse">
             <a:avLst/>
@@ -17209,8 +17209,8 @@
         </p:nvSpPr>
         <p:spPr>
           <a:xfrm>
-            <a:off x="6056986" y="1207008"/>
-            <a:ext cx="438912" cy="438912"/>
+            <a:off x="6075274" y="1188720"/>
+            <a:ext cx="402336" cy="402336"/>
           </a:xfrm>
           <a:prstGeom prst="rect">
             <a:avLst/>
@@ -17226,7 +17226,7 @@
               <a:buNone/>
             </a:pPr>
             <a:r>
-              <a:rPr lang="en-US" sz="1500" dirty="0">
+              <a:rPr lang="en-US" sz="1400" dirty="0">
                 <a:solidFill>
                   <a:srgbClr val="000000"/>
                 </a:solidFill>
@@ -17236,7 +17236,7 @@
               </a:rPr>
               <a:t>📈</a:t>
             </a:r>
-            <a:endParaRPr lang="en-US" sz="1500" dirty="0"/>
+            <a:endParaRPr lang="en-US" sz="1400" dirty="0"/>
           </a:p>
         </p:txBody>
       </p:sp>
@@ -17248,8 +17248,8 @@
         </p:nvSpPr>
         <p:spPr>
           <a:xfrm>
-            <a:off x="5524805" y="1719072"/>
-            <a:ext cx="1503274" cy="274320"/>
+            <a:off x="5524805" y="1682496"/>
+            <a:ext cx="1503274" cy="256032"/>
           </a:xfrm>
           <a:prstGeom prst="rect">
             <a:avLst/>
@@ -17268,7 +17268,7 @@
               <a:buNone/>
             </a:pPr>
             <a:r>
-              <a:rPr lang="en-US" sz="850" b="1" dirty="0">
+              <a:rPr lang="en-US" sz="800" b="1" dirty="0">
                 <a:solidFill>
                   <a:srgbClr val="1B2F5E"/>
                 </a:solidFill>
@@ -17278,7 +17278,7 @@
               </a:rPr>
               <a:t>품질 데이터</a:t>
             </a:r>
-            <a:endParaRPr lang="en-US" sz="850" dirty="0"/>
+            <a:endParaRPr lang="en-US" sz="800" dirty="0"/>
           </a:p>
           <a:p>
             <a:pPr algn="ctr" indent="0" marL="0">
@@ -17288,7 +17288,7 @@
               <a:buNone/>
             </a:pPr>
             <a:r>
-              <a:rPr lang="en-US" sz="850" b="1" dirty="0">
+              <a:rPr lang="en-US" sz="800" b="1" dirty="0">
                 <a:solidFill>
                   <a:srgbClr val="1B2F5E"/>
                 </a:solidFill>
@@ -17298,7 +17298,7 @@
               </a:rPr>
               <a:t>자산화</a:t>
             </a:r>
-            <a:endParaRPr lang="en-US" sz="850" dirty="0"/>
+            <a:endParaRPr lang="en-US" sz="800" dirty="0"/>
           </a:p>
         </p:txBody>
       </p:sp>
@@ -17310,7 +17310,7 @@
         </p:nvSpPr>
         <p:spPr>
           <a:xfrm>
-            <a:off x="5588813" y="2011680"/>
+            <a:off x="5588813" y="1956816"/>
             <a:ext cx="1375258" cy="0"/>
           </a:xfrm>
           <a:prstGeom prst="line">
@@ -17333,8 +17333,8 @@
         </p:nvSpPr>
         <p:spPr>
           <a:xfrm>
-            <a:off x="5524805" y="2066544"/>
-            <a:ext cx="1503274" cy="274320"/>
+            <a:off x="5524805" y="2002536"/>
+            <a:ext cx="1503274" cy="237744"/>
           </a:xfrm>
           <a:prstGeom prst="rect">
             <a:avLst/>
@@ -17348,12 +17348,12 @@
           <a:p>
             <a:pPr algn="ctr" indent="0" marL="0">
               <a:lnSpc>
-                <a:spcPct val="120000"/>
+                <a:spcPct val="115000"/>
               </a:lnSpc>
               <a:buNone/>
             </a:pPr>
             <a:r>
-              <a:rPr lang="en-US" sz="750" dirty="0">
+              <a:rPr lang="en-US" sz="700" dirty="0">
                 <a:solidFill>
                   <a:srgbClr val="475569"/>
                 </a:solidFill>
@@ -17363,17 +17363,17 @@
               </a:rPr>
               <a:t>통계·트렌드</a:t>
             </a:r>
-            <a:endParaRPr lang="en-US" sz="750" dirty="0"/>
+            <a:endParaRPr lang="en-US" sz="700" dirty="0"/>
           </a:p>
           <a:p>
             <a:pPr algn="ctr" indent="0" marL="0">
               <a:lnSpc>
-                <a:spcPct val="120000"/>
+                <a:spcPct val="115000"/>
               </a:lnSpc>
               <a:buNone/>
             </a:pPr>
             <a:r>
-              <a:rPr lang="en-US" sz="750" dirty="0">
+              <a:rPr lang="en-US" sz="700" dirty="0">
                 <a:solidFill>
                   <a:srgbClr val="475569"/>
                 </a:solidFill>
@@ -17383,7 +17383,7 @@
               </a:rPr>
               <a:t>리포트 자동 생성</a:t>
             </a:r>
-            <a:endParaRPr lang="en-US" sz="750" dirty="0"/>
+            <a:endParaRPr lang="en-US" sz="700" dirty="0"/>
           </a:p>
         </p:txBody>
       </p:sp>
@@ -17396,11 +17396,11 @@
         <p:spPr>
           <a:xfrm>
             <a:off x="7183526" y="1042416"/>
-            <a:ext cx="1594714" cy="1170432"/>
+            <a:ext cx="1594714" cy="1078992"/>
           </a:xfrm>
           <a:prstGeom prst="roundRect">
             <a:avLst>
-              <a:gd name="adj" fmla="val 5469"/>
+              <a:gd name="adj" fmla="val 5932"/>
             </a:avLst>
           </a:prstGeom>
           <a:solidFill>
@@ -17430,7 +17430,7 @@
         <p:spPr>
           <a:xfrm>
             <a:off x="7183526" y="1042416"/>
-            <a:ext cx="1594714" cy="118872"/>
+            <a:ext cx="1594714" cy="109728"/>
           </a:xfrm>
           <a:prstGeom prst="rect">
             <a:avLst/>
@@ -17454,8 +17454,8 @@
         </p:nvSpPr>
         <p:spPr>
           <a:xfrm>
-            <a:off x="7761427" y="1207008"/>
-            <a:ext cx="438912" cy="438912"/>
+            <a:off x="7779715" y="1188720"/>
+            <a:ext cx="402336" cy="402336"/>
           </a:xfrm>
           <a:prstGeom prst="ellipse">
             <a:avLst/>
@@ -17479,8 +17479,8 @@
         </p:nvSpPr>
         <p:spPr>
           <a:xfrm>
-            <a:off x="7761427" y="1207008"/>
-            <a:ext cx="438912" cy="438912"/>
+            <a:off x="7779715" y="1188720"/>
+            <a:ext cx="402336" cy="402336"/>
           </a:xfrm>
           <a:prstGeom prst="rect">
             <a:avLst/>
@@ -17496,7 +17496,7 @@
               <a:buNone/>
             </a:pPr>
             <a:r>
-              <a:rPr lang="en-US" sz="1500" dirty="0">
+              <a:rPr lang="en-US" sz="1400" dirty="0">
                 <a:solidFill>
                   <a:srgbClr val="000000"/>
                 </a:solidFill>
@@ -17506,7 +17506,7 @@
               </a:rPr>
               <a:t>👤</a:t>
             </a:r>
-            <a:endParaRPr lang="en-US" sz="1500" dirty="0"/>
+            <a:endParaRPr lang="en-US" sz="1400" dirty="0"/>
           </a:p>
         </p:txBody>
       </p:sp>
@@ -17518,8 +17518,8 @@
         </p:nvSpPr>
         <p:spPr>
           <a:xfrm>
-            <a:off x="7229246" y="1719072"/>
-            <a:ext cx="1503274" cy="274320"/>
+            <a:off x="7229246" y="1682496"/>
+            <a:ext cx="1503274" cy="256032"/>
           </a:xfrm>
           <a:prstGeom prst="rect">
             <a:avLst/>
@@ -17538,7 +17538,7 @@
               <a:buNone/>
             </a:pPr>
             <a:r>
-              <a:rPr lang="en-US" sz="850" b="1" dirty="0">
+              <a:rPr lang="en-US" sz="800" b="1" dirty="0">
                 <a:solidFill>
                   <a:srgbClr val="1B2F5E"/>
                 </a:solidFill>
@@ -17548,7 +17548,7 @@
               </a:rPr>
               <a:t>별도 인력</a:t>
             </a:r>
-            <a:endParaRPr lang="en-US" sz="850" dirty="0"/>
+            <a:endParaRPr lang="en-US" sz="800" dirty="0"/>
           </a:p>
           <a:p>
             <a:pPr algn="ctr" indent="0" marL="0">
@@ -17558,7 +17558,7 @@
               <a:buNone/>
             </a:pPr>
             <a:r>
-              <a:rPr lang="en-US" sz="850" b="1" dirty="0">
+              <a:rPr lang="en-US" sz="800" b="1" dirty="0">
                 <a:solidFill>
                   <a:srgbClr val="1B2F5E"/>
                 </a:solidFill>
@@ -17568,7 +17568,7 @@
               </a:rPr>
               <a:t>불필요</a:t>
             </a:r>
-            <a:endParaRPr lang="en-US" sz="850" dirty="0"/>
+            <a:endParaRPr lang="en-US" sz="800" dirty="0"/>
           </a:p>
         </p:txBody>
       </p:sp>
@@ -17580,7 +17580,7 @@
         </p:nvSpPr>
         <p:spPr>
           <a:xfrm>
-            <a:off x="7293254" y="2011680"/>
+            <a:off x="7293254" y="1956816"/>
             <a:ext cx="1375258" cy="0"/>
           </a:xfrm>
           <a:prstGeom prst="line">
@@ -17603,8 +17603,8 @@
         </p:nvSpPr>
         <p:spPr>
           <a:xfrm>
-            <a:off x="7229246" y="2066544"/>
-            <a:ext cx="1503274" cy="274320"/>
+            <a:off x="7229246" y="2002536"/>
+            <a:ext cx="1503274" cy="237744"/>
           </a:xfrm>
           <a:prstGeom prst="rect">
             <a:avLst/>
@@ -17618,12 +17618,12 @@
           <a:p>
             <a:pPr algn="ctr" indent="0" marL="0">
               <a:lnSpc>
-                <a:spcPct val="120000"/>
+                <a:spcPct val="115000"/>
               </a:lnSpc>
               <a:buNone/>
             </a:pPr>
             <a:r>
-              <a:rPr lang="en-US" sz="750" dirty="0">
+              <a:rPr lang="en-US" sz="700" dirty="0">
                 <a:solidFill>
                   <a:srgbClr val="475569"/>
                 </a:solidFill>
@@ -17633,17 +17633,17 @@
               </a:rPr>
               <a:t>전 과정 자동</a:t>
             </a:r>
-            <a:endParaRPr lang="en-US" sz="750" dirty="0"/>
+            <a:endParaRPr lang="en-US" sz="700" dirty="0"/>
           </a:p>
           <a:p>
             <a:pPr algn="ctr" indent="0" marL="0">
               <a:lnSpc>
-                <a:spcPct val="120000"/>
+                <a:spcPct val="115000"/>
               </a:lnSpc>
               <a:buNone/>
             </a:pPr>
             <a:r>
-              <a:rPr lang="en-US" sz="750" dirty="0">
+              <a:rPr lang="en-US" sz="700" dirty="0">
                 <a:solidFill>
                   <a:srgbClr val="475569"/>
                 </a:solidFill>
@@ -17653,7 +17653,7 @@
               </a:rPr>
               <a:t>인력 재배치 가능</a:t>
             </a:r>
-            <a:endParaRPr lang="en-US" sz="750" dirty="0"/>
+            <a:endParaRPr lang="en-US" sz="700" dirty="0"/>
           </a:p>
         </p:txBody>
       </p:sp>
@@ -17665,8 +17665,8 @@
         </p:nvSpPr>
         <p:spPr>
           <a:xfrm>
-            <a:off x="365760" y="2304288"/>
-            <a:ext cx="2743200" cy="2793492"/>
+            <a:off x="365760" y="2212848"/>
+            <a:ext cx="2743200" cy="2884932"/>
           </a:xfrm>
           <a:prstGeom prst="roundRect">
             <a:avLst>
@@ -17699,12 +17699,12 @@
         </p:nvSpPr>
         <p:spPr>
           <a:xfrm>
-            <a:off x="365760" y="2304288"/>
-            <a:ext cx="2743200" cy="347472"/>
+            <a:off x="365760" y="2212848"/>
+            <a:ext cx="2743200" cy="329184"/>
           </a:xfrm>
           <a:prstGeom prst="roundRect">
             <a:avLst>
-              <a:gd name="adj" fmla="val 18421"/>
+              <a:gd name="adj" fmla="val 19444"/>
             </a:avLst>
           </a:prstGeom>
           <a:solidFill>
@@ -17726,8 +17726,8 @@
         </p:nvSpPr>
         <p:spPr>
           <a:xfrm>
-            <a:off x="365760" y="2304288"/>
-            <a:ext cx="2743200" cy="347472"/>
+            <a:off x="365760" y="2212848"/>
+            <a:ext cx="2743200" cy="329184"/>
           </a:xfrm>
           <a:prstGeom prst="rect">
             <a:avLst/>
@@ -17765,12 +17765,12 @@
         </p:nvSpPr>
         <p:spPr>
           <a:xfrm>
-            <a:off x="457200" y="2706624"/>
-            <a:ext cx="2560320" cy="760476"/>
+            <a:off x="457200" y="2587752"/>
+            <a:ext cx="2560320" cy="809244"/>
           </a:xfrm>
           <a:prstGeom prst="roundRect">
             <a:avLst>
-              <a:gd name="adj" fmla="val 8417"/>
+              <a:gd name="adj" fmla="val 7910"/>
             </a:avLst>
           </a:prstGeom>
           <a:solidFill>
@@ -17799,8 +17799,8 @@
         </p:nvSpPr>
         <p:spPr>
           <a:xfrm>
-            <a:off x="530352" y="2761488"/>
-            <a:ext cx="2414016" cy="669036"/>
+            <a:off x="530352" y="2624328"/>
+            <a:ext cx="2414016" cy="736092"/>
           </a:xfrm>
           <a:prstGeom prst="rect">
             <a:avLst/>
@@ -17814,7 +17814,7 @@
           <a:p>
             <a:pPr indent="0" marL="0">
               <a:lnSpc>
-                <a:spcPct val="120000"/>
+                <a:spcPct val="115000"/>
               </a:lnSpc>
               <a:buNone/>
             </a:pPr>
@@ -17834,7 +17834,7 @@
           <a:p>
             <a:pPr indent="0" marL="0">
               <a:lnSpc>
-                <a:spcPct val="120000"/>
+                <a:spcPct val="115000"/>
               </a:lnSpc>
               <a:buNone/>
             </a:pPr>
@@ -17861,12 +17861,12 @@
         </p:nvSpPr>
         <p:spPr>
           <a:xfrm>
-            <a:off x="457200" y="3512820"/>
-            <a:ext cx="2560320" cy="760476"/>
+            <a:off x="457200" y="3433572"/>
+            <a:ext cx="2560320" cy="809244"/>
           </a:xfrm>
           <a:prstGeom prst="roundRect">
             <a:avLst>
-              <a:gd name="adj" fmla="val 8417"/>
+              <a:gd name="adj" fmla="val 7910"/>
             </a:avLst>
           </a:prstGeom>
           <a:solidFill>
@@ -17895,8 +17895,8 @@
         </p:nvSpPr>
         <p:spPr>
           <a:xfrm>
-            <a:off x="530352" y="3567684"/>
-            <a:ext cx="2414016" cy="669036"/>
+            <a:off x="530352" y="3470148"/>
+            <a:ext cx="2414016" cy="736092"/>
           </a:xfrm>
           <a:prstGeom prst="rect">
             <a:avLst/>
@@ -17910,7 +17910,7 @@
           <a:p>
             <a:pPr indent="0" marL="0">
               <a:lnSpc>
-                <a:spcPct val="120000"/>
+                <a:spcPct val="115000"/>
               </a:lnSpc>
               <a:buNone/>
             </a:pPr>
@@ -17937,12 +17937,12 @@
         </p:nvSpPr>
         <p:spPr>
           <a:xfrm>
-            <a:off x="457200" y="4319016"/>
-            <a:ext cx="2560320" cy="760476"/>
+            <a:off x="457200" y="4279392"/>
+            <a:ext cx="2560320" cy="809244"/>
           </a:xfrm>
           <a:prstGeom prst="roundRect">
             <a:avLst>
-              <a:gd name="adj" fmla="val 8417"/>
+              <a:gd name="adj" fmla="val 7910"/>
             </a:avLst>
           </a:prstGeom>
           <a:solidFill>
@@ -17971,8 +17971,8 @@
         </p:nvSpPr>
         <p:spPr>
           <a:xfrm>
-            <a:off x="530352" y="4373880"/>
-            <a:ext cx="2414016" cy="669036"/>
+            <a:off x="530352" y="4315968"/>
+            <a:ext cx="2414016" cy="736092"/>
           </a:xfrm>
           <a:prstGeom prst="rect">
             <a:avLst/>
@@ -17986,7 +17986,7 @@
           <a:p>
             <a:pPr indent="0" marL="0">
               <a:lnSpc>
-                <a:spcPct val="120000"/>
+                <a:spcPct val="115000"/>
               </a:lnSpc>
               <a:buNone/>
             </a:pPr>
@@ -18013,8 +18013,8 @@
         </p:nvSpPr>
         <p:spPr>
           <a:xfrm>
-            <a:off x="3200400" y="2304288"/>
-            <a:ext cx="2743200" cy="2793492"/>
+            <a:off x="3200400" y="2212848"/>
+            <a:ext cx="2743200" cy="2884932"/>
           </a:xfrm>
           <a:prstGeom prst="roundRect">
             <a:avLst>
@@ -18047,12 +18047,12 @@
         </p:nvSpPr>
         <p:spPr>
           <a:xfrm>
-            <a:off x="3200400" y="2304288"/>
-            <a:ext cx="2743200" cy="347472"/>
+            <a:off x="3200400" y="2212848"/>
+            <a:ext cx="2743200" cy="329184"/>
           </a:xfrm>
           <a:prstGeom prst="roundRect">
             <a:avLst>
-              <a:gd name="adj" fmla="val 18421"/>
+              <a:gd name="adj" fmla="val 19444"/>
             </a:avLst>
           </a:prstGeom>
           <a:solidFill>
@@ -18074,8 +18074,8 @@
         </p:nvSpPr>
         <p:spPr>
           <a:xfrm>
-            <a:off x="3200400" y="2304288"/>
-            <a:ext cx="2743200" cy="347472"/>
+            <a:off x="3200400" y="2212848"/>
+            <a:ext cx="2743200" cy="329184"/>
           </a:xfrm>
           <a:prstGeom prst="rect">
             <a:avLst/>
@@ -18113,12 +18113,12 @@
         </p:nvSpPr>
         <p:spPr>
           <a:xfrm>
-            <a:off x="3291840" y="2706624"/>
-            <a:ext cx="2560320" cy="760476"/>
+            <a:off x="3291840" y="2587752"/>
+            <a:ext cx="2560320" cy="809244"/>
           </a:xfrm>
           <a:prstGeom prst="roundRect">
             <a:avLst>
-              <a:gd name="adj" fmla="val 8417"/>
+              <a:gd name="adj" fmla="val 7910"/>
             </a:avLst>
           </a:prstGeom>
           <a:solidFill>
@@ -18147,8 +18147,8 @@
         </p:nvSpPr>
         <p:spPr>
           <a:xfrm>
-            <a:off x="3364992" y="2761488"/>
-            <a:ext cx="2414016" cy="669036"/>
+            <a:off x="3364992" y="2624328"/>
+            <a:ext cx="2414016" cy="736092"/>
           </a:xfrm>
           <a:prstGeom prst="rect">
             <a:avLst/>
@@ -18162,7 +18162,7 @@
           <a:p>
             <a:pPr indent="0" marL="0">
               <a:lnSpc>
-                <a:spcPct val="120000"/>
+                <a:spcPct val="115000"/>
               </a:lnSpc>
               <a:buNone/>
             </a:pPr>
@@ -18189,12 +18189,12 @@
         </p:nvSpPr>
         <p:spPr>
           <a:xfrm>
-            <a:off x="3291840" y="3512820"/>
-            <a:ext cx="2560320" cy="760476"/>
+            <a:off x="3291840" y="3433572"/>
+            <a:ext cx="2560320" cy="809244"/>
           </a:xfrm>
           <a:prstGeom prst="roundRect">
             <a:avLst>
-              <a:gd name="adj" fmla="val 8417"/>
+              <a:gd name="adj" fmla="val 7910"/>
             </a:avLst>
           </a:prstGeom>
           <a:solidFill>
@@ -18223,8 +18223,8 @@
         </p:nvSpPr>
         <p:spPr>
           <a:xfrm>
-            <a:off x="3364992" y="3567684"/>
-            <a:ext cx="2414016" cy="669036"/>
+            <a:off x="3364992" y="3470148"/>
+            <a:ext cx="2414016" cy="736092"/>
           </a:xfrm>
           <a:prstGeom prst="rect">
             <a:avLst/>
@@ -18238,7 +18238,7 @@
           <a:p>
             <a:pPr indent="0" marL="0">
               <a:lnSpc>
-                <a:spcPct val="120000"/>
+                <a:spcPct val="115000"/>
               </a:lnSpc>
               <a:buNone/>
             </a:pPr>
@@ -18265,12 +18265,12 @@
         </p:nvSpPr>
         <p:spPr>
           <a:xfrm>
-            <a:off x="3291840" y="4319016"/>
-            <a:ext cx="2560320" cy="760476"/>
+            <a:off x="3291840" y="4279392"/>
+            <a:ext cx="2560320" cy="809244"/>
           </a:xfrm>
           <a:prstGeom prst="roundRect">
             <a:avLst>
-              <a:gd name="adj" fmla="val 8417"/>
+              <a:gd name="adj" fmla="val 7910"/>
             </a:avLst>
           </a:prstGeom>
           <a:solidFill>
@@ -18299,8 +18299,8 @@
         </p:nvSpPr>
         <p:spPr>
           <a:xfrm>
-            <a:off x="3364992" y="4373880"/>
-            <a:ext cx="2414016" cy="669036"/>
+            <a:off x="3364992" y="4315968"/>
+            <a:ext cx="2414016" cy="736092"/>
           </a:xfrm>
           <a:prstGeom prst="rect">
             <a:avLst/>
@@ -18314,7 +18314,7 @@
           <a:p>
             <a:pPr indent="0" marL="0">
               <a:lnSpc>
-                <a:spcPct val="120000"/>
+                <a:spcPct val="115000"/>
               </a:lnSpc>
               <a:buNone/>
             </a:pPr>
@@ -18341,8 +18341,8 @@
         </p:nvSpPr>
         <p:spPr>
           <a:xfrm>
-            <a:off x="6035040" y="2304288"/>
-            <a:ext cx="2743200" cy="2793492"/>
+            <a:off x="6035040" y="2212848"/>
+            <a:ext cx="2743200" cy="2884932"/>
           </a:xfrm>
           <a:prstGeom prst="roundRect">
             <a:avLst>
@@ -18375,12 +18375,12 @@
         </p:nvSpPr>
         <p:spPr>
           <a:xfrm>
-            <a:off x="6035040" y="2304288"/>
-            <a:ext cx="2743200" cy="347472"/>
+            <a:off x="6035040" y="2212848"/>
+            <a:ext cx="2743200" cy="329184"/>
           </a:xfrm>
           <a:prstGeom prst="roundRect">
             <a:avLst>
-              <a:gd name="adj" fmla="val 18421"/>
+              <a:gd name="adj" fmla="val 19444"/>
             </a:avLst>
           </a:prstGeom>
           <a:solidFill>
@@ -18402,8 +18402,8 @@
         </p:nvSpPr>
         <p:spPr>
           <a:xfrm>
-            <a:off x="6035040" y="2304288"/>
-            <a:ext cx="2743200" cy="347472"/>
+            <a:off x="6035040" y="2212848"/>
+            <a:ext cx="2743200" cy="329184"/>
           </a:xfrm>
           <a:prstGeom prst="rect">
             <a:avLst/>
@@ -18441,12 +18441,12 @@
         </p:nvSpPr>
         <p:spPr>
           <a:xfrm>
-            <a:off x="6126480" y="2706624"/>
-            <a:ext cx="2560320" cy="760476"/>
+            <a:off x="6126480" y="2587752"/>
+            <a:ext cx="2560320" cy="809244"/>
           </a:xfrm>
           <a:prstGeom prst="roundRect">
             <a:avLst>
-              <a:gd name="adj" fmla="val 8417"/>
+              <a:gd name="adj" fmla="val 7910"/>
             </a:avLst>
           </a:prstGeom>
           <a:solidFill>
@@ -18475,8 +18475,8 @@
         </p:nvSpPr>
         <p:spPr>
           <a:xfrm>
-            <a:off x="6199632" y="2761488"/>
-            <a:ext cx="2414016" cy="669036"/>
+            <a:off x="6199632" y="2624328"/>
+            <a:ext cx="2414016" cy="736092"/>
           </a:xfrm>
           <a:prstGeom prst="rect">
             <a:avLst/>
@@ -18490,7 +18490,7 @@
           <a:p>
             <a:pPr indent="0" marL="0">
               <a:lnSpc>
-                <a:spcPct val="120000"/>
+                <a:spcPct val="115000"/>
               </a:lnSpc>
               <a:buNone/>
             </a:pPr>
@@ -18517,12 +18517,12 @@
         </p:nvSpPr>
         <p:spPr>
           <a:xfrm>
-            <a:off x="6126480" y="3512820"/>
-            <a:ext cx="2560320" cy="760476"/>
+            <a:off x="6126480" y="3433572"/>
+            <a:ext cx="2560320" cy="809244"/>
           </a:xfrm>
           <a:prstGeom prst="roundRect">
             <a:avLst>
-              <a:gd name="adj" fmla="val 8417"/>
+              <a:gd name="adj" fmla="val 7910"/>
             </a:avLst>
           </a:prstGeom>
           <a:solidFill>
@@ -18551,8 +18551,8 @@
         </p:nvSpPr>
         <p:spPr>
           <a:xfrm>
-            <a:off x="6199632" y="3567684"/>
-            <a:ext cx="2414016" cy="669036"/>
+            <a:off x="6199632" y="3470148"/>
+            <a:ext cx="2414016" cy="736092"/>
           </a:xfrm>
           <a:prstGeom prst="rect">
             <a:avLst/>
@@ -18566,7 +18566,7 @@
           <a:p>
             <a:pPr indent="0" marL="0">
               <a:lnSpc>
-                <a:spcPct val="120000"/>
+                <a:spcPct val="115000"/>
               </a:lnSpc>
               <a:buNone/>
             </a:pPr>
@@ -18586,7 +18586,7 @@
           <a:p>
             <a:pPr indent="0" marL="0">
               <a:lnSpc>
-                <a:spcPct val="120000"/>
+                <a:spcPct val="115000"/>
               </a:lnSpc>
               <a:buNone/>
             </a:pPr>
@@ -18613,12 +18613,12 @@
         </p:nvSpPr>
         <p:spPr>
           <a:xfrm>
-            <a:off x="6126480" y="4319016"/>
-            <a:ext cx="2560320" cy="760476"/>
+            <a:off x="6126480" y="4279392"/>
+            <a:ext cx="2560320" cy="809244"/>
           </a:xfrm>
           <a:prstGeom prst="roundRect">
             <a:avLst>
-              <a:gd name="adj" fmla="val 8417"/>
+              <a:gd name="adj" fmla="val 7910"/>
             </a:avLst>
           </a:prstGeom>
           <a:solidFill>
@@ -18647,8 +18647,8 @@
         </p:nvSpPr>
         <p:spPr>
           <a:xfrm>
-            <a:off x="6199632" y="4373880"/>
-            <a:ext cx="2414016" cy="669036"/>
+            <a:off x="6199632" y="4315968"/>
+            <a:ext cx="2414016" cy="736092"/>
           </a:xfrm>
           <a:prstGeom prst="rect">
             <a:avLst/>
@@ -18662,7 +18662,7 @@
           <a:p>
             <a:pPr indent="0" marL="0">
               <a:lnSpc>
-                <a:spcPct val="120000"/>
+                <a:spcPct val="115000"/>
               </a:lnSpc>
               <a:buNone/>
             </a:pPr>

</xml_diff>

<commit_message>
Update winnercomb.pptx - slide8 clean separation
</commit_message>
<xml_diff>
--- a/winnercomb.pptx
+++ b/winnercomb.pptx
@@ -16316,11 +16316,11 @@
         <p:spPr>
           <a:xfrm>
             <a:off x="365760" y="1042416"/>
-            <a:ext cx="1594714" cy="1078992"/>
+            <a:ext cx="1594714" cy="1554480"/>
           </a:xfrm>
           <a:prstGeom prst="roundRect">
             <a:avLst>
-              <a:gd name="adj" fmla="val 5932"/>
+              <a:gd name="adj" fmla="val 4118"/>
             </a:avLst>
           </a:prstGeom>
           <a:solidFill>
@@ -16350,7 +16350,7 @@
         <p:spPr>
           <a:xfrm>
             <a:off x="365760" y="1042416"/>
-            <a:ext cx="1594714" cy="109728"/>
+            <a:ext cx="1594714" cy="128016"/>
           </a:xfrm>
           <a:prstGeom prst="rect">
             <a:avLst/>
@@ -16374,8 +16374,8 @@
         </p:nvSpPr>
         <p:spPr>
           <a:xfrm>
-            <a:off x="961949" y="1188720"/>
-            <a:ext cx="402336" cy="402336"/>
+            <a:off x="907085" y="1261872"/>
+            <a:ext cx="512064" cy="512064"/>
           </a:xfrm>
           <a:prstGeom prst="ellipse">
             <a:avLst/>
@@ -16399,8 +16399,8 @@
         </p:nvSpPr>
         <p:spPr>
           <a:xfrm>
-            <a:off x="961949" y="1188720"/>
-            <a:ext cx="402336" cy="402336"/>
+            <a:off x="907085" y="1261872"/>
+            <a:ext cx="512064" cy="512064"/>
           </a:xfrm>
           <a:prstGeom prst="rect">
             <a:avLst/>
@@ -16416,7 +16416,7 @@
               <a:buNone/>
             </a:pPr>
             <a:r>
-              <a:rPr lang="en-US" sz="1400" dirty="0">
+              <a:rPr lang="en-US" sz="1800" dirty="0">
                 <a:solidFill>
                   <a:srgbClr val="000000"/>
                 </a:solidFill>
@@ -16426,7 +16426,7 @@
               </a:rPr>
               <a:t>🎯</a:t>
             </a:r>
-            <a:endParaRPr lang="en-US" sz="1400" dirty="0"/>
+            <a:endParaRPr lang="en-US" sz="1800" dirty="0"/>
           </a:p>
         </p:txBody>
       </p:sp>
@@ -16438,93 +16438,8 @@
         </p:nvSpPr>
         <p:spPr>
           <a:xfrm>
-            <a:off x="411480" y="1682496"/>
-            <a:ext cx="1503274" cy="256032"/>
-          </a:xfrm>
-          <a:prstGeom prst="rect">
-            <a:avLst/>
-          </a:prstGeom>
-          <a:noFill/>
-          <a:ln/>
-        </p:spPr>
-        <p:txBody>
-          <a:bodyPr wrap="square" lIns="0" tIns="0" rIns="0" bIns="0" rtlCol="0" anchor="ctr"/>
-          <a:lstStyle/>
-          <a:p>
-            <a:pPr algn="ctr" indent="0" marL="0">
-              <a:lnSpc>
-                <a:spcPct val="110000"/>
-              </a:lnSpc>
-              <a:buNone/>
-            </a:pPr>
-            <a:r>
-              <a:rPr lang="en-US" sz="800" b="1" dirty="0">
-                <a:solidFill>
-                  <a:srgbClr val="1B2F5E"/>
-                </a:solidFill>
-                <a:latin typeface="Noto Sans KR" pitchFamily="34" charset="0"/>
-                <a:ea typeface="Noto Sans KR" pitchFamily="34" charset="-122"/>
-                <a:cs typeface="Noto Sans KR" pitchFamily="34" charset="-120"/>
-              </a:rPr>
-              <a:t>딥러닝</a:t>
-            </a:r>
-            <a:endParaRPr lang="en-US" sz="800" dirty="0"/>
-          </a:p>
-          <a:p>
-            <a:pPr algn="ctr" indent="0" marL="0">
-              <a:lnSpc>
-                <a:spcPct val="110000"/>
-              </a:lnSpc>
-              <a:buNone/>
-            </a:pPr>
-            <a:r>
-              <a:rPr lang="en-US" sz="800" b="1" dirty="0">
-                <a:solidFill>
-                  <a:srgbClr val="1B2F5E"/>
-                </a:solidFill>
-                <a:latin typeface="Noto Sans KR" pitchFamily="34" charset="0"/>
-                <a:ea typeface="Noto Sans KR" pitchFamily="34" charset="-122"/>
-                <a:cs typeface="Noto Sans KR" pitchFamily="34" charset="-120"/>
-              </a:rPr>
-              <a:t>자동학습</a:t>
-            </a:r>
-            <a:endParaRPr lang="en-US" sz="800" dirty="0"/>
-          </a:p>
-        </p:txBody>
-      </p:sp>
-      <p:sp>
-        <p:nvSpPr>
-          <p:cNvPr id="11" name="Shape 9"/>
-          <p:cNvSpPr/>
-          <p:nvPr/>
-        </p:nvSpPr>
-        <p:spPr>
-          <a:xfrm>
-            <a:off x="475488" y="1956816"/>
-            <a:ext cx="1375258" cy="0"/>
-          </a:xfrm>
-          <a:prstGeom prst="line">
-            <a:avLst/>
-          </a:prstGeom>
-          <a:noFill/>
-          <a:ln w="12700">
-            <a:solidFill>
-              <a:srgbClr val="E2E8F0"/>
-            </a:solidFill>
-            <a:prstDash val="solid"/>
-          </a:ln>
-        </p:spPr>
-      </p:sp>
-      <p:sp>
-        <p:nvSpPr>
-          <p:cNvPr id="12" name="Text 10"/>
-          <p:cNvSpPr/>
-          <p:nvPr/>
-        </p:nvSpPr>
-        <p:spPr>
-          <a:xfrm>
-            <a:off x="411480" y="2002536"/>
-            <a:ext cx="1503274" cy="237744"/>
+            <a:off x="411480" y="1828800"/>
+            <a:ext cx="1503274" cy="329184"/>
           </a:xfrm>
           <a:prstGeom prst="rect">
             <a:avLst/>
@@ -16543,17 +16458,17 @@
               <a:buNone/>
             </a:pPr>
             <a:r>
-              <a:rPr lang="en-US" sz="700" dirty="0">
-                <a:solidFill>
-                  <a:srgbClr val="475569"/>
-                </a:solidFill>
-                <a:latin typeface="Noto Sans KR" pitchFamily="34" charset="0"/>
-                <a:ea typeface="Noto Sans KR" pitchFamily="34" charset="-122"/>
-                <a:cs typeface="Noto Sans KR" pitchFamily="34" charset="-120"/>
-              </a:rPr>
-              <a:t>데이터 누적</a:t>
-            </a:r>
-            <a:endParaRPr lang="en-US" sz="700" dirty="0"/>
+              <a:rPr lang="en-US" sz="900" b="1" dirty="0">
+                <a:solidFill>
+                  <a:srgbClr val="1B2F5E"/>
+                </a:solidFill>
+                <a:latin typeface="Noto Sans KR" pitchFamily="34" charset="0"/>
+                <a:ea typeface="Noto Sans KR" pitchFamily="34" charset="-122"/>
+                <a:cs typeface="Noto Sans KR" pitchFamily="34" charset="-120"/>
+              </a:rPr>
+              <a:t>딥러닝</a:t>
+            </a:r>
+            <a:endParaRPr lang="en-US" sz="900" dirty="0"/>
           </a:p>
           <a:p>
             <a:pPr algn="ctr" indent="0" marL="0">
@@ -16563,7 +16478,72 @@
               <a:buNone/>
             </a:pPr>
             <a:r>
-              <a:rPr lang="en-US" sz="700" dirty="0">
+              <a:rPr lang="en-US" sz="900" b="1" dirty="0">
+                <a:solidFill>
+                  <a:srgbClr val="1B2F5E"/>
+                </a:solidFill>
+                <a:latin typeface="Noto Sans KR" pitchFamily="34" charset="0"/>
+                <a:ea typeface="Noto Sans KR" pitchFamily="34" charset="-122"/>
+                <a:cs typeface="Noto Sans KR" pitchFamily="34" charset="-120"/>
+              </a:rPr>
+              <a:t>자동학습</a:t>
+            </a:r>
+            <a:endParaRPr lang="en-US" sz="900" dirty="0"/>
+          </a:p>
+        </p:txBody>
+      </p:sp>
+      <p:sp>
+        <p:nvSpPr>
+          <p:cNvPr id="11" name="Shape 9"/>
+          <p:cNvSpPr/>
+          <p:nvPr/>
+        </p:nvSpPr>
+        <p:spPr>
+          <a:xfrm>
+            <a:off x="475488" y="2194560"/>
+            <a:ext cx="1375258" cy="0"/>
+          </a:xfrm>
+          <a:prstGeom prst="line">
+            <a:avLst/>
+          </a:prstGeom>
+          <a:noFill/>
+          <a:ln w="12700">
+            <a:solidFill>
+              <a:srgbClr val="E2E8F0"/>
+            </a:solidFill>
+            <a:prstDash val="solid"/>
+          </a:ln>
+        </p:spPr>
+      </p:sp>
+      <p:sp>
+        <p:nvSpPr>
+          <p:cNvPr id="12" name="Text 10"/>
+          <p:cNvSpPr/>
+          <p:nvPr/>
+        </p:nvSpPr>
+        <p:spPr>
+          <a:xfrm>
+            <a:off x="411480" y="2267712"/>
+            <a:ext cx="1503274" cy="274320"/>
+          </a:xfrm>
+          <a:prstGeom prst="rect">
+            <a:avLst/>
+          </a:prstGeom>
+          <a:noFill/>
+          <a:ln/>
+        </p:spPr>
+        <p:txBody>
+          <a:bodyPr wrap="square" lIns="0" tIns="0" rIns="0" bIns="0" rtlCol="0" anchor="ctr"/>
+          <a:lstStyle/>
+          <a:p>
+            <a:pPr algn="ctr" indent="0" marL="0">
+              <a:lnSpc>
+                <a:spcPct val="120000"/>
+              </a:lnSpc>
+              <a:buNone/>
+            </a:pPr>
+            <a:r>
+              <a:rPr lang="en-US" sz="800" dirty="0">
                 <a:solidFill>
                   <a:srgbClr val="475569"/>
                 </a:solidFill>
@@ -16571,9 +16551,29 @@
                 <a:ea typeface="Noto Sans KR" pitchFamily="34" charset="-122"/>
                 <a:cs typeface="Noto Sans KR" pitchFamily="34" charset="-120"/>
               </a:rPr>
+              <a:t>데이터 누적</a:t>
+            </a:r>
+            <a:endParaRPr lang="en-US" sz="800" dirty="0"/>
+          </a:p>
+          <a:p>
+            <a:pPr algn="ctr" indent="0" marL="0">
+              <a:lnSpc>
+                <a:spcPct val="120000"/>
+              </a:lnSpc>
+              <a:buNone/>
+            </a:pPr>
+            <a:r>
+              <a:rPr lang="en-US" sz="800" dirty="0">
+                <a:solidFill>
+                  <a:srgbClr val="475569"/>
+                </a:solidFill>
+                <a:latin typeface="Noto Sans KR" pitchFamily="34" charset="0"/>
+                <a:ea typeface="Noto Sans KR" pitchFamily="34" charset="-122"/>
+                <a:cs typeface="Noto Sans KR" pitchFamily="34" charset="-120"/>
+              </a:rPr>
               <a:t>→ 정확도 지속 향상</a:t>
             </a:r>
-            <a:endParaRPr lang="en-US" sz="700" dirty="0"/>
+            <a:endParaRPr lang="en-US" sz="800" dirty="0"/>
           </a:p>
         </p:txBody>
       </p:sp>
@@ -16586,11 +16586,11 @@
         <p:spPr>
           <a:xfrm>
             <a:off x="2070202" y="1042416"/>
-            <a:ext cx="1594714" cy="1078992"/>
+            <a:ext cx="1594714" cy="1554480"/>
           </a:xfrm>
           <a:prstGeom prst="roundRect">
             <a:avLst>
-              <a:gd name="adj" fmla="val 5932"/>
+              <a:gd name="adj" fmla="val 4118"/>
             </a:avLst>
           </a:prstGeom>
           <a:solidFill>
@@ -16620,7 +16620,7 @@
         <p:spPr>
           <a:xfrm>
             <a:off x="2070202" y="1042416"/>
-            <a:ext cx="1594714" cy="109728"/>
+            <a:ext cx="1594714" cy="128016"/>
           </a:xfrm>
           <a:prstGeom prst="rect">
             <a:avLst/>
@@ -16644,8 +16644,8 @@
         </p:nvSpPr>
         <p:spPr>
           <a:xfrm>
-            <a:off x="2666390" y="1188720"/>
-            <a:ext cx="402336" cy="402336"/>
+            <a:off x="2611526" y="1261872"/>
+            <a:ext cx="512064" cy="512064"/>
           </a:xfrm>
           <a:prstGeom prst="ellipse">
             <a:avLst/>
@@ -16669,8 +16669,8 @@
         </p:nvSpPr>
         <p:spPr>
           <a:xfrm>
-            <a:off x="2666390" y="1188720"/>
-            <a:ext cx="402336" cy="402336"/>
+            <a:off x="2611526" y="1261872"/>
+            <a:ext cx="512064" cy="512064"/>
           </a:xfrm>
           <a:prstGeom prst="rect">
             <a:avLst/>
@@ -16686,7 +16686,7 @@
               <a:buNone/>
             </a:pPr>
             <a:r>
-              <a:rPr lang="en-US" sz="1400" dirty="0">
+              <a:rPr lang="en-US" sz="1800" dirty="0">
                 <a:solidFill>
                   <a:srgbClr val="000000"/>
                 </a:solidFill>
@@ -16696,7 +16696,7 @@
               </a:rPr>
               <a:t>⚖️</a:t>
             </a:r>
-            <a:endParaRPr lang="en-US" sz="1400" dirty="0"/>
+            <a:endParaRPr lang="en-US" sz="1800" dirty="0"/>
           </a:p>
         </p:txBody>
       </p:sp>
@@ -16708,93 +16708,8 @@
         </p:nvSpPr>
         <p:spPr>
           <a:xfrm>
-            <a:off x="2115922" y="1682496"/>
-            <a:ext cx="1503274" cy="256032"/>
-          </a:xfrm>
-          <a:prstGeom prst="rect">
-            <a:avLst/>
-          </a:prstGeom>
-          <a:noFill/>
-          <a:ln/>
-        </p:spPr>
-        <p:txBody>
-          <a:bodyPr wrap="square" lIns="0" tIns="0" rIns="0" bIns="0" rtlCol="0" anchor="ctr"/>
-          <a:lstStyle/>
-          <a:p>
-            <a:pPr algn="ctr" indent="0" marL="0">
-              <a:lnSpc>
-                <a:spcPct val="110000"/>
-              </a:lnSpc>
-              <a:buNone/>
-            </a:pPr>
-            <a:r>
-              <a:rPr lang="en-US" sz="800" b="1" dirty="0">
-                <a:solidFill>
-                  <a:srgbClr val="1B2F5E"/>
-                </a:solidFill>
-                <a:latin typeface="Noto Sans KR" pitchFamily="34" charset="0"/>
-                <a:ea typeface="Noto Sans KR" pitchFamily="34" charset="-122"/>
-                <a:cs typeface="Noto Sans KR" pitchFamily="34" charset="-120"/>
-              </a:rPr>
-              <a:t>일관된</a:t>
-            </a:r>
-            <a:endParaRPr lang="en-US" sz="800" dirty="0"/>
-          </a:p>
-          <a:p>
-            <a:pPr algn="ctr" indent="0" marL="0">
-              <a:lnSpc>
-                <a:spcPct val="110000"/>
-              </a:lnSpc>
-              <a:buNone/>
-            </a:pPr>
-            <a:r>
-              <a:rPr lang="en-US" sz="800" b="1" dirty="0">
-                <a:solidFill>
-                  <a:srgbClr val="1B2F5E"/>
-                </a:solidFill>
-                <a:latin typeface="Noto Sans KR" pitchFamily="34" charset="0"/>
-                <a:ea typeface="Noto Sans KR" pitchFamily="34" charset="-122"/>
-                <a:cs typeface="Noto Sans KR" pitchFamily="34" charset="-120"/>
-              </a:rPr>
-              <a:t>검사 기준</a:t>
-            </a:r>
-            <a:endParaRPr lang="en-US" sz="800" dirty="0"/>
-          </a:p>
-        </p:txBody>
-      </p:sp>
-      <p:sp>
-        <p:nvSpPr>
-          <p:cNvPr id="18" name="Shape 16"/>
-          <p:cNvSpPr/>
-          <p:nvPr/>
-        </p:nvSpPr>
-        <p:spPr>
-          <a:xfrm>
-            <a:off x="2179930" y="1956816"/>
-            <a:ext cx="1375258" cy="0"/>
-          </a:xfrm>
-          <a:prstGeom prst="line">
-            <a:avLst/>
-          </a:prstGeom>
-          <a:noFill/>
-          <a:ln w="12700">
-            <a:solidFill>
-              <a:srgbClr val="E2E8F0"/>
-            </a:solidFill>
-            <a:prstDash val="solid"/>
-          </a:ln>
-        </p:spPr>
-      </p:sp>
-      <p:sp>
-        <p:nvSpPr>
-          <p:cNvPr id="19" name="Text 17"/>
-          <p:cNvSpPr/>
-          <p:nvPr/>
-        </p:nvSpPr>
-        <p:spPr>
-          <a:xfrm>
-            <a:off x="2115922" y="2002536"/>
-            <a:ext cx="1503274" cy="237744"/>
+            <a:off x="2115922" y="1828800"/>
+            <a:ext cx="1503274" cy="329184"/>
           </a:xfrm>
           <a:prstGeom prst="rect">
             <a:avLst/>
@@ -16813,17 +16728,17 @@
               <a:buNone/>
             </a:pPr>
             <a:r>
-              <a:rPr lang="en-US" sz="700" dirty="0">
-                <a:solidFill>
-                  <a:srgbClr val="475569"/>
-                </a:solidFill>
-                <a:latin typeface="Noto Sans KR" pitchFamily="34" charset="0"/>
-                <a:ea typeface="Noto Sans KR" pitchFamily="34" charset="-122"/>
-                <a:cs typeface="Noto Sans KR" pitchFamily="34" charset="-120"/>
-              </a:rPr>
-              <a:t>컨디션 무관</a:t>
-            </a:r>
-            <a:endParaRPr lang="en-US" sz="700" dirty="0"/>
+              <a:rPr lang="en-US" sz="900" b="1" dirty="0">
+                <a:solidFill>
+                  <a:srgbClr val="1B2F5E"/>
+                </a:solidFill>
+                <a:latin typeface="Noto Sans KR" pitchFamily="34" charset="0"/>
+                <a:ea typeface="Noto Sans KR" pitchFamily="34" charset="-122"/>
+                <a:cs typeface="Noto Sans KR" pitchFamily="34" charset="-120"/>
+              </a:rPr>
+              <a:t>일관된</a:t>
+            </a:r>
+            <a:endParaRPr lang="en-US" sz="900" dirty="0"/>
           </a:p>
           <a:p>
             <a:pPr algn="ctr" indent="0" marL="0">
@@ -16833,7 +16748,72 @@
               <a:buNone/>
             </a:pPr>
             <a:r>
-              <a:rPr lang="en-US" sz="700" dirty="0">
+              <a:rPr lang="en-US" sz="900" b="1" dirty="0">
+                <a:solidFill>
+                  <a:srgbClr val="1B2F5E"/>
+                </a:solidFill>
+                <a:latin typeface="Noto Sans KR" pitchFamily="34" charset="0"/>
+                <a:ea typeface="Noto Sans KR" pitchFamily="34" charset="-122"/>
+                <a:cs typeface="Noto Sans KR" pitchFamily="34" charset="-120"/>
+              </a:rPr>
+              <a:t>검사 기준</a:t>
+            </a:r>
+            <a:endParaRPr lang="en-US" sz="900" dirty="0"/>
+          </a:p>
+        </p:txBody>
+      </p:sp>
+      <p:sp>
+        <p:nvSpPr>
+          <p:cNvPr id="18" name="Shape 16"/>
+          <p:cNvSpPr/>
+          <p:nvPr/>
+        </p:nvSpPr>
+        <p:spPr>
+          <a:xfrm>
+            <a:off x="2179930" y="2194560"/>
+            <a:ext cx="1375258" cy="0"/>
+          </a:xfrm>
+          <a:prstGeom prst="line">
+            <a:avLst/>
+          </a:prstGeom>
+          <a:noFill/>
+          <a:ln w="12700">
+            <a:solidFill>
+              <a:srgbClr val="E2E8F0"/>
+            </a:solidFill>
+            <a:prstDash val="solid"/>
+          </a:ln>
+        </p:spPr>
+      </p:sp>
+      <p:sp>
+        <p:nvSpPr>
+          <p:cNvPr id="19" name="Text 17"/>
+          <p:cNvSpPr/>
+          <p:nvPr/>
+        </p:nvSpPr>
+        <p:spPr>
+          <a:xfrm>
+            <a:off x="2115922" y="2267712"/>
+            <a:ext cx="1503274" cy="274320"/>
+          </a:xfrm>
+          <a:prstGeom prst="rect">
+            <a:avLst/>
+          </a:prstGeom>
+          <a:noFill/>
+          <a:ln/>
+        </p:spPr>
+        <p:txBody>
+          <a:bodyPr wrap="square" lIns="0" tIns="0" rIns="0" bIns="0" rtlCol="0" anchor="ctr"/>
+          <a:lstStyle/>
+          <a:p>
+            <a:pPr algn="ctr" indent="0" marL="0">
+              <a:lnSpc>
+                <a:spcPct val="120000"/>
+              </a:lnSpc>
+              <a:buNone/>
+            </a:pPr>
+            <a:r>
+              <a:rPr lang="en-US" sz="800" dirty="0">
                 <a:solidFill>
                   <a:srgbClr val="475569"/>
                 </a:solidFill>
@@ -16841,9 +16821,29 @@
                 <a:ea typeface="Noto Sans KR" pitchFamily="34" charset="-122"/>
                 <a:cs typeface="Noto Sans KR" pitchFamily="34" charset="-120"/>
               </a:rPr>
+              <a:t>컨디션 무관</a:t>
+            </a:r>
+            <a:endParaRPr lang="en-US" sz="800" dirty="0"/>
+          </a:p>
+          <a:p>
+            <a:pPr algn="ctr" indent="0" marL="0">
+              <a:lnSpc>
+                <a:spcPct val="120000"/>
+              </a:lnSpc>
+              <a:buNone/>
+            </a:pPr>
+            <a:r>
+              <a:rPr lang="en-US" sz="800" dirty="0">
+                <a:solidFill>
+                  <a:srgbClr val="475569"/>
+                </a:solidFill>
+                <a:latin typeface="Noto Sans KR" pitchFamily="34" charset="0"/>
+                <a:ea typeface="Noto Sans KR" pitchFamily="34" charset="-122"/>
+                <a:cs typeface="Noto Sans KR" pitchFamily="34" charset="-120"/>
+              </a:rPr>
               <a:t>동일 기준 판정</a:t>
             </a:r>
-            <a:endParaRPr lang="en-US" sz="700" dirty="0"/>
+            <a:endParaRPr lang="en-US" sz="800" dirty="0"/>
           </a:p>
         </p:txBody>
       </p:sp>
@@ -16856,11 +16856,11 @@
         <p:spPr>
           <a:xfrm>
             <a:off x="3774643" y="1042416"/>
-            <a:ext cx="1594714" cy="1078992"/>
+            <a:ext cx="1594714" cy="1554480"/>
           </a:xfrm>
           <a:prstGeom prst="roundRect">
             <a:avLst>
-              <a:gd name="adj" fmla="val 5932"/>
+              <a:gd name="adj" fmla="val 4118"/>
             </a:avLst>
           </a:prstGeom>
           <a:solidFill>
@@ -16890,7 +16890,7 @@
         <p:spPr>
           <a:xfrm>
             <a:off x="3774643" y="1042416"/>
-            <a:ext cx="1594714" cy="109728"/>
+            <a:ext cx="1594714" cy="128016"/>
           </a:xfrm>
           <a:prstGeom prst="rect">
             <a:avLst/>
@@ -16914,8 +16914,8 @@
         </p:nvSpPr>
         <p:spPr>
           <a:xfrm>
-            <a:off x="4370832" y="1188720"/>
-            <a:ext cx="402336" cy="402336"/>
+            <a:off x="4315968" y="1261872"/>
+            <a:ext cx="512064" cy="512064"/>
           </a:xfrm>
           <a:prstGeom prst="ellipse">
             <a:avLst/>
@@ -16939,8 +16939,8 @@
         </p:nvSpPr>
         <p:spPr>
           <a:xfrm>
-            <a:off x="4370832" y="1188720"/>
-            <a:ext cx="402336" cy="402336"/>
+            <a:off x="4315968" y="1261872"/>
+            <a:ext cx="512064" cy="512064"/>
           </a:xfrm>
           <a:prstGeom prst="rect">
             <a:avLst/>
@@ -16956,7 +16956,7 @@
               <a:buNone/>
             </a:pPr>
             <a:r>
-              <a:rPr lang="en-US" sz="1400" dirty="0">
+              <a:rPr lang="en-US" sz="1800" dirty="0">
                 <a:solidFill>
                   <a:srgbClr val="000000"/>
                 </a:solidFill>
@@ -16966,7 +16966,7 @@
               </a:rPr>
               <a:t>🚫</a:t>
             </a:r>
-            <a:endParaRPr lang="en-US" sz="1400" dirty="0"/>
+            <a:endParaRPr lang="en-US" sz="1800" dirty="0"/>
           </a:p>
         </p:txBody>
       </p:sp>
@@ -16978,93 +16978,8 @@
         </p:nvSpPr>
         <p:spPr>
           <a:xfrm>
-            <a:off x="3820363" y="1682496"/>
-            <a:ext cx="1503274" cy="256032"/>
-          </a:xfrm>
-          <a:prstGeom prst="rect">
-            <a:avLst/>
-          </a:prstGeom>
-          <a:noFill/>
-          <a:ln/>
-        </p:spPr>
-        <p:txBody>
-          <a:bodyPr wrap="square" lIns="0" tIns="0" rIns="0" bIns="0" rtlCol="0" anchor="ctr"/>
-          <a:lstStyle/>
-          <a:p>
-            <a:pPr algn="ctr" indent="0" marL="0">
-              <a:lnSpc>
-                <a:spcPct val="110000"/>
-              </a:lnSpc>
-              <a:buNone/>
-            </a:pPr>
-            <a:r>
-              <a:rPr lang="en-US" sz="800" b="1" dirty="0">
-                <a:solidFill>
-                  <a:srgbClr val="1B2F5E"/>
-                </a:solidFill>
-                <a:latin typeface="Noto Sans KR" pitchFamily="34" charset="0"/>
-                <a:ea typeface="Noto Sans KR" pitchFamily="34" charset="-122"/>
-                <a:cs typeface="Noto Sans KR" pitchFamily="34" charset="-120"/>
-              </a:rPr>
-              <a:t>불량 혼입</a:t>
-            </a:r>
-            <a:endParaRPr lang="en-US" sz="800" dirty="0"/>
-          </a:p>
-          <a:p>
-            <a:pPr algn="ctr" indent="0" marL="0">
-              <a:lnSpc>
-                <a:spcPct val="110000"/>
-              </a:lnSpc>
-              <a:buNone/>
-            </a:pPr>
-            <a:r>
-              <a:rPr lang="en-US" sz="800" b="1" dirty="0">
-                <a:solidFill>
-                  <a:srgbClr val="1B2F5E"/>
-                </a:solidFill>
-                <a:latin typeface="Noto Sans KR" pitchFamily="34" charset="0"/>
-                <a:ea typeface="Noto Sans KR" pitchFamily="34" charset="-122"/>
-                <a:cs typeface="Noto Sans KR" pitchFamily="34" charset="-120"/>
-              </a:rPr>
-              <a:t>원천 차단</a:t>
-            </a:r>
-            <a:endParaRPr lang="en-US" sz="800" dirty="0"/>
-          </a:p>
-        </p:txBody>
-      </p:sp>
-      <p:sp>
-        <p:nvSpPr>
-          <p:cNvPr id="25" name="Shape 23"/>
-          <p:cNvSpPr/>
-          <p:nvPr/>
-        </p:nvSpPr>
-        <p:spPr>
-          <a:xfrm>
-            <a:off x="3884371" y="1956816"/>
-            <a:ext cx="1375258" cy="0"/>
-          </a:xfrm>
-          <a:prstGeom prst="line">
-            <a:avLst/>
-          </a:prstGeom>
-          <a:noFill/>
-          <a:ln w="12700">
-            <a:solidFill>
-              <a:srgbClr val="E2E8F0"/>
-            </a:solidFill>
-            <a:prstDash val="solid"/>
-          </a:ln>
-        </p:spPr>
-      </p:sp>
-      <p:sp>
-        <p:nvSpPr>
-          <p:cNvPr id="26" name="Text 24"/>
-          <p:cNvSpPr/>
-          <p:nvPr/>
-        </p:nvSpPr>
-        <p:spPr>
-          <a:xfrm>
-            <a:off x="3820363" y="2002536"/>
-            <a:ext cx="1503274" cy="237744"/>
+            <a:off x="3820363" y="1828800"/>
+            <a:ext cx="1503274" cy="329184"/>
           </a:xfrm>
           <a:prstGeom prst="rect">
             <a:avLst/>
@@ -17083,17 +16998,17 @@
               <a:buNone/>
             </a:pPr>
             <a:r>
-              <a:rPr lang="en-US" sz="700" dirty="0">
-                <a:solidFill>
-                  <a:srgbClr val="475569"/>
-                </a:solidFill>
-                <a:latin typeface="Noto Sans KR" pitchFamily="34" charset="0"/>
-                <a:ea typeface="Noto Sans KR" pitchFamily="34" charset="-122"/>
-                <a:cs typeface="Noto Sans KR" pitchFamily="34" charset="-120"/>
-              </a:rPr>
-              <a:t>자동 분리 배출</a:t>
-            </a:r>
-            <a:endParaRPr lang="en-US" sz="700" dirty="0"/>
+              <a:rPr lang="en-US" sz="900" b="1" dirty="0">
+                <a:solidFill>
+                  <a:srgbClr val="1B2F5E"/>
+                </a:solidFill>
+                <a:latin typeface="Noto Sans KR" pitchFamily="34" charset="0"/>
+                <a:ea typeface="Noto Sans KR" pitchFamily="34" charset="-122"/>
+                <a:cs typeface="Noto Sans KR" pitchFamily="34" charset="-120"/>
+              </a:rPr>
+              <a:t>불량 혼입</a:t>
+            </a:r>
+            <a:endParaRPr lang="en-US" sz="900" dirty="0"/>
           </a:p>
           <a:p>
             <a:pPr algn="ctr" indent="0" marL="0">
@@ -17103,7 +17018,72 @@
               <a:buNone/>
             </a:pPr>
             <a:r>
-              <a:rPr lang="en-US" sz="700" dirty="0">
+              <a:rPr lang="en-US" sz="900" b="1" dirty="0">
+                <a:solidFill>
+                  <a:srgbClr val="1B2F5E"/>
+                </a:solidFill>
+                <a:latin typeface="Noto Sans KR" pitchFamily="34" charset="0"/>
+                <a:ea typeface="Noto Sans KR" pitchFamily="34" charset="-122"/>
+                <a:cs typeface="Noto Sans KR" pitchFamily="34" charset="-120"/>
+              </a:rPr>
+              <a:t>원천 차단</a:t>
+            </a:r>
+            <a:endParaRPr lang="en-US" sz="900" dirty="0"/>
+          </a:p>
+        </p:txBody>
+      </p:sp>
+      <p:sp>
+        <p:nvSpPr>
+          <p:cNvPr id="25" name="Shape 23"/>
+          <p:cNvSpPr/>
+          <p:nvPr/>
+        </p:nvSpPr>
+        <p:spPr>
+          <a:xfrm>
+            <a:off x="3884371" y="2194560"/>
+            <a:ext cx="1375258" cy="0"/>
+          </a:xfrm>
+          <a:prstGeom prst="line">
+            <a:avLst/>
+          </a:prstGeom>
+          <a:noFill/>
+          <a:ln w="12700">
+            <a:solidFill>
+              <a:srgbClr val="E2E8F0"/>
+            </a:solidFill>
+            <a:prstDash val="solid"/>
+          </a:ln>
+        </p:spPr>
+      </p:sp>
+      <p:sp>
+        <p:nvSpPr>
+          <p:cNvPr id="26" name="Text 24"/>
+          <p:cNvSpPr/>
+          <p:nvPr/>
+        </p:nvSpPr>
+        <p:spPr>
+          <a:xfrm>
+            <a:off x="3820363" y="2267712"/>
+            <a:ext cx="1503274" cy="274320"/>
+          </a:xfrm>
+          <a:prstGeom prst="rect">
+            <a:avLst/>
+          </a:prstGeom>
+          <a:noFill/>
+          <a:ln/>
+        </p:spPr>
+        <p:txBody>
+          <a:bodyPr wrap="square" lIns="0" tIns="0" rIns="0" bIns="0" rtlCol="0" anchor="ctr"/>
+          <a:lstStyle/>
+          <a:p>
+            <a:pPr algn="ctr" indent="0" marL="0">
+              <a:lnSpc>
+                <a:spcPct val="120000"/>
+              </a:lnSpc>
+              <a:buNone/>
+            </a:pPr>
+            <a:r>
+              <a:rPr lang="en-US" sz="800" dirty="0">
                 <a:solidFill>
                   <a:srgbClr val="475569"/>
                 </a:solidFill>
@@ -17111,9 +17091,29 @@
                 <a:ea typeface="Noto Sans KR" pitchFamily="34" charset="-122"/>
                 <a:cs typeface="Noto Sans KR" pitchFamily="34" charset="-120"/>
               </a:rPr>
+              <a:t>자동 분리 배출</a:t>
+            </a:r>
+            <a:endParaRPr lang="en-US" sz="800" dirty="0"/>
+          </a:p>
+          <a:p>
+            <a:pPr algn="ctr" indent="0" marL="0">
+              <a:lnSpc>
+                <a:spcPct val="120000"/>
+              </a:lnSpc>
+              <a:buNone/>
+            </a:pPr>
+            <a:r>
+              <a:rPr lang="en-US" sz="800" dirty="0">
+                <a:solidFill>
+                  <a:srgbClr val="475569"/>
+                </a:solidFill>
+                <a:latin typeface="Noto Sans KR" pitchFamily="34" charset="0"/>
+                <a:ea typeface="Noto Sans KR" pitchFamily="34" charset="-122"/>
+                <a:cs typeface="Noto Sans KR" pitchFamily="34" charset="-120"/>
+              </a:rPr>
               <a:t>재검사 불필요</a:t>
             </a:r>
-            <a:endParaRPr lang="en-US" sz="700" dirty="0"/>
+            <a:endParaRPr lang="en-US" sz="800" dirty="0"/>
           </a:p>
         </p:txBody>
       </p:sp>
@@ -17126,11 +17126,11 @@
         <p:spPr>
           <a:xfrm>
             <a:off x="5479085" y="1042416"/>
-            <a:ext cx="1594714" cy="1078992"/>
+            <a:ext cx="1594714" cy="1554480"/>
           </a:xfrm>
           <a:prstGeom prst="roundRect">
             <a:avLst>
-              <a:gd name="adj" fmla="val 5932"/>
+              <a:gd name="adj" fmla="val 4118"/>
             </a:avLst>
           </a:prstGeom>
           <a:solidFill>
@@ -17160,7 +17160,7 @@
         <p:spPr>
           <a:xfrm>
             <a:off x="5479085" y="1042416"/>
-            <a:ext cx="1594714" cy="109728"/>
+            <a:ext cx="1594714" cy="128016"/>
           </a:xfrm>
           <a:prstGeom prst="rect">
             <a:avLst/>
@@ -17184,8 +17184,8 @@
         </p:nvSpPr>
         <p:spPr>
           <a:xfrm>
-            <a:off x="6075274" y="1188720"/>
-            <a:ext cx="402336" cy="402336"/>
+            <a:off x="6020410" y="1261872"/>
+            <a:ext cx="512064" cy="512064"/>
           </a:xfrm>
           <a:prstGeom prst="ellipse">
             <a:avLst/>
@@ -17209,8 +17209,8 @@
         </p:nvSpPr>
         <p:spPr>
           <a:xfrm>
-            <a:off x="6075274" y="1188720"/>
-            <a:ext cx="402336" cy="402336"/>
+            <a:off x="6020410" y="1261872"/>
+            <a:ext cx="512064" cy="512064"/>
           </a:xfrm>
           <a:prstGeom prst="rect">
             <a:avLst/>
@@ -17226,7 +17226,7 @@
               <a:buNone/>
             </a:pPr>
             <a:r>
-              <a:rPr lang="en-US" sz="1400" dirty="0">
+              <a:rPr lang="en-US" sz="1800" dirty="0">
                 <a:solidFill>
                   <a:srgbClr val="000000"/>
                 </a:solidFill>
@@ -17236,7 +17236,7 @@
               </a:rPr>
               <a:t>📈</a:t>
             </a:r>
-            <a:endParaRPr lang="en-US" sz="1400" dirty="0"/>
+            <a:endParaRPr lang="en-US" sz="1800" dirty="0"/>
           </a:p>
         </p:txBody>
       </p:sp>
@@ -17248,93 +17248,8 @@
         </p:nvSpPr>
         <p:spPr>
           <a:xfrm>
-            <a:off x="5524805" y="1682496"/>
-            <a:ext cx="1503274" cy="256032"/>
-          </a:xfrm>
-          <a:prstGeom prst="rect">
-            <a:avLst/>
-          </a:prstGeom>
-          <a:noFill/>
-          <a:ln/>
-        </p:spPr>
-        <p:txBody>
-          <a:bodyPr wrap="square" lIns="0" tIns="0" rIns="0" bIns="0" rtlCol="0" anchor="ctr"/>
-          <a:lstStyle/>
-          <a:p>
-            <a:pPr algn="ctr" indent="0" marL="0">
-              <a:lnSpc>
-                <a:spcPct val="110000"/>
-              </a:lnSpc>
-              <a:buNone/>
-            </a:pPr>
-            <a:r>
-              <a:rPr lang="en-US" sz="800" b="1" dirty="0">
-                <a:solidFill>
-                  <a:srgbClr val="1B2F5E"/>
-                </a:solidFill>
-                <a:latin typeface="Noto Sans KR" pitchFamily="34" charset="0"/>
-                <a:ea typeface="Noto Sans KR" pitchFamily="34" charset="-122"/>
-                <a:cs typeface="Noto Sans KR" pitchFamily="34" charset="-120"/>
-              </a:rPr>
-              <a:t>품질 데이터</a:t>
-            </a:r>
-            <a:endParaRPr lang="en-US" sz="800" dirty="0"/>
-          </a:p>
-          <a:p>
-            <a:pPr algn="ctr" indent="0" marL="0">
-              <a:lnSpc>
-                <a:spcPct val="110000"/>
-              </a:lnSpc>
-              <a:buNone/>
-            </a:pPr>
-            <a:r>
-              <a:rPr lang="en-US" sz="800" b="1" dirty="0">
-                <a:solidFill>
-                  <a:srgbClr val="1B2F5E"/>
-                </a:solidFill>
-                <a:latin typeface="Noto Sans KR" pitchFamily="34" charset="0"/>
-                <a:ea typeface="Noto Sans KR" pitchFamily="34" charset="-122"/>
-                <a:cs typeface="Noto Sans KR" pitchFamily="34" charset="-120"/>
-              </a:rPr>
-              <a:t>자산화</a:t>
-            </a:r>
-            <a:endParaRPr lang="en-US" sz="800" dirty="0"/>
-          </a:p>
-        </p:txBody>
-      </p:sp>
-      <p:sp>
-        <p:nvSpPr>
-          <p:cNvPr id="32" name="Shape 30"/>
-          <p:cNvSpPr/>
-          <p:nvPr/>
-        </p:nvSpPr>
-        <p:spPr>
-          <a:xfrm>
-            <a:off x="5588813" y="1956816"/>
-            <a:ext cx="1375258" cy="0"/>
-          </a:xfrm>
-          <a:prstGeom prst="line">
-            <a:avLst/>
-          </a:prstGeom>
-          <a:noFill/>
-          <a:ln w="12700">
-            <a:solidFill>
-              <a:srgbClr val="E2E8F0"/>
-            </a:solidFill>
-            <a:prstDash val="solid"/>
-          </a:ln>
-        </p:spPr>
-      </p:sp>
-      <p:sp>
-        <p:nvSpPr>
-          <p:cNvPr id="33" name="Text 31"/>
-          <p:cNvSpPr/>
-          <p:nvPr/>
-        </p:nvSpPr>
-        <p:spPr>
-          <a:xfrm>
-            <a:off x="5524805" y="2002536"/>
-            <a:ext cx="1503274" cy="237744"/>
+            <a:off x="5524805" y="1828800"/>
+            <a:ext cx="1503274" cy="329184"/>
           </a:xfrm>
           <a:prstGeom prst="rect">
             <a:avLst/>
@@ -17353,17 +17268,17 @@
               <a:buNone/>
             </a:pPr>
             <a:r>
-              <a:rPr lang="en-US" sz="700" dirty="0">
-                <a:solidFill>
-                  <a:srgbClr val="475569"/>
-                </a:solidFill>
-                <a:latin typeface="Noto Sans KR" pitchFamily="34" charset="0"/>
-                <a:ea typeface="Noto Sans KR" pitchFamily="34" charset="-122"/>
-                <a:cs typeface="Noto Sans KR" pitchFamily="34" charset="-120"/>
-              </a:rPr>
-              <a:t>통계·트렌드</a:t>
-            </a:r>
-            <a:endParaRPr lang="en-US" sz="700" dirty="0"/>
+              <a:rPr lang="en-US" sz="900" b="1" dirty="0">
+                <a:solidFill>
+                  <a:srgbClr val="1B2F5E"/>
+                </a:solidFill>
+                <a:latin typeface="Noto Sans KR" pitchFamily="34" charset="0"/>
+                <a:ea typeface="Noto Sans KR" pitchFamily="34" charset="-122"/>
+                <a:cs typeface="Noto Sans KR" pitchFamily="34" charset="-120"/>
+              </a:rPr>
+              <a:t>품질 데이터</a:t>
+            </a:r>
+            <a:endParaRPr lang="en-US" sz="900" dirty="0"/>
           </a:p>
           <a:p>
             <a:pPr algn="ctr" indent="0" marL="0">
@@ -17373,7 +17288,72 @@
               <a:buNone/>
             </a:pPr>
             <a:r>
-              <a:rPr lang="en-US" sz="700" dirty="0">
+              <a:rPr lang="en-US" sz="900" b="1" dirty="0">
+                <a:solidFill>
+                  <a:srgbClr val="1B2F5E"/>
+                </a:solidFill>
+                <a:latin typeface="Noto Sans KR" pitchFamily="34" charset="0"/>
+                <a:ea typeface="Noto Sans KR" pitchFamily="34" charset="-122"/>
+                <a:cs typeface="Noto Sans KR" pitchFamily="34" charset="-120"/>
+              </a:rPr>
+              <a:t>자산화</a:t>
+            </a:r>
+            <a:endParaRPr lang="en-US" sz="900" dirty="0"/>
+          </a:p>
+        </p:txBody>
+      </p:sp>
+      <p:sp>
+        <p:nvSpPr>
+          <p:cNvPr id="32" name="Shape 30"/>
+          <p:cNvSpPr/>
+          <p:nvPr/>
+        </p:nvSpPr>
+        <p:spPr>
+          <a:xfrm>
+            <a:off x="5588813" y="2194560"/>
+            <a:ext cx="1375258" cy="0"/>
+          </a:xfrm>
+          <a:prstGeom prst="line">
+            <a:avLst/>
+          </a:prstGeom>
+          <a:noFill/>
+          <a:ln w="12700">
+            <a:solidFill>
+              <a:srgbClr val="E2E8F0"/>
+            </a:solidFill>
+            <a:prstDash val="solid"/>
+          </a:ln>
+        </p:spPr>
+      </p:sp>
+      <p:sp>
+        <p:nvSpPr>
+          <p:cNvPr id="33" name="Text 31"/>
+          <p:cNvSpPr/>
+          <p:nvPr/>
+        </p:nvSpPr>
+        <p:spPr>
+          <a:xfrm>
+            <a:off x="5524805" y="2267712"/>
+            <a:ext cx="1503274" cy="274320"/>
+          </a:xfrm>
+          <a:prstGeom prst="rect">
+            <a:avLst/>
+          </a:prstGeom>
+          <a:noFill/>
+          <a:ln/>
+        </p:spPr>
+        <p:txBody>
+          <a:bodyPr wrap="square" lIns="0" tIns="0" rIns="0" bIns="0" rtlCol="0" anchor="ctr"/>
+          <a:lstStyle/>
+          <a:p>
+            <a:pPr algn="ctr" indent="0" marL="0">
+              <a:lnSpc>
+                <a:spcPct val="120000"/>
+              </a:lnSpc>
+              <a:buNone/>
+            </a:pPr>
+            <a:r>
+              <a:rPr lang="en-US" sz="800" dirty="0">
                 <a:solidFill>
                   <a:srgbClr val="475569"/>
                 </a:solidFill>
@@ -17381,9 +17361,29 @@
                 <a:ea typeface="Noto Sans KR" pitchFamily="34" charset="-122"/>
                 <a:cs typeface="Noto Sans KR" pitchFamily="34" charset="-120"/>
               </a:rPr>
+              <a:t>통계·트렌드</a:t>
+            </a:r>
+            <a:endParaRPr lang="en-US" sz="800" dirty="0"/>
+          </a:p>
+          <a:p>
+            <a:pPr algn="ctr" indent="0" marL="0">
+              <a:lnSpc>
+                <a:spcPct val="120000"/>
+              </a:lnSpc>
+              <a:buNone/>
+            </a:pPr>
+            <a:r>
+              <a:rPr lang="en-US" sz="800" dirty="0">
+                <a:solidFill>
+                  <a:srgbClr val="475569"/>
+                </a:solidFill>
+                <a:latin typeface="Noto Sans KR" pitchFamily="34" charset="0"/>
+                <a:ea typeface="Noto Sans KR" pitchFamily="34" charset="-122"/>
+                <a:cs typeface="Noto Sans KR" pitchFamily="34" charset="-120"/>
+              </a:rPr>
               <a:t>리포트 자동 생성</a:t>
             </a:r>
-            <a:endParaRPr lang="en-US" sz="700" dirty="0"/>
+            <a:endParaRPr lang="en-US" sz="800" dirty="0"/>
           </a:p>
         </p:txBody>
       </p:sp>
@@ -17396,11 +17396,11 @@
         <p:spPr>
           <a:xfrm>
             <a:off x="7183526" y="1042416"/>
-            <a:ext cx="1594714" cy="1078992"/>
+            <a:ext cx="1594714" cy="1554480"/>
           </a:xfrm>
           <a:prstGeom prst="roundRect">
             <a:avLst>
-              <a:gd name="adj" fmla="val 5932"/>
+              <a:gd name="adj" fmla="val 4118"/>
             </a:avLst>
           </a:prstGeom>
           <a:solidFill>
@@ -17430,7 +17430,7 @@
         <p:spPr>
           <a:xfrm>
             <a:off x="7183526" y="1042416"/>
-            <a:ext cx="1594714" cy="109728"/>
+            <a:ext cx="1594714" cy="128016"/>
           </a:xfrm>
           <a:prstGeom prst="rect">
             <a:avLst/>
@@ -17454,8 +17454,8 @@
         </p:nvSpPr>
         <p:spPr>
           <a:xfrm>
-            <a:off x="7779715" y="1188720"/>
-            <a:ext cx="402336" cy="402336"/>
+            <a:off x="7724851" y="1261872"/>
+            <a:ext cx="512064" cy="512064"/>
           </a:xfrm>
           <a:prstGeom prst="ellipse">
             <a:avLst/>
@@ -17479,8 +17479,8 @@
         </p:nvSpPr>
         <p:spPr>
           <a:xfrm>
-            <a:off x="7779715" y="1188720"/>
-            <a:ext cx="402336" cy="402336"/>
+            <a:off x="7724851" y="1261872"/>
+            <a:ext cx="512064" cy="512064"/>
           </a:xfrm>
           <a:prstGeom prst="rect">
             <a:avLst/>
@@ -17496,7 +17496,7 @@
               <a:buNone/>
             </a:pPr>
             <a:r>
-              <a:rPr lang="en-US" sz="1400" dirty="0">
+              <a:rPr lang="en-US" sz="1800" dirty="0">
                 <a:solidFill>
                   <a:srgbClr val="000000"/>
                 </a:solidFill>
@@ -17506,7 +17506,7 @@
               </a:rPr>
               <a:t>👤</a:t>
             </a:r>
-            <a:endParaRPr lang="en-US" sz="1400" dirty="0"/>
+            <a:endParaRPr lang="en-US" sz="1800" dirty="0"/>
           </a:p>
         </p:txBody>
       </p:sp>
@@ -17518,93 +17518,8 @@
         </p:nvSpPr>
         <p:spPr>
           <a:xfrm>
-            <a:off x="7229246" y="1682496"/>
-            <a:ext cx="1503274" cy="256032"/>
-          </a:xfrm>
-          <a:prstGeom prst="rect">
-            <a:avLst/>
-          </a:prstGeom>
-          <a:noFill/>
-          <a:ln/>
-        </p:spPr>
-        <p:txBody>
-          <a:bodyPr wrap="square" lIns="0" tIns="0" rIns="0" bIns="0" rtlCol="0" anchor="ctr"/>
-          <a:lstStyle/>
-          <a:p>
-            <a:pPr algn="ctr" indent="0" marL="0">
-              <a:lnSpc>
-                <a:spcPct val="110000"/>
-              </a:lnSpc>
-              <a:buNone/>
-            </a:pPr>
-            <a:r>
-              <a:rPr lang="en-US" sz="800" b="1" dirty="0">
-                <a:solidFill>
-                  <a:srgbClr val="1B2F5E"/>
-                </a:solidFill>
-                <a:latin typeface="Noto Sans KR" pitchFamily="34" charset="0"/>
-                <a:ea typeface="Noto Sans KR" pitchFamily="34" charset="-122"/>
-                <a:cs typeface="Noto Sans KR" pitchFamily="34" charset="-120"/>
-              </a:rPr>
-              <a:t>별도 인력</a:t>
-            </a:r>
-            <a:endParaRPr lang="en-US" sz="800" dirty="0"/>
-          </a:p>
-          <a:p>
-            <a:pPr algn="ctr" indent="0" marL="0">
-              <a:lnSpc>
-                <a:spcPct val="110000"/>
-              </a:lnSpc>
-              <a:buNone/>
-            </a:pPr>
-            <a:r>
-              <a:rPr lang="en-US" sz="800" b="1" dirty="0">
-                <a:solidFill>
-                  <a:srgbClr val="1B2F5E"/>
-                </a:solidFill>
-                <a:latin typeface="Noto Sans KR" pitchFamily="34" charset="0"/>
-                <a:ea typeface="Noto Sans KR" pitchFamily="34" charset="-122"/>
-                <a:cs typeface="Noto Sans KR" pitchFamily="34" charset="-120"/>
-              </a:rPr>
-              <a:t>불필요</a:t>
-            </a:r>
-            <a:endParaRPr lang="en-US" sz="800" dirty="0"/>
-          </a:p>
-        </p:txBody>
-      </p:sp>
-      <p:sp>
-        <p:nvSpPr>
-          <p:cNvPr id="39" name="Shape 37"/>
-          <p:cNvSpPr/>
-          <p:nvPr/>
-        </p:nvSpPr>
-        <p:spPr>
-          <a:xfrm>
-            <a:off x="7293254" y="1956816"/>
-            <a:ext cx="1375258" cy="0"/>
-          </a:xfrm>
-          <a:prstGeom prst="line">
-            <a:avLst/>
-          </a:prstGeom>
-          <a:noFill/>
-          <a:ln w="12700">
-            <a:solidFill>
-              <a:srgbClr val="E2E8F0"/>
-            </a:solidFill>
-            <a:prstDash val="solid"/>
-          </a:ln>
-        </p:spPr>
-      </p:sp>
-      <p:sp>
-        <p:nvSpPr>
-          <p:cNvPr id="40" name="Text 38"/>
-          <p:cNvSpPr/>
-          <p:nvPr/>
-        </p:nvSpPr>
-        <p:spPr>
-          <a:xfrm>
-            <a:off x="7229246" y="2002536"/>
-            <a:ext cx="1503274" cy="237744"/>
+            <a:off x="7229246" y="1828800"/>
+            <a:ext cx="1503274" cy="329184"/>
           </a:xfrm>
           <a:prstGeom prst="rect">
             <a:avLst/>
@@ -17623,17 +17538,17 @@
               <a:buNone/>
             </a:pPr>
             <a:r>
-              <a:rPr lang="en-US" sz="700" dirty="0">
-                <a:solidFill>
-                  <a:srgbClr val="475569"/>
-                </a:solidFill>
-                <a:latin typeface="Noto Sans KR" pitchFamily="34" charset="0"/>
-                <a:ea typeface="Noto Sans KR" pitchFamily="34" charset="-122"/>
-                <a:cs typeface="Noto Sans KR" pitchFamily="34" charset="-120"/>
-              </a:rPr>
-              <a:t>전 과정 자동</a:t>
-            </a:r>
-            <a:endParaRPr lang="en-US" sz="700" dirty="0"/>
+              <a:rPr lang="en-US" sz="900" b="1" dirty="0">
+                <a:solidFill>
+                  <a:srgbClr val="1B2F5E"/>
+                </a:solidFill>
+                <a:latin typeface="Noto Sans KR" pitchFamily="34" charset="0"/>
+                <a:ea typeface="Noto Sans KR" pitchFamily="34" charset="-122"/>
+                <a:cs typeface="Noto Sans KR" pitchFamily="34" charset="-120"/>
+              </a:rPr>
+              <a:t>별도 인력</a:t>
+            </a:r>
+            <a:endParaRPr lang="en-US" sz="900" dirty="0"/>
           </a:p>
           <a:p>
             <a:pPr algn="ctr" indent="0" marL="0">
@@ -17643,7 +17558,72 @@
               <a:buNone/>
             </a:pPr>
             <a:r>
-              <a:rPr lang="en-US" sz="700" dirty="0">
+              <a:rPr lang="en-US" sz="900" b="1" dirty="0">
+                <a:solidFill>
+                  <a:srgbClr val="1B2F5E"/>
+                </a:solidFill>
+                <a:latin typeface="Noto Sans KR" pitchFamily="34" charset="0"/>
+                <a:ea typeface="Noto Sans KR" pitchFamily="34" charset="-122"/>
+                <a:cs typeface="Noto Sans KR" pitchFamily="34" charset="-120"/>
+              </a:rPr>
+              <a:t>불필요</a:t>
+            </a:r>
+            <a:endParaRPr lang="en-US" sz="900" dirty="0"/>
+          </a:p>
+        </p:txBody>
+      </p:sp>
+      <p:sp>
+        <p:nvSpPr>
+          <p:cNvPr id="39" name="Shape 37"/>
+          <p:cNvSpPr/>
+          <p:nvPr/>
+        </p:nvSpPr>
+        <p:spPr>
+          <a:xfrm>
+            <a:off x="7293254" y="2194560"/>
+            <a:ext cx="1375258" cy="0"/>
+          </a:xfrm>
+          <a:prstGeom prst="line">
+            <a:avLst/>
+          </a:prstGeom>
+          <a:noFill/>
+          <a:ln w="12700">
+            <a:solidFill>
+              <a:srgbClr val="E2E8F0"/>
+            </a:solidFill>
+            <a:prstDash val="solid"/>
+          </a:ln>
+        </p:spPr>
+      </p:sp>
+      <p:sp>
+        <p:nvSpPr>
+          <p:cNvPr id="40" name="Text 38"/>
+          <p:cNvSpPr/>
+          <p:nvPr/>
+        </p:nvSpPr>
+        <p:spPr>
+          <a:xfrm>
+            <a:off x="7229246" y="2267712"/>
+            <a:ext cx="1503274" cy="274320"/>
+          </a:xfrm>
+          <a:prstGeom prst="rect">
+            <a:avLst/>
+          </a:prstGeom>
+          <a:noFill/>
+          <a:ln/>
+        </p:spPr>
+        <p:txBody>
+          <a:bodyPr wrap="square" lIns="0" tIns="0" rIns="0" bIns="0" rtlCol="0" anchor="ctr"/>
+          <a:lstStyle/>
+          <a:p>
+            <a:pPr algn="ctr" indent="0" marL="0">
+              <a:lnSpc>
+                <a:spcPct val="120000"/>
+              </a:lnSpc>
+              <a:buNone/>
+            </a:pPr>
+            <a:r>
+              <a:rPr lang="en-US" sz="800" dirty="0">
                 <a:solidFill>
                   <a:srgbClr val="475569"/>
                 </a:solidFill>
@@ -17651,9 +17631,29 @@
                 <a:ea typeface="Noto Sans KR" pitchFamily="34" charset="-122"/>
                 <a:cs typeface="Noto Sans KR" pitchFamily="34" charset="-120"/>
               </a:rPr>
+              <a:t>전 과정 자동</a:t>
+            </a:r>
+            <a:endParaRPr lang="en-US" sz="800" dirty="0"/>
+          </a:p>
+          <a:p>
+            <a:pPr algn="ctr" indent="0" marL="0">
+              <a:lnSpc>
+                <a:spcPct val="120000"/>
+              </a:lnSpc>
+              <a:buNone/>
+            </a:pPr>
+            <a:r>
+              <a:rPr lang="en-US" sz="800" dirty="0">
+                <a:solidFill>
+                  <a:srgbClr val="475569"/>
+                </a:solidFill>
+                <a:latin typeface="Noto Sans KR" pitchFamily="34" charset="0"/>
+                <a:ea typeface="Noto Sans KR" pitchFamily="34" charset="-122"/>
+                <a:cs typeface="Noto Sans KR" pitchFamily="34" charset="-120"/>
+              </a:rPr>
               <a:t>인력 재배치 가능</a:t>
             </a:r>
-            <a:endParaRPr lang="en-US" sz="700" dirty="0"/>
+            <a:endParaRPr lang="en-US" sz="800" dirty="0"/>
           </a:p>
         </p:txBody>
       </p:sp>
@@ -17665,12 +17665,12 @@
         </p:nvSpPr>
         <p:spPr>
           <a:xfrm>
-            <a:off x="365760" y="2212848"/>
-            <a:ext cx="2743200" cy="2884932"/>
+            <a:off x="365760" y="2743200"/>
+            <a:ext cx="2743200" cy="2327148"/>
           </a:xfrm>
           <a:prstGeom prst="roundRect">
             <a:avLst>
-              <a:gd name="adj" fmla="val 2333"/>
+              <a:gd name="adj" fmla="val 2750"/>
             </a:avLst>
           </a:prstGeom>
           <a:solidFill>
@@ -17699,12 +17699,12 @@
         </p:nvSpPr>
         <p:spPr>
           <a:xfrm>
-            <a:off x="365760" y="2212848"/>
-            <a:ext cx="2743200" cy="329184"/>
+            <a:off x="365760" y="2743200"/>
+            <a:ext cx="2743200" cy="292608"/>
           </a:xfrm>
           <a:prstGeom prst="roundRect">
             <a:avLst>
-              <a:gd name="adj" fmla="val 19444"/>
+              <a:gd name="adj" fmla="val 21875"/>
             </a:avLst>
           </a:prstGeom>
           <a:solidFill>
@@ -17726,8 +17726,8 @@
         </p:nvSpPr>
         <p:spPr>
           <a:xfrm>
-            <a:off x="365760" y="2212848"/>
-            <a:ext cx="2743200" cy="329184"/>
+            <a:off x="365760" y="2743200"/>
+            <a:ext cx="2743200" cy="292608"/>
           </a:xfrm>
           <a:prstGeom prst="rect">
             <a:avLst/>
@@ -17743,7 +17743,7 @@
               <a:buNone/>
             </a:pPr>
             <a:r>
-              <a:rPr lang="en-US" sz="1200" b="1" dirty="0">
+              <a:rPr lang="en-US" sz="1100" b="1" dirty="0">
                 <a:solidFill>
                   <a:srgbClr val="FFFFFF"/>
                 </a:solidFill>
@@ -17753,7 +17753,7 @@
               </a:rPr>
               <a:t>품질</a:t>
             </a:r>
-            <a:endParaRPr lang="en-US" sz="1200" dirty="0"/>
+            <a:endParaRPr lang="en-US" sz="1100" dirty="0"/>
           </a:p>
         </p:txBody>
       </p:sp>
@@ -17765,12 +17765,12 @@
         </p:nvSpPr>
         <p:spPr>
           <a:xfrm>
-            <a:off x="457200" y="2587752"/>
-            <a:ext cx="2560320" cy="809244"/>
+            <a:off x="457200" y="3072384"/>
+            <a:ext cx="2560320" cy="638556"/>
           </a:xfrm>
           <a:prstGeom prst="roundRect">
             <a:avLst>
-              <a:gd name="adj" fmla="val 7910"/>
+              <a:gd name="adj" fmla="val 10024"/>
             </a:avLst>
           </a:prstGeom>
           <a:solidFill>
@@ -17799,8 +17799,8 @@
         </p:nvSpPr>
         <p:spPr>
           <a:xfrm>
-            <a:off x="530352" y="2624328"/>
-            <a:ext cx="2414016" cy="736092"/>
+            <a:off x="530352" y="3090672"/>
+            <a:ext cx="2414016" cy="601980"/>
           </a:xfrm>
           <a:prstGeom prst="rect">
             <a:avLst/>
@@ -17814,12 +17814,12 @@
           <a:p>
             <a:pPr indent="0" marL="0">
               <a:lnSpc>
-                <a:spcPct val="115000"/>
+                <a:spcPct val="110000"/>
               </a:lnSpc>
               <a:buNone/>
             </a:pPr>
             <a:r>
-              <a:rPr lang="en-US" sz="950" dirty="0">
+              <a:rPr lang="en-US" sz="850" dirty="0">
                 <a:solidFill>
                   <a:srgbClr val="1E293B"/>
                 </a:solidFill>
@@ -17827,29 +17827,9 @@
                 <a:ea typeface="Noto Sans KR" pitchFamily="34" charset="-122"/>
                 <a:cs typeface="Noto Sans KR" pitchFamily="34" charset="-120"/>
               </a:rPr>
-              <a:t>불량 검출율 지속 향상</a:t>
-            </a:r>
-            <a:endParaRPr lang="en-US" sz="950" dirty="0"/>
-          </a:p>
-          <a:p>
-            <a:pPr indent="0" marL="0">
-              <a:lnSpc>
-                <a:spcPct val="115000"/>
-              </a:lnSpc>
-              <a:buNone/>
-            </a:pPr>
-            <a:r>
-              <a:rPr lang="en-US" sz="950" dirty="0">
-                <a:solidFill>
-                  <a:srgbClr val="1E293B"/>
-                </a:solidFill>
-                <a:latin typeface="Noto Sans KR" pitchFamily="34" charset="0"/>
-                <a:ea typeface="Noto Sans KR" pitchFamily="34" charset="-122"/>
-                <a:cs typeface="Noto Sans KR" pitchFamily="34" charset="-120"/>
-              </a:rPr>
-              <a:t>(딥러닝 누적 학습)</a:t>
-            </a:r>
-            <a:endParaRPr lang="en-US" sz="950" dirty="0"/>
+              <a:t>불량 검출율 지속 향상 (딥러닝 누적 학습)</a:t>
+            </a:r>
+            <a:endParaRPr lang="en-US" sz="850" dirty="0"/>
           </a:p>
         </p:txBody>
       </p:sp>
@@ -17861,12 +17841,12 @@
         </p:nvSpPr>
         <p:spPr>
           <a:xfrm>
-            <a:off x="457200" y="3433572"/>
-            <a:ext cx="2560320" cy="809244"/>
+            <a:off x="457200" y="3747516"/>
+            <a:ext cx="2560320" cy="638556"/>
           </a:xfrm>
           <a:prstGeom prst="roundRect">
             <a:avLst>
-              <a:gd name="adj" fmla="val 7910"/>
+              <a:gd name="adj" fmla="val 10024"/>
             </a:avLst>
           </a:prstGeom>
           <a:solidFill>
@@ -17895,8 +17875,8 @@
         </p:nvSpPr>
         <p:spPr>
           <a:xfrm>
-            <a:off x="530352" y="3470148"/>
-            <a:ext cx="2414016" cy="736092"/>
+            <a:off x="530352" y="3765804"/>
+            <a:ext cx="2414016" cy="601980"/>
           </a:xfrm>
           <a:prstGeom prst="rect">
             <a:avLst/>
@@ -17910,12 +17890,12 @@
           <a:p>
             <a:pPr indent="0" marL="0">
               <a:lnSpc>
-                <a:spcPct val="115000"/>
+                <a:spcPct val="110000"/>
               </a:lnSpc>
               <a:buNone/>
             </a:pPr>
             <a:r>
-              <a:rPr lang="en-US" sz="950" dirty="0">
+              <a:rPr lang="en-US" sz="850" dirty="0">
                 <a:solidFill>
                   <a:srgbClr val="1E293B"/>
                 </a:solidFill>
@@ -17925,7 +17905,7 @@
               </a:rPr>
               <a:t>불량 유형별 자동 분류·통계 제공</a:t>
             </a:r>
-            <a:endParaRPr lang="en-US" sz="950" dirty="0"/>
+            <a:endParaRPr lang="en-US" sz="850" dirty="0"/>
           </a:p>
         </p:txBody>
       </p:sp>
@@ -17937,12 +17917,12 @@
         </p:nvSpPr>
         <p:spPr>
           <a:xfrm>
-            <a:off x="457200" y="4279392"/>
-            <a:ext cx="2560320" cy="809244"/>
+            <a:off x="457200" y="4422648"/>
+            <a:ext cx="2560320" cy="638556"/>
           </a:xfrm>
           <a:prstGeom prst="roundRect">
             <a:avLst>
-              <a:gd name="adj" fmla="val 7910"/>
+              <a:gd name="adj" fmla="val 10024"/>
             </a:avLst>
           </a:prstGeom>
           <a:solidFill>
@@ -17971,8 +17951,8 @@
         </p:nvSpPr>
         <p:spPr>
           <a:xfrm>
-            <a:off x="530352" y="4315968"/>
-            <a:ext cx="2414016" cy="736092"/>
+            <a:off x="530352" y="4440936"/>
+            <a:ext cx="2414016" cy="601980"/>
           </a:xfrm>
           <a:prstGeom prst="rect">
             <a:avLst/>
@@ -17986,12 +17966,12 @@
           <a:p>
             <a:pPr indent="0" marL="0">
               <a:lnSpc>
-                <a:spcPct val="115000"/>
+                <a:spcPct val="110000"/>
               </a:lnSpc>
               <a:buNone/>
             </a:pPr>
             <a:r>
-              <a:rPr lang="en-US" sz="950" dirty="0">
+              <a:rPr lang="en-US" sz="850" dirty="0">
                 <a:solidFill>
                   <a:srgbClr val="1E293B"/>
                 </a:solidFill>
@@ -18001,7 +17981,7 @@
               </a:rPr>
               <a:t>후공정 불량 혼입 원천 차단</a:t>
             </a:r>
-            <a:endParaRPr lang="en-US" sz="950" dirty="0"/>
+            <a:endParaRPr lang="en-US" sz="850" dirty="0"/>
           </a:p>
         </p:txBody>
       </p:sp>
@@ -18013,12 +17993,12 @@
         </p:nvSpPr>
         <p:spPr>
           <a:xfrm>
-            <a:off x="3200400" y="2212848"/>
-            <a:ext cx="2743200" cy="2884932"/>
+            <a:off x="3200400" y="2743200"/>
+            <a:ext cx="2743200" cy="2327148"/>
           </a:xfrm>
           <a:prstGeom prst="roundRect">
             <a:avLst>
-              <a:gd name="adj" fmla="val 2333"/>
+              <a:gd name="adj" fmla="val 2750"/>
             </a:avLst>
           </a:prstGeom>
           <a:solidFill>
@@ -18047,12 +18027,12 @@
         </p:nvSpPr>
         <p:spPr>
           <a:xfrm>
-            <a:off x="3200400" y="2212848"/>
-            <a:ext cx="2743200" cy="329184"/>
+            <a:off x="3200400" y="2743200"/>
+            <a:ext cx="2743200" cy="292608"/>
           </a:xfrm>
           <a:prstGeom prst="roundRect">
             <a:avLst>
-              <a:gd name="adj" fmla="val 19444"/>
+              <a:gd name="adj" fmla="val 21875"/>
             </a:avLst>
           </a:prstGeom>
           <a:solidFill>
@@ -18074,8 +18054,8 @@
         </p:nvSpPr>
         <p:spPr>
           <a:xfrm>
-            <a:off x="3200400" y="2212848"/>
-            <a:ext cx="2743200" cy="329184"/>
+            <a:off x="3200400" y="2743200"/>
+            <a:ext cx="2743200" cy="292608"/>
           </a:xfrm>
           <a:prstGeom prst="rect">
             <a:avLst/>
@@ -18091,7 +18071,7 @@
               <a:buNone/>
             </a:pPr>
             <a:r>
-              <a:rPr lang="en-US" sz="1200" b="1" dirty="0">
+              <a:rPr lang="en-US" sz="1100" b="1" dirty="0">
                 <a:solidFill>
                   <a:srgbClr val="FFFFFF"/>
                 </a:solidFill>
@@ -18101,7 +18081,7 @@
               </a:rPr>
               <a:t>운영</a:t>
             </a:r>
-            <a:endParaRPr lang="en-US" sz="1200" dirty="0"/>
+            <a:endParaRPr lang="en-US" sz="1100" dirty="0"/>
           </a:p>
         </p:txBody>
       </p:sp>
@@ -18113,12 +18093,12 @@
         </p:nvSpPr>
         <p:spPr>
           <a:xfrm>
-            <a:off x="3291840" y="2587752"/>
-            <a:ext cx="2560320" cy="809244"/>
+            <a:off x="3291840" y="3072384"/>
+            <a:ext cx="2560320" cy="638556"/>
           </a:xfrm>
           <a:prstGeom prst="roundRect">
             <a:avLst>
-              <a:gd name="adj" fmla="val 7910"/>
+              <a:gd name="adj" fmla="val 10024"/>
             </a:avLst>
           </a:prstGeom>
           <a:solidFill>
@@ -18147,8 +18127,8 @@
         </p:nvSpPr>
         <p:spPr>
           <a:xfrm>
-            <a:off x="3364992" y="2624328"/>
-            <a:ext cx="2414016" cy="736092"/>
+            <a:off x="3364992" y="3090672"/>
+            <a:ext cx="2414016" cy="601980"/>
           </a:xfrm>
           <a:prstGeom prst="rect">
             <a:avLst/>
@@ -18162,12 +18142,12 @@
           <a:p>
             <a:pPr indent="0" marL="0">
               <a:lnSpc>
-                <a:spcPct val="115000"/>
+                <a:spcPct val="110000"/>
               </a:lnSpc>
               <a:buNone/>
             </a:pPr>
             <a:r>
-              <a:rPr lang="en-US" sz="950" dirty="0">
+              <a:rPr lang="en-US" sz="850" dirty="0">
                 <a:solidFill>
                   <a:srgbClr val="1E293B"/>
                 </a:solidFill>
@@ -18177,7 +18157,7 @@
               </a:rPr>
               <a:t>검사 공정 무인 자동 운영</a:t>
             </a:r>
-            <a:endParaRPr lang="en-US" sz="950" dirty="0"/>
+            <a:endParaRPr lang="en-US" sz="850" dirty="0"/>
           </a:p>
         </p:txBody>
       </p:sp>
@@ -18189,12 +18169,12 @@
         </p:nvSpPr>
         <p:spPr>
           <a:xfrm>
-            <a:off x="3291840" y="3433572"/>
-            <a:ext cx="2560320" cy="809244"/>
+            <a:off x="3291840" y="3747516"/>
+            <a:ext cx="2560320" cy="638556"/>
           </a:xfrm>
           <a:prstGeom prst="roundRect">
             <a:avLst>
-              <a:gd name="adj" fmla="val 7910"/>
+              <a:gd name="adj" fmla="val 10024"/>
             </a:avLst>
           </a:prstGeom>
           <a:solidFill>
@@ -18223,8 +18203,8 @@
         </p:nvSpPr>
         <p:spPr>
           <a:xfrm>
-            <a:off x="3364992" y="3470148"/>
-            <a:ext cx="2414016" cy="736092"/>
+            <a:off x="3364992" y="3765804"/>
+            <a:ext cx="2414016" cy="601980"/>
           </a:xfrm>
           <a:prstGeom prst="rect">
             <a:avLst/>
@@ -18238,12 +18218,12 @@
           <a:p>
             <a:pPr indent="0" marL="0">
               <a:lnSpc>
-                <a:spcPct val="115000"/>
+                <a:spcPct val="110000"/>
               </a:lnSpc>
               <a:buNone/>
             </a:pPr>
             <a:r>
-              <a:rPr lang="en-US" sz="950" dirty="0">
+              <a:rPr lang="en-US" sz="850" dirty="0">
                 <a:solidFill>
                   <a:srgbClr val="1E293B"/>
                 </a:solidFill>
@@ -18253,7 +18233,7 @@
               </a:rPr>
               <a:t>검사 인력 생산 공정 재배치</a:t>
             </a:r>
-            <a:endParaRPr lang="en-US" sz="950" dirty="0"/>
+            <a:endParaRPr lang="en-US" sz="850" dirty="0"/>
           </a:p>
         </p:txBody>
       </p:sp>
@@ -18265,12 +18245,12 @@
         </p:nvSpPr>
         <p:spPr>
           <a:xfrm>
-            <a:off x="3291840" y="4279392"/>
-            <a:ext cx="2560320" cy="809244"/>
+            <a:off x="3291840" y="4422648"/>
+            <a:ext cx="2560320" cy="638556"/>
           </a:xfrm>
           <a:prstGeom prst="roundRect">
             <a:avLst>
-              <a:gd name="adj" fmla="val 7910"/>
+              <a:gd name="adj" fmla="val 10024"/>
             </a:avLst>
           </a:prstGeom>
           <a:solidFill>
@@ -18299,8 +18279,8 @@
         </p:nvSpPr>
         <p:spPr>
           <a:xfrm>
-            <a:off x="3364992" y="4315968"/>
-            <a:ext cx="2414016" cy="736092"/>
+            <a:off x="3364992" y="4440936"/>
+            <a:ext cx="2414016" cy="601980"/>
           </a:xfrm>
           <a:prstGeom prst="rect">
             <a:avLst/>
@@ -18314,12 +18294,12 @@
           <a:p>
             <a:pPr indent="0" marL="0">
               <a:lnSpc>
-                <a:spcPct val="115000"/>
+                <a:spcPct val="110000"/>
               </a:lnSpc>
               <a:buNone/>
             </a:pPr>
             <a:r>
-              <a:rPr lang="en-US" sz="950" dirty="0">
+              <a:rPr lang="en-US" sz="850" dirty="0">
                 <a:solidFill>
                   <a:srgbClr val="1E293B"/>
                 </a:solidFill>
@@ -18329,7 +18309,7 @@
               </a:rPr>
               <a:t>품질 편차 완전 제거</a:t>
             </a:r>
-            <a:endParaRPr lang="en-US" sz="950" dirty="0"/>
+            <a:endParaRPr lang="en-US" sz="850" dirty="0"/>
           </a:p>
         </p:txBody>
       </p:sp>
@@ -18341,12 +18321,12 @@
         </p:nvSpPr>
         <p:spPr>
           <a:xfrm>
-            <a:off x="6035040" y="2212848"/>
-            <a:ext cx="2743200" cy="2884932"/>
+            <a:off x="6035040" y="2743200"/>
+            <a:ext cx="2743200" cy="2327148"/>
           </a:xfrm>
           <a:prstGeom prst="roundRect">
             <a:avLst>
-              <a:gd name="adj" fmla="val 2333"/>
+              <a:gd name="adj" fmla="val 2750"/>
             </a:avLst>
           </a:prstGeom>
           <a:solidFill>
@@ -18375,12 +18355,12 @@
         </p:nvSpPr>
         <p:spPr>
           <a:xfrm>
-            <a:off x="6035040" y="2212848"/>
-            <a:ext cx="2743200" cy="329184"/>
+            <a:off x="6035040" y="2743200"/>
+            <a:ext cx="2743200" cy="292608"/>
           </a:xfrm>
           <a:prstGeom prst="roundRect">
             <a:avLst>
-              <a:gd name="adj" fmla="val 19444"/>
+              <a:gd name="adj" fmla="val 21875"/>
             </a:avLst>
           </a:prstGeom>
           <a:solidFill>
@@ -18402,8 +18382,8 @@
         </p:nvSpPr>
         <p:spPr>
           <a:xfrm>
-            <a:off x="6035040" y="2212848"/>
-            <a:ext cx="2743200" cy="329184"/>
+            <a:off x="6035040" y="2743200"/>
+            <a:ext cx="2743200" cy="292608"/>
           </a:xfrm>
           <a:prstGeom prst="rect">
             <a:avLst/>
@@ -18419,7 +18399,7 @@
               <a:buNone/>
             </a:pPr>
             <a:r>
-              <a:rPr lang="en-US" sz="1200" b="1" dirty="0">
+              <a:rPr lang="en-US" sz="1100" b="1" dirty="0">
                 <a:solidFill>
                   <a:srgbClr val="FFFFFF"/>
                 </a:solidFill>
@@ -18429,7 +18409,7 @@
               </a:rPr>
               <a:t>경쟁력</a:t>
             </a:r>
-            <a:endParaRPr lang="en-US" sz="1200" dirty="0"/>
+            <a:endParaRPr lang="en-US" sz="1100" dirty="0"/>
           </a:p>
         </p:txBody>
       </p:sp>
@@ -18441,12 +18421,12 @@
         </p:nvSpPr>
         <p:spPr>
           <a:xfrm>
-            <a:off x="6126480" y="2587752"/>
-            <a:ext cx="2560320" cy="809244"/>
+            <a:off x="6126480" y="3072384"/>
+            <a:ext cx="2560320" cy="638556"/>
           </a:xfrm>
           <a:prstGeom prst="roundRect">
             <a:avLst>
-              <a:gd name="adj" fmla="val 7910"/>
+              <a:gd name="adj" fmla="val 10024"/>
             </a:avLst>
           </a:prstGeom>
           <a:solidFill>
@@ -18475,8 +18455,8 @@
         </p:nvSpPr>
         <p:spPr>
           <a:xfrm>
-            <a:off x="6199632" y="2624328"/>
-            <a:ext cx="2414016" cy="736092"/>
+            <a:off x="6199632" y="3090672"/>
+            <a:ext cx="2414016" cy="601980"/>
           </a:xfrm>
           <a:prstGeom prst="rect">
             <a:avLst/>
@@ -18490,12 +18470,12 @@
           <a:p>
             <a:pPr indent="0" marL="0">
               <a:lnSpc>
-                <a:spcPct val="115000"/>
+                <a:spcPct val="110000"/>
               </a:lnSpc>
               <a:buNone/>
             </a:pPr>
             <a:r>
-              <a:rPr lang="en-US" sz="950" dirty="0">
+              <a:rPr lang="en-US" sz="850" dirty="0">
                 <a:solidFill>
                   <a:srgbClr val="1E293B"/>
                 </a:solidFill>
@@ -18505,7 +18485,7 @@
               </a:rPr>
               <a:t>납품처 신뢰도 향상</a:t>
             </a:r>
-            <a:endParaRPr lang="en-US" sz="950" dirty="0"/>
+            <a:endParaRPr lang="en-US" sz="850" dirty="0"/>
           </a:p>
         </p:txBody>
       </p:sp>
@@ -18517,12 +18497,12 @@
         </p:nvSpPr>
         <p:spPr>
           <a:xfrm>
-            <a:off x="6126480" y="3433572"/>
-            <a:ext cx="2560320" cy="809244"/>
+            <a:off x="6126480" y="3747516"/>
+            <a:ext cx="2560320" cy="638556"/>
           </a:xfrm>
           <a:prstGeom prst="roundRect">
             <a:avLst>
-              <a:gd name="adj" fmla="val 7910"/>
+              <a:gd name="adj" fmla="val 10024"/>
             </a:avLst>
           </a:prstGeom>
           <a:solidFill>
@@ -18551,8 +18531,8 @@
         </p:nvSpPr>
         <p:spPr>
           <a:xfrm>
-            <a:off x="6199632" y="3470148"/>
-            <a:ext cx="2414016" cy="736092"/>
+            <a:off x="6199632" y="3765804"/>
+            <a:ext cx="2414016" cy="601980"/>
           </a:xfrm>
           <a:prstGeom prst="rect">
             <a:avLst/>
@@ -18566,12 +18546,12 @@
           <a:p>
             <a:pPr indent="0" marL="0">
               <a:lnSpc>
-                <a:spcPct val="115000"/>
+                <a:spcPct val="110000"/>
               </a:lnSpc>
               <a:buNone/>
             </a:pPr>
             <a:r>
-              <a:rPr lang="en-US" sz="950" dirty="0">
+              <a:rPr lang="en-US" sz="850" dirty="0">
                 <a:solidFill>
                   <a:srgbClr val="1E293B"/>
                 </a:solidFill>
@@ -18579,29 +18559,9 @@
                 <a:ea typeface="Noto Sans KR" pitchFamily="34" charset="-122"/>
                 <a:cs typeface="Noto Sans KR" pitchFamily="34" charset="-120"/>
               </a:rPr>
-              <a:t>클레임 대응 근거</a:t>
-            </a:r>
-            <a:endParaRPr lang="en-US" sz="950" dirty="0"/>
-          </a:p>
-          <a:p>
-            <a:pPr indent="0" marL="0">
-              <a:lnSpc>
-                <a:spcPct val="115000"/>
-              </a:lnSpc>
-              <a:buNone/>
-            </a:pPr>
-            <a:r>
-              <a:rPr lang="en-US" sz="950" dirty="0">
-                <a:solidFill>
-                  <a:srgbClr val="1E293B"/>
-                </a:solidFill>
-                <a:latin typeface="Noto Sans KR" pitchFamily="34" charset="0"/>
-                <a:ea typeface="Noto Sans KR" pitchFamily="34" charset="-122"/>
-                <a:cs typeface="Noto Sans KR" pitchFamily="34" charset="-120"/>
-              </a:rPr>
-              <a:t>데이터 확보</a:t>
-            </a:r>
-            <a:endParaRPr lang="en-US" sz="950" dirty="0"/>
+              <a:t>클레임 대응 근거 데이터 확보</a:t>
+            </a:r>
+            <a:endParaRPr lang="en-US" sz="850" dirty="0"/>
           </a:p>
         </p:txBody>
       </p:sp>
@@ -18613,12 +18573,12 @@
         </p:nvSpPr>
         <p:spPr>
           <a:xfrm>
-            <a:off x="6126480" y="4279392"/>
-            <a:ext cx="2560320" cy="809244"/>
+            <a:off x="6126480" y="4422648"/>
+            <a:ext cx="2560320" cy="638556"/>
           </a:xfrm>
           <a:prstGeom prst="roundRect">
             <a:avLst>
-              <a:gd name="adj" fmla="val 7910"/>
+              <a:gd name="adj" fmla="val 10024"/>
             </a:avLst>
           </a:prstGeom>
           <a:solidFill>
@@ -18647,8 +18607,8 @@
         </p:nvSpPr>
         <p:spPr>
           <a:xfrm>
-            <a:off x="6199632" y="4315968"/>
-            <a:ext cx="2414016" cy="736092"/>
+            <a:off x="6199632" y="4440936"/>
+            <a:ext cx="2414016" cy="601980"/>
           </a:xfrm>
           <a:prstGeom prst="rect">
             <a:avLst/>
@@ -18662,12 +18622,12 @@
           <a:p>
             <a:pPr indent="0" marL="0">
               <a:lnSpc>
-                <a:spcPct val="115000"/>
+                <a:spcPct val="110000"/>
               </a:lnSpc>
               <a:buNone/>
             </a:pPr>
             <a:r>
-              <a:rPr lang="en-US" sz="950" dirty="0">
+              <a:rPr lang="en-US" sz="850" dirty="0">
                 <a:solidFill>
                   <a:srgbClr val="1E293B"/>
                 </a:solidFill>
@@ -18677,7 +18637,7 @@
               </a:rPr>
               <a:t>수주 경쟁력 강화</a:t>
             </a:r>
-            <a:endParaRPr lang="en-US" sz="950" dirty="0"/>
+            <a:endParaRPr lang="en-US" sz="850" dirty="0"/>
           </a:p>
         </p:txBody>
       </p:sp>

</xml_diff>

<commit_message>
Update winnercomb.pptx - add cover image
</commit_message>
<xml_diff>
--- a/winnercomb.pptx
+++ b/winnercomb.pptx
@@ -1930,8 +1930,8 @@
         </p:nvSpPr>
         <p:spPr>
           <a:xfrm>
-            <a:off x="530352" y="1307592"/>
-            <a:ext cx="6858000" cy="1572768"/>
+            <a:off x="530352" y="1133856"/>
+            <a:ext cx="4754880" cy="1920240"/>
           </a:xfrm>
           <a:prstGeom prst="rect">
             <a:avLst/>
@@ -1945,12 +1945,12 @@
           <a:p>
             <a:pPr indent="0" marL="0">
               <a:lnSpc>
-                <a:spcPct val="125000"/>
+                <a:spcPct val="120000"/>
               </a:lnSpc>
               <a:buNone/>
             </a:pPr>
             <a:r>
-              <a:rPr lang="en-US" sz="3000" b="1" dirty="0">
+              <a:rPr lang="en-US" sz="2800" b="1" dirty="0">
                 <a:solidFill>
                   <a:srgbClr val="FFFFFF"/>
                 </a:solidFill>
@@ -1958,19 +1958,19 @@
                 <a:ea typeface="Noto Sans KR" pitchFamily="34" charset="-122"/>
                 <a:cs typeface="Noto Sans KR" pitchFamily="34" charset="-120"/>
               </a:rPr>
-              <a:t>인라인 딥러닝 비전검사 시스템</a:t>
-            </a:r>
-            <a:endParaRPr lang="en-US" sz="3000" dirty="0"/>
+              <a:t>인라인 딥러닝</a:t>
+            </a:r>
+            <a:endParaRPr lang="en-US" sz="2800" dirty="0"/>
           </a:p>
           <a:p>
             <a:pPr indent="0" marL="0">
               <a:lnSpc>
-                <a:spcPct val="125000"/>
+                <a:spcPct val="120000"/>
               </a:lnSpc>
               <a:buNone/>
             </a:pPr>
             <a:r>
-              <a:rPr lang="en-US" sz="3000" b="1" dirty="0">
+              <a:rPr lang="en-US" sz="2800" b="1" dirty="0">
                 <a:solidFill>
                   <a:srgbClr val="FFFFFF"/>
                 </a:solidFill>
@@ -1978,9 +1978,29 @@
                 <a:ea typeface="Noto Sans KR" pitchFamily="34" charset="-122"/>
                 <a:cs typeface="Noto Sans KR" pitchFamily="34" charset="-120"/>
               </a:rPr>
+              <a:t>비전검사 시스템</a:t>
+            </a:r>
+            <a:endParaRPr lang="en-US" sz="2800" dirty="0"/>
+          </a:p>
+          <a:p>
+            <a:pPr indent="0" marL="0">
+              <a:lnSpc>
+                <a:spcPct val="120000"/>
+              </a:lnSpc>
+              <a:buNone/>
+            </a:pPr>
+            <a:r>
+              <a:rPr lang="en-US" sz="2800" b="1" dirty="0">
+                <a:solidFill>
+                  <a:srgbClr val="FFFFFF"/>
+                </a:solidFill>
+                <a:latin typeface="Noto Sans KR" pitchFamily="34" charset="0"/>
+                <a:ea typeface="Noto Sans KR" pitchFamily="34" charset="-122"/>
+                <a:cs typeface="Noto Sans KR" pitchFamily="34" charset="-120"/>
+              </a:rPr>
               <a:t>도입 제안</a:t>
             </a:r>
-            <a:endParaRPr lang="en-US" sz="3000" dirty="0"/>
+            <a:endParaRPr lang="en-US" sz="2800" dirty="0"/>
           </a:p>
         </p:txBody>
       </p:sp>
@@ -1992,8 +2012,8 @@
         </p:nvSpPr>
         <p:spPr>
           <a:xfrm>
-            <a:off x="530352" y="2907792"/>
-            <a:ext cx="6858000" cy="310896"/>
+            <a:off x="530352" y="3054096"/>
+            <a:ext cx="4754880" cy="310896"/>
           </a:xfrm>
           <a:prstGeom prst="rect">
             <a:avLst/>
@@ -2009,7 +2029,7 @@
               <a:buNone/>
             </a:pPr>
             <a:r>
-              <a:rPr lang="en-US" sz="1300" dirty="0">
+              <a:rPr lang="en-US" sz="1200" dirty="0">
                 <a:solidFill>
                   <a:srgbClr val="A5C4F3"/>
                 </a:solidFill>
@@ -2019,7 +2039,7 @@
               </a:rPr>
               <a:t>불량 제로화를 위한 스마트 인라인 자동화 솔루션</a:t>
             </a:r>
-            <a:endParaRPr lang="en-US" sz="1300" dirty="0"/>
+            <a:endParaRPr lang="en-US" sz="1200" dirty="0"/>
           </a:p>
         </p:txBody>
       </p:sp>
@@ -2031,8 +2051,8 @@
         </p:nvSpPr>
         <p:spPr>
           <a:xfrm>
-            <a:off x="530352" y="3291840"/>
-            <a:ext cx="5486400" cy="0"/>
+            <a:off x="530352" y="3419856"/>
+            <a:ext cx="4389120" cy="0"/>
           </a:xfrm>
           <a:prstGeom prst="line">
             <a:avLst/>
@@ -2054,7 +2074,7 @@
         </p:nvSpPr>
         <p:spPr>
           <a:xfrm>
-            <a:off x="530352" y="3438144"/>
+            <a:off x="530352" y="3547872"/>
             <a:ext cx="4572000" cy="256032"/>
           </a:xfrm>
           <a:prstGeom prst="rect">
@@ -2093,7 +2113,7 @@
         </p:nvSpPr>
         <p:spPr>
           <a:xfrm>
-            <a:off x="530352" y="3694176"/>
+            <a:off x="530352" y="3803904"/>
             <a:ext cx="4572000" cy="256032"/>
           </a:xfrm>
           <a:prstGeom prst="rect">
@@ -2124,6 +2144,30 @@
           </a:p>
         </p:txBody>
       </p:sp>
+      <p:pic>
+        <p:nvPicPr>
+          <p:cNvPr id="10" name="Image 0" descr="preencoded.png">    </p:cNvPr>
+          <p:cNvPicPr>
+            <a:picLocks noChangeAspect="1"/>
+          </p:cNvPicPr>
+          <p:nvPr/>
+        </p:nvPicPr>
+        <p:blipFill>
+          <a:blip r:embed="rId1"/>
+          <a:stretch>
+            <a:fillRect/>
+          </a:stretch>
+        </p:blipFill>
+        <p:spPr>
+          <a:xfrm>
+            <a:off x="5349240" y="457200"/>
+            <a:ext cx="3703320" cy="3703320"/>
+          </a:xfrm>
+          <a:prstGeom prst="rect">
+            <a:avLst/>
+          </a:prstGeom>
+        </p:spPr>
+      </p:pic>
     </p:spTree>
   </p:cSld>
   <p:clrMapOvr>

</xml_diff>